<commit_message>
Reorder deck: portfolio health, drivers, then investment plan
Move the recommendation slide after the portfolio, risk and repeat-
customer slides and relabel it Investment plan; fix seasoned-period
footnote.

Co-Authored-By: Claude Opus 5.5 <noreply@anthropic.com>
Claude-Session: https://claude.ai/code/session_01W2UPg5WygeJNMeisH6AsMo
</commit_message>
<xml_diff>
--- a/deck/portfolio_recommendation.pptx
+++ b/deck/portfolio_recommendation.pptx
@@ -1847,7 +1847,7 @@
           <a:p>
             <a:r>
               <a:rPr lang="en-US" dirty="0"/>
-              <a:t>Four moves. Two where we invest: merchant acquisition in healthcare and home furnishing, and converting first-time customers into repeat customers. One where we pull back: travel borrowers below 640 FICO, via the risk model rather than a blunt cut-off. One pricing fix: 0% APR merchant fee. Together: profit grows faster than GMV and the loss rate goes down, because growth is steered toward low-loss segments.</a:t>
+              <a:t>Healthy trajectory: GMV up every quarter, 33% year over year for the second half. Credit quality is stable: average FICO ~652 throughout. Economics: revenue 10% of GMV, loss 2%, funding 1%, leaving ~7% contribution. Two things to flag: growth is led by interest-bearing, which is good, but also by fashion, our lowest-margin vertical; and the Q4-2024 holiday vintage had double the bad rate. Recent quarters show lower margins only because those loans are young.</a:t>
             </a:r>
             <a:endParaRPr lang="en-US" dirty="0"/>
           </a:p>
@@ -1935,7 +1935,7 @@
           <a:p>
             <a:r>
               <a:rPr lang="en-US" dirty="0"/>
-              <a:t>Healthy trajectory: GMV up every quarter, 33% year over year for the second half. Credit quality is stable: average FICO ~652 throughout. Economics: revenue 10% of GMV, loss 2%, funding 1%, leaving ~7% contribution. Two things to flag: growth is led by interest-bearing, which is good, but also by fashion, our lowest-margin vertical; and the Q4-2024 holiday vintage had double the bad rate. Recent quarters show lower margins only because those loans are young.</a:t>
+              <a:t>Sorted by margin. Travel has five times the bad rate of any other vertical, but it is still our largest profit pool because revenue is high. The risk is concentrated in sub-640 FICO travel borrowers: 40% bad rate, and the margin disappears if the delinquent loans charge off. Fashion is half our loans but a tenth of profit. Healthcare and home furnishing combine low loss with high revenue. By product, interest-bearing earns 82% of profit.</a:t>
             </a:r>
             <a:endParaRPr lang="en-US" dirty="0"/>
           </a:p>
@@ -2023,7 +2023,7 @@
           <a:p>
             <a:r>
               <a:rPr lang="en-US" dirty="0"/>
-              <a:t>Sorted by margin. Travel has five times the bad rate of any other vertical, but it is still our largest profit pool because revenue is high. The risk is concentrated in sub-640 FICO travel borrowers: 40% bad rate, and the margin disappears if the delinquent loans charge off. Fashion is half our loans but a tenth of profit. Healthcare and home furnishing combine low loss with high revenue. By product, interest-bearing earns 82% of profit.</a:t>
+              <a:t>A customer who repays their first loan is a much better risk the second time: loss falls from 2.6% to 1.0%, and that holds in every vertical and product, including on seasoned loans. 82% of loss dollars come from first loans. Repeat rates are set by the vertical: frequent-purchase verticals like fashion and electronics already get ~95%; big-ticket verticals only ~20%, which is where the upside is. And Split Pay works as an entry product: most customers move to interest-bearing, our highest-margin product, on their next loan.</a:t>
             </a:r>
             <a:endParaRPr lang="en-US" dirty="0"/>
           </a:p>
@@ -2111,7 +2111,7 @@
           <a:p>
             <a:r>
               <a:rPr lang="en-US" dirty="0"/>
-              <a:t>A customer who repays their first loan is a much better risk the second time: loss falls from 2.6% to 1.0%, and that holds in every vertical and product, including on seasoned loans. 82% of loss dollars come from first loans. Repeat rates are set by the vertical: frequent-purchase verticals like fashion and electronics already get ~95%; big-ticket verticals only ~20%, which is where the upside is. And Split Pay works as an entry product: most customers move to interest-bearing, our highest-margin product, on their next loan.</a:t>
+              <a:t>Four moves. Two where we invest: merchant acquisition in healthcare and home furnishing, and converting first-time customers into repeat customers. One where we pull back: travel borrowers below 640 FICO, via the risk model rather than a blunt cut-off. One pricing fix: 0% APR merchant fee. Together: profit grows faster than GMV and the loss rate goes down, because growth is steered toward low-loss segments.</a:t>
             </a:r>
             <a:endParaRPr lang="en-US" dirty="0"/>
           </a:p>
@@ -3630,1178 +3630,6 @@
                 <a:ea typeface="Arial" pitchFamily="34" charset="-122"/>
                 <a:cs typeface="Arial" pitchFamily="34" charset="-120"/>
               </a:rPr>
-              <a:t>RECOMMENDATION</a:t>
-            </a:r>
-            <a:endParaRPr lang="en-US" sz="1100" dirty="0"/>
-          </a:p>
-        </p:txBody>
-      </p:sp>
-      <p:sp>
-        <p:nvSpPr>
-          <p:cNvPr id="3" name="Text 1"/>
-          <p:cNvSpPr txBox="1"/>
-          <p:nvPr/>
-        </p:nvSpPr>
-        <p:spPr>
-          <a:xfrm>
-            <a:off x="548640" y="411480"/>
-            <a:ext cx="11094415" cy="868680"/>
-          </a:xfrm>
-          <a:prstGeom prst="rect">
-            <a:avLst/>
-          </a:prstGeom>
-          <a:noFill/>
-          <a:ln/>
-        </p:spPr>
-        <p:txBody>
-          <a:bodyPr wrap="square" lIns="0" tIns="0" rIns="0" bIns="0" rtlCol="0" anchor="t"/>
-          <a:lstStyle/>
-          <a:p>
-            <a:pPr indent="0" marL="0">
-              <a:buNone/>
-            </a:pPr>
-            <a:r>
-              <a:rPr lang="en-US" sz="2600" b="1" dirty="0">
-                <a:solidFill>
-                  <a:srgbClr val="1A1A2E"/>
-                </a:solidFill>
-                <a:latin typeface="Arial" pitchFamily="34" charset="0"/>
-                <a:ea typeface="Arial" pitchFamily="34" charset="-122"/>
-                <a:cs typeface="Arial" pitchFamily="34" charset="-120"/>
-              </a:rPr>
-              <a:t>Shift growth to where losses are low and customers come back</a:t>
-            </a:r>
-            <a:endParaRPr lang="en-US" sz="2600" dirty="0"/>
-          </a:p>
-        </p:txBody>
-      </p:sp>
-      <p:sp>
-        <p:nvSpPr>
-          <p:cNvPr id="4" name="Shape 2"/>
-          <p:cNvSpPr/>
-          <p:nvPr/>
-        </p:nvSpPr>
-        <p:spPr>
-          <a:xfrm>
-            <a:off x="548640" y="1417320"/>
-            <a:ext cx="6949440" cy="1051560"/>
-          </a:xfrm>
-          <a:prstGeom prst="roundRect">
-            <a:avLst>
-              <a:gd name="adj" fmla="val 10435"/>
-            </a:avLst>
-          </a:prstGeom>
-          <a:solidFill>
-            <a:srgbClr val="F6F6FE"/>
-          </a:solidFill>
-          <a:ln w="12700">
-            <a:solidFill>
-              <a:srgbClr val="F6F6FE"/>
-            </a:solidFill>
-            <a:prstDash val="solid"/>
-          </a:ln>
-        </p:spPr>
-      </p:sp>
-      <p:sp>
-        <p:nvSpPr>
-          <p:cNvPr id="5" name="Shape 3"/>
-          <p:cNvSpPr/>
-          <p:nvPr/>
-        </p:nvSpPr>
-        <p:spPr>
-          <a:xfrm>
-            <a:off x="777240" y="1600200"/>
-            <a:ext cx="1188720" cy="274320"/>
-          </a:xfrm>
-          <a:prstGeom prst="roundRect">
-            <a:avLst>
-              <a:gd name="adj" fmla="val 50000"/>
-            </a:avLst>
-          </a:prstGeom>
-          <a:solidFill>
-            <a:srgbClr val="1E8A4C"/>
-          </a:solidFill>
-          <a:ln w="12700">
-            <a:solidFill>
-              <a:srgbClr val="1E8A4C"/>
-            </a:solidFill>
-            <a:prstDash val="solid"/>
-          </a:ln>
-        </p:spPr>
-      </p:sp>
-      <p:sp>
-        <p:nvSpPr>
-          <p:cNvPr id="6" name="Text 4"/>
-          <p:cNvSpPr txBox="1"/>
-          <p:nvPr/>
-        </p:nvSpPr>
-        <p:spPr>
-          <a:xfrm>
-            <a:off x="777240" y="1600200"/>
-            <a:ext cx="1188720" cy="274320"/>
-          </a:xfrm>
-          <a:prstGeom prst="rect">
-            <a:avLst/>
-          </a:prstGeom>
-          <a:noFill/>
-          <a:ln/>
-        </p:spPr>
-        <p:txBody>
-          <a:bodyPr wrap="square" lIns="0" tIns="0" rIns="0" bIns="0" rtlCol="0" anchor="ctr"/>
-          <a:lstStyle/>
-          <a:p>
-            <a:pPr algn="ctr" indent="0" marL="0">
-              <a:buNone/>
-            </a:pPr>
-            <a:r>
-              <a:rPr lang="en-US" sz="1000" b="1" dirty="0">
-                <a:solidFill>
-                  <a:srgbClr val="FFFFFF"/>
-                </a:solidFill>
-                <a:latin typeface="Arial" pitchFamily="34" charset="0"/>
-                <a:ea typeface="Arial" pitchFamily="34" charset="-122"/>
-                <a:cs typeface="Arial" pitchFamily="34" charset="-120"/>
-              </a:rPr>
-              <a:t>INVEST</a:t>
-            </a:r>
-            <a:endParaRPr lang="en-US" sz="1000" dirty="0"/>
-          </a:p>
-        </p:txBody>
-      </p:sp>
-      <p:sp>
-        <p:nvSpPr>
-          <p:cNvPr id="7" name="Text 5"/>
-          <p:cNvSpPr txBox="1"/>
-          <p:nvPr/>
-        </p:nvSpPr>
-        <p:spPr>
-          <a:xfrm>
-            <a:off x="2148840" y="1536192"/>
-            <a:ext cx="5212080" cy="365760"/>
-          </a:xfrm>
-          <a:prstGeom prst="rect">
-            <a:avLst/>
-          </a:prstGeom>
-          <a:noFill/>
-          <a:ln/>
-        </p:spPr>
-        <p:txBody>
-          <a:bodyPr wrap="square" lIns="0" tIns="0" rIns="0" bIns="0" rtlCol="0" anchor="ctr"/>
-          <a:lstStyle/>
-          <a:p>
-            <a:pPr indent="0" marL="0">
-              <a:buNone/>
-            </a:pPr>
-            <a:r>
-              <a:rPr lang="en-US" sz="1500" b="1" dirty="0">
-                <a:solidFill>
-                  <a:srgbClr val="1A1A2E"/>
-                </a:solidFill>
-                <a:latin typeface="Arial" pitchFamily="34" charset="0"/>
-                <a:ea typeface="Arial" pitchFamily="34" charset="-122"/>
-                <a:cs typeface="Arial" pitchFamily="34" charset="-120"/>
-              </a:rPr>
-              <a:t>Merchant acquisition: healthcare &amp; home furnishing</a:t>
-            </a:r>
-            <a:endParaRPr lang="en-US" sz="1500" dirty="0"/>
-          </a:p>
-        </p:txBody>
-      </p:sp>
-      <p:sp>
-        <p:nvSpPr>
-          <p:cNvPr id="8" name="Text 6"/>
-          <p:cNvSpPr txBox="1"/>
-          <p:nvPr/>
-        </p:nvSpPr>
-        <p:spPr>
-          <a:xfrm>
-            <a:off x="2148840" y="1892808"/>
-            <a:ext cx="5212080" cy="530352"/>
-          </a:xfrm>
-          <a:prstGeom prst="rect">
-            <a:avLst/>
-          </a:prstGeom>
-          <a:noFill/>
-          <a:ln/>
-        </p:spPr>
-        <p:txBody>
-          <a:bodyPr wrap="square" lIns="0" tIns="0" rIns="0" bIns="0" rtlCol="0" anchor="t"/>
-          <a:lstStyle/>
-          <a:p>
-            <a:pPr indent="0" marL="0">
-              <a:buNone/>
-            </a:pPr>
-            <a:r>
-              <a:rPr lang="en-US" sz="1200" dirty="0">
-                <a:solidFill>
-                  <a:srgbClr val="5B5B73"/>
-                </a:solidFill>
-                <a:latin typeface="Arial" pitchFamily="34" charset="0"/>
-                <a:ea typeface="Arial" pitchFamily="34" charset="-122"/>
-                <a:cs typeface="Arial" pitchFamily="34" charset="-120"/>
-              </a:rPr>
-              <a:t>Best risk-adjusted margins (9.1%, 7.4%) with low loss. One new merchant ≈ +25–35% vertical GMV.</a:t>
-            </a:r>
-            <a:endParaRPr lang="en-US" sz="1200" dirty="0"/>
-          </a:p>
-        </p:txBody>
-      </p:sp>
-      <p:sp>
-        <p:nvSpPr>
-          <p:cNvPr id="9" name="Shape 7"/>
-          <p:cNvSpPr/>
-          <p:nvPr/>
-        </p:nvSpPr>
-        <p:spPr>
-          <a:xfrm>
-            <a:off x="548640" y="2606040"/>
-            <a:ext cx="6949440" cy="1051560"/>
-          </a:xfrm>
-          <a:prstGeom prst="roundRect">
-            <a:avLst>
-              <a:gd name="adj" fmla="val 10435"/>
-            </a:avLst>
-          </a:prstGeom>
-          <a:solidFill>
-            <a:srgbClr val="F6F6FE"/>
-          </a:solidFill>
-          <a:ln w="12700">
-            <a:solidFill>
-              <a:srgbClr val="F6F6FE"/>
-            </a:solidFill>
-            <a:prstDash val="solid"/>
-          </a:ln>
-        </p:spPr>
-      </p:sp>
-      <p:sp>
-        <p:nvSpPr>
-          <p:cNvPr id="10" name="Shape 8"/>
-          <p:cNvSpPr/>
-          <p:nvPr/>
-        </p:nvSpPr>
-        <p:spPr>
-          <a:xfrm>
-            <a:off x="777240" y="2788920"/>
-            <a:ext cx="1188720" cy="274320"/>
-          </a:xfrm>
-          <a:prstGeom prst="roundRect">
-            <a:avLst>
-              <a:gd name="adj" fmla="val 50000"/>
-            </a:avLst>
-          </a:prstGeom>
-          <a:solidFill>
-            <a:srgbClr val="1E8A4C"/>
-          </a:solidFill>
-          <a:ln w="12700">
-            <a:solidFill>
-              <a:srgbClr val="1E8A4C"/>
-            </a:solidFill>
-            <a:prstDash val="solid"/>
-          </a:ln>
-        </p:spPr>
-      </p:sp>
-      <p:sp>
-        <p:nvSpPr>
-          <p:cNvPr id="11" name="Text 9"/>
-          <p:cNvSpPr txBox="1"/>
-          <p:nvPr/>
-        </p:nvSpPr>
-        <p:spPr>
-          <a:xfrm>
-            <a:off x="777240" y="2788920"/>
-            <a:ext cx="1188720" cy="274320"/>
-          </a:xfrm>
-          <a:prstGeom prst="rect">
-            <a:avLst/>
-          </a:prstGeom>
-          <a:noFill/>
-          <a:ln/>
-        </p:spPr>
-        <p:txBody>
-          <a:bodyPr wrap="square" lIns="0" tIns="0" rIns="0" bIns="0" rtlCol="0" anchor="ctr"/>
-          <a:lstStyle/>
-          <a:p>
-            <a:pPr algn="ctr" indent="0" marL="0">
-              <a:buNone/>
-            </a:pPr>
-            <a:r>
-              <a:rPr lang="en-US" sz="1000" b="1" dirty="0">
-                <a:solidFill>
-                  <a:srgbClr val="FFFFFF"/>
-                </a:solidFill>
-                <a:latin typeface="Arial" pitchFamily="34" charset="0"/>
-                <a:ea typeface="Arial" pitchFamily="34" charset="-122"/>
-                <a:cs typeface="Arial" pitchFamily="34" charset="-120"/>
-              </a:rPr>
-              <a:t>INVEST</a:t>
-            </a:r>
-            <a:endParaRPr lang="en-US" sz="1000" dirty="0"/>
-          </a:p>
-        </p:txBody>
-      </p:sp>
-      <p:sp>
-        <p:nvSpPr>
-          <p:cNvPr id="12" name="Text 10"/>
-          <p:cNvSpPr txBox="1"/>
-          <p:nvPr/>
-        </p:nvSpPr>
-        <p:spPr>
-          <a:xfrm>
-            <a:off x="2148840" y="2724912"/>
-            <a:ext cx="5212080" cy="365760"/>
-          </a:xfrm>
-          <a:prstGeom prst="rect">
-            <a:avLst/>
-          </a:prstGeom>
-          <a:noFill/>
-          <a:ln/>
-        </p:spPr>
-        <p:txBody>
-          <a:bodyPr wrap="square" lIns="0" tIns="0" rIns="0" bIns="0" rtlCol="0" anchor="ctr"/>
-          <a:lstStyle/>
-          <a:p>
-            <a:pPr indent="0" marL="0">
-              <a:buNone/>
-            </a:pPr>
-            <a:r>
-              <a:rPr lang="en-US" sz="1500" b="1" dirty="0">
-                <a:solidFill>
-                  <a:srgbClr val="1A1A2E"/>
-                </a:solidFill>
-                <a:latin typeface="Arial" pitchFamily="34" charset="0"/>
-                <a:ea typeface="Arial" pitchFamily="34" charset="-122"/>
-                <a:cs typeface="Arial" pitchFamily="34" charset="-120"/>
-              </a:rPr>
-              <a:t>Repeat customers</a:t>
-            </a:r>
-            <a:endParaRPr lang="en-US" sz="1500" dirty="0"/>
-          </a:p>
-        </p:txBody>
-      </p:sp>
-      <p:sp>
-        <p:nvSpPr>
-          <p:cNvPr id="13" name="Text 11"/>
-          <p:cNvSpPr txBox="1"/>
-          <p:nvPr/>
-        </p:nvSpPr>
-        <p:spPr>
-          <a:xfrm>
-            <a:off x="2148840" y="3081528"/>
-            <a:ext cx="5212080" cy="530352"/>
-          </a:xfrm>
-          <a:prstGeom prst="rect">
-            <a:avLst/>
-          </a:prstGeom>
-          <a:noFill/>
-          <a:ln/>
-        </p:spPr>
-        <p:txBody>
-          <a:bodyPr wrap="square" lIns="0" tIns="0" rIns="0" bIns="0" rtlCol="0" anchor="t"/>
-          <a:lstStyle/>
-          <a:p>
-            <a:pPr indent="0" marL="0">
-              <a:buNone/>
-            </a:pPr>
-            <a:r>
-              <a:rPr lang="en-US" sz="1200" dirty="0">
-                <a:solidFill>
-                  <a:srgbClr val="5B5B73"/>
-                </a:solidFill>
-                <a:latin typeface="Arial" pitchFamily="34" charset="0"/>
-                <a:ea typeface="Arial" pitchFamily="34" charset="-122"/>
-                <a:cs typeface="Arial" pitchFamily="34" charset="-120"/>
-              </a:rPr>
-              <a:t>Repeat loans lose 2.5× less; 82% of loss comes from first loans. Lift big-ticket repeat rate and steer second loans to interest-bearing.</a:t>
-            </a:r>
-            <a:endParaRPr lang="en-US" sz="1200" dirty="0"/>
-          </a:p>
-        </p:txBody>
-      </p:sp>
-      <p:sp>
-        <p:nvSpPr>
-          <p:cNvPr id="14" name="Shape 12"/>
-          <p:cNvSpPr/>
-          <p:nvPr/>
-        </p:nvSpPr>
-        <p:spPr>
-          <a:xfrm>
-            <a:off x="548640" y="3794760"/>
-            <a:ext cx="6949440" cy="1051560"/>
-          </a:xfrm>
-          <a:prstGeom prst="roundRect">
-            <a:avLst>
-              <a:gd name="adj" fmla="val 10435"/>
-            </a:avLst>
-          </a:prstGeom>
-          <a:solidFill>
-            <a:srgbClr val="F6F6FE"/>
-          </a:solidFill>
-          <a:ln w="12700">
-            <a:solidFill>
-              <a:srgbClr val="F6F6FE"/>
-            </a:solidFill>
-            <a:prstDash val="solid"/>
-          </a:ln>
-        </p:spPr>
-      </p:sp>
-      <p:sp>
-        <p:nvSpPr>
-          <p:cNvPr id="15" name="Shape 13"/>
-          <p:cNvSpPr/>
-          <p:nvPr/>
-        </p:nvSpPr>
-        <p:spPr>
-          <a:xfrm>
-            <a:off x="777240" y="3977640"/>
-            <a:ext cx="1188720" cy="274320"/>
-          </a:xfrm>
-          <a:prstGeom prst="roundRect">
-            <a:avLst>
-              <a:gd name="adj" fmla="val 50000"/>
-            </a:avLst>
-          </a:prstGeom>
-          <a:solidFill>
-            <a:srgbClr val="C93B3B"/>
-          </a:solidFill>
-          <a:ln w="12700">
-            <a:solidFill>
-              <a:srgbClr val="C93B3B"/>
-            </a:solidFill>
-            <a:prstDash val="solid"/>
-          </a:ln>
-        </p:spPr>
-      </p:sp>
-      <p:sp>
-        <p:nvSpPr>
-          <p:cNvPr id="16" name="Text 14"/>
-          <p:cNvSpPr txBox="1"/>
-          <p:nvPr/>
-        </p:nvSpPr>
-        <p:spPr>
-          <a:xfrm>
-            <a:off x="777240" y="3977640"/>
-            <a:ext cx="1188720" cy="274320"/>
-          </a:xfrm>
-          <a:prstGeom prst="rect">
-            <a:avLst/>
-          </a:prstGeom>
-          <a:noFill/>
-          <a:ln/>
-        </p:spPr>
-        <p:txBody>
-          <a:bodyPr wrap="square" lIns="0" tIns="0" rIns="0" bIns="0" rtlCol="0" anchor="ctr"/>
-          <a:lstStyle/>
-          <a:p>
-            <a:pPr algn="ctr" indent="0" marL="0">
-              <a:buNone/>
-            </a:pPr>
-            <a:r>
-              <a:rPr lang="en-US" sz="1000" b="1" dirty="0">
-                <a:solidFill>
-                  <a:srgbClr val="FFFFFF"/>
-                </a:solidFill>
-                <a:latin typeface="Arial" pitchFamily="34" charset="0"/>
-                <a:ea typeface="Arial" pitchFamily="34" charset="-122"/>
-                <a:cs typeface="Arial" pitchFamily="34" charset="-120"/>
-              </a:rPr>
-              <a:t>TIGHTEN</a:t>
-            </a:r>
-            <a:endParaRPr lang="en-US" sz="1000" dirty="0"/>
-          </a:p>
-        </p:txBody>
-      </p:sp>
-      <p:sp>
-        <p:nvSpPr>
-          <p:cNvPr id="17" name="Text 15"/>
-          <p:cNvSpPr txBox="1"/>
-          <p:nvPr/>
-        </p:nvSpPr>
-        <p:spPr>
-          <a:xfrm>
-            <a:off x="2148840" y="3913632"/>
-            <a:ext cx="5212080" cy="365760"/>
-          </a:xfrm>
-          <a:prstGeom prst="rect">
-            <a:avLst/>
-          </a:prstGeom>
-          <a:noFill/>
-          <a:ln/>
-        </p:spPr>
-        <p:txBody>
-          <a:bodyPr wrap="square" lIns="0" tIns="0" rIns="0" bIns="0" rtlCol="0" anchor="ctr"/>
-          <a:lstStyle/>
-          <a:p>
-            <a:pPr indent="0" marL="0">
-              <a:buNone/>
-            </a:pPr>
-            <a:r>
-              <a:rPr lang="en-US" sz="1500" b="1" dirty="0">
-                <a:solidFill>
-                  <a:srgbClr val="1A1A2E"/>
-                </a:solidFill>
-                <a:latin typeface="Arial" pitchFamily="34" charset="0"/>
-                <a:ea typeface="Arial" pitchFamily="34" charset="-122"/>
-                <a:cs typeface="Arial" pitchFamily="34" charset="-120"/>
-              </a:rPr>
-              <a:t>Travel borrowers with FICO &lt; 640</a:t>
-            </a:r>
-            <a:endParaRPr lang="en-US" sz="1500" dirty="0"/>
-          </a:p>
-        </p:txBody>
-      </p:sp>
-      <p:sp>
-        <p:nvSpPr>
-          <p:cNvPr id="18" name="Text 16"/>
-          <p:cNvSpPr txBox="1"/>
-          <p:nvPr/>
-        </p:nvSpPr>
-        <p:spPr>
-          <a:xfrm>
-            <a:off x="2148840" y="4270248"/>
-            <a:ext cx="5212080" cy="530352"/>
-          </a:xfrm>
-          <a:prstGeom prst="rect">
-            <a:avLst/>
-          </a:prstGeom>
-          <a:noFill/>
-          <a:ln/>
-        </p:spPr>
-        <p:txBody>
-          <a:bodyPr wrap="square" lIns="0" tIns="0" rIns="0" bIns="0" rtlCol="0" anchor="t"/>
-          <a:lstStyle/>
-          <a:p>
-            <a:pPr indent="0" marL="0">
-              <a:buNone/>
-            </a:pPr>
-            <a:r>
-              <a:rPr lang="en-US" sz="1200" dirty="0">
-                <a:solidFill>
-                  <a:srgbClr val="5B5B73"/>
-                </a:solidFill>
-                <a:latin typeface="Arial" pitchFamily="34" charset="0"/>
-                <a:ea typeface="Arial" pitchFamily="34" charset="-122"/>
-                <a:cs typeface="Arial" pitchFamily="34" charset="-120"/>
-              </a:rPr>
-              <a:t>~40% delinquent or charged off, 6.3% loss. Raise the risk model cut-off and lower limits: −25% to −50% volume.</a:t>
-            </a:r>
-            <a:endParaRPr lang="en-US" sz="1200" dirty="0"/>
-          </a:p>
-        </p:txBody>
-      </p:sp>
-      <p:sp>
-        <p:nvSpPr>
-          <p:cNvPr id="19" name="Shape 17"/>
-          <p:cNvSpPr/>
-          <p:nvPr/>
-        </p:nvSpPr>
-        <p:spPr>
-          <a:xfrm>
-            <a:off x="548640" y="4983480"/>
-            <a:ext cx="6949440" cy="1051560"/>
-          </a:xfrm>
-          <a:prstGeom prst="roundRect">
-            <a:avLst>
-              <a:gd name="adj" fmla="val 10435"/>
-            </a:avLst>
-          </a:prstGeom>
-          <a:solidFill>
-            <a:srgbClr val="F6F6FE"/>
-          </a:solidFill>
-          <a:ln w="12700">
-            <a:solidFill>
-              <a:srgbClr val="F6F6FE"/>
-            </a:solidFill>
-            <a:prstDash val="solid"/>
-          </a:ln>
-        </p:spPr>
-      </p:sp>
-      <p:sp>
-        <p:nvSpPr>
-          <p:cNvPr id="20" name="Shape 18"/>
-          <p:cNvSpPr/>
-          <p:nvPr/>
-        </p:nvSpPr>
-        <p:spPr>
-          <a:xfrm>
-            <a:off x="777240" y="5166360"/>
-            <a:ext cx="1188720" cy="274320"/>
-          </a:xfrm>
-          <a:prstGeom prst="roundRect">
-            <a:avLst>
-              <a:gd name="adj" fmla="val 50000"/>
-            </a:avLst>
-          </a:prstGeom>
-          <a:solidFill>
-            <a:srgbClr val="4A4AF4"/>
-          </a:solidFill>
-          <a:ln w="12700">
-            <a:solidFill>
-              <a:srgbClr val="4A4AF4"/>
-            </a:solidFill>
-            <a:prstDash val="solid"/>
-          </a:ln>
-        </p:spPr>
-      </p:sp>
-      <p:sp>
-        <p:nvSpPr>
-          <p:cNvPr id="21" name="Text 19"/>
-          <p:cNvSpPr txBox="1"/>
-          <p:nvPr/>
-        </p:nvSpPr>
-        <p:spPr>
-          <a:xfrm>
-            <a:off x="777240" y="5166360"/>
-            <a:ext cx="1188720" cy="274320"/>
-          </a:xfrm>
-          <a:prstGeom prst="rect">
-            <a:avLst/>
-          </a:prstGeom>
-          <a:noFill/>
-          <a:ln/>
-        </p:spPr>
-        <p:txBody>
-          <a:bodyPr wrap="square" lIns="0" tIns="0" rIns="0" bIns="0" rtlCol="0" anchor="ctr"/>
-          <a:lstStyle/>
-          <a:p>
-            <a:pPr algn="ctr" indent="0" marL="0">
-              <a:buNone/>
-            </a:pPr>
-            <a:r>
-              <a:rPr lang="en-US" sz="1000" b="1" dirty="0">
-                <a:solidFill>
-                  <a:srgbClr val="FFFFFF"/>
-                </a:solidFill>
-                <a:latin typeface="Arial" pitchFamily="34" charset="0"/>
-                <a:ea typeface="Arial" pitchFamily="34" charset="-122"/>
-                <a:cs typeface="Arial" pitchFamily="34" charset="-120"/>
-              </a:rPr>
-              <a:t>REPRICE</a:t>
-            </a:r>
-            <a:endParaRPr lang="en-US" sz="1000" dirty="0"/>
-          </a:p>
-        </p:txBody>
-      </p:sp>
-      <p:sp>
-        <p:nvSpPr>
-          <p:cNvPr id="22" name="Text 20"/>
-          <p:cNvSpPr txBox="1"/>
-          <p:nvPr/>
-        </p:nvSpPr>
-        <p:spPr>
-          <a:xfrm>
-            <a:off x="2148840" y="5102352"/>
-            <a:ext cx="5212080" cy="365760"/>
-          </a:xfrm>
-          <a:prstGeom prst="rect">
-            <a:avLst/>
-          </a:prstGeom>
-          <a:noFill/>
-          <a:ln/>
-        </p:spPr>
-        <p:txBody>
-          <a:bodyPr wrap="square" lIns="0" tIns="0" rIns="0" bIns="0" rtlCol="0" anchor="ctr"/>
-          <a:lstStyle/>
-          <a:p>
-            <a:pPr indent="0" marL="0">
-              <a:buNone/>
-            </a:pPr>
-            <a:r>
-              <a:rPr lang="en-US" sz="1500" b="1" dirty="0">
-                <a:solidFill>
-                  <a:srgbClr val="1A1A2E"/>
-                </a:solidFill>
-                <a:latin typeface="Arial" pitchFamily="34" charset="0"/>
-                <a:ea typeface="Arial" pitchFamily="34" charset="-122"/>
-                <a:cs typeface="Arial" pitchFamily="34" charset="-120"/>
-              </a:rPr>
-              <a:t>0% APR merchant fee</a:t>
-            </a:r>
-            <a:endParaRPr lang="en-US" sz="1500" dirty="0"/>
-          </a:p>
-        </p:txBody>
-      </p:sp>
-      <p:sp>
-        <p:nvSpPr>
-          <p:cNvPr id="23" name="Text 21"/>
-          <p:cNvSpPr txBox="1"/>
-          <p:nvPr/>
-        </p:nvSpPr>
-        <p:spPr>
-          <a:xfrm>
-            <a:off x="2148840" y="5458968"/>
-            <a:ext cx="5212080" cy="530352"/>
-          </a:xfrm>
-          <a:prstGeom prst="rect">
-            <a:avLst/>
-          </a:prstGeom>
-          <a:noFill/>
-          <a:ln/>
-        </p:spPr>
-        <p:txBody>
-          <a:bodyPr wrap="square" lIns="0" tIns="0" rIns="0" bIns="0" rtlCol="0" anchor="t"/>
-          <a:lstStyle/>
-          <a:p>
-            <a:pPr indent="0" marL="0">
-              <a:buNone/>
-            </a:pPr>
-            <a:r>
-              <a:rPr lang="en-US" sz="1200" dirty="0">
-                <a:solidFill>
-                  <a:srgbClr val="5B5B73"/>
-                </a:solidFill>
-                <a:latin typeface="Arial" pitchFamily="34" charset="0"/>
-                <a:ea typeface="Arial" pitchFamily="34" charset="-122"/>
-                <a:cs typeface="Arial" pitchFamily="34" charset="-120"/>
-              </a:rPr>
-              <a:t>Fee (5.0%) is below interest-bearing (5.4%) at the same merchants. Raise to at least parity.</a:t>
-            </a:r>
-            <a:endParaRPr lang="en-US" sz="1200" dirty="0"/>
-          </a:p>
-        </p:txBody>
-      </p:sp>
-      <p:sp>
-        <p:nvSpPr>
-          <p:cNvPr id="24" name="Shape 22"/>
-          <p:cNvSpPr/>
-          <p:nvPr/>
-        </p:nvSpPr>
-        <p:spPr>
-          <a:xfrm>
-            <a:off x="7909560" y="1417320"/>
-            <a:ext cx="3733495" cy="4617720"/>
-          </a:xfrm>
-          <a:prstGeom prst="roundRect">
-            <a:avLst>
-              <a:gd name="adj" fmla="val 2939"/>
-            </a:avLst>
-          </a:prstGeom>
-          <a:solidFill>
-            <a:srgbClr val="0F1033"/>
-          </a:solidFill>
-          <a:ln w="12700">
-            <a:solidFill>
-              <a:srgbClr val="0F1033"/>
-            </a:solidFill>
-            <a:prstDash val="solid"/>
-          </a:ln>
-        </p:spPr>
-      </p:sp>
-      <p:sp>
-        <p:nvSpPr>
-          <p:cNvPr id="25" name="Text 23"/>
-          <p:cNvSpPr txBox="1"/>
-          <p:nvPr/>
-        </p:nvSpPr>
-        <p:spPr>
-          <a:xfrm>
-            <a:off x="8229600" y="1645920"/>
-            <a:ext cx="3093415" cy="365760"/>
-          </a:xfrm>
-          <a:prstGeom prst="rect">
-            <a:avLst/>
-          </a:prstGeom>
-          <a:noFill/>
-          <a:ln/>
-        </p:spPr>
-        <p:txBody>
-          <a:bodyPr wrap="square" lIns="0" tIns="0" rIns="0" bIns="0" rtlCol="0" anchor="ctr"/>
-          <a:lstStyle/>
-          <a:p>
-            <a:pPr indent="0" marL="0">
-              <a:buNone/>
-            </a:pPr>
-            <a:r>
-              <a:rPr lang="en-US" sz="1400" b="1" dirty="0">
-                <a:solidFill>
-                  <a:srgbClr val="D9D9FC"/>
-                </a:solidFill>
-                <a:latin typeface="Arial" pitchFamily="34" charset="0"/>
-                <a:ea typeface="Arial" pitchFamily="34" charset="-122"/>
-                <a:cs typeface="Arial" pitchFamily="34" charset="-120"/>
-              </a:rPr>
-              <a:t>One-year impact</a:t>
-            </a:r>
-            <a:endParaRPr lang="en-US" sz="1400" dirty="0"/>
-          </a:p>
-        </p:txBody>
-      </p:sp>
-      <p:sp>
-        <p:nvSpPr>
-          <p:cNvPr id="26" name="Text 24"/>
-          <p:cNvSpPr txBox="1"/>
-          <p:nvPr/>
-        </p:nvSpPr>
-        <p:spPr>
-          <a:xfrm>
-            <a:off x="8229600" y="1965960"/>
-            <a:ext cx="3093415" cy="274320"/>
-          </a:xfrm>
-          <a:prstGeom prst="rect">
-            <a:avLst/>
-          </a:prstGeom>
-          <a:noFill/>
-          <a:ln/>
-        </p:spPr>
-        <p:txBody>
-          <a:bodyPr wrap="square" lIns="0" tIns="0" rIns="0" bIns="0" rtlCol="0" anchor="ctr"/>
-          <a:lstStyle/>
-          <a:p>
-            <a:pPr indent="0" marL="0">
-              <a:buNone/>
-            </a:pPr>
-            <a:r>
-              <a:rPr lang="en-US" sz="1100" dirty="0">
-                <a:solidFill>
-                  <a:srgbClr val="D9D9FC"/>
-                </a:solidFill>
-                <a:latin typeface="Arial" pitchFamily="34" charset="0"/>
-                <a:ea typeface="Arial" pitchFamily="34" charset="-122"/>
-                <a:cs typeface="Arial" pitchFamily="34" charset="-120"/>
-              </a:rPr>
-              <a:t>conservative → ambitious</a:t>
-            </a:r>
-            <a:endParaRPr lang="en-US" sz="1100" dirty="0"/>
-          </a:p>
-        </p:txBody>
-      </p:sp>
-      <p:sp>
-        <p:nvSpPr>
-          <p:cNvPr id="27" name="Text 25"/>
-          <p:cNvSpPr txBox="1"/>
-          <p:nvPr/>
-        </p:nvSpPr>
-        <p:spPr>
-          <a:xfrm>
-            <a:off x="8229600" y="2468880"/>
-            <a:ext cx="3093415" cy="502920"/>
-          </a:xfrm>
-          <a:prstGeom prst="rect">
-            <a:avLst/>
-          </a:prstGeom>
-          <a:noFill/>
-          <a:ln/>
-        </p:spPr>
-        <p:txBody>
-          <a:bodyPr wrap="square" lIns="0" tIns="0" rIns="0" bIns="0" rtlCol="0" anchor="ctr"/>
-          <a:lstStyle/>
-          <a:p>
-            <a:pPr indent="0" marL="0">
-              <a:buNone/>
-            </a:pPr>
-            <a:r>
-              <a:rPr lang="en-US" sz="2600" b="1" dirty="0">
-                <a:solidFill>
-                  <a:srgbClr val="FFFFFF"/>
-                </a:solidFill>
-                <a:latin typeface="Arial" pitchFamily="34" charset="0"/>
-                <a:ea typeface="Arial" pitchFamily="34" charset="-122"/>
-                <a:cs typeface="Arial" pitchFamily="34" charset="-120"/>
-              </a:rPr>
-              <a:t>+7% → +15%</a:t>
-            </a:r>
-            <a:endParaRPr lang="en-US" sz="2600" dirty="0"/>
-          </a:p>
-        </p:txBody>
-      </p:sp>
-      <p:sp>
-        <p:nvSpPr>
-          <p:cNvPr id="28" name="Text 26"/>
-          <p:cNvSpPr txBox="1"/>
-          <p:nvPr/>
-        </p:nvSpPr>
-        <p:spPr>
-          <a:xfrm>
-            <a:off x="8229600" y="2971800"/>
-            <a:ext cx="3093415" cy="320040"/>
-          </a:xfrm>
-          <a:prstGeom prst="rect">
-            <a:avLst/>
-          </a:prstGeom>
-          <a:noFill/>
-          <a:ln/>
-        </p:spPr>
-        <p:txBody>
-          <a:bodyPr wrap="square" lIns="0" tIns="0" rIns="0" bIns="0" rtlCol="0" anchor="ctr"/>
-          <a:lstStyle/>
-          <a:p>
-            <a:pPr indent="0" marL="0">
-              <a:buNone/>
-            </a:pPr>
-            <a:r>
-              <a:rPr lang="en-US" sz="1200" dirty="0">
-                <a:solidFill>
-                  <a:srgbClr val="D9D9FC"/>
-                </a:solidFill>
-                <a:latin typeface="Arial" pitchFamily="34" charset="0"/>
-                <a:ea typeface="Arial" pitchFamily="34" charset="-122"/>
-                <a:cs typeface="Arial" pitchFamily="34" charset="-120"/>
-              </a:rPr>
-              <a:t>profit (contribution)</a:t>
-            </a:r>
-            <a:endParaRPr lang="en-US" sz="1200" dirty="0"/>
-          </a:p>
-        </p:txBody>
-      </p:sp>
-      <p:sp>
-        <p:nvSpPr>
-          <p:cNvPr id="29" name="Text 27"/>
-          <p:cNvSpPr txBox="1"/>
-          <p:nvPr/>
-        </p:nvSpPr>
-        <p:spPr>
-          <a:xfrm>
-            <a:off x="8229600" y="3611880"/>
-            <a:ext cx="3093415" cy="502920"/>
-          </a:xfrm>
-          <a:prstGeom prst="rect">
-            <a:avLst/>
-          </a:prstGeom>
-          <a:noFill/>
-          <a:ln/>
-        </p:spPr>
-        <p:txBody>
-          <a:bodyPr wrap="square" lIns="0" tIns="0" rIns="0" bIns="0" rtlCol="0" anchor="ctr"/>
-          <a:lstStyle/>
-          <a:p>
-            <a:pPr indent="0" marL="0">
-              <a:buNone/>
-            </a:pPr>
-            <a:r>
-              <a:rPr lang="en-US" sz="2600" b="1" dirty="0">
-                <a:solidFill>
-                  <a:srgbClr val="FFFFFF"/>
-                </a:solidFill>
-                <a:latin typeface="Arial" pitchFamily="34" charset="0"/>
-                <a:ea typeface="Arial" pitchFamily="34" charset="-122"/>
-                <a:cs typeface="Arial" pitchFamily="34" charset="-120"/>
-              </a:rPr>
-              <a:t>+4% → +8%</a:t>
-            </a:r>
-            <a:endParaRPr lang="en-US" sz="2600" dirty="0"/>
-          </a:p>
-        </p:txBody>
-      </p:sp>
-      <p:sp>
-        <p:nvSpPr>
-          <p:cNvPr id="30" name="Text 28"/>
-          <p:cNvSpPr txBox="1"/>
-          <p:nvPr/>
-        </p:nvSpPr>
-        <p:spPr>
-          <a:xfrm>
-            <a:off x="8229600" y="4114800"/>
-            <a:ext cx="3093415" cy="320040"/>
-          </a:xfrm>
-          <a:prstGeom prst="rect">
-            <a:avLst/>
-          </a:prstGeom>
-          <a:noFill/>
-          <a:ln/>
-        </p:spPr>
-        <p:txBody>
-          <a:bodyPr wrap="square" lIns="0" tIns="0" rIns="0" bIns="0" rtlCol="0" anchor="ctr"/>
-          <a:lstStyle/>
-          <a:p>
-            <a:pPr indent="0" marL="0">
-              <a:buNone/>
-            </a:pPr>
-            <a:r>
-              <a:rPr lang="en-US" sz="1200" dirty="0">
-                <a:solidFill>
-                  <a:srgbClr val="D9D9FC"/>
-                </a:solidFill>
-                <a:latin typeface="Arial" pitchFamily="34" charset="0"/>
-                <a:ea typeface="Arial" pitchFamily="34" charset="-122"/>
-                <a:cs typeface="Arial" pitchFamily="34" charset="-120"/>
-              </a:rPr>
-              <a:t>GMV</a:t>
-            </a:r>
-            <a:endParaRPr lang="en-US" sz="1200" dirty="0"/>
-          </a:p>
-        </p:txBody>
-      </p:sp>
-      <p:sp>
-        <p:nvSpPr>
-          <p:cNvPr id="31" name="Text 29"/>
-          <p:cNvSpPr txBox="1"/>
-          <p:nvPr/>
-        </p:nvSpPr>
-        <p:spPr>
-          <a:xfrm>
-            <a:off x="8229600" y="4754880"/>
-            <a:ext cx="3093415" cy="502920"/>
-          </a:xfrm>
-          <a:prstGeom prst="rect">
-            <a:avLst/>
-          </a:prstGeom>
-          <a:noFill/>
-          <a:ln/>
-        </p:spPr>
-        <p:txBody>
-          <a:bodyPr wrap="square" lIns="0" tIns="0" rIns="0" bIns="0" rtlCol="0" anchor="ctr"/>
-          <a:lstStyle/>
-          <a:p>
-            <a:pPr indent="0" marL="0">
-              <a:buNone/>
-            </a:pPr>
-            <a:r>
-              <a:rPr lang="en-US" sz="2600" b="1" dirty="0">
-                <a:solidFill>
-                  <a:srgbClr val="FFFFFF"/>
-                </a:solidFill>
-                <a:latin typeface="Arial" pitchFamily="34" charset="0"/>
-                <a:ea typeface="Arial" pitchFamily="34" charset="-122"/>
-                <a:cs typeface="Arial" pitchFamily="34" charset="-120"/>
-              </a:rPr>
-              <a:t>2.32% → 2.1–2.2%</a:t>
-            </a:r>
-            <a:endParaRPr lang="en-US" sz="2600" dirty="0"/>
-          </a:p>
-        </p:txBody>
-      </p:sp>
-      <p:sp>
-        <p:nvSpPr>
-          <p:cNvPr id="32" name="Text 30"/>
-          <p:cNvSpPr txBox="1"/>
-          <p:nvPr/>
-        </p:nvSpPr>
-        <p:spPr>
-          <a:xfrm>
-            <a:off x="8229600" y="5257800"/>
-            <a:ext cx="3093415" cy="320040"/>
-          </a:xfrm>
-          <a:prstGeom prst="rect">
-            <a:avLst/>
-          </a:prstGeom>
-          <a:noFill/>
-          <a:ln/>
-        </p:spPr>
-        <p:txBody>
-          <a:bodyPr wrap="square" lIns="0" tIns="0" rIns="0" bIns="0" rtlCol="0" anchor="ctr"/>
-          <a:lstStyle/>
-          <a:p>
-            <a:pPr indent="0" marL="0">
-              <a:buNone/>
-            </a:pPr>
-            <a:r>
-              <a:rPr lang="en-US" sz="1200" dirty="0">
-                <a:solidFill>
-                  <a:srgbClr val="D9D9FC"/>
-                </a:solidFill>
-                <a:latin typeface="Arial" pitchFamily="34" charset="0"/>
-                <a:ea typeface="Arial" pitchFamily="34" charset="-122"/>
-                <a:cs typeface="Arial" pitchFamily="34" charset="-120"/>
-              </a:rPr>
-              <a:t>credit loss rate</a:t>
-            </a:r>
-            <a:endParaRPr lang="en-US" sz="1200" dirty="0"/>
-          </a:p>
-        </p:txBody>
-      </p:sp>
-      <p:sp>
-        <p:nvSpPr>
-          <p:cNvPr id="33" name="Text 31"/>
-          <p:cNvSpPr txBox="1"/>
-          <p:nvPr/>
-        </p:nvSpPr>
-        <p:spPr>
-          <a:xfrm>
-            <a:off x="548640" y="6355080"/>
-            <a:ext cx="11094415" cy="320040"/>
-          </a:xfrm>
-          <a:prstGeom prst="rect">
-            <a:avLst/>
-          </a:prstGeom>
-          <a:noFill/>
-          <a:ln/>
-        </p:spPr>
-        <p:txBody>
-          <a:bodyPr wrap="square" lIns="0" tIns="0" rIns="0" bIns="0" rtlCol="0" anchor="b"/>
-          <a:lstStyle/>
-          <a:p>
-            <a:pPr indent="0" marL="0">
-              <a:buNone/>
-            </a:pPr>
-            <a:r>
-              <a:rPr lang="en-US" sz="1000" dirty="0">
-                <a:solidFill>
-                  <a:srgbClr val="5B5B73"/>
-                </a:solidFill>
-                <a:latin typeface="Arial" pitchFamily="34" charset="0"/>
-                <a:ea typeface="Arial" pitchFamily="34" charset="-122"/>
-                <a:cs typeface="Arial" pitchFamily="34" charset="-120"/>
-              </a:rPr>
-              <a:t>Impact sized on 2025 volume at seasoned (Jan 2024–Jun 2025) margins and loss rates; 0% APR repricing not included in totals.</a:t>
-            </a:r>
-            <a:endParaRPr lang="en-US" sz="1000" dirty="0"/>
-          </a:p>
-        </p:txBody>
-      </p:sp>
-    </p:spTree>
-  </p:cSld>
-  <p:clrMapOvr>
-    <a:masterClrMapping/>
-  </p:clrMapOvr>
-</p:sld>
-</file>
-
-<file path=ppt/slides/slide3.xml><?xml version="1.0" encoding="utf-8"?>
-<p:sld xmlns:a="http://schemas.openxmlformats.org/drawingml/2006/main" xmlns:r="http://schemas.openxmlformats.org/officeDocument/2006/relationships" xmlns:p="http://schemas.openxmlformats.org/presentationml/2006/main">
-  <p:cSld name="Slide 3">
-    <p:bg>
-      <p:bgPr>
-        <a:solidFill>
-          <a:srgbClr val="FFFFFF"/>
-        </a:solidFill>
-      </p:bgPr>
-    </p:bg>
-    <p:spTree>
-      <p:nvGrpSpPr>
-        <p:cNvPr id="1" name=""/>
-        <p:cNvGrpSpPr/>
-        <p:nvPr/>
-      </p:nvGrpSpPr>
-      <p:grpSpPr>
-        <a:xfrm>
-          <a:off x="0" y="0"/>
-          <a:ext cx="0" cy="0"/>
-          <a:chOff x="0" y="0"/>
-          <a:chExt cx="0" cy="0"/>
-        </a:xfrm>
-      </p:grpSpPr>
-      <p:sp>
-        <p:nvSpPr>
-          <p:cNvPr id="2" name="Text 0"/>
-          <p:cNvSpPr txBox="1"/>
-          <p:nvPr/>
-        </p:nvSpPr>
-        <p:spPr>
-          <a:xfrm>
-            <a:off x="548640" y="164592"/>
-            <a:ext cx="7315200" cy="274320"/>
-          </a:xfrm>
-          <a:prstGeom prst="rect">
-            <a:avLst/>
-          </a:prstGeom>
-          <a:noFill/>
-          <a:ln/>
-        </p:spPr>
-        <p:txBody>
-          <a:bodyPr wrap="square" lIns="0" tIns="0" rIns="0" bIns="0" rtlCol="0" anchor="ctr"/>
-          <a:lstStyle/>
-          <a:p>
-            <a:pPr indent="0" marL="0">
-              <a:buNone/>
-            </a:pPr>
-            <a:r>
-              <a:rPr lang="en-US" sz="1100" b="1" spc="200" kern="0" dirty="0">
-                <a:solidFill>
-                  <a:srgbClr val="4A4AF4"/>
-                </a:solidFill>
-                <a:latin typeface="Arial" pitchFamily="34" charset="0"/>
-                <a:ea typeface="Arial" pitchFamily="34" charset="-122"/>
-                <a:cs typeface="Arial" pitchFamily="34" charset="-120"/>
-              </a:rPr>
               <a:t>PORTFOLIO HEALTH</a:t>
             </a:r>
             <a:endParaRPr lang="en-US" sz="1100" dirty="0"/>
@@ -5373,9 +4201,9 @@
 </p:sld>
 </file>
 
-<file path=ppt/slides/slide4.xml><?xml version="1.0" encoding="utf-8"?>
+<file path=ppt/slides/slide3.xml><?xml version="1.0" encoding="utf-8"?>
 <p:sld xmlns:a="http://schemas.openxmlformats.org/drawingml/2006/main" xmlns:r="http://schemas.openxmlformats.org/officeDocument/2006/relationships" xmlns:p="http://schemas.openxmlformats.org/presentationml/2006/main">
-  <p:cSld name="Slide 4">
+  <p:cSld name="Slide 3">
     <p:bg>
       <p:bgPr>
         <a:solidFill>
@@ -5477,7 +4305,7 @@
       </p:sp>
       <p:graphicFrame>
         <p:nvGraphicFramePr>
-          <p:cNvPr id="5" name="Table 0"/>
+          <p:cNvPr id="4" name="Table 0"/>
           <p:cNvGraphicFramePr>
             <a:graphicFrameLocks noGrp="1"/>
           </p:cNvGraphicFramePr>
@@ -9151,9 +7979,9 @@
 </p:sld>
 </file>
 
-<file path=ppt/slides/slide5.xml><?xml version="1.0" encoding="utf-8"?>
+<file path=ppt/slides/slide4.xml><?xml version="1.0" encoding="utf-8"?>
 <p:sld xmlns:a="http://schemas.openxmlformats.org/drawingml/2006/main" xmlns:r="http://schemas.openxmlformats.org/officeDocument/2006/relationships" xmlns:p="http://schemas.openxmlformats.org/presentationml/2006/main">
-  <p:cSld name="Slide 5">
+  <p:cSld name="Slide 4">
     <p:bg>
       <p:bgPr>
         <a:solidFill>
@@ -9657,6 +8485,1178 @@
                 <a:cs typeface="Arial" pitchFamily="34" charset="-120"/>
               </a:rPr>
               <a:t>Customers whose first loan was by Jun 2025. Synthetic data: repeat timing is very regular (100–185 days), so read sizes as indicative.</a:t>
+            </a:r>
+            <a:endParaRPr lang="en-US" sz="1000" dirty="0"/>
+          </a:p>
+        </p:txBody>
+      </p:sp>
+    </p:spTree>
+  </p:cSld>
+  <p:clrMapOvr>
+    <a:masterClrMapping/>
+  </p:clrMapOvr>
+</p:sld>
+</file>
+
+<file path=ppt/slides/slide5.xml><?xml version="1.0" encoding="utf-8"?>
+<p:sld xmlns:a="http://schemas.openxmlformats.org/drawingml/2006/main" xmlns:r="http://schemas.openxmlformats.org/officeDocument/2006/relationships" xmlns:p="http://schemas.openxmlformats.org/presentationml/2006/main">
+  <p:cSld name="Slide 5">
+    <p:bg>
+      <p:bgPr>
+        <a:solidFill>
+          <a:srgbClr val="FFFFFF"/>
+        </a:solidFill>
+      </p:bgPr>
+    </p:bg>
+    <p:spTree>
+      <p:nvGrpSpPr>
+        <p:cNvPr id="1" name=""/>
+        <p:cNvGrpSpPr/>
+        <p:nvPr/>
+      </p:nvGrpSpPr>
+      <p:grpSpPr>
+        <a:xfrm>
+          <a:off x="0" y="0"/>
+          <a:ext cx="0" cy="0"/>
+          <a:chOff x="0" y="0"/>
+          <a:chExt cx="0" cy="0"/>
+        </a:xfrm>
+      </p:grpSpPr>
+      <p:sp>
+        <p:nvSpPr>
+          <p:cNvPr id="2" name="Text 0"/>
+          <p:cNvSpPr txBox="1"/>
+          <p:nvPr/>
+        </p:nvSpPr>
+        <p:spPr>
+          <a:xfrm>
+            <a:off x="548640" y="164592"/>
+            <a:ext cx="7315200" cy="274320"/>
+          </a:xfrm>
+          <a:prstGeom prst="rect">
+            <a:avLst/>
+          </a:prstGeom>
+          <a:noFill/>
+          <a:ln/>
+        </p:spPr>
+        <p:txBody>
+          <a:bodyPr wrap="square" lIns="0" tIns="0" rIns="0" bIns="0" rtlCol="0" anchor="ctr"/>
+          <a:lstStyle/>
+          <a:p>
+            <a:pPr indent="0" marL="0">
+              <a:buNone/>
+            </a:pPr>
+            <a:r>
+              <a:rPr lang="en-US" sz="1100" b="1" spc="200" kern="0" dirty="0">
+                <a:solidFill>
+                  <a:srgbClr val="4A4AF4"/>
+                </a:solidFill>
+                <a:latin typeface="Arial" pitchFamily="34" charset="0"/>
+                <a:ea typeface="Arial" pitchFamily="34" charset="-122"/>
+                <a:cs typeface="Arial" pitchFamily="34" charset="-120"/>
+              </a:rPr>
+              <a:t>INVESTMENT PLAN</a:t>
+            </a:r>
+            <a:endParaRPr lang="en-US" sz="1100" dirty="0"/>
+          </a:p>
+        </p:txBody>
+      </p:sp>
+      <p:sp>
+        <p:nvSpPr>
+          <p:cNvPr id="3" name="Text 1"/>
+          <p:cNvSpPr txBox="1"/>
+          <p:nvPr/>
+        </p:nvSpPr>
+        <p:spPr>
+          <a:xfrm>
+            <a:off x="548640" y="411480"/>
+            <a:ext cx="11094415" cy="868680"/>
+          </a:xfrm>
+          <a:prstGeom prst="rect">
+            <a:avLst/>
+          </a:prstGeom>
+          <a:noFill/>
+          <a:ln/>
+        </p:spPr>
+        <p:txBody>
+          <a:bodyPr wrap="square" lIns="0" tIns="0" rIns="0" bIns="0" rtlCol="0" anchor="t"/>
+          <a:lstStyle/>
+          <a:p>
+            <a:pPr indent="0" marL="0">
+              <a:buNone/>
+            </a:pPr>
+            <a:r>
+              <a:rPr lang="en-US" sz="2600" b="1" dirty="0">
+                <a:solidFill>
+                  <a:srgbClr val="1A1A2E"/>
+                </a:solidFill>
+                <a:latin typeface="Arial" pitchFamily="34" charset="0"/>
+                <a:ea typeface="Arial" pitchFamily="34" charset="-122"/>
+                <a:cs typeface="Arial" pitchFamily="34" charset="-120"/>
+              </a:rPr>
+              <a:t>Shift growth to where losses are low and customers come back</a:t>
+            </a:r>
+            <a:endParaRPr lang="en-US" sz="2600" dirty="0"/>
+          </a:p>
+        </p:txBody>
+      </p:sp>
+      <p:sp>
+        <p:nvSpPr>
+          <p:cNvPr id="4" name="Shape 2"/>
+          <p:cNvSpPr/>
+          <p:nvPr/>
+        </p:nvSpPr>
+        <p:spPr>
+          <a:xfrm>
+            <a:off x="548640" y="1417320"/>
+            <a:ext cx="6949440" cy="1051560"/>
+          </a:xfrm>
+          <a:prstGeom prst="roundRect">
+            <a:avLst>
+              <a:gd name="adj" fmla="val 10435"/>
+            </a:avLst>
+          </a:prstGeom>
+          <a:solidFill>
+            <a:srgbClr val="F6F6FE"/>
+          </a:solidFill>
+          <a:ln w="12700">
+            <a:solidFill>
+              <a:srgbClr val="F6F6FE"/>
+            </a:solidFill>
+            <a:prstDash val="solid"/>
+          </a:ln>
+        </p:spPr>
+      </p:sp>
+      <p:sp>
+        <p:nvSpPr>
+          <p:cNvPr id="5" name="Shape 3"/>
+          <p:cNvSpPr/>
+          <p:nvPr/>
+        </p:nvSpPr>
+        <p:spPr>
+          <a:xfrm>
+            <a:off x="777240" y="1600200"/>
+            <a:ext cx="1188720" cy="274320"/>
+          </a:xfrm>
+          <a:prstGeom prst="roundRect">
+            <a:avLst>
+              <a:gd name="adj" fmla="val 50000"/>
+            </a:avLst>
+          </a:prstGeom>
+          <a:solidFill>
+            <a:srgbClr val="1E8A4C"/>
+          </a:solidFill>
+          <a:ln w="12700">
+            <a:solidFill>
+              <a:srgbClr val="1E8A4C"/>
+            </a:solidFill>
+            <a:prstDash val="solid"/>
+          </a:ln>
+        </p:spPr>
+      </p:sp>
+      <p:sp>
+        <p:nvSpPr>
+          <p:cNvPr id="6" name="Text 4"/>
+          <p:cNvSpPr txBox="1"/>
+          <p:nvPr/>
+        </p:nvSpPr>
+        <p:spPr>
+          <a:xfrm>
+            <a:off x="777240" y="1600200"/>
+            <a:ext cx="1188720" cy="274320"/>
+          </a:xfrm>
+          <a:prstGeom prst="rect">
+            <a:avLst/>
+          </a:prstGeom>
+          <a:noFill/>
+          <a:ln/>
+        </p:spPr>
+        <p:txBody>
+          <a:bodyPr wrap="square" lIns="0" tIns="0" rIns="0" bIns="0" rtlCol="0" anchor="ctr"/>
+          <a:lstStyle/>
+          <a:p>
+            <a:pPr algn="ctr" indent="0" marL="0">
+              <a:buNone/>
+            </a:pPr>
+            <a:r>
+              <a:rPr lang="en-US" sz="1000" b="1" dirty="0">
+                <a:solidFill>
+                  <a:srgbClr val="FFFFFF"/>
+                </a:solidFill>
+                <a:latin typeface="Arial" pitchFamily="34" charset="0"/>
+                <a:ea typeface="Arial" pitchFamily="34" charset="-122"/>
+                <a:cs typeface="Arial" pitchFamily="34" charset="-120"/>
+              </a:rPr>
+              <a:t>INVEST</a:t>
+            </a:r>
+            <a:endParaRPr lang="en-US" sz="1000" dirty="0"/>
+          </a:p>
+        </p:txBody>
+      </p:sp>
+      <p:sp>
+        <p:nvSpPr>
+          <p:cNvPr id="7" name="Text 5"/>
+          <p:cNvSpPr txBox="1"/>
+          <p:nvPr/>
+        </p:nvSpPr>
+        <p:spPr>
+          <a:xfrm>
+            <a:off x="2148840" y="1536192"/>
+            <a:ext cx="5212080" cy="365760"/>
+          </a:xfrm>
+          <a:prstGeom prst="rect">
+            <a:avLst/>
+          </a:prstGeom>
+          <a:noFill/>
+          <a:ln/>
+        </p:spPr>
+        <p:txBody>
+          <a:bodyPr wrap="square" lIns="0" tIns="0" rIns="0" bIns="0" rtlCol="0" anchor="ctr"/>
+          <a:lstStyle/>
+          <a:p>
+            <a:pPr indent="0" marL="0">
+              <a:buNone/>
+            </a:pPr>
+            <a:r>
+              <a:rPr lang="en-US" sz="1500" b="1" dirty="0">
+                <a:solidFill>
+                  <a:srgbClr val="1A1A2E"/>
+                </a:solidFill>
+                <a:latin typeface="Arial" pitchFamily="34" charset="0"/>
+                <a:ea typeface="Arial" pitchFamily="34" charset="-122"/>
+                <a:cs typeface="Arial" pitchFamily="34" charset="-120"/>
+              </a:rPr>
+              <a:t>Merchant acquisition: healthcare &amp; home furnishing</a:t>
+            </a:r>
+            <a:endParaRPr lang="en-US" sz="1500" dirty="0"/>
+          </a:p>
+        </p:txBody>
+      </p:sp>
+      <p:sp>
+        <p:nvSpPr>
+          <p:cNvPr id="8" name="Text 6"/>
+          <p:cNvSpPr txBox="1"/>
+          <p:nvPr/>
+        </p:nvSpPr>
+        <p:spPr>
+          <a:xfrm>
+            <a:off x="2148840" y="1892808"/>
+            <a:ext cx="5212080" cy="530352"/>
+          </a:xfrm>
+          <a:prstGeom prst="rect">
+            <a:avLst/>
+          </a:prstGeom>
+          <a:noFill/>
+          <a:ln/>
+        </p:spPr>
+        <p:txBody>
+          <a:bodyPr wrap="square" lIns="0" tIns="0" rIns="0" bIns="0" rtlCol="0" anchor="t"/>
+          <a:lstStyle/>
+          <a:p>
+            <a:pPr indent="0" marL="0">
+              <a:buNone/>
+            </a:pPr>
+            <a:r>
+              <a:rPr lang="en-US" sz="1200" dirty="0">
+                <a:solidFill>
+                  <a:srgbClr val="5B5B73"/>
+                </a:solidFill>
+                <a:latin typeface="Arial" pitchFamily="34" charset="0"/>
+                <a:ea typeface="Arial" pitchFamily="34" charset="-122"/>
+                <a:cs typeface="Arial" pitchFamily="34" charset="-120"/>
+              </a:rPr>
+              <a:t>Best risk-adjusted margins (9.1%, 7.4%) with low loss. One new merchant ≈ +25–35% vertical GMV.</a:t>
+            </a:r>
+            <a:endParaRPr lang="en-US" sz="1200" dirty="0"/>
+          </a:p>
+        </p:txBody>
+      </p:sp>
+      <p:sp>
+        <p:nvSpPr>
+          <p:cNvPr id="9" name="Shape 7"/>
+          <p:cNvSpPr/>
+          <p:nvPr/>
+        </p:nvSpPr>
+        <p:spPr>
+          <a:xfrm>
+            <a:off x="548640" y="2606040"/>
+            <a:ext cx="6949440" cy="1051560"/>
+          </a:xfrm>
+          <a:prstGeom prst="roundRect">
+            <a:avLst>
+              <a:gd name="adj" fmla="val 10435"/>
+            </a:avLst>
+          </a:prstGeom>
+          <a:solidFill>
+            <a:srgbClr val="F6F6FE"/>
+          </a:solidFill>
+          <a:ln w="12700">
+            <a:solidFill>
+              <a:srgbClr val="F6F6FE"/>
+            </a:solidFill>
+            <a:prstDash val="solid"/>
+          </a:ln>
+        </p:spPr>
+      </p:sp>
+      <p:sp>
+        <p:nvSpPr>
+          <p:cNvPr id="10" name="Shape 8"/>
+          <p:cNvSpPr/>
+          <p:nvPr/>
+        </p:nvSpPr>
+        <p:spPr>
+          <a:xfrm>
+            <a:off x="777240" y="2788920"/>
+            <a:ext cx="1188720" cy="274320"/>
+          </a:xfrm>
+          <a:prstGeom prst="roundRect">
+            <a:avLst>
+              <a:gd name="adj" fmla="val 50000"/>
+            </a:avLst>
+          </a:prstGeom>
+          <a:solidFill>
+            <a:srgbClr val="1E8A4C"/>
+          </a:solidFill>
+          <a:ln w="12700">
+            <a:solidFill>
+              <a:srgbClr val="1E8A4C"/>
+            </a:solidFill>
+            <a:prstDash val="solid"/>
+          </a:ln>
+        </p:spPr>
+      </p:sp>
+      <p:sp>
+        <p:nvSpPr>
+          <p:cNvPr id="11" name="Text 9"/>
+          <p:cNvSpPr txBox="1"/>
+          <p:nvPr/>
+        </p:nvSpPr>
+        <p:spPr>
+          <a:xfrm>
+            <a:off x="777240" y="2788920"/>
+            <a:ext cx="1188720" cy="274320"/>
+          </a:xfrm>
+          <a:prstGeom prst="rect">
+            <a:avLst/>
+          </a:prstGeom>
+          <a:noFill/>
+          <a:ln/>
+        </p:spPr>
+        <p:txBody>
+          <a:bodyPr wrap="square" lIns="0" tIns="0" rIns="0" bIns="0" rtlCol="0" anchor="ctr"/>
+          <a:lstStyle/>
+          <a:p>
+            <a:pPr algn="ctr" indent="0" marL="0">
+              <a:buNone/>
+            </a:pPr>
+            <a:r>
+              <a:rPr lang="en-US" sz="1000" b="1" dirty="0">
+                <a:solidFill>
+                  <a:srgbClr val="FFFFFF"/>
+                </a:solidFill>
+                <a:latin typeface="Arial" pitchFamily="34" charset="0"/>
+                <a:ea typeface="Arial" pitchFamily="34" charset="-122"/>
+                <a:cs typeface="Arial" pitchFamily="34" charset="-120"/>
+              </a:rPr>
+              <a:t>INVEST</a:t>
+            </a:r>
+            <a:endParaRPr lang="en-US" sz="1000" dirty="0"/>
+          </a:p>
+        </p:txBody>
+      </p:sp>
+      <p:sp>
+        <p:nvSpPr>
+          <p:cNvPr id="12" name="Text 10"/>
+          <p:cNvSpPr txBox="1"/>
+          <p:nvPr/>
+        </p:nvSpPr>
+        <p:spPr>
+          <a:xfrm>
+            <a:off x="2148840" y="2724912"/>
+            <a:ext cx="5212080" cy="365760"/>
+          </a:xfrm>
+          <a:prstGeom prst="rect">
+            <a:avLst/>
+          </a:prstGeom>
+          <a:noFill/>
+          <a:ln/>
+        </p:spPr>
+        <p:txBody>
+          <a:bodyPr wrap="square" lIns="0" tIns="0" rIns="0" bIns="0" rtlCol="0" anchor="ctr"/>
+          <a:lstStyle/>
+          <a:p>
+            <a:pPr indent="0" marL="0">
+              <a:buNone/>
+            </a:pPr>
+            <a:r>
+              <a:rPr lang="en-US" sz="1500" b="1" dirty="0">
+                <a:solidFill>
+                  <a:srgbClr val="1A1A2E"/>
+                </a:solidFill>
+                <a:latin typeface="Arial" pitchFamily="34" charset="0"/>
+                <a:ea typeface="Arial" pitchFamily="34" charset="-122"/>
+                <a:cs typeface="Arial" pitchFamily="34" charset="-120"/>
+              </a:rPr>
+              <a:t>Repeat customers</a:t>
+            </a:r>
+            <a:endParaRPr lang="en-US" sz="1500" dirty="0"/>
+          </a:p>
+        </p:txBody>
+      </p:sp>
+      <p:sp>
+        <p:nvSpPr>
+          <p:cNvPr id="13" name="Text 11"/>
+          <p:cNvSpPr txBox="1"/>
+          <p:nvPr/>
+        </p:nvSpPr>
+        <p:spPr>
+          <a:xfrm>
+            <a:off x="2148840" y="3081528"/>
+            <a:ext cx="5212080" cy="530352"/>
+          </a:xfrm>
+          <a:prstGeom prst="rect">
+            <a:avLst/>
+          </a:prstGeom>
+          <a:noFill/>
+          <a:ln/>
+        </p:spPr>
+        <p:txBody>
+          <a:bodyPr wrap="square" lIns="0" tIns="0" rIns="0" bIns="0" rtlCol="0" anchor="t"/>
+          <a:lstStyle/>
+          <a:p>
+            <a:pPr indent="0" marL="0">
+              <a:buNone/>
+            </a:pPr>
+            <a:r>
+              <a:rPr lang="en-US" sz="1200" dirty="0">
+                <a:solidFill>
+                  <a:srgbClr val="5B5B73"/>
+                </a:solidFill>
+                <a:latin typeface="Arial" pitchFamily="34" charset="0"/>
+                <a:ea typeface="Arial" pitchFamily="34" charset="-122"/>
+                <a:cs typeface="Arial" pitchFamily="34" charset="-120"/>
+              </a:rPr>
+              <a:t>Repeat loans lose 2.5× less; 82% of loss comes from first loans. Lift big-ticket repeat rate and steer second loans to interest-bearing.</a:t>
+            </a:r>
+            <a:endParaRPr lang="en-US" sz="1200" dirty="0"/>
+          </a:p>
+        </p:txBody>
+      </p:sp>
+      <p:sp>
+        <p:nvSpPr>
+          <p:cNvPr id="14" name="Shape 12"/>
+          <p:cNvSpPr/>
+          <p:nvPr/>
+        </p:nvSpPr>
+        <p:spPr>
+          <a:xfrm>
+            <a:off x="548640" y="3794760"/>
+            <a:ext cx="6949440" cy="1051560"/>
+          </a:xfrm>
+          <a:prstGeom prst="roundRect">
+            <a:avLst>
+              <a:gd name="adj" fmla="val 10435"/>
+            </a:avLst>
+          </a:prstGeom>
+          <a:solidFill>
+            <a:srgbClr val="F6F6FE"/>
+          </a:solidFill>
+          <a:ln w="12700">
+            <a:solidFill>
+              <a:srgbClr val="F6F6FE"/>
+            </a:solidFill>
+            <a:prstDash val="solid"/>
+          </a:ln>
+        </p:spPr>
+      </p:sp>
+      <p:sp>
+        <p:nvSpPr>
+          <p:cNvPr id="15" name="Shape 13"/>
+          <p:cNvSpPr/>
+          <p:nvPr/>
+        </p:nvSpPr>
+        <p:spPr>
+          <a:xfrm>
+            <a:off x="777240" y="3977640"/>
+            <a:ext cx="1188720" cy="274320"/>
+          </a:xfrm>
+          <a:prstGeom prst="roundRect">
+            <a:avLst>
+              <a:gd name="adj" fmla="val 50000"/>
+            </a:avLst>
+          </a:prstGeom>
+          <a:solidFill>
+            <a:srgbClr val="C93B3B"/>
+          </a:solidFill>
+          <a:ln w="12700">
+            <a:solidFill>
+              <a:srgbClr val="C93B3B"/>
+            </a:solidFill>
+            <a:prstDash val="solid"/>
+          </a:ln>
+        </p:spPr>
+      </p:sp>
+      <p:sp>
+        <p:nvSpPr>
+          <p:cNvPr id="16" name="Text 14"/>
+          <p:cNvSpPr txBox="1"/>
+          <p:nvPr/>
+        </p:nvSpPr>
+        <p:spPr>
+          <a:xfrm>
+            <a:off x="777240" y="3977640"/>
+            <a:ext cx="1188720" cy="274320"/>
+          </a:xfrm>
+          <a:prstGeom prst="rect">
+            <a:avLst/>
+          </a:prstGeom>
+          <a:noFill/>
+          <a:ln/>
+        </p:spPr>
+        <p:txBody>
+          <a:bodyPr wrap="square" lIns="0" tIns="0" rIns="0" bIns="0" rtlCol="0" anchor="ctr"/>
+          <a:lstStyle/>
+          <a:p>
+            <a:pPr algn="ctr" indent="0" marL="0">
+              <a:buNone/>
+            </a:pPr>
+            <a:r>
+              <a:rPr lang="en-US" sz="1000" b="1" dirty="0">
+                <a:solidFill>
+                  <a:srgbClr val="FFFFFF"/>
+                </a:solidFill>
+                <a:latin typeface="Arial" pitchFamily="34" charset="0"/>
+                <a:ea typeface="Arial" pitchFamily="34" charset="-122"/>
+                <a:cs typeface="Arial" pitchFamily="34" charset="-120"/>
+              </a:rPr>
+              <a:t>TIGHTEN</a:t>
+            </a:r>
+            <a:endParaRPr lang="en-US" sz="1000" dirty="0"/>
+          </a:p>
+        </p:txBody>
+      </p:sp>
+      <p:sp>
+        <p:nvSpPr>
+          <p:cNvPr id="17" name="Text 15"/>
+          <p:cNvSpPr txBox="1"/>
+          <p:nvPr/>
+        </p:nvSpPr>
+        <p:spPr>
+          <a:xfrm>
+            <a:off x="2148840" y="3913632"/>
+            <a:ext cx="5212080" cy="365760"/>
+          </a:xfrm>
+          <a:prstGeom prst="rect">
+            <a:avLst/>
+          </a:prstGeom>
+          <a:noFill/>
+          <a:ln/>
+        </p:spPr>
+        <p:txBody>
+          <a:bodyPr wrap="square" lIns="0" tIns="0" rIns="0" bIns="0" rtlCol="0" anchor="ctr"/>
+          <a:lstStyle/>
+          <a:p>
+            <a:pPr indent="0" marL="0">
+              <a:buNone/>
+            </a:pPr>
+            <a:r>
+              <a:rPr lang="en-US" sz="1500" b="1" dirty="0">
+                <a:solidFill>
+                  <a:srgbClr val="1A1A2E"/>
+                </a:solidFill>
+                <a:latin typeface="Arial" pitchFamily="34" charset="0"/>
+                <a:ea typeface="Arial" pitchFamily="34" charset="-122"/>
+                <a:cs typeface="Arial" pitchFamily="34" charset="-120"/>
+              </a:rPr>
+              <a:t>Travel borrowers with FICO &lt; 640</a:t>
+            </a:r>
+            <a:endParaRPr lang="en-US" sz="1500" dirty="0"/>
+          </a:p>
+        </p:txBody>
+      </p:sp>
+      <p:sp>
+        <p:nvSpPr>
+          <p:cNvPr id="18" name="Text 16"/>
+          <p:cNvSpPr txBox="1"/>
+          <p:nvPr/>
+        </p:nvSpPr>
+        <p:spPr>
+          <a:xfrm>
+            <a:off x="2148840" y="4270248"/>
+            <a:ext cx="5212080" cy="530352"/>
+          </a:xfrm>
+          <a:prstGeom prst="rect">
+            <a:avLst/>
+          </a:prstGeom>
+          <a:noFill/>
+          <a:ln/>
+        </p:spPr>
+        <p:txBody>
+          <a:bodyPr wrap="square" lIns="0" tIns="0" rIns="0" bIns="0" rtlCol="0" anchor="t"/>
+          <a:lstStyle/>
+          <a:p>
+            <a:pPr indent="0" marL="0">
+              <a:buNone/>
+            </a:pPr>
+            <a:r>
+              <a:rPr lang="en-US" sz="1200" dirty="0">
+                <a:solidFill>
+                  <a:srgbClr val="5B5B73"/>
+                </a:solidFill>
+                <a:latin typeface="Arial" pitchFamily="34" charset="0"/>
+                <a:ea typeface="Arial" pitchFamily="34" charset="-122"/>
+                <a:cs typeface="Arial" pitchFamily="34" charset="-120"/>
+              </a:rPr>
+              <a:t>~40% delinquent or charged off, 6.3% loss. Raise the risk model cut-off and lower limits: −25% to −50% volume.</a:t>
+            </a:r>
+            <a:endParaRPr lang="en-US" sz="1200" dirty="0"/>
+          </a:p>
+        </p:txBody>
+      </p:sp>
+      <p:sp>
+        <p:nvSpPr>
+          <p:cNvPr id="19" name="Shape 17"/>
+          <p:cNvSpPr/>
+          <p:nvPr/>
+        </p:nvSpPr>
+        <p:spPr>
+          <a:xfrm>
+            <a:off x="548640" y="4983480"/>
+            <a:ext cx="6949440" cy="1051560"/>
+          </a:xfrm>
+          <a:prstGeom prst="roundRect">
+            <a:avLst>
+              <a:gd name="adj" fmla="val 10435"/>
+            </a:avLst>
+          </a:prstGeom>
+          <a:solidFill>
+            <a:srgbClr val="F6F6FE"/>
+          </a:solidFill>
+          <a:ln w="12700">
+            <a:solidFill>
+              <a:srgbClr val="F6F6FE"/>
+            </a:solidFill>
+            <a:prstDash val="solid"/>
+          </a:ln>
+        </p:spPr>
+      </p:sp>
+      <p:sp>
+        <p:nvSpPr>
+          <p:cNvPr id="20" name="Shape 18"/>
+          <p:cNvSpPr/>
+          <p:nvPr/>
+        </p:nvSpPr>
+        <p:spPr>
+          <a:xfrm>
+            <a:off x="777240" y="5166360"/>
+            <a:ext cx="1188720" cy="274320"/>
+          </a:xfrm>
+          <a:prstGeom prst="roundRect">
+            <a:avLst>
+              <a:gd name="adj" fmla="val 50000"/>
+            </a:avLst>
+          </a:prstGeom>
+          <a:solidFill>
+            <a:srgbClr val="4A4AF4"/>
+          </a:solidFill>
+          <a:ln w="12700">
+            <a:solidFill>
+              <a:srgbClr val="4A4AF4"/>
+            </a:solidFill>
+            <a:prstDash val="solid"/>
+          </a:ln>
+        </p:spPr>
+      </p:sp>
+      <p:sp>
+        <p:nvSpPr>
+          <p:cNvPr id="21" name="Text 19"/>
+          <p:cNvSpPr txBox="1"/>
+          <p:nvPr/>
+        </p:nvSpPr>
+        <p:spPr>
+          <a:xfrm>
+            <a:off x="777240" y="5166360"/>
+            <a:ext cx="1188720" cy="274320"/>
+          </a:xfrm>
+          <a:prstGeom prst="rect">
+            <a:avLst/>
+          </a:prstGeom>
+          <a:noFill/>
+          <a:ln/>
+        </p:spPr>
+        <p:txBody>
+          <a:bodyPr wrap="square" lIns="0" tIns="0" rIns="0" bIns="0" rtlCol="0" anchor="ctr"/>
+          <a:lstStyle/>
+          <a:p>
+            <a:pPr algn="ctr" indent="0" marL="0">
+              <a:buNone/>
+            </a:pPr>
+            <a:r>
+              <a:rPr lang="en-US" sz="1000" b="1" dirty="0">
+                <a:solidFill>
+                  <a:srgbClr val="FFFFFF"/>
+                </a:solidFill>
+                <a:latin typeface="Arial" pitchFamily="34" charset="0"/>
+                <a:ea typeface="Arial" pitchFamily="34" charset="-122"/>
+                <a:cs typeface="Arial" pitchFamily="34" charset="-120"/>
+              </a:rPr>
+              <a:t>REPRICE</a:t>
+            </a:r>
+            <a:endParaRPr lang="en-US" sz="1000" dirty="0"/>
+          </a:p>
+        </p:txBody>
+      </p:sp>
+      <p:sp>
+        <p:nvSpPr>
+          <p:cNvPr id="22" name="Text 20"/>
+          <p:cNvSpPr txBox="1"/>
+          <p:nvPr/>
+        </p:nvSpPr>
+        <p:spPr>
+          <a:xfrm>
+            <a:off x="2148840" y="5102352"/>
+            <a:ext cx="5212080" cy="365760"/>
+          </a:xfrm>
+          <a:prstGeom prst="rect">
+            <a:avLst/>
+          </a:prstGeom>
+          <a:noFill/>
+          <a:ln/>
+        </p:spPr>
+        <p:txBody>
+          <a:bodyPr wrap="square" lIns="0" tIns="0" rIns="0" bIns="0" rtlCol="0" anchor="ctr"/>
+          <a:lstStyle/>
+          <a:p>
+            <a:pPr indent="0" marL="0">
+              <a:buNone/>
+            </a:pPr>
+            <a:r>
+              <a:rPr lang="en-US" sz="1500" b="1" dirty="0">
+                <a:solidFill>
+                  <a:srgbClr val="1A1A2E"/>
+                </a:solidFill>
+                <a:latin typeface="Arial" pitchFamily="34" charset="0"/>
+                <a:ea typeface="Arial" pitchFamily="34" charset="-122"/>
+                <a:cs typeface="Arial" pitchFamily="34" charset="-120"/>
+              </a:rPr>
+              <a:t>0% APR merchant fee</a:t>
+            </a:r>
+            <a:endParaRPr lang="en-US" sz="1500" dirty="0"/>
+          </a:p>
+        </p:txBody>
+      </p:sp>
+      <p:sp>
+        <p:nvSpPr>
+          <p:cNvPr id="23" name="Text 21"/>
+          <p:cNvSpPr txBox="1"/>
+          <p:nvPr/>
+        </p:nvSpPr>
+        <p:spPr>
+          <a:xfrm>
+            <a:off x="2148840" y="5458968"/>
+            <a:ext cx="5212080" cy="530352"/>
+          </a:xfrm>
+          <a:prstGeom prst="rect">
+            <a:avLst/>
+          </a:prstGeom>
+          <a:noFill/>
+          <a:ln/>
+        </p:spPr>
+        <p:txBody>
+          <a:bodyPr wrap="square" lIns="0" tIns="0" rIns="0" bIns="0" rtlCol="0" anchor="t"/>
+          <a:lstStyle/>
+          <a:p>
+            <a:pPr indent="0" marL="0">
+              <a:buNone/>
+            </a:pPr>
+            <a:r>
+              <a:rPr lang="en-US" sz="1200" dirty="0">
+                <a:solidFill>
+                  <a:srgbClr val="5B5B73"/>
+                </a:solidFill>
+                <a:latin typeface="Arial" pitchFamily="34" charset="0"/>
+                <a:ea typeface="Arial" pitchFamily="34" charset="-122"/>
+                <a:cs typeface="Arial" pitchFamily="34" charset="-120"/>
+              </a:rPr>
+              <a:t>Fee (5.0%) is below interest-bearing (5.4%) at the same merchants. Raise to at least parity.</a:t>
+            </a:r>
+            <a:endParaRPr lang="en-US" sz="1200" dirty="0"/>
+          </a:p>
+        </p:txBody>
+      </p:sp>
+      <p:sp>
+        <p:nvSpPr>
+          <p:cNvPr id="24" name="Shape 22"/>
+          <p:cNvSpPr/>
+          <p:nvPr/>
+        </p:nvSpPr>
+        <p:spPr>
+          <a:xfrm>
+            <a:off x="7909560" y="1417320"/>
+            <a:ext cx="3733495" cy="4617720"/>
+          </a:xfrm>
+          <a:prstGeom prst="roundRect">
+            <a:avLst>
+              <a:gd name="adj" fmla="val 2939"/>
+            </a:avLst>
+          </a:prstGeom>
+          <a:solidFill>
+            <a:srgbClr val="0F1033"/>
+          </a:solidFill>
+          <a:ln w="12700">
+            <a:solidFill>
+              <a:srgbClr val="0F1033"/>
+            </a:solidFill>
+            <a:prstDash val="solid"/>
+          </a:ln>
+        </p:spPr>
+      </p:sp>
+      <p:sp>
+        <p:nvSpPr>
+          <p:cNvPr id="25" name="Text 23"/>
+          <p:cNvSpPr txBox="1"/>
+          <p:nvPr/>
+        </p:nvSpPr>
+        <p:spPr>
+          <a:xfrm>
+            <a:off x="8229600" y="1645920"/>
+            <a:ext cx="3093415" cy="365760"/>
+          </a:xfrm>
+          <a:prstGeom prst="rect">
+            <a:avLst/>
+          </a:prstGeom>
+          <a:noFill/>
+          <a:ln/>
+        </p:spPr>
+        <p:txBody>
+          <a:bodyPr wrap="square" lIns="0" tIns="0" rIns="0" bIns="0" rtlCol="0" anchor="ctr"/>
+          <a:lstStyle/>
+          <a:p>
+            <a:pPr indent="0" marL="0">
+              <a:buNone/>
+            </a:pPr>
+            <a:r>
+              <a:rPr lang="en-US" sz="1400" b="1" dirty="0">
+                <a:solidFill>
+                  <a:srgbClr val="D9D9FC"/>
+                </a:solidFill>
+                <a:latin typeface="Arial" pitchFamily="34" charset="0"/>
+                <a:ea typeface="Arial" pitchFamily="34" charset="-122"/>
+                <a:cs typeface="Arial" pitchFamily="34" charset="-120"/>
+              </a:rPr>
+              <a:t>One-year impact</a:t>
+            </a:r>
+            <a:endParaRPr lang="en-US" sz="1400" dirty="0"/>
+          </a:p>
+        </p:txBody>
+      </p:sp>
+      <p:sp>
+        <p:nvSpPr>
+          <p:cNvPr id="26" name="Text 24"/>
+          <p:cNvSpPr txBox="1"/>
+          <p:nvPr/>
+        </p:nvSpPr>
+        <p:spPr>
+          <a:xfrm>
+            <a:off x="8229600" y="1965960"/>
+            <a:ext cx="3093415" cy="274320"/>
+          </a:xfrm>
+          <a:prstGeom prst="rect">
+            <a:avLst/>
+          </a:prstGeom>
+          <a:noFill/>
+          <a:ln/>
+        </p:spPr>
+        <p:txBody>
+          <a:bodyPr wrap="square" lIns="0" tIns="0" rIns="0" bIns="0" rtlCol="0" anchor="ctr"/>
+          <a:lstStyle/>
+          <a:p>
+            <a:pPr indent="0" marL="0">
+              <a:buNone/>
+            </a:pPr>
+            <a:r>
+              <a:rPr lang="en-US" sz="1100" dirty="0">
+                <a:solidFill>
+                  <a:srgbClr val="D9D9FC"/>
+                </a:solidFill>
+                <a:latin typeface="Arial" pitchFamily="34" charset="0"/>
+                <a:ea typeface="Arial" pitchFamily="34" charset="-122"/>
+                <a:cs typeface="Arial" pitchFamily="34" charset="-120"/>
+              </a:rPr>
+              <a:t>conservative → ambitious</a:t>
+            </a:r>
+            <a:endParaRPr lang="en-US" sz="1100" dirty="0"/>
+          </a:p>
+        </p:txBody>
+      </p:sp>
+      <p:sp>
+        <p:nvSpPr>
+          <p:cNvPr id="27" name="Text 25"/>
+          <p:cNvSpPr txBox="1"/>
+          <p:nvPr/>
+        </p:nvSpPr>
+        <p:spPr>
+          <a:xfrm>
+            <a:off x="8229600" y="2468880"/>
+            <a:ext cx="3093415" cy="502920"/>
+          </a:xfrm>
+          <a:prstGeom prst="rect">
+            <a:avLst/>
+          </a:prstGeom>
+          <a:noFill/>
+          <a:ln/>
+        </p:spPr>
+        <p:txBody>
+          <a:bodyPr wrap="square" lIns="0" tIns="0" rIns="0" bIns="0" rtlCol="0" anchor="ctr"/>
+          <a:lstStyle/>
+          <a:p>
+            <a:pPr indent="0" marL="0">
+              <a:buNone/>
+            </a:pPr>
+            <a:r>
+              <a:rPr lang="en-US" sz="2600" b="1" dirty="0">
+                <a:solidFill>
+                  <a:srgbClr val="FFFFFF"/>
+                </a:solidFill>
+                <a:latin typeface="Arial" pitchFamily="34" charset="0"/>
+                <a:ea typeface="Arial" pitchFamily="34" charset="-122"/>
+                <a:cs typeface="Arial" pitchFamily="34" charset="-120"/>
+              </a:rPr>
+              <a:t>+7% → +15%</a:t>
+            </a:r>
+            <a:endParaRPr lang="en-US" sz="2600" dirty="0"/>
+          </a:p>
+        </p:txBody>
+      </p:sp>
+      <p:sp>
+        <p:nvSpPr>
+          <p:cNvPr id="28" name="Text 26"/>
+          <p:cNvSpPr txBox="1"/>
+          <p:nvPr/>
+        </p:nvSpPr>
+        <p:spPr>
+          <a:xfrm>
+            <a:off x="8229600" y="2971800"/>
+            <a:ext cx="3093415" cy="320040"/>
+          </a:xfrm>
+          <a:prstGeom prst="rect">
+            <a:avLst/>
+          </a:prstGeom>
+          <a:noFill/>
+          <a:ln/>
+        </p:spPr>
+        <p:txBody>
+          <a:bodyPr wrap="square" lIns="0" tIns="0" rIns="0" bIns="0" rtlCol="0" anchor="ctr"/>
+          <a:lstStyle/>
+          <a:p>
+            <a:pPr indent="0" marL="0">
+              <a:buNone/>
+            </a:pPr>
+            <a:r>
+              <a:rPr lang="en-US" sz="1200" dirty="0">
+                <a:solidFill>
+                  <a:srgbClr val="D9D9FC"/>
+                </a:solidFill>
+                <a:latin typeface="Arial" pitchFamily="34" charset="0"/>
+                <a:ea typeface="Arial" pitchFamily="34" charset="-122"/>
+                <a:cs typeface="Arial" pitchFamily="34" charset="-120"/>
+              </a:rPr>
+              <a:t>profit (contribution)</a:t>
+            </a:r>
+            <a:endParaRPr lang="en-US" sz="1200" dirty="0"/>
+          </a:p>
+        </p:txBody>
+      </p:sp>
+      <p:sp>
+        <p:nvSpPr>
+          <p:cNvPr id="29" name="Text 27"/>
+          <p:cNvSpPr txBox="1"/>
+          <p:nvPr/>
+        </p:nvSpPr>
+        <p:spPr>
+          <a:xfrm>
+            <a:off x="8229600" y="3611880"/>
+            <a:ext cx="3093415" cy="502920"/>
+          </a:xfrm>
+          <a:prstGeom prst="rect">
+            <a:avLst/>
+          </a:prstGeom>
+          <a:noFill/>
+          <a:ln/>
+        </p:spPr>
+        <p:txBody>
+          <a:bodyPr wrap="square" lIns="0" tIns="0" rIns="0" bIns="0" rtlCol="0" anchor="ctr"/>
+          <a:lstStyle/>
+          <a:p>
+            <a:pPr indent="0" marL="0">
+              <a:buNone/>
+            </a:pPr>
+            <a:r>
+              <a:rPr lang="en-US" sz="2600" b="1" dirty="0">
+                <a:solidFill>
+                  <a:srgbClr val="FFFFFF"/>
+                </a:solidFill>
+                <a:latin typeface="Arial" pitchFamily="34" charset="0"/>
+                <a:ea typeface="Arial" pitchFamily="34" charset="-122"/>
+                <a:cs typeface="Arial" pitchFamily="34" charset="-120"/>
+              </a:rPr>
+              <a:t>+4% → +8%</a:t>
+            </a:r>
+            <a:endParaRPr lang="en-US" sz="2600" dirty="0"/>
+          </a:p>
+        </p:txBody>
+      </p:sp>
+      <p:sp>
+        <p:nvSpPr>
+          <p:cNvPr id="30" name="Text 28"/>
+          <p:cNvSpPr txBox="1"/>
+          <p:nvPr/>
+        </p:nvSpPr>
+        <p:spPr>
+          <a:xfrm>
+            <a:off x="8229600" y="4114800"/>
+            <a:ext cx="3093415" cy="320040"/>
+          </a:xfrm>
+          <a:prstGeom prst="rect">
+            <a:avLst/>
+          </a:prstGeom>
+          <a:noFill/>
+          <a:ln/>
+        </p:spPr>
+        <p:txBody>
+          <a:bodyPr wrap="square" lIns="0" tIns="0" rIns="0" bIns="0" rtlCol="0" anchor="ctr"/>
+          <a:lstStyle/>
+          <a:p>
+            <a:pPr indent="0" marL="0">
+              <a:buNone/>
+            </a:pPr>
+            <a:r>
+              <a:rPr lang="en-US" sz="1200" dirty="0">
+                <a:solidFill>
+                  <a:srgbClr val="D9D9FC"/>
+                </a:solidFill>
+                <a:latin typeface="Arial" pitchFamily="34" charset="0"/>
+                <a:ea typeface="Arial" pitchFamily="34" charset="-122"/>
+                <a:cs typeface="Arial" pitchFamily="34" charset="-120"/>
+              </a:rPr>
+              <a:t>GMV</a:t>
+            </a:r>
+            <a:endParaRPr lang="en-US" sz="1200" dirty="0"/>
+          </a:p>
+        </p:txBody>
+      </p:sp>
+      <p:sp>
+        <p:nvSpPr>
+          <p:cNvPr id="31" name="Text 29"/>
+          <p:cNvSpPr txBox="1"/>
+          <p:nvPr/>
+        </p:nvSpPr>
+        <p:spPr>
+          <a:xfrm>
+            <a:off x="8229600" y="4754880"/>
+            <a:ext cx="3093415" cy="502920"/>
+          </a:xfrm>
+          <a:prstGeom prst="rect">
+            <a:avLst/>
+          </a:prstGeom>
+          <a:noFill/>
+          <a:ln/>
+        </p:spPr>
+        <p:txBody>
+          <a:bodyPr wrap="square" lIns="0" tIns="0" rIns="0" bIns="0" rtlCol="0" anchor="ctr"/>
+          <a:lstStyle/>
+          <a:p>
+            <a:pPr indent="0" marL="0">
+              <a:buNone/>
+            </a:pPr>
+            <a:r>
+              <a:rPr lang="en-US" sz="2600" b="1" dirty="0">
+                <a:solidFill>
+                  <a:srgbClr val="FFFFFF"/>
+                </a:solidFill>
+                <a:latin typeface="Arial" pitchFamily="34" charset="0"/>
+                <a:ea typeface="Arial" pitchFamily="34" charset="-122"/>
+                <a:cs typeface="Arial" pitchFamily="34" charset="-120"/>
+              </a:rPr>
+              <a:t>2.32% → 2.1–2.2%</a:t>
+            </a:r>
+            <a:endParaRPr lang="en-US" sz="2600" dirty="0"/>
+          </a:p>
+        </p:txBody>
+      </p:sp>
+      <p:sp>
+        <p:nvSpPr>
+          <p:cNvPr id="32" name="Text 30"/>
+          <p:cNvSpPr txBox="1"/>
+          <p:nvPr/>
+        </p:nvSpPr>
+        <p:spPr>
+          <a:xfrm>
+            <a:off x="8229600" y="5257800"/>
+            <a:ext cx="3093415" cy="320040"/>
+          </a:xfrm>
+          <a:prstGeom prst="rect">
+            <a:avLst/>
+          </a:prstGeom>
+          <a:noFill/>
+          <a:ln/>
+        </p:spPr>
+        <p:txBody>
+          <a:bodyPr wrap="square" lIns="0" tIns="0" rIns="0" bIns="0" rtlCol="0" anchor="ctr"/>
+          <a:lstStyle/>
+          <a:p>
+            <a:pPr indent="0" marL="0">
+              <a:buNone/>
+            </a:pPr>
+            <a:r>
+              <a:rPr lang="en-US" sz="1200" dirty="0">
+                <a:solidFill>
+                  <a:srgbClr val="D9D9FC"/>
+                </a:solidFill>
+                <a:latin typeface="Arial" pitchFamily="34" charset="0"/>
+                <a:ea typeface="Arial" pitchFamily="34" charset="-122"/>
+                <a:cs typeface="Arial" pitchFamily="34" charset="-120"/>
+              </a:rPr>
+              <a:t>credit loss rate</a:t>
+            </a:r>
+            <a:endParaRPr lang="en-US" sz="1200" dirty="0"/>
+          </a:p>
+        </p:txBody>
+      </p:sp>
+      <p:sp>
+        <p:nvSpPr>
+          <p:cNvPr id="33" name="Text 31"/>
+          <p:cNvSpPr txBox="1"/>
+          <p:nvPr/>
+        </p:nvSpPr>
+        <p:spPr>
+          <a:xfrm>
+            <a:off x="548640" y="6355080"/>
+            <a:ext cx="11094415" cy="320040"/>
+          </a:xfrm>
+          <a:prstGeom prst="rect">
+            <a:avLst/>
+          </a:prstGeom>
+          <a:noFill/>
+          <a:ln/>
+        </p:spPr>
+        <p:txBody>
+          <a:bodyPr wrap="square" lIns="0" tIns="0" rIns="0" bIns="0" rtlCol="0" anchor="b"/>
+          <a:lstStyle/>
+          <a:p>
+            <a:pPr indent="0" marL="0">
+              <a:buNone/>
+            </a:pPr>
+            <a:r>
+              <a:rPr lang="en-US" sz="1000" dirty="0">
+                <a:solidFill>
+                  <a:srgbClr val="5B5B73"/>
+                </a:solidFill>
+                <a:latin typeface="Arial" pitchFamily="34" charset="0"/>
+                <a:ea typeface="Arial" pitchFamily="34" charset="-122"/>
+                <a:cs typeface="Arial" pitchFamily="34" charset="-120"/>
+              </a:rPr>
+              <a:t>Impact sized on 2025 volume at seasoned (Jul 2024–Jun 2025) margins and loss rates; 0% APR repricing not included in totals.</a:t>
             </a:r>
             <a:endParaRPr lang="en-US" sz="1000" dirty="0"/>
           </a:p>

</xml_diff>

<commit_message>
Add unit-economics lines to portfolio health chart
Overlay revenue, credit loss and funding cost (% of GMV) on a secondary
axis over quarterly GMV bars, and note that recent quarters are still
accruing.

Co-Authored-By: Claude Opus 5.5 <noreply@anthropic.com>
Claude-Session: https://claude.ai/code/session_01W2UPg5WygeJNMeisH6AsMo
</commit_message>
<xml_diff>
--- a/deck/portfolio_recommendation.pptx
+++ b/deck/portfolio_recommendation.pptx
@@ -142,7 +142,7 @@
                 </a:solidFill>
                 <a:latin typeface="Arial"/>
               </a:rPr>
-              <a:t>GMV by origination quarter ($K)</a:t>
+              <a:t>GMV and unit economics by origination quarter</a:t>
             </a:r>
           </a:p>
         </c:rich>
@@ -166,14 +166,14 @@
               <c:strCache>
                 <c:ptCount val="1"/>
                 <c:pt idx="0">
-                  <c:v>GMV ($K)</c:v>
+                  <c:v>GMV ($K, left axis)</c:v>
                 </c:pt>
               </c:strCache>
             </c:strRef>
           </c:tx>
           <c:spPr>
             <a:solidFill>
-              <a:srgbClr val="4A4AF4"/>
+              <a:srgbClr val="D9D9FC"/>
             </a:solidFill>
             <a:effectLst/>
           </c:spPr>
@@ -185,7 +185,7 @@
               <a:lstStyle/>
               <a:p>
                 <a:pPr>
-                  <a:defRPr b="0" i="0" strike="noStrike" sz="1100" u="none">
+                  <a:defRPr b="0" i="0" strike="noStrike" sz="1000" u="none">
                     <a:solidFill>
                       <a:srgbClr val="1A1A2E"/>
                     </a:solidFill>
@@ -194,6 +194,7 @@
                 </a:pPr>
               </a:p>
             </c:txPr>
+            <c:dLblPos val="inEnd"/>
             <c:showLegendKey val="0"/>
             <c:showVal val="1"/>
             <c:showCatName val="0"/>
@@ -265,7 +266,7 @@
             <a:lstStyle/>
             <a:p>
               <a:pPr>
-                <a:defRPr b="0" i="0" strike="noStrike" sz="1100" u="none">
+                <a:defRPr b="0" i="0" strike="noStrike" sz="1000" u="none">
                   <a:solidFill>
                     <a:srgbClr val="1A1A2E"/>
                   </a:solidFill>
@@ -274,6 +275,7 @@
               </a:pPr>
             </a:p>
           </c:txPr>
+          <c:dLblPos val="inEnd"/>
           <c:showLegendKey val="0"/>
           <c:showVal val="1"/>
           <c:showCatName val="0"/>
@@ -288,6 +290,415 @@
         <c:axId val="2094734552"/>
         <c:axId val="2094734556"/>
       </c:barChart>
+      <c:lineChart>
+        <c:varyColors val="0"/>
+        <c:ser>
+          <c:idx val="1"/>
+          <c:order val="1"/>
+          <c:tx>
+            <c:strRef>
+              <c:f>Sheet1!$C$1</c:f>
+              <c:strCache>
+                <c:ptCount val="1"/>
+                <c:pt idx="0">
+                  <c:v>Revenue (% of GMV)</c:v>
+                </c:pt>
+              </c:strCache>
+            </c:strRef>
+          </c:tx>
+          <c:spPr>
+            <a:solidFill>
+              <a:srgbClr val="4A4AF4"/>
+            </a:solidFill>
+            <a:ln w="31750" cap="flat">
+              <a:solidFill>
+                <a:srgbClr val="4A4AF4"/>
+              </a:solidFill>
+              <a:prstDash val="solid"/>
+              <a:round/>
+            </a:ln>
+            <a:effectLst/>
+          </c:spPr>
+          <c:invertIfNegative val="0"/>
+          <c:dLbls>
+            <c:numFmt formatCode="#,##0" sourceLinked="0"/>
+            <c:txPr>
+              <a:bodyPr/>
+              <a:lstStyle/>
+              <a:p>
+                <a:pPr>
+                  <a:defRPr b="0" i="0" strike="noStrike" sz="1200" u="none">
+                    <a:solidFill>
+                      <a:srgbClr val="000000"/>
+                    </a:solidFill>
+                    <a:latin typeface="Arial"/>
+                  </a:defRPr>
+                </a:pPr>
+              </a:p>
+            </c:txPr>
+            <c:showLegendKey val="0"/>
+            <c:showVal val="0"/>
+            <c:showCatName val="0"/>
+            <c:showSerName val="0"/>
+            <c:showPercent val="0"/>
+            <c:showBubbleSize val="0"/>
+            <c:showLeaderLines val="0"/>
+          </c:dLbls>
+          <c:marker>
+            <c:symbol val="circle"/>
+            <c:size val="7"/>
+            <c:spPr>
+              <a:solidFill>
+                <a:srgbClr val="C93B3B"/>
+              </a:solidFill>
+              <a:ln w="9525" cap="flat">
+                <a:solidFill>
+                  <a:srgbClr val="4A4AF4"/>
+                </a:solidFill>
+                <a:prstDash val="solid"/>
+                <a:round/>
+              </a:ln>
+              <a:effectLst/>
+            </c:spPr>
+          </c:marker>
+          <c:cat>
+            <c:multiLvlStrRef>
+              <c:f>Sheet1!$A$2:$A$7</c:f>
+              <c:multiLvlStrCache>
+                <c:ptCount val="6"/>
+                <c:lvl>
+                  <c:pt idx="0">
+                    <c:v>Q3-24</c:v>
+                  </c:pt>
+                  <c:pt idx="1">
+                    <c:v>Q4-24</c:v>
+                  </c:pt>
+                  <c:pt idx="2">
+                    <c:v>Q1-25</c:v>
+                  </c:pt>
+                  <c:pt idx="3">
+                    <c:v>Q2-25</c:v>
+                  </c:pt>
+                  <c:pt idx="4">
+                    <c:v>Q3-25</c:v>
+                  </c:pt>
+                  <c:pt idx="5">
+                    <c:v>Q4-25</c:v>
+                  </c:pt>
+                </c:lvl>
+              </c:multiLvlStrCache>
+            </c:multiLvlStrRef>
+          </c:cat>
+          <c:val>
+            <c:numRef>
+              <c:f>Sheet1!$C$2:$C$7</c:f>
+              <c:numCache>
+                <c:formatCode>General</c:formatCode>
+                <c:ptCount val="6"/>
+                <c:pt idx="0">
+                  <c:v>10.8</c:v>
+                </c:pt>
+                <c:pt idx="1">
+                  <c:v>11</c:v>
+                </c:pt>
+                <c:pt idx="2">
+                  <c:v>11.3</c:v>
+                </c:pt>
+                <c:pt idx="3">
+                  <c:v>10.7</c:v>
+                </c:pt>
+                <c:pt idx="4">
+                  <c:v>9.7</c:v>
+                </c:pt>
+                <c:pt idx="5">
+                  <c:v>7.5</c:v>
+                </c:pt>
+              </c:numCache>
+            </c:numRef>
+          </c:val>
+          <c:smooth val="0"/>
+        </c:ser>
+        <c:ser>
+          <c:idx val="2"/>
+          <c:order val="2"/>
+          <c:tx>
+            <c:strRef>
+              <c:f>Sheet1!$D$1</c:f>
+              <c:strCache>
+                <c:ptCount val="1"/>
+                <c:pt idx="0">
+                  <c:v>Credit loss (% of GMV)</c:v>
+                </c:pt>
+              </c:strCache>
+            </c:strRef>
+          </c:tx>
+          <c:spPr>
+            <a:solidFill>
+              <a:srgbClr val="C93B3B"/>
+            </a:solidFill>
+            <a:ln w="31750" cap="flat">
+              <a:solidFill>
+                <a:srgbClr val="C93B3B"/>
+              </a:solidFill>
+              <a:prstDash val="solid"/>
+              <a:round/>
+            </a:ln>
+            <a:effectLst/>
+          </c:spPr>
+          <c:invertIfNegative val="0"/>
+          <c:dLbls>
+            <c:numFmt formatCode="#,##0" sourceLinked="0"/>
+            <c:txPr>
+              <a:bodyPr/>
+              <a:lstStyle/>
+              <a:p>
+                <a:pPr>
+                  <a:defRPr b="0" i="0" strike="noStrike" sz="1200" u="none">
+                    <a:solidFill>
+                      <a:srgbClr val="000000"/>
+                    </a:solidFill>
+                    <a:latin typeface="Arial"/>
+                  </a:defRPr>
+                </a:pPr>
+              </a:p>
+            </c:txPr>
+            <c:showLegendKey val="0"/>
+            <c:showVal val="0"/>
+            <c:showCatName val="0"/>
+            <c:showSerName val="0"/>
+            <c:showPercent val="0"/>
+            <c:showBubbleSize val="0"/>
+            <c:showLeaderLines val="0"/>
+          </c:dLbls>
+          <c:marker>
+            <c:symbol val="circle"/>
+            <c:size val="7"/>
+            <c:spPr>
+              <a:solidFill>
+                <a:srgbClr val="5B5B73"/>
+              </a:solidFill>
+              <a:ln w="9525" cap="flat">
+                <a:solidFill>
+                  <a:srgbClr val="C93B3B"/>
+                </a:solidFill>
+                <a:prstDash val="solid"/>
+                <a:round/>
+              </a:ln>
+              <a:effectLst/>
+            </c:spPr>
+          </c:marker>
+          <c:cat>
+            <c:multiLvlStrRef>
+              <c:f>Sheet1!$A$2:$A$7</c:f>
+              <c:multiLvlStrCache>
+                <c:ptCount val="6"/>
+                <c:lvl>
+                  <c:pt idx="0">
+                    <c:v>Q3-24</c:v>
+                  </c:pt>
+                  <c:pt idx="1">
+                    <c:v>Q4-24</c:v>
+                  </c:pt>
+                  <c:pt idx="2">
+                    <c:v>Q1-25</c:v>
+                  </c:pt>
+                  <c:pt idx="3">
+                    <c:v>Q2-25</c:v>
+                  </c:pt>
+                  <c:pt idx="4">
+                    <c:v>Q3-25</c:v>
+                  </c:pt>
+                  <c:pt idx="5">
+                    <c:v>Q4-25</c:v>
+                  </c:pt>
+                </c:lvl>
+              </c:multiLvlStrCache>
+            </c:multiLvlStrRef>
+          </c:cat>
+          <c:val>
+            <c:numRef>
+              <c:f>Sheet1!$D$2:$D$7</c:f>
+              <c:numCache>
+                <c:formatCode>General</c:formatCode>
+                <c:ptCount val="6"/>
+                <c:pt idx="0">
+                  <c:v>1.4</c:v>
+                </c:pt>
+                <c:pt idx="1">
+                  <c:v>2.9</c:v>
+                </c:pt>
+                <c:pt idx="2">
+                  <c:v>2.1</c:v>
+                </c:pt>
+                <c:pt idx="3">
+                  <c:v>2.5</c:v>
+                </c:pt>
+                <c:pt idx="4">
+                  <c:v>2</c:v>
+                </c:pt>
+                <c:pt idx="5">
+                  <c:v>1.2</c:v>
+                </c:pt>
+              </c:numCache>
+            </c:numRef>
+          </c:val>
+          <c:smooth val="0"/>
+        </c:ser>
+        <c:ser>
+          <c:idx val="3"/>
+          <c:order val="3"/>
+          <c:tx>
+            <c:strRef>
+              <c:f>Sheet1!$E$1</c:f>
+              <c:strCache>
+                <c:ptCount val="1"/>
+                <c:pt idx="0">
+                  <c:v>Funding cost (% of GMV)</c:v>
+                </c:pt>
+              </c:strCache>
+            </c:strRef>
+          </c:tx>
+          <c:spPr>
+            <a:solidFill>
+              <a:srgbClr val="5B5B73"/>
+            </a:solidFill>
+            <a:ln w="31750" cap="flat">
+              <a:solidFill>
+                <a:srgbClr val="5B5B73"/>
+              </a:solidFill>
+              <a:prstDash val="solid"/>
+              <a:round/>
+            </a:ln>
+            <a:effectLst/>
+          </c:spPr>
+          <c:invertIfNegative val="0"/>
+          <c:dLbls>
+            <c:numFmt formatCode="#,##0" sourceLinked="0"/>
+            <c:txPr>
+              <a:bodyPr/>
+              <a:lstStyle/>
+              <a:p>
+                <a:pPr>
+                  <a:defRPr b="0" i="0" strike="noStrike" sz="1200" u="none">
+                    <a:solidFill>
+                      <a:srgbClr val="000000"/>
+                    </a:solidFill>
+                    <a:latin typeface="Arial"/>
+                  </a:defRPr>
+                </a:pPr>
+              </a:p>
+            </c:txPr>
+            <c:showLegendKey val="0"/>
+            <c:showVal val="0"/>
+            <c:showCatName val="0"/>
+            <c:showSerName val="0"/>
+            <c:showPercent val="0"/>
+            <c:showBubbleSize val="0"/>
+            <c:showLeaderLines val="0"/>
+          </c:dLbls>
+          <c:marker>
+            <c:symbol val="circle"/>
+            <c:size val="7"/>
+            <c:spPr>
+              <a:solidFill>
+                <a:srgbClr val="C93B3B"/>
+              </a:solidFill>
+              <a:ln w="9525" cap="flat">
+                <a:solidFill>
+                  <a:srgbClr val="5B5B73"/>
+                </a:solidFill>
+                <a:prstDash val="solid"/>
+                <a:round/>
+              </a:ln>
+              <a:effectLst/>
+            </c:spPr>
+          </c:marker>
+          <c:cat>
+            <c:multiLvlStrRef>
+              <c:f>Sheet1!$A$2:$A$7</c:f>
+              <c:multiLvlStrCache>
+                <c:ptCount val="6"/>
+                <c:lvl>
+                  <c:pt idx="0">
+                    <c:v>Q3-24</c:v>
+                  </c:pt>
+                  <c:pt idx="1">
+                    <c:v>Q4-24</c:v>
+                  </c:pt>
+                  <c:pt idx="2">
+                    <c:v>Q1-25</c:v>
+                  </c:pt>
+                  <c:pt idx="3">
+                    <c:v>Q2-25</c:v>
+                  </c:pt>
+                  <c:pt idx="4">
+                    <c:v>Q3-25</c:v>
+                  </c:pt>
+                  <c:pt idx="5">
+                    <c:v>Q4-25</c:v>
+                  </c:pt>
+                </c:lvl>
+              </c:multiLvlStrCache>
+            </c:multiLvlStrRef>
+          </c:cat>
+          <c:val>
+            <c:numRef>
+              <c:f>Sheet1!$E$2:$E$7</c:f>
+              <c:numCache>
+                <c:formatCode>General</c:formatCode>
+                <c:ptCount val="6"/>
+                <c:pt idx="0">
+                  <c:v>1</c:v>
+                </c:pt>
+                <c:pt idx="1">
+                  <c:v>1.1</c:v>
+                </c:pt>
+                <c:pt idx="2">
+                  <c:v>1.1</c:v>
+                </c:pt>
+                <c:pt idx="3">
+                  <c:v>1.1</c:v>
+                </c:pt>
+                <c:pt idx="4">
+                  <c:v>1.1</c:v>
+                </c:pt>
+                <c:pt idx="5">
+                  <c:v>1.1</c:v>
+                </c:pt>
+              </c:numCache>
+            </c:numRef>
+          </c:val>
+          <c:smooth val="0"/>
+        </c:ser>
+        <c:dLbls>
+          <c:numFmt formatCode="#,##0" sourceLinked="0"/>
+          <c:txPr>
+            <a:bodyPr/>
+            <a:lstStyle/>
+            <a:p>
+              <a:pPr>
+                <a:defRPr b="0" i="0" strike="noStrike" sz="1200" u="none">
+                  <a:solidFill>
+                    <a:srgbClr val="000000"/>
+                  </a:solidFill>
+                  <a:latin typeface="Arial"/>
+                </a:defRPr>
+              </a:pPr>
+            </a:p>
+          </c:txPr>
+          <c:showLegendKey val="0"/>
+          <c:showVal val="0"/>
+          <c:showCatName val="0"/>
+          <c:showSerName val="0"/>
+          <c:showPercent val="0"/>
+          <c:showBubbleSize val="0"/>
+          <c:showLeaderLines val="0"/>
+        </c:dLbls>
+        <c:marker val="1"/>
+        <c:axId val="2094734555"/>
+        <c:axId val="2094734553"/>
+        <c:axId val="2094734556"/>
+      </c:lineChart>
       <c:catAx>
         <c:axId val="2094734554"/>
         <c:scaling>
@@ -333,6 +744,8 @@
         <c:axId val="2094734552"/>
         <c:scaling>
           <c:orientation val="minMax"/>
+          <c:max val="900"/>
+          <c:min val="0"/>
         </c:scaling>
         <c:delete val="0"/>
         <c:axPos val="l"/>
@@ -347,6 +760,35 @@
             </a:ln>
           </c:spPr>
         </c:majorGridlines>
+        <c:title>
+          <c:tx>
+            <c:rich>
+              <a:bodyPr/>
+              <a:lstStyle/>
+              <a:p>
+                <a:pPr>
+                  <a:defRPr sz="1000" b="0" i="0" u="none" strike="noStrike">
+                    <a:solidFill>
+                      <a:srgbClr val="5B5B73"/>
+                    </a:solidFill>
+                    <a:latin typeface="Arial"/>
+                  </a:defRPr>
+                </a:pPr>
+                <a:r>
+                  <a:rPr sz="1000" b="0" i="0" u="none" strike="noStrike">
+                    <a:solidFill>
+                      <a:srgbClr val="5B5B73"/>
+                    </a:solidFill>
+                    <a:latin typeface="Arial"/>
+                  </a:rPr>
+                  <a:t>GMV ($K)</a:t>
+                </a:r>
+              </a:p>
+            </c:rich>
+          </c:tx>
+          <c:layout/>
+          <c:overlay val="0"/>
+        </c:title>
         <c:numFmt formatCode="General" sourceLinked="0"/>
         <c:majorTickMark val="out"/>
         <c:minorTickMark val="none"/>
@@ -379,6 +821,117 @@
         <c:crosses val="autoZero"/>
         <c:crossBetween val="between"/>
       </c:valAx>
+      <c:valAx>
+        <c:axId val="2094734553"/>
+        <c:scaling>
+          <c:orientation val="minMax"/>
+          <c:max val="12"/>
+          <c:min val="0"/>
+        </c:scaling>
+        <c:delete val="0"/>
+        <c:axPos val="r"/>
+        <c:title>
+          <c:tx>
+            <c:rich>
+              <a:bodyPr/>
+              <a:lstStyle/>
+              <a:p>
+                <a:pPr>
+                  <a:defRPr sz="1000" b="0" i="0" u="none" strike="noStrike">
+                    <a:solidFill>
+                      <a:srgbClr val="5B5B73"/>
+                    </a:solidFill>
+                    <a:latin typeface="Arial"/>
+                  </a:defRPr>
+                </a:pPr>
+                <a:r>
+                  <a:rPr sz="1000" b="0" i="0" u="none" strike="noStrike">
+                    <a:solidFill>
+                      <a:srgbClr val="5B5B73"/>
+                    </a:solidFill>
+                    <a:latin typeface="Arial"/>
+                  </a:rPr>
+                  <a:t>% of GMV</a:t>
+                </a:r>
+              </a:p>
+            </c:rich>
+          </c:tx>
+          <c:layout/>
+          <c:overlay val="0"/>
+        </c:title>
+        <c:numFmt formatCode="General" sourceLinked="0"/>
+        <c:majorTickMark val="out"/>
+        <c:minorTickMark val="none"/>
+        <c:tickLblPos val="nextTo"/>
+        <c:spPr>
+          <a:ln w="12700" cap="flat">
+            <a:solidFill>
+              <a:srgbClr val="888888"/>
+            </a:solidFill>
+            <a:prstDash val="solid"/>
+            <a:round/>
+          </a:ln>
+        </c:spPr>
+        <c:txPr>
+          <a:bodyPr/>
+          <a:lstStyle/>
+          <a:p>
+            <a:pPr>
+              <a:defRPr sz="1000" b="0" i="0" u="none" strike="noStrike">
+                <a:solidFill>
+                  <a:srgbClr val="5B5B73"/>
+                </a:solidFill>
+                <a:latin typeface="Arial"/>
+              </a:defRPr>
+            </a:pPr>
+            <a:endParaRPr lang="en-US"/>
+          </a:p>
+        </c:txPr>
+        <c:crossAx val="2094734555"/>
+        <c:crosses val="max"/>
+        <c:crossBetween val="between"/>
+      </c:valAx>
+      <c:catAx>
+        <c:axId val="2094734555"/>
+        <c:scaling>
+          <c:orientation val="minMax"/>
+        </c:scaling>
+        <c:delete val="1"/>
+        <c:axPos val="b"/>
+        <c:numFmt formatCode="General" sourceLinked="1"/>
+        <c:majorTickMark val="out"/>
+        <c:minorTickMark val="none"/>
+        <c:tickLblPos val="low"/>
+        <c:spPr>
+          <a:ln w="12700" cap="flat">
+            <a:solidFill>
+              <a:srgbClr val="888888"/>
+            </a:solidFill>
+            <a:prstDash val="solid"/>
+            <a:round/>
+          </a:ln>
+        </c:spPr>
+        <c:txPr>
+          <a:bodyPr/>
+          <a:lstStyle/>
+          <a:p>
+            <a:pPr>
+              <a:defRPr sz="1200" b="0" i="0" u="none" strike="noStrike">
+                <a:solidFill>
+                  <a:srgbClr val="000000"/>
+                </a:solidFill>
+                <a:latin typeface="Arial"/>
+              </a:defRPr>
+            </a:pPr>
+            <a:endParaRPr lang="en-US"/>
+          </a:p>
+        </c:txPr>
+        <c:crossAx val="2094734553"/>
+        <c:crosses val="autoZero"/>
+        <c:auto val="1"/>
+        <c:lblAlgn val="ctr"/>
+        <c:noMultiLvlLbl val="1"/>
+      </c:catAx>
       <c:spPr>
         <a:noFill/>
         <a:ln>
@@ -387,6 +940,26 @@
         <a:effectLst/>
       </c:spPr>
     </c:plotArea>
+    <c:legend>
+      <c:legendPos val="b"/>
+      <c:overlay val="0"/>
+      <c:txPr>
+        <a:bodyPr/>
+        <a:lstStyle/>
+        <a:p>
+          <a:pPr>
+            <a:defRPr sz="1000">
+              <a:solidFill>
+                <a:srgbClr val="1A1A2E"/>
+              </a:solidFill>
+              <a:latin typeface="Arial"/>
+              <a:cs typeface="Arial"/>
+            </a:defRPr>
+          </a:pPr>
+          <a:endParaRPr lang="en-US"/>
+        </a:p>
+      </c:txPr>
+    </c:legend>
     <c:plotVisOnly val="1"/>
     <c:dispBlanksAs val="span"/>
   </c:chart>
@@ -3682,8 +4255,8 @@
           <p:nvPr/>
         </p:nvGraphicFramePr>
         <p:xfrm>
-          <a:off x="548640" y="1371600"/>
-          <a:ext cx="6583680" cy="3840480"/>
+          <a:off x="548640" y="1325880"/>
+          <a:ext cx="6675120" cy="4480560"/>
         </p:xfrm>
         <a:graphic xmlns:a="http://schemas.openxmlformats.org/drawingml/2006/main">
           <a:graphicData uri="http://schemas.openxmlformats.org/drawingml/2006/chart">
@@ -4187,7 +4760,7 @@
                 <a:ea typeface="Arial" pitchFamily="34" charset="-122"/>
                 <a:cs typeface="Arial" pitchFamily="34" charset="-120"/>
               </a:rPr>
-              <a:t>YoY = Jul–Dec 2025 vs Jul–Dec 2024. Funding cost = cost of funds × term × average outstanding balance (½ principal).</a:t>
+              <a:t>YoY = Jul–Dec 2025 vs Jul–Dec 2024. Q3–Q4 2025 loans are young, so their revenue and loss are still accruing. Funding = cost of funds × term × ½ principal.</a:t>
             </a:r>
             <a:endParaRPr lang="en-US" sz="1000" dirty="0"/>
           </a:p>

</xml_diff>

<commit_message>
Add share of loans column to vertical table in deck
Co-Authored-By: Claude Opus 5.5 <noreply@anthropic.com>
Claude-Session: https://claude.ai/code/session_01W2UPg5WygeJNMeisH6AsMo
</commit_message>
<xml_diff>
--- a/deck/portfolio_recommendation.pptx
+++ b/deck/portfolio_recommendation.pptx
@@ -601,7 +601,7 @@
             <c:size val="7"/>
             <c:spPr>
               <a:solidFill>
-                <a:srgbClr val="C93B3B"/>
+                <a:srgbClr val="5B5B73"/>
               </a:solidFill>
               <a:ln w="9525" cap="flat">
                 <a:solidFill>
@@ -4899,12 +4899,13 @@
             <a:tbl>
               <a:tblPr/>
               <a:tblGrid>
-                <a:gridCol w="1737360"/>
+                <a:gridCol w="1600200"/>
+                <a:gridCol w="960120"/>
+                <a:gridCol w="960120"/>
+                <a:gridCol w="868680"/>
+                <a:gridCol w="868680"/>
+                <a:gridCol w="868680"/>
                 <a:gridCol w="1097280"/>
-                <a:gridCol w="1005840"/>
-                <a:gridCol w="1005840"/>
-                <a:gridCol w="1005840"/>
-                <a:gridCol w="1371600"/>
               </a:tblGrid>
               <a:tr h="475488">
                 <a:tc>
@@ -4916,7 +4917,7 @@
                         <a:buNone/>
                       </a:pPr>
                       <a:r>
-                        <a:rPr lang="en-US" sz="1300" b="1" dirty="0">
+                        <a:rPr lang="en-US" sz="1200" b="1" dirty="0">
                           <a:solidFill>
                             <a:srgbClr val="FFFFFF"/>
                           </a:solidFill>
@@ -4926,7 +4927,7 @@
                         </a:rPr>
                         <a:t>Vertical</a:t>
                       </a:r>
-                      <a:endParaRPr lang="en-US" sz="1300" dirty="0">
+                      <a:endParaRPr lang="en-US" sz="1200" dirty="0">
                         <a:latin typeface="Arial" charset="0"/>
                         <a:ea typeface="Arial" charset="0"/>
                         <a:cs typeface="Arial" charset="0"/>
@@ -4984,7 +4985,7 @@
                         <a:buNone/>
                       </a:pPr>
                       <a:r>
-                        <a:rPr lang="en-US" sz="1300" b="1" dirty="0">
+                        <a:rPr lang="en-US" sz="1200" b="1" dirty="0">
                           <a:solidFill>
                             <a:srgbClr val="FFFFFF"/>
                           </a:solidFill>
@@ -4992,9 +4993,9 @@
                           <a:ea typeface="Arial" pitchFamily="34" charset="-122"/>
                           <a:cs typeface="Arial" pitchFamily="34" charset="-120"/>
                         </a:rPr>
-                        <a:t>Share of GMV</a:t>
+                        <a:t>Share of loans</a:t>
                       </a:r>
-                      <a:endParaRPr lang="en-US" sz="1300" dirty="0">
+                      <a:endParaRPr lang="en-US" sz="1200" dirty="0">
                         <a:latin typeface="Arial" charset="0"/>
                         <a:ea typeface="Arial" charset="0"/>
                         <a:cs typeface="Arial" charset="0"/>
@@ -5052,7 +5053,7 @@
                         <a:buNone/>
                       </a:pPr>
                       <a:r>
-                        <a:rPr lang="en-US" sz="1300" b="1" dirty="0">
+                        <a:rPr lang="en-US" sz="1200" b="1" dirty="0">
                           <a:solidFill>
                             <a:srgbClr val="FFFFFF"/>
                           </a:solidFill>
@@ -5060,9 +5061,9 @@
                           <a:ea typeface="Arial" pitchFamily="34" charset="-122"/>
                           <a:cs typeface="Arial" pitchFamily="34" charset="-120"/>
                         </a:rPr>
-                        <a:t>Bad rate</a:t>
+                        <a:t>Share of GMV</a:t>
                       </a:r>
-                      <a:endParaRPr lang="en-US" sz="1300" dirty="0">
+                      <a:endParaRPr lang="en-US" sz="1200" dirty="0">
                         <a:latin typeface="Arial" charset="0"/>
                         <a:ea typeface="Arial" charset="0"/>
                         <a:cs typeface="Arial" charset="0"/>
@@ -5120,7 +5121,7 @@
                         <a:buNone/>
                       </a:pPr>
                       <a:r>
-                        <a:rPr lang="en-US" sz="1300" b="1" dirty="0">
+                        <a:rPr lang="en-US" sz="1200" b="1" dirty="0">
                           <a:solidFill>
                             <a:srgbClr val="FFFFFF"/>
                           </a:solidFill>
@@ -5128,9 +5129,9 @@
                           <a:ea typeface="Arial" pitchFamily="34" charset="-122"/>
                           <a:cs typeface="Arial" pitchFamily="34" charset="-120"/>
                         </a:rPr>
-                        <a:t>Loss rate</a:t>
+                        <a:t>Bad rate</a:t>
                       </a:r>
-                      <a:endParaRPr lang="en-US" sz="1300" dirty="0">
+                      <a:endParaRPr lang="en-US" sz="1200" dirty="0">
                         <a:latin typeface="Arial" charset="0"/>
                         <a:ea typeface="Arial" charset="0"/>
                         <a:cs typeface="Arial" charset="0"/>
@@ -5188,7 +5189,7 @@
                         <a:buNone/>
                       </a:pPr>
                       <a:r>
-                        <a:rPr lang="en-US" sz="1300" b="1" dirty="0">
+                        <a:rPr lang="en-US" sz="1200" b="1" dirty="0">
                           <a:solidFill>
                             <a:srgbClr val="FFFFFF"/>
                           </a:solidFill>
@@ -5196,9 +5197,9 @@
                           <a:ea typeface="Arial" pitchFamily="34" charset="-122"/>
                           <a:cs typeface="Arial" pitchFamily="34" charset="-120"/>
                         </a:rPr>
-                        <a:t>Margin</a:t>
+                        <a:t>Loss rate</a:t>
                       </a:r>
-                      <a:endParaRPr lang="en-US" sz="1300" dirty="0">
+                      <a:endParaRPr lang="en-US" sz="1200" dirty="0">
                         <a:latin typeface="Arial" charset="0"/>
                         <a:ea typeface="Arial" charset="0"/>
                         <a:cs typeface="Arial" charset="0"/>
@@ -5256,7 +5257,75 @@
                         <a:buNone/>
                       </a:pPr>
                       <a:r>
-                        <a:rPr lang="en-US" sz="1300" b="1" dirty="0">
+                        <a:rPr lang="en-US" sz="1200" b="1" dirty="0">
+                          <a:solidFill>
+                            <a:srgbClr val="FFFFFF"/>
+                          </a:solidFill>
+                          <a:latin typeface="Arial" pitchFamily="34" charset="0"/>
+                          <a:ea typeface="Arial" pitchFamily="34" charset="-122"/>
+                          <a:cs typeface="Arial" pitchFamily="34" charset="-120"/>
+                        </a:rPr>
+                        <a:t>Margin</a:t>
+                      </a:r>
+                      <a:endParaRPr lang="en-US" sz="1200" dirty="0">
+                        <a:latin typeface="Arial" charset="0"/>
+                        <a:ea typeface="Arial" charset="0"/>
+                        <a:cs typeface="Arial" charset="0"/>
+                      </a:endParaRPr>
+                    </a:p>
+                  </a:txBody>
+                  <a:tcPr marL="91440" marR="91440" marT="27432" marB="27432" anchor="ctr">
+                    <a:lnL w="6350" cap="flat" cmpd="sng" algn="ctr">
+                      <a:solidFill>
+                        <a:srgbClr val="DADAF0"/>
+                      </a:solidFill>
+                      <a:prstDash val="solid"/>
+                      <a:round/>
+                      <a:headEnd type="none" w="med" len="med"/>
+                      <a:tailEnd type="none" w="med" len="med"/>
+                    </a:lnL>
+                    <a:lnR w="6350" cap="flat" cmpd="sng" algn="ctr">
+                      <a:solidFill>
+                        <a:srgbClr val="DADAF0"/>
+                      </a:solidFill>
+                      <a:prstDash val="solid"/>
+                      <a:round/>
+                      <a:headEnd type="none" w="med" len="med"/>
+                      <a:tailEnd type="none" w="med" len="med"/>
+                    </a:lnR>
+                    <a:lnT w="6350" cap="flat" cmpd="sng" algn="ctr">
+                      <a:solidFill>
+                        <a:srgbClr val="DADAF0"/>
+                      </a:solidFill>
+                      <a:prstDash val="solid"/>
+                      <a:round/>
+                      <a:headEnd type="none" w="med" len="med"/>
+                      <a:tailEnd type="none" w="med" len="med"/>
+                    </a:lnT>
+                    <a:lnB w="6350" cap="flat" cmpd="sng" algn="ctr">
+                      <a:solidFill>
+                        <a:srgbClr val="DADAF0"/>
+                      </a:solidFill>
+                      <a:prstDash val="solid"/>
+                      <a:round/>
+                      <a:headEnd type="none" w="med" len="med"/>
+                      <a:tailEnd type="none" w="med" len="med"/>
+                    </a:lnB>
+                    <a:solidFill>
+                      <a:srgbClr val="0F1033"/>
+                    </a:solidFill>
+                  </a:tcPr>
+                </a:tc>
+                <a:tc>
+                  <a:txBody>
+                    <a:bodyPr/>
+                    <a:lstStyle/>
+                    <a:p>
+                      <a:pPr algn="ctr" indent="0" marL="0">
+                        <a:buNone/>
+                      </a:pPr>
+                      <a:r>
+                        <a:rPr lang="en-US" sz="1200" b="1" dirty="0">
                           <a:solidFill>
                             <a:srgbClr val="FFFFFF"/>
                           </a:solidFill>
@@ -5266,7 +5335,7 @@
                         </a:rPr>
                         <a:t>Share of profit</a:t>
                       </a:r>
-                      <a:endParaRPr lang="en-US" sz="1300" dirty="0">
+                      <a:endParaRPr lang="en-US" sz="1200" dirty="0">
                         <a:latin typeface="Arial" charset="0"/>
                         <a:ea typeface="Arial" charset="0"/>
                         <a:cs typeface="Arial" charset="0"/>
@@ -5326,7 +5395,7 @@
                         <a:buNone/>
                       </a:pPr>
                       <a:r>
-                        <a:rPr lang="en-US" sz="1300" b="1" dirty="0">
+                        <a:rPr lang="en-US" sz="1200" b="1" dirty="0">
                           <a:solidFill>
                             <a:srgbClr val="1A1A2E"/>
                           </a:solidFill>
@@ -5336,7 +5405,7 @@
                         </a:rPr>
                         <a:t>Healthcare</a:t>
                       </a:r>
-                      <a:endParaRPr lang="en-US" sz="1300" dirty="0">
+                      <a:endParaRPr lang="en-US" sz="1200" dirty="0">
                         <a:latin typeface="Arial" charset="0"/>
                         <a:ea typeface="Arial" charset="0"/>
                         <a:cs typeface="Arial" charset="0"/>
@@ -5394,7 +5463,7 @@
                         <a:buNone/>
                       </a:pPr>
                       <a:r>
-                        <a:rPr lang="en-US" sz="1300" dirty="0">
+                        <a:rPr lang="en-US" sz="1200" dirty="0">
                           <a:solidFill>
                             <a:srgbClr val="1A1A2E"/>
                           </a:solidFill>
@@ -5402,9 +5471,9 @@
                           <a:ea typeface="Arial" pitchFamily="34" charset="-122"/>
                           <a:cs typeface="Arial" pitchFamily="34" charset="-120"/>
                         </a:rPr>
-                        <a:t>15%</a:t>
+                        <a:t>5%</a:t>
                       </a:r>
-                      <a:endParaRPr lang="en-US" sz="1300" dirty="0">
+                      <a:endParaRPr lang="en-US" sz="1200" dirty="0">
                         <a:latin typeface="Arial" charset="0"/>
                         <a:ea typeface="Arial" charset="0"/>
                         <a:cs typeface="Arial" charset="0"/>
@@ -5462,7 +5531,7 @@
                         <a:buNone/>
                       </a:pPr>
                       <a:r>
-                        <a:rPr lang="en-US" sz="1300" dirty="0">
+                        <a:rPr lang="en-US" sz="1200" dirty="0">
                           <a:solidFill>
                             <a:srgbClr val="1A1A2E"/>
                           </a:solidFill>
@@ -5470,9 +5539,9 @@
                           <a:ea typeface="Arial" pitchFamily="34" charset="-122"/>
                           <a:cs typeface="Arial" pitchFamily="34" charset="-120"/>
                         </a:rPr>
-                        <a:t>4%</a:t>
+                        <a:t>15%</a:t>
                       </a:r>
-                      <a:endParaRPr lang="en-US" sz="1300" dirty="0">
+                      <a:endParaRPr lang="en-US" sz="1200" dirty="0">
                         <a:latin typeface="Arial" charset="0"/>
                         <a:ea typeface="Arial" charset="0"/>
                         <a:cs typeface="Arial" charset="0"/>
@@ -5530,7 +5599,7 @@
                         <a:buNone/>
                       </a:pPr>
                       <a:r>
-                        <a:rPr lang="en-US" sz="1300" dirty="0">
+                        <a:rPr lang="en-US" sz="1200" dirty="0">
                           <a:solidFill>
                             <a:srgbClr val="1A1A2E"/>
                           </a:solidFill>
@@ -5538,9 +5607,9 @@
                           <a:ea typeface="Arial" pitchFamily="34" charset="-122"/>
                           <a:cs typeface="Arial" pitchFamily="34" charset="-120"/>
                         </a:rPr>
-                        <a:t>1.5%</a:t>
+                        <a:t>4%</a:t>
                       </a:r>
-                      <a:endParaRPr lang="en-US" sz="1300" dirty="0">
+                      <a:endParaRPr lang="en-US" sz="1200" dirty="0">
                         <a:latin typeface="Arial" charset="0"/>
                         <a:ea typeface="Arial" charset="0"/>
                         <a:cs typeface="Arial" charset="0"/>
@@ -5598,17 +5667,17 @@
                         <a:buNone/>
                       </a:pPr>
                       <a:r>
-                        <a:rPr lang="en-US" sz="1300" b="1" dirty="0">
+                        <a:rPr lang="en-US" sz="1200" dirty="0">
                           <a:solidFill>
-                            <a:srgbClr val="1E8A4C"/>
+                            <a:srgbClr val="1A1A2E"/>
                           </a:solidFill>
                           <a:latin typeface="Arial" pitchFamily="34" charset="0"/>
                           <a:ea typeface="Arial" pitchFamily="34" charset="-122"/>
                           <a:cs typeface="Arial" pitchFamily="34" charset="-120"/>
                         </a:rPr>
-                        <a:t>9.1%</a:t>
+                        <a:t>1.5%</a:t>
                       </a:r>
-                      <a:endParaRPr lang="en-US" sz="1300" dirty="0">
+                      <a:endParaRPr lang="en-US" sz="1200" dirty="0">
                         <a:latin typeface="Arial" charset="0"/>
                         <a:ea typeface="Arial" charset="0"/>
                         <a:cs typeface="Arial" charset="0"/>
@@ -5666,7 +5735,75 @@
                         <a:buNone/>
                       </a:pPr>
                       <a:r>
-                        <a:rPr lang="en-US" sz="1300" dirty="0">
+                        <a:rPr lang="en-US" sz="1200" b="1" dirty="0">
+                          <a:solidFill>
+                            <a:srgbClr val="1E8A4C"/>
+                          </a:solidFill>
+                          <a:latin typeface="Arial" pitchFamily="34" charset="0"/>
+                          <a:ea typeface="Arial" pitchFamily="34" charset="-122"/>
+                          <a:cs typeface="Arial" pitchFamily="34" charset="-120"/>
+                        </a:rPr>
+                        <a:t>9.1%</a:t>
+                      </a:r>
+                      <a:endParaRPr lang="en-US" sz="1200" dirty="0">
+                        <a:latin typeface="Arial" charset="0"/>
+                        <a:ea typeface="Arial" charset="0"/>
+                        <a:cs typeface="Arial" charset="0"/>
+                      </a:endParaRPr>
+                    </a:p>
+                  </a:txBody>
+                  <a:tcPr marL="91440" marR="91440" marT="27432" marB="27432" anchor="ctr">
+                    <a:lnL w="6350" cap="flat" cmpd="sng" algn="ctr">
+                      <a:solidFill>
+                        <a:srgbClr val="DADAF0"/>
+                      </a:solidFill>
+                      <a:prstDash val="solid"/>
+                      <a:round/>
+                      <a:headEnd type="none" w="med" len="med"/>
+                      <a:tailEnd type="none" w="med" len="med"/>
+                    </a:lnL>
+                    <a:lnR w="6350" cap="flat" cmpd="sng" algn="ctr">
+                      <a:solidFill>
+                        <a:srgbClr val="DADAF0"/>
+                      </a:solidFill>
+                      <a:prstDash val="solid"/>
+                      <a:round/>
+                      <a:headEnd type="none" w="med" len="med"/>
+                      <a:tailEnd type="none" w="med" len="med"/>
+                    </a:lnR>
+                    <a:lnT w="6350" cap="flat" cmpd="sng" algn="ctr">
+                      <a:solidFill>
+                        <a:srgbClr val="DADAF0"/>
+                      </a:solidFill>
+                      <a:prstDash val="solid"/>
+                      <a:round/>
+                      <a:headEnd type="none" w="med" len="med"/>
+                      <a:tailEnd type="none" w="med" len="med"/>
+                    </a:lnT>
+                    <a:lnB w="6350" cap="flat" cmpd="sng" algn="ctr">
+                      <a:solidFill>
+                        <a:srgbClr val="DADAF0"/>
+                      </a:solidFill>
+                      <a:prstDash val="solid"/>
+                      <a:round/>
+                      <a:headEnd type="none" w="med" len="med"/>
+                      <a:tailEnd type="none" w="med" len="med"/>
+                    </a:lnB>
+                    <a:solidFill>
+                      <a:srgbClr val="FFFFFF"/>
+                    </a:solidFill>
+                  </a:tcPr>
+                </a:tc>
+                <a:tc>
+                  <a:txBody>
+                    <a:bodyPr/>
+                    <a:lstStyle/>
+                    <a:p>
+                      <a:pPr algn="ctr" indent="0" marL="0">
+                        <a:buNone/>
+                      </a:pPr>
+                      <a:r>
+                        <a:rPr lang="en-US" sz="1200" dirty="0">
                           <a:solidFill>
                             <a:srgbClr val="1A1A2E"/>
                           </a:solidFill>
@@ -5676,7 +5813,7 @@
                         </a:rPr>
                         <a:t>20%</a:t>
                       </a:r>
-                      <a:endParaRPr lang="en-US" sz="1300" dirty="0">
+                      <a:endParaRPr lang="en-US" sz="1200" dirty="0">
                         <a:latin typeface="Arial" charset="0"/>
                         <a:ea typeface="Arial" charset="0"/>
                         <a:cs typeface="Arial" charset="0"/>
@@ -5736,7 +5873,7 @@
                         <a:buNone/>
                       </a:pPr>
                       <a:r>
-                        <a:rPr lang="en-US" sz="1300" b="1" dirty="0">
+                        <a:rPr lang="en-US" sz="1200" b="1" dirty="0">
                           <a:solidFill>
                             <a:srgbClr val="1A1A2E"/>
                           </a:solidFill>
@@ -5746,7 +5883,7 @@
                         </a:rPr>
                         <a:t>Travel</a:t>
                       </a:r>
-                      <a:endParaRPr lang="en-US" sz="1300" dirty="0">
+                      <a:endParaRPr lang="en-US" sz="1200" dirty="0">
                         <a:latin typeface="Arial" charset="0"/>
                         <a:ea typeface="Arial" charset="0"/>
                         <a:cs typeface="Arial" charset="0"/>
@@ -5804,7 +5941,7 @@
                         <a:buNone/>
                       </a:pPr>
                       <a:r>
-                        <a:rPr lang="en-US" sz="1300" dirty="0">
+                        <a:rPr lang="en-US" sz="1200" dirty="0">
                           <a:solidFill>
                             <a:srgbClr val="1A1A2E"/>
                           </a:solidFill>
@@ -5812,9 +5949,9 @@
                           <a:ea typeface="Arial" pitchFamily="34" charset="-122"/>
                           <a:cs typeface="Arial" pitchFamily="34" charset="-120"/>
                         </a:rPr>
-                        <a:t>20%</a:t>
+                        <a:t>6%</a:t>
                       </a:r>
-                      <a:endParaRPr lang="en-US" sz="1300" dirty="0">
+                      <a:endParaRPr lang="en-US" sz="1200" dirty="0">
                         <a:latin typeface="Arial" charset="0"/>
                         <a:ea typeface="Arial" charset="0"/>
                         <a:cs typeface="Arial" charset="0"/>
@@ -5872,17 +6009,17 @@
                         <a:buNone/>
                       </a:pPr>
                       <a:r>
-                        <a:rPr lang="en-US" sz="1300" b="1" dirty="0">
+                        <a:rPr lang="en-US" sz="1200" dirty="0">
                           <a:solidFill>
-                            <a:srgbClr val="C93B3B"/>
+                            <a:srgbClr val="1A1A2E"/>
                           </a:solidFill>
                           <a:latin typeface="Arial" pitchFamily="34" charset="0"/>
                           <a:ea typeface="Arial" pitchFamily="34" charset="-122"/>
                           <a:cs typeface="Arial" pitchFamily="34" charset="-120"/>
                         </a:rPr>
-                        <a:t>21%</a:t>
+                        <a:t>20%</a:t>
                       </a:r>
-                      <a:endParaRPr lang="en-US" sz="1300" dirty="0">
+                      <a:endParaRPr lang="en-US" sz="1200" dirty="0">
                         <a:latin typeface="Arial" charset="0"/>
                         <a:ea typeface="Arial" charset="0"/>
                         <a:cs typeface="Arial" charset="0"/>
@@ -5940,7 +6077,7 @@
                         <a:buNone/>
                       </a:pPr>
                       <a:r>
-                        <a:rPr lang="en-US" sz="1300" b="1" dirty="0">
+                        <a:rPr lang="en-US" sz="1200" b="1" dirty="0">
                           <a:solidFill>
                             <a:srgbClr val="C93B3B"/>
                           </a:solidFill>
@@ -5948,9 +6085,9 @@
                           <a:ea typeface="Arial" pitchFamily="34" charset="-122"/>
                           <a:cs typeface="Arial" pitchFamily="34" charset="-120"/>
                         </a:rPr>
-                        <a:t>3.5%</a:t>
+                        <a:t>21%</a:t>
                       </a:r>
-                      <a:endParaRPr lang="en-US" sz="1300" dirty="0">
+                      <a:endParaRPr lang="en-US" sz="1200" dirty="0">
                         <a:latin typeface="Arial" charset="0"/>
                         <a:ea typeface="Arial" charset="0"/>
                         <a:cs typeface="Arial" charset="0"/>
@@ -6008,17 +6145,17 @@
                         <a:buNone/>
                       </a:pPr>
                       <a:r>
-                        <a:rPr lang="en-US" sz="1300" dirty="0">
+                        <a:rPr lang="en-US" sz="1200" b="1" dirty="0">
                           <a:solidFill>
-                            <a:srgbClr val="1A1A2E"/>
+                            <a:srgbClr val="C93B3B"/>
                           </a:solidFill>
                           <a:latin typeface="Arial" pitchFamily="34" charset="0"/>
                           <a:ea typeface="Arial" pitchFamily="34" charset="-122"/>
                           <a:cs typeface="Arial" pitchFamily="34" charset="-120"/>
                         </a:rPr>
-                        <a:t>8.7%</a:t>
+                        <a:t>3.5%</a:t>
                       </a:r>
-                      <a:endParaRPr lang="en-US" sz="1300" dirty="0">
+                      <a:endParaRPr lang="en-US" sz="1200" dirty="0">
                         <a:latin typeface="Arial" charset="0"/>
                         <a:ea typeface="Arial" charset="0"/>
                         <a:cs typeface="Arial" charset="0"/>
@@ -6076,7 +6213,75 @@
                         <a:buNone/>
                       </a:pPr>
                       <a:r>
-                        <a:rPr lang="en-US" sz="1300" dirty="0">
+                        <a:rPr lang="en-US" sz="1200" dirty="0">
+                          <a:solidFill>
+                            <a:srgbClr val="1A1A2E"/>
+                          </a:solidFill>
+                          <a:latin typeface="Arial" pitchFamily="34" charset="0"/>
+                          <a:ea typeface="Arial" pitchFamily="34" charset="-122"/>
+                          <a:cs typeface="Arial" pitchFamily="34" charset="-120"/>
+                        </a:rPr>
+                        <a:t>8.7%</a:t>
+                      </a:r>
+                      <a:endParaRPr lang="en-US" sz="1200" dirty="0">
+                        <a:latin typeface="Arial" charset="0"/>
+                        <a:ea typeface="Arial" charset="0"/>
+                        <a:cs typeface="Arial" charset="0"/>
+                      </a:endParaRPr>
+                    </a:p>
+                  </a:txBody>
+                  <a:tcPr marL="91440" marR="91440" marT="27432" marB="27432" anchor="ctr">
+                    <a:lnL w="6350" cap="flat" cmpd="sng" algn="ctr">
+                      <a:solidFill>
+                        <a:srgbClr val="DADAF0"/>
+                      </a:solidFill>
+                      <a:prstDash val="solid"/>
+                      <a:round/>
+                      <a:headEnd type="none" w="med" len="med"/>
+                      <a:tailEnd type="none" w="med" len="med"/>
+                    </a:lnL>
+                    <a:lnR w="6350" cap="flat" cmpd="sng" algn="ctr">
+                      <a:solidFill>
+                        <a:srgbClr val="DADAF0"/>
+                      </a:solidFill>
+                      <a:prstDash val="solid"/>
+                      <a:round/>
+                      <a:headEnd type="none" w="med" len="med"/>
+                      <a:tailEnd type="none" w="med" len="med"/>
+                    </a:lnR>
+                    <a:lnT w="6350" cap="flat" cmpd="sng" algn="ctr">
+                      <a:solidFill>
+                        <a:srgbClr val="DADAF0"/>
+                      </a:solidFill>
+                      <a:prstDash val="solid"/>
+                      <a:round/>
+                      <a:headEnd type="none" w="med" len="med"/>
+                      <a:tailEnd type="none" w="med" len="med"/>
+                    </a:lnT>
+                    <a:lnB w="6350" cap="flat" cmpd="sng" algn="ctr">
+                      <a:solidFill>
+                        <a:srgbClr val="DADAF0"/>
+                      </a:solidFill>
+                      <a:prstDash val="solid"/>
+                      <a:round/>
+                      <a:headEnd type="none" w="med" len="med"/>
+                      <a:tailEnd type="none" w="med" len="med"/>
+                    </a:lnB>
+                    <a:solidFill>
+                      <a:srgbClr val="F6F6FE"/>
+                    </a:solidFill>
+                  </a:tcPr>
+                </a:tc>
+                <a:tc>
+                  <a:txBody>
+                    <a:bodyPr/>
+                    <a:lstStyle/>
+                    <a:p>
+                      <a:pPr algn="ctr" indent="0" marL="0">
+                        <a:buNone/>
+                      </a:pPr>
+                      <a:r>
+                        <a:rPr lang="en-US" sz="1200" dirty="0">
                           <a:solidFill>
                             <a:srgbClr val="1A1A2E"/>
                           </a:solidFill>
@@ -6086,7 +6291,7 @@
                         </a:rPr>
                         <a:t>24%</a:t>
                       </a:r>
-                      <a:endParaRPr lang="en-US" sz="1300" dirty="0">
+                      <a:endParaRPr lang="en-US" sz="1200" dirty="0">
                         <a:latin typeface="Arial" charset="0"/>
                         <a:ea typeface="Arial" charset="0"/>
                         <a:cs typeface="Arial" charset="0"/>
@@ -6146,7 +6351,7 @@
                         <a:buNone/>
                       </a:pPr>
                       <a:r>
-                        <a:rPr lang="en-US" sz="1300" b="1" dirty="0">
+                        <a:rPr lang="en-US" sz="1200" b="1" dirty="0">
                           <a:solidFill>
                             <a:srgbClr val="1A1A2E"/>
                           </a:solidFill>
@@ -6156,7 +6361,7 @@
                         </a:rPr>
                         <a:t>Fitness</a:t>
                       </a:r>
-                      <a:endParaRPr lang="en-US" sz="1300" dirty="0">
+                      <a:endParaRPr lang="en-US" sz="1200" dirty="0">
                         <a:latin typeface="Arial" charset="0"/>
                         <a:ea typeface="Arial" charset="0"/>
                         <a:cs typeface="Arial" charset="0"/>
@@ -6214,7 +6419,7 @@
                         <a:buNone/>
                       </a:pPr>
                       <a:r>
-                        <a:rPr lang="en-US" sz="1300" dirty="0">
+                        <a:rPr lang="en-US" sz="1200" dirty="0">
                           <a:solidFill>
                             <a:srgbClr val="1A1A2E"/>
                           </a:solidFill>
@@ -6222,9 +6427,9 @@
                           <a:ea typeface="Arial" pitchFamily="34" charset="-122"/>
                           <a:cs typeface="Arial" pitchFamily="34" charset="-120"/>
                         </a:rPr>
-                        <a:t>7%</a:t>
+                        <a:t>8%</a:t>
                       </a:r>
-                      <a:endParaRPr lang="en-US" sz="1300" dirty="0">
+                      <a:endParaRPr lang="en-US" sz="1200" dirty="0">
                         <a:latin typeface="Arial" charset="0"/>
                         <a:ea typeface="Arial" charset="0"/>
                         <a:cs typeface="Arial" charset="0"/>
@@ -6282,7 +6487,7 @@
                         <a:buNone/>
                       </a:pPr>
                       <a:r>
-                        <a:rPr lang="en-US" sz="1300" dirty="0">
+                        <a:rPr lang="en-US" sz="1200" dirty="0">
                           <a:solidFill>
                             <a:srgbClr val="1A1A2E"/>
                           </a:solidFill>
@@ -6290,9 +6495,9 @@
                           <a:ea typeface="Arial" pitchFamily="34" charset="-122"/>
                           <a:cs typeface="Arial" pitchFamily="34" charset="-120"/>
                         </a:rPr>
-                        <a:t>5%</a:t>
+                        <a:t>7%</a:t>
                       </a:r>
-                      <a:endParaRPr lang="en-US" sz="1300" dirty="0">
+                      <a:endParaRPr lang="en-US" sz="1200" dirty="0">
                         <a:latin typeface="Arial" charset="0"/>
                         <a:ea typeface="Arial" charset="0"/>
                         <a:cs typeface="Arial" charset="0"/>
@@ -6350,7 +6555,7 @@
                         <a:buNone/>
                       </a:pPr>
                       <a:r>
-                        <a:rPr lang="en-US" sz="1300" dirty="0">
+                        <a:rPr lang="en-US" sz="1200" dirty="0">
                           <a:solidFill>
                             <a:srgbClr val="1A1A2E"/>
                           </a:solidFill>
@@ -6358,9 +6563,9 @@
                           <a:ea typeface="Arial" pitchFamily="34" charset="-122"/>
                           <a:cs typeface="Arial" pitchFamily="34" charset="-120"/>
                         </a:rPr>
-                        <a:t>1.2%</a:t>
+                        <a:t>5%</a:t>
                       </a:r>
-                      <a:endParaRPr lang="en-US" sz="1300" dirty="0">
+                      <a:endParaRPr lang="en-US" sz="1200" dirty="0">
                         <a:latin typeface="Arial" charset="0"/>
                         <a:ea typeface="Arial" charset="0"/>
                         <a:cs typeface="Arial" charset="0"/>
@@ -6418,7 +6623,7 @@
                         <a:buNone/>
                       </a:pPr>
                       <a:r>
-                        <a:rPr lang="en-US" sz="1300" dirty="0">
+                        <a:rPr lang="en-US" sz="1200" dirty="0">
                           <a:solidFill>
                             <a:srgbClr val="1A1A2E"/>
                           </a:solidFill>
@@ -6426,9 +6631,9 @@
                           <a:ea typeface="Arial" pitchFamily="34" charset="-122"/>
                           <a:cs typeface="Arial" pitchFamily="34" charset="-120"/>
                         </a:rPr>
-                        <a:t>7.4%</a:t>
+                        <a:t>1.2%</a:t>
                       </a:r>
-                      <a:endParaRPr lang="en-US" sz="1300" dirty="0">
+                      <a:endParaRPr lang="en-US" sz="1200" dirty="0">
                         <a:latin typeface="Arial" charset="0"/>
                         <a:ea typeface="Arial" charset="0"/>
                         <a:cs typeface="Arial" charset="0"/>
@@ -6486,7 +6691,75 @@
                         <a:buNone/>
                       </a:pPr>
                       <a:r>
-                        <a:rPr lang="en-US" sz="1300" dirty="0">
+                        <a:rPr lang="en-US" sz="1200" dirty="0">
+                          <a:solidFill>
+                            <a:srgbClr val="1A1A2E"/>
+                          </a:solidFill>
+                          <a:latin typeface="Arial" pitchFamily="34" charset="0"/>
+                          <a:ea typeface="Arial" pitchFamily="34" charset="-122"/>
+                          <a:cs typeface="Arial" pitchFamily="34" charset="-120"/>
+                        </a:rPr>
+                        <a:t>7.4%</a:t>
+                      </a:r>
+                      <a:endParaRPr lang="en-US" sz="1200" dirty="0">
+                        <a:latin typeface="Arial" charset="0"/>
+                        <a:ea typeface="Arial" charset="0"/>
+                        <a:cs typeface="Arial" charset="0"/>
+                      </a:endParaRPr>
+                    </a:p>
+                  </a:txBody>
+                  <a:tcPr marL="91440" marR="91440" marT="27432" marB="27432" anchor="ctr">
+                    <a:lnL w="6350" cap="flat" cmpd="sng" algn="ctr">
+                      <a:solidFill>
+                        <a:srgbClr val="DADAF0"/>
+                      </a:solidFill>
+                      <a:prstDash val="solid"/>
+                      <a:round/>
+                      <a:headEnd type="none" w="med" len="med"/>
+                      <a:tailEnd type="none" w="med" len="med"/>
+                    </a:lnL>
+                    <a:lnR w="6350" cap="flat" cmpd="sng" algn="ctr">
+                      <a:solidFill>
+                        <a:srgbClr val="DADAF0"/>
+                      </a:solidFill>
+                      <a:prstDash val="solid"/>
+                      <a:round/>
+                      <a:headEnd type="none" w="med" len="med"/>
+                      <a:tailEnd type="none" w="med" len="med"/>
+                    </a:lnR>
+                    <a:lnT w="6350" cap="flat" cmpd="sng" algn="ctr">
+                      <a:solidFill>
+                        <a:srgbClr val="DADAF0"/>
+                      </a:solidFill>
+                      <a:prstDash val="solid"/>
+                      <a:round/>
+                      <a:headEnd type="none" w="med" len="med"/>
+                      <a:tailEnd type="none" w="med" len="med"/>
+                    </a:lnT>
+                    <a:lnB w="6350" cap="flat" cmpd="sng" algn="ctr">
+                      <a:solidFill>
+                        <a:srgbClr val="DADAF0"/>
+                      </a:solidFill>
+                      <a:prstDash val="solid"/>
+                      <a:round/>
+                      <a:headEnd type="none" w="med" len="med"/>
+                      <a:tailEnd type="none" w="med" len="med"/>
+                    </a:lnB>
+                    <a:solidFill>
+                      <a:srgbClr val="FFFFFF"/>
+                    </a:solidFill>
+                  </a:tcPr>
+                </a:tc>
+                <a:tc>
+                  <a:txBody>
+                    <a:bodyPr/>
+                    <a:lstStyle/>
+                    <a:p>
+                      <a:pPr algn="ctr" indent="0" marL="0">
+                        <a:buNone/>
+                      </a:pPr>
+                      <a:r>
+                        <a:rPr lang="en-US" sz="1200" dirty="0">
                           <a:solidFill>
                             <a:srgbClr val="1A1A2E"/>
                           </a:solidFill>
@@ -6496,7 +6769,7 @@
                         </a:rPr>
                         <a:t>7%</a:t>
                       </a:r>
-                      <a:endParaRPr lang="en-US" sz="1300" dirty="0">
+                      <a:endParaRPr lang="en-US" sz="1200" dirty="0">
                         <a:latin typeface="Arial" charset="0"/>
                         <a:ea typeface="Arial" charset="0"/>
                         <a:cs typeface="Arial" charset="0"/>
@@ -6556,7 +6829,7 @@
                         <a:buNone/>
                       </a:pPr>
                       <a:r>
-                        <a:rPr lang="en-US" sz="1300" b="1" dirty="0">
+                        <a:rPr lang="en-US" sz="1200" b="1" dirty="0">
                           <a:solidFill>
                             <a:srgbClr val="1A1A2E"/>
                           </a:solidFill>
@@ -6566,7 +6839,7 @@
                         </a:rPr>
                         <a:t>Home furnishing</a:t>
                       </a:r>
-                      <a:endParaRPr lang="en-US" sz="1300" dirty="0">
+                      <a:endParaRPr lang="en-US" sz="1200" dirty="0">
                         <a:latin typeface="Arial" charset="0"/>
                         <a:ea typeface="Arial" charset="0"/>
                         <a:cs typeface="Arial" charset="0"/>
@@ -6624,7 +6897,7 @@
                         <a:buNone/>
                       </a:pPr>
                       <a:r>
-                        <a:rPr lang="en-US" sz="1300" dirty="0">
+                        <a:rPr lang="en-US" sz="1200" dirty="0">
                           <a:solidFill>
                             <a:srgbClr val="1A1A2E"/>
                           </a:solidFill>
@@ -6632,9 +6905,9 @@
                           <a:ea typeface="Arial" pitchFamily="34" charset="-122"/>
                           <a:cs typeface="Arial" pitchFamily="34" charset="-120"/>
                         </a:rPr>
-                        <a:t>14%</a:t>
+                        <a:t>8%</a:t>
                       </a:r>
-                      <a:endParaRPr lang="en-US" sz="1300" dirty="0">
+                      <a:endParaRPr lang="en-US" sz="1200" dirty="0">
                         <a:latin typeface="Arial" charset="0"/>
                         <a:ea typeface="Arial" charset="0"/>
                         <a:cs typeface="Arial" charset="0"/>
@@ -6692,7 +6965,7 @@
                         <a:buNone/>
                       </a:pPr>
                       <a:r>
-                        <a:rPr lang="en-US" sz="1300" dirty="0">
+                        <a:rPr lang="en-US" sz="1200" dirty="0">
                           <a:solidFill>
                             <a:srgbClr val="1A1A2E"/>
                           </a:solidFill>
@@ -6700,9 +6973,9 @@
                           <a:ea typeface="Arial" pitchFamily="34" charset="-122"/>
                           <a:cs typeface="Arial" pitchFamily="34" charset="-120"/>
                         </a:rPr>
-                        <a:t>4%</a:t>
+                        <a:t>14%</a:t>
                       </a:r>
-                      <a:endParaRPr lang="en-US" sz="1300" dirty="0">
+                      <a:endParaRPr lang="en-US" sz="1200" dirty="0">
                         <a:latin typeface="Arial" charset="0"/>
                         <a:ea typeface="Arial" charset="0"/>
                         <a:cs typeface="Arial" charset="0"/>
@@ -6760,17 +7033,17 @@
                         <a:buNone/>
                       </a:pPr>
                       <a:r>
-                        <a:rPr lang="en-US" sz="1300" b="1" dirty="0">
+                        <a:rPr lang="en-US" sz="1200" dirty="0">
                           <a:solidFill>
-                            <a:srgbClr val="1E8A4C"/>
+                            <a:srgbClr val="1A1A2E"/>
                           </a:solidFill>
                           <a:latin typeface="Arial" pitchFamily="34" charset="0"/>
                           <a:ea typeface="Arial" pitchFamily="34" charset="-122"/>
                           <a:cs typeface="Arial" pitchFamily="34" charset="-120"/>
                         </a:rPr>
-                        <a:t>1.2%</a:t>
+                        <a:t>4%</a:t>
                       </a:r>
-                      <a:endParaRPr lang="en-US" sz="1300" dirty="0">
+                      <a:endParaRPr lang="en-US" sz="1200" dirty="0">
                         <a:latin typeface="Arial" charset="0"/>
                         <a:ea typeface="Arial" charset="0"/>
                         <a:cs typeface="Arial" charset="0"/>
@@ -6828,7 +7101,7 @@
                         <a:buNone/>
                       </a:pPr>
                       <a:r>
-                        <a:rPr lang="en-US" sz="1300" b="1" dirty="0">
+                        <a:rPr lang="en-US" sz="1200" b="1" dirty="0">
                           <a:solidFill>
                             <a:srgbClr val="1E8A4C"/>
                           </a:solidFill>
@@ -6836,9 +7109,9 @@
                           <a:ea typeface="Arial" pitchFamily="34" charset="-122"/>
                           <a:cs typeface="Arial" pitchFamily="34" charset="-120"/>
                         </a:rPr>
-                        <a:t>7.4%</a:t>
+                        <a:t>1.2%</a:t>
                       </a:r>
-                      <a:endParaRPr lang="en-US" sz="1300" dirty="0">
+                      <a:endParaRPr lang="en-US" sz="1200" dirty="0">
                         <a:latin typeface="Arial" charset="0"/>
                         <a:ea typeface="Arial" charset="0"/>
                         <a:cs typeface="Arial" charset="0"/>
@@ -6896,7 +7169,75 @@
                         <a:buNone/>
                       </a:pPr>
                       <a:r>
-                        <a:rPr lang="en-US" sz="1300" dirty="0">
+                        <a:rPr lang="en-US" sz="1200" b="1" dirty="0">
+                          <a:solidFill>
+                            <a:srgbClr val="1E8A4C"/>
+                          </a:solidFill>
+                          <a:latin typeface="Arial" pitchFamily="34" charset="0"/>
+                          <a:ea typeface="Arial" pitchFamily="34" charset="-122"/>
+                          <a:cs typeface="Arial" pitchFamily="34" charset="-120"/>
+                        </a:rPr>
+                        <a:t>7.4%</a:t>
+                      </a:r>
+                      <a:endParaRPr lang="en-US" sz="1200" dirty="0">
+                        <a:latin typeface="Arial" charset="0"/>
+                        <a:ea typeface="Arial" charset="0"/>
+                        <a:cs typeface="Arial" charset="0"/>
+                      </a:endParaRPr>
+                    </a:p>
+                  </a:txBody>
+                  <a:tcPr marL="91440" marR="91440" marT="27432" marB="27432" anchor="ctr">
+                    <a:lnL w="6350" cap="flat" cmpd="sng" algn="ctr">
+                      <a:solidFill>
+                        <a:srgbClr val="DADAF0"/>
+                      </a:solidFill>
+                      <a:prstDash val="solid"/>
+                      <a:round/>
+                      <a:headEnd type="none" w="med" len="med"/>
+                      <a:tailEnd type="none" w="med" len="med"/>
+                    </a:lnL>
+                    <a:lnR w="6350" cap="flat" cmpd="sng" algn="ctr">
+                      <a:solidFill>
+                        <a:srgbClr val="DADAF0"/>
+                      </a:solidFill>
+                      <a:prstDash val="solid"/>
+                      <a:round/>
+                      <a:headEnd type="none" w="med" len="med"/>
+                      <a:tailEnd type="none" w="med" len="med"/>
+                    </a:lnR>
+                    <a:lnT w="6350" cap="flat" cmpd="sng" algn="ctr">
+                      <a:solidFill>
+                        <a:srgbClr val="DADAF0"/>
+                      </a:solidFill>
+                      <a:prstDash val="solid"/>
+                      <a:round/>
+                      <a:headEnd type="none" w="med" len="med"/>
+                      <a:tailEnd type="none" w="med" len="med"/>
+                    </a:lnT>
+                    <a:lnB w="6350" cap="flat" cmpd="sng" algn="ctr">
+                      <a:solidFill>
+                        <a:srgbClr val="DADAF0"/>
+                      </a:solidFill>
+                      <a:prstDash val="solid"/>
+                      <a:round/>
+                      <a:headEnd type="none" w="med" len="med"/>
+                      <a:tailEnd type="none" w="med" len="med"/>
+                    </a:lnB>
+                    <a:solidFill>
+                      <a:srgbClr val="F6F6FE"/>
+                    </a:solidFill>
+                  </a:tcPr>
+                </a:tc>
+                <a:tc>
+                  <a:txBody>
+                    <a:bodyPr/>
+                    <a:lstStyle/>
+                    <a:p>
+                      <a:pPr algn="ctr" indent="0" marL="0">
+                        <a:buNone/>
+                      </a:pPr>
+                      <a:r>
+                        <a:rPr lang="en-US" sz="1200" dirty="0">
                           <a:solidFill>
                             <a:srgbClr val="1A1A2E"/>
                           </a:solidFill>
@@ -6906,7 +7247,7 @@
                         </a:rPr>
                         <a:t>15%</a:t>
                       </a:r>
-                      <a:endParaRPr lang="en-US" sz="1300" dirty="0">
+                      <a:endParaRPr lang="en-US" sz="1200" dirty="0">
                         <a:latin typeface="Arial" charset="0"/>
                         <a:ea typeface="Arial" charset="0"/>
                         <a:cs typeface="Arial" charset="0"/>
@@ -6966,7 +7307,7 @@
                         <a:buNone/>
                       </a:pPr>
                       <a:r>
-                        <a:rPr lang="en-US" sz="1300" b="1" dirty="0">
+                        <a:rPr lang="en-US" sz="1200" b="1" dirty="0">
                           <a:solidFill>
                             <a:srgbClr val="1A1A2E"/>
                           </a:solidFill>
@@ -6976,7 +7317,7 @@
                         </a:rPr>
                         <a:t>Electronics</a:t>
                       </a:r>
-                      <a:endParaRPr lang="en-US" sz="1300" dirty="0">
+                      <a:endParaRPr lang="en-US" sz="1200" dirty="0">
                         <a:latin typeface="Arial" charset="0"/>
                         <a:ea typeface="Arial" charset="0"/>
                         <a:cs typeface="Arial" charset="0"/>
@@ -7034,7 +7375,7 @@
                         <a:buNone/>
                       </a:pPr>
                       <a:r>
-                        <a:rPr lang="en-US" sz="1300" dirty="0">
+                        <a:rPr lang="en-US" sz="1200" dirty="0">
                           <a:solidFill>
                             <a:srgbClr val="1A1A2E"/>
                           </a:solidFill>
@@ -7042,9 +7383,9 @@
                           <a:ea typeface="Arial" pitchFamily="34" charset="-122"/>
                           <a:cs typeface="Arial" pitchFamily="34" charset="-120"/>
                         </a:rPr>
-                        <a:t>20%</a:t>
+                        <a:t>16%</a:t>
                       </a:r>
-                      <a:endParaRPr lang="en-US" sz="1300" dirty="0">
+                      <a:endParaRPr lang="en-US" sz="1200" dirty="0">
                         <a:latin typeface="Arial" charset="0"/>
                         <a:ea typeface="Arial" charset="0"/>
                         <a:cs typeface="Arial" charset="0"/>
@@ -7102,7 +7443,7 @@
                         <a:buNone/>
                       </a:pPr>
                       <a:r>
-                        <a:rPr lang="en-US" sz="1300" dirty="0">
+                        <a:rPr lang="en-US" sz="1200" dirty="0">
                           <a:solidFill>
                             <a:srgbClr val="1A1A2E"/>
                           </a:solidFill>
@@ -7110,9 +7451,9 @@
                           <a:ea typeface="Arial" pitchFamily="34" charset="-122"/>
                           <a:cs typeface="Arial" pitchFamily="34" charset="-120"/>
                         </a:rPr>
-                        <a:t>4%</a:t>
+                        <a:t>20%</a:t>
                       </a:r>
-                      <a:endParaRPr lang="en-US" sz="1300" dirty="0">
+                      <a:endParaRPr lang="en-US" sz="1200" dirty="0">
                         <a:latin typeface="Arial" charset="0"/>
                         <a:ea typeface="Arial" charset="0"/>
                         <a:cs typeface="Arial" charset="0"/>
@@ -7170,7 +7511,7 @@
                         <a:buNone/>
                       </a:pPr>
                       <a:r>
-                        <a:rPr lang="en-US" sz="1300" dirty="0">
+                        <a:rPr lang="en-US" sz="1200" dirty="0">
                           <a:solidFill>
                             <a:srgbClr val="1A1A2E"/>
                           </a:solidFill>
@@ -7178,9 +7519,9 @@
                           <a:ea typeface="Arial" pitchFamily="34" charset="-122"/>
                           <a:cs typeface="Arial" pitchFamily="34" charset="-120"/>
                         </a:rPr>
-                        <a:t>1.4%</a:t>
+                        <a:t>4%</a:t>
                       </a:r>
-                      <a:endParaRPr lang="en-US" sz="1300" dirty="0">
+                      <a:endParaRPr lang="en-US" sz="1200" dirty="0">
                         <a:latin typeface="Arial" charset="0"/>
                         <a:ea typeface="Arial" charset="0"/>
                         <a:cs typeface="Arial" charset="0"/>
@@ -7238,7 +7579,7 @@
                         <a:buNone/>
                       </a:pPr>
                       <a:r>
-                        <a:rPr lang="en-US" sz="1300" dirty="0">
+                        <a:rPr lang="en-US" sz="1200" dirty="0">
                           <a:solidFill>
                             <a:srgbClr val="1A1A2E"/>
                           </a:solidFill>
@@ -7246,9 +7587,9 @@
                           <a:ea typeface="Arial" pitchFamily="34" charset="-122"/>
                           <a:cs typeface="Arial" pitchFamily="34" charset="-120"/>
                         </a:rPr>
-                        <a:t>6.4%</a:t>
+                        <a:t>1.4%</a:t>
                       </a:r>
-                      <a:endParaRPr lang="en-US" sz="1300" dirty="0">
+                      <a:endParaRPr lang="en-US" sz="1200" dirty="0">
                         <a:latin typeface="Arial" charset="0"/>
                         <a:ea typeface="Arial" charset="0"/>
                         <a:cs typeface="Arial" charset="0"/>
@@ -7306,7 +7647,75 @@
                         <a:buNone/>
                       </a:pPr>
                       <a:r>
-                        <a:rPr lang="en-US" sz="1300" dirty="0">
+                        <a:rPr lang="en-US" sz="1200" dirty="0">
+                          <a:solidFill>
+                            <a:srgbClr val="1A1A2E"/>
+                          </a:solidFill>
+                          <a:latin typeface="Arial" pitchFamily="34" charset="0"/>
+                          <a:ea typeface="Arial" pitchFamily="34" charset="-122"/>
+                          <a:cs typeface="Arial" pitchFamily="34" charset="-120"/>
+                        </a:rPr>
+                        <a:t>6.4%</a:t>
+                      </a:r>
+                      <a:endParaRPr lang="en-US" sz="1200" dirty="0">
+                        <a:latin typeface="Arial" charset="0"/>
+                        <a:ea typeface="Arial" charset="0"/>
+                        <a:cs typeface="Arial" charset="0"/>
+                      </a:endParaRPr>
+                    </a:p>
+                  </a:txBody>
+                  <a:tcPr marL="91440" marR="91440" marT="27432" marB="27432" anchor="ctr">
+                    <a:lnL w="6350" cap="flat" cmpd="sng" algn="ctr">
+                      <a:solidFill>
+                        <a:srgbClr val="DADAF0"/>
+                      </a:solidFill>
+                      <a:prstDash val="solid"/>
+                      <a:round/>
+                      <a:headEnd type="none" w="med" len="med"/>
+                      <a:tailEnd type="none" w="med" len="med"/>
+                    </a:lnL>
+                    <a:lnR w="6350" cap="flat" cmpd="sng" algn="ctr">
+                      <a:solidFill>
+                        <a:srgbClr val="DADAF0"/>
+                      </a:solidFill>
+                      <a:prstDash val="solid"/>
+                      <a:round/>
+                      <a:headEnd type="none" w="med" len="med"/>
+                      <a:tailEnd type="none" w="med" len="med"/>
+                    </a:lnR>
+                    <a:lnT w="6350" cap="flat" cmpd="sng" algn="ctr">
+                      <a:solidFill>
+                        <a:srgbClr val="DADAF0"/>
+                      </a:solidFill>
+                      <a:prstDash val="solid"/>
+                      <a:round/>
+                      <a:headEnd type="none" w="med" len="med"/>
+                      <a:tailEnd type="none" w="med" len="med"/>
+                    </a:lnT>
+                    <a:lnB w="6350" cap="flat" cmpd="sng" algn="ctr">
+                      <a:solidFill>
+                        <a:srgbClr val="DADAF0"/>
+                      </a:solidFill>
+                      <a:prstDash val="solid"/>
+                      <a:round/>
+                      <a:headEnd type="none" w="med" len="med"/>
+                      <a:tailEnd type="none" w="med" len="med"/>
+                    </a:lnB>
+                    <a:solidFill>
+                      <a:srgbClr val="FFFFFF"/>
+                    </a:solidFill>
+                  </a:tcPr>
+                </a:tc>
+                <a:tc>
+                  <a:txBody>
+                    <a:bodyPr/>
+                    <a:lstStyle/>
+                    <a:p>
+                      <a:pPr algn="ctr" indent="0" marL="0">
+                        <a:buNone/>
+                      </a:pPr>
+                      <a:r>
+                        <a:rPr lang="en-US" sz="1200" dirty="0">
                           <a:solidFill>
                             <a:srgbClr val="1A1A2E"/>
                           </a:solidFill>
@@ -7316,7 +7725,7 @@
                         </a:rPr>
                         <a:t>18%</a:t>
                       </a:r>
-                      <a:endParaRPr lang="en-US" sz="1300" dirty="0">
+                      <a:endParaRPr lang="en-US" sz="1200" dirty="0">
                         <a:latin typeface="Arial" charset="0"/>
                         <a:ea typeface="Arial" charset="0"/>
                         <a:cs typeface="Arial" charset="0"/>
@@ -7376,7 +7785,7 @@
                         <a:buNone/>
                       </a:pPr>
                       <a:r>
-                        <a:rPr lang="en-US" sz="1300" b="1" dirty="0">
+                        <a:rPr lang="en-US" sz="1200" b="1" dirty="0">
                           <a:solidFill>
                             <a:srgbClr val="1A1A2E"/>
                           </a:solidFill>
@@ -7386,7 +7795,7 @@
                         </a:rPr>
                         <a:t>Auto parts</a:t>
                       </a:r>
-                      <a:endParaRPr lang="en-US" sz="1300" dirty="0">
+                      <a:endParaRPr lang="en-US" sz="1200" dirty="0">
                         <a:latin typeface="Arial" charset="0"/>
                         <a:ea typeface="Arial" charset="0"/>
                         <a:cs typeface="Arial" charset="0"/>
@@ -7444,7 +7853,7 @@
                         <a:buNone/>
                       </a:pPr>
                       <a:r>
-                        <a:rPr lang="en-US" sz="1300" dirty="0">
+                        <a:rPr lang="en-US" sz="1200" dirty="0">
                           <a:solidFill>
                             <a:srgbClr val="1A1A2E"/>
                           </a:solidFill>
@@ -7454,7 +7863,7 @@
                         </a:rPr>
                         <a:t>7%</a:t>
                       </a:r>
-                      <a:endParaRPr lang="en-US" sz="1300" dirty="0">
+                      <a:endParaRPr lang="en-US" sz="1200" dirty="0">
                         <a:latin typeface="Arial" charset="0"/>
                         <a:ea typeface="Arial" charset="0"/>
                         <a:cs typeface="Arial" charset="0"/>
@@ -7512,7 +7921,7 @@
                         <a:buNone/>
                       </a:pPr>
                       <a:r>
-                        <a:rPr lang="en-US" sz="1300" dirty="0">
+                        <a:rPr lang="en-US" sz="1200" dirty="0">
                           <a:solidFill>
                             <a:srgbClr val="1A1A2E"/>
                           </a:solidFill>
@@ -7520,9 +7929,9 @@
                           <a:ea typeface="Arial" pitchFamily="34" charset="-122"/>
                           <a:cs typeface="Arial" pitchFamily="34" charset="-120"/>
                         </a:rPr>
-                        <a:t>4%</a:t>
+                        <a:t>7%</a:t>
                       </a:r>
-                      <a:endParaRPr lang="en-US" sz="1300" dirty="0">
+                      <a:endParaRPr lang="en-US" sz="1200" dirty="0">
                         <a:latin typeface="Arial" charset="0"/>
                         <a:ea typeface="Arial" charset="0"/>
                         <a:cs typeface="Arial" charset="0"/>
@@ -7580,7 +7989,7 @@
                         <a:buNone/>
                       </a:pPr>
                       <a:r>
-                        <a:rPr lang="en-US" sz="1300" dirty="0">
+                        <a:rPr lang="en-US" sz="1200" dirty="0">
                           <a:solidFill>
                             <a:srgbClr val="1A1A2E"/>
                           </a:solidFill>
@@ -7588,9 +7997,9 @@
                           <a:ea typeface="Arial" pitchFamily="34" charset="-122"/>
                           <a:cs typeface="Arial" pitchFamily="34" charset="-120"/>
                         </a:rPr>
-                        <a:t>1.9%</a:t>
+                        <a:t>4%</a:t>
                       </a:r>
-                      <a:endParaRPr lang="en-US" sz="1300" dirty="0">
+                      <a:endParaRPr lang="en-US" sz="1200" dirty="0">
                         <a:latin typeface="Arial" charset="0"/>
                         <a:ea typeface="Arial" charset="0"/>
                         <a:cs typeface="Arial" charset="0"/>
@@ -7648,7 +8057,7 @@
                         <a:buNone/>
                       </a:pPr>
                       <a:r>
-                        <a:rPr lang="en-US" sz="1300" dirty="0">
+                        <a:rPr lang="en-US" sz="1200" dirty="0">
                           <a:solidFill>
                             <a:srgbClr val="1A1A2E"/>
                           </a:solidFill>
@@ -7656,9 +8065,9 @@
                           <a:ea typeface="Arial" pitchFamily="34" charset="-122"/>
                           <a:cs typeface="Arial" pitchFamily="34" charset="-120"/>
                         </a:rPr>
-                        <a:t>6.1%</a:t>
+                        <a:t>1.9%</a:t>
                       </a:r>
-                      <a:endParaRPr lang="en-US" sz="1300" dirty="0">
+                      <a:endParaRPr lang="en-US" sz="1200" dirty="0">
                         <a:latin typeface="Arial" charset="0"/>
                         <a:ea typeface="Arial" charset="0"/>
                         <a:cs typeface="Arial" charset="0"/>
@@ -7716,7 +8125,75 @@
                         <a:buNone/>
                       </a:pPr>
                       <a:r>
-                        <a:rPr lang="en-US" sz="1300" dirty="0">
+                        <a:rPr lang="en-US" sz="1200" dirty="0">
+                          <a:solidFill>
+                            <a:srgbClr val="1A1A2E"/>
+                          </a:solidFill>
+                          <a:latin typeface="Arial" pitchFamily="34" charset="0"/>
+                          <a:ea typeface="Arial" pitchFamily="34" charset="-122"/>
+                          <a:cs typeface="Arial" pitchFamily="34" charset="-120"/>
+                        </a:rPr>
+                        <a:t>6.1%</a:t>
+                      </a:r>
+                      <a:endParaRPr lang="en-US" sz="1200" dirty="0">
+                        <a:latin typeface="Arial" charset="0"/>
+                        <a:ea typeface="Arial" charset="0"/>
+                        <a:cs typeface="Arial" charset="0"/>
+                      </a:endParaRPr>
+                    </a:p>
+                  </a:txBody>
+                  <a:tcPr marL="91440" marR="91440" marT="27432" marB="27432" anchor="ctr">
+                    <a:lnL w="6350" cap="flat" cmpd="sng" algn="ctr">
+                      <a:solidFill>
+                        <a:srgbClr val="DADAF0"/>
+                      </a:solidFill>
+                      <a:prstDash val="solid"/>
+                      <a:round/>
+                      <a:headEnd type="none" w="med" len="med"/>
+                      <a:tailEnd type="none" w="med" len="med"/>
+                    </a:lnL>
+                    <a:lnR w="6350" cap="flat" cmpd="sng" algn="ctr">
+                      <a:solidFill>
+                        <a:srgbClr val="DADAF0"/>
+                      </a:solidFill>
+                      <a:prstDash val="solid"/>
+                      <a:round/>
+                      <a:headEnd type="none" w="med" len="med"/>
+                      <a:tailEnd type="none" w="med" len="med"/>
+                    </a:lnR>
+                    <a:lnT w="6350" cap="flat" cmpd="sng" algn="ctr">
+                      <a:solidFill>
+                        <a:srgbClr val="DADAF0"/>
+                      </a:solidFill>
+                      <a:prstDash val="solid"/>
+                      <a:round/>
+                      <a:headEnd type="none" w="med" len="med"/>
+                      <a:tailEnd type="none" w="med" len="med"/>
+                    </a:lnT>
+                    <a:lnB w="6350" cap="flat" cmpd="sng" algn="ctr">
+                      <a:solidFill>
+                        <a:srgbClr val="DADAF0"/>
+                      </a:solidFill>
+                      <a:prstDash val="solid"/>
+                      <a:round/>
+                      <a:headEnd type="none" w="med" len="med"/>
+                      <a:tailEnd type="none" w="med" len="med"/>
+                    </a:lnB>
+                    <a:solidFill>
+                      <a:srgbClr val="F6F6FE"/>
+                    </a:solidFill>
+                  </a:tcPr>
+                </a:tc>
+                <a:tc>
+                  <a:txBody>
+                    <a:bodyPr/>
+                    <a:lstStyle/>
+                    <a:p>
+                      <a:pPr algn="ctr" indent="0" marL="0">
+                        <a:buNone/>
+                      </a:pPr>
+                      <a:r>
+                        <a:rPr lang="en-US" sz="1200" dirty="0">
                           <a:solidFill>
                             <a:srgbClr val="1A1A2E"/>
                           </a:solidFill>
@@ -7726,7 +8203,7 @@
                         </a:rPr>
                         <a:t>6%</a:t>
                       </a:r>
-                      <a:endParaRPr lang="en-US" sz="1300" dirty="0">
+                      <a:endParaRPr lang="en-US" sz="1200" dirty="0">
                         <a:latin typeface="Arial" charset="0"/>
                         <a:ea typeface="Arial" charset="0"/>
                         <a:cs typeface="Arial" charset="0"/>
@@ -7786,7 +8263,7 @@
                         <a:buNone/>
                       </a:pPr>
                       <a:r>
-                        <a:rPr lang="en-US" sz="1300" b="1" dirty="0">
+                        <a:rPr lang="en-US" sz="1200" b="1" dirty="0">
                           <a:solidFill>
                             <a:srgbClr val="1A1A2E"/>
                           </a:solidFill>
@@ -7796,7 +8273,7 @@
                         </a:rPr>
                         <a:t>Fashion</a:t>
                       </a:r>
-                      <a:endParaRPr lang="en-US" sz="1300" dirty="0">
+                      <a:endParaRPr lang="en-US" sz="1200" dirty="0">
                         <a:latin typeface="Arial" charset="0"/>
                         <a:ea typeface="Arial" charset="0"/>
                         <a:cs typeface="Arial" charset="0"/>
@@ -7854,7 +8331,7 @@
                         <a:buNone/>
                       </a:pPr>
                       <a:r>
-                        <a:rPr lang="en-US" sz="1300" dirty="0">
+                        <a:rPr lang="en-US" sz="1200" b="1" dirty="0">
                           <a:solidFill>
                             <a:srgbClr val="1A1A2E"/>
                           </a:solidFill>
@@ -7862,9 +8339,9 @@
                           <a:ea typeface="Arial" pitchFamily="34" charset="-122"/>
                           <a:cs typeface="Arial" pitchFamily="34" charset="-120"/>
                         </a:rPr>
-                        <a:t>18%</a:t>
+                        <a:t>51%</a:t>
                       </a:r>
-                      <a:endParaRPr lang="en-US" sz="1300" dirty="0">
+                      <a:endParaRPr lang="en-US" sz="1200" dirty="0">
                         <a:latin typeface="Arial" charset="0"/>
                         <a:ea typeface="Arial" charset="0"/>
                         <a:cs typeface="Arial" charset="0"/>
@@ -7922,7 +8399,7 @@
                         <a:buNone/>
                       </a:pPr>
                       <a:r>
-                        <a:rPr lang="en-US" sz="1300" dirty="0">
+                        <a:rPr lang="en-US" sz="1200" dirty="0">
                           <a:solidFill>
                             <a:srgbClr val="1A1A2E"/>
                           </a:solidFill>
@@ -7930,9 +8407,9 @@
                           <a:ea typeface="Arial" pitchFamily="34" charset="-122"/>
                           <a:cs typeface="Arial" pitchFamily="34" charset="-120"/>
                         </a:rPr>
-                        <a:t>5%</a:t>
+                        <a:t>18%</a:t>
                       </a:r>
-                      <a:endParaRPr lang="en-US" sz="1300" dirty="0">
+                      <a:endParaRPr lang="en-US" sz="1200" dirty="0">
                         <a:latin typeface="Arial" charset="0"/>
                         <a:ea typeface="Arial" charset="0"/>
                         <a:cs typeface="Arial" charset="0"/>
@@ -7990,17 +8467,17 @@
                         <a:buNone/>
                       </a:pPr>
                       <a:r>
-                        <a:rPr lang="en-US" sz="1300" b="1" dirty="0">
+                        <a:rPr lang="en-US" sz="1200" dirty="0">
                           <a:solidFill>
-                            <a:srgbClr val="C93B3B"/>
+                            <a:srgbClr val="1A1A2E"/>
                           </a:solidFill>
                           <a:latin typeface="Arial" pitchFamily="34" charset="0"/>
                           <a:ea typeface="Arial" pitchFamily="34" charset="-122"/>
                           <a:cs typeface="Arial" pitchFamily="34" charset="-120"/>
                         </a:rPr>
-                        <a:t>2.5%</a:t>
+                        <a:t>5%</a:t>
                       </a:r>
-                      <a:endParaRPr lang="en-US" sz="1300" dirty="0">
+                      <a:endParaRPr lang="en-US" sz="1200" dirty="0">
                         <a:latin typeface="Arial" charset="0"/>
                         <a:ea typeface="Arial" charset="0"/>
                         <a:cs typeface="Arial" charset="0"/>
@@ -8058,7 +8535,7 @@
                         <a:buNone/>
                       </a:pPr>
                       <a:r>
-                        <a:rPr lang="en-US" sz="1300" b="1" dirty="0">
+                        <a:rPr lang="en-US" sz="1200" b="1" dirty="0">
                           <a:solidFill>
                             <a:srgbClr val="C93B3B"/>
                           </a:solidFill>
@@ -8066,9 +8543,9 @@
                           <a:ea typeface="Arial" pitchFamily="34" charset="-122"/>
                           <a:cs typeface="Arial" pitchFamily="34" charset="-120"/>
                         </a:rPr>
-                        <a:t>3.8%</a:t>
+                        <a:t>2.5%</a:t>
                       </a:r>
-                      <a:endParaRPr lang="en-US" sz="1300" dirty="0">
+                      <a:endParaRPr lang="en-US" sz="1200" dirty="0">
                         <a:latin typeface="Arial" charset="0"/>
                         <a:ea typeface="Arial" charset="0"/>
                         <a:cs typeface="Arial" charset="0"/>
@@ -8126,7 +8603,75 @@
                         <a:buNone/>
                       </a:pPr>
                       <a:r>
-                        <a:rPr lang="en-US" sz="1300" dirty="0">
+                        <a:rPr lang="en-US" sz="1200" b="1" dirty="0">
+                          <a:solidFill>
+                            <a:srgbClr val="C93B3B"/>
+                          </a:solidFill>
+                          <a:latin typeface="Arial" pitchFamily="34" charset="0"/>
+                          <a:ea typeface="Arial" pitchFamily="34" charset="-122"/>
+                          <a:cs typeface="Arial" pitchFamily="34" charset="-120"/>
+                        </a:rPr>
+                        <a:t>3.8%</a:t>
+                      </a:r>
+                      <a:endParaRPr lang="en-US" sz="1200" dirty="0">
+                        <a:latin typeface="Arial" charset="0"/>
+                        <a:ea typeface="Arial" charset="0"/>
+                        <a:cs typeface="Arial" charset="0"/>
+                      </a:endParaRPr>
+                    </a:p>
+                  </a:txBody>
+                  <a:tcPr marL="91440" marR="91440" marT="27432" marB="27432" anchor="ctr">
+                    <a:lnL w="6350" cap="flat" cmpd="sng" algn="ctr">
+                      <a:solidFill>
+                        <a:srgbClr val="DADAF0"/>
+                      </a:solidFill>
+                      <a:prstDash val="solid"/>
+                      <a:round/>
+                      <a:headEnd type="none" w="med" len="med"/>
+                      <a:tailEnd type="none" w="med" len="med"/>
+                    </a:lnL>
+                    <a:lnR w="6350" cap="flat" cmpd="sng" algn="ctr">
+                      <a:solidFill>
+                        <a:srgbClr val="DADAF0"/>
+                      </a:solidFill>
+                      <a:prstDash val="solid"/>
+                      <a:round/>
+                      <a:headEnd type="none" w="med" len="med"/>
+                      <a:tailEnd type="none" w="med" len="med"/>
+                    </a:lnR>
+                    <a:lnT w="6350" cap="flat" cmpd="sng" algn="ctr">
+                      <a:solidFill>
+                        <a:srgbClr val="DADAF0"/>
+                      </a:solidFill>
+                      <a:prstDash val="solid"/>
+                      <a:round/>
+                      <a:headEnd type="none" w="med" len="med"/>
+                      <a:tailEnd type="none" w="med" len="med"/>
+                    </a:lnT>
+                    <a:lnB w="6350" cap="flat" cmpd="sng" algn="ctr">
+                      <a:solidFill>
+                        <a:srgbClr val="DADAF0"/>
+                      </a:solidFill>
+                      <a:prstDash val="solid"/>
+                      <a:round/>
+                      <a:headEnd type="none" w="med" len="med"/>
+                      <a:tailEnd type="none" w="med" len="med"/>
+                    </a:lnB>
+                    <a:solidFill>
+                      <a:srgbClr val="FFFFFF"/>
+                    </a:solidFill>
+                  </a:tcPr>
+                </a:tc>
+                <a:tc>
+                  <a:txBody>
+                    <a:bodyPr/>
+                    <a:lstStyle/>
+                    <a:p>
+                      <a:pPr algn="ctr" indent="0" marL="0">
+                        <a:buNone/>
+                      </a:pPr>
+                      <a:r>
+                        <a:rPr lang="en-US" sz="1200" dirty="0">
                           <a:solidFill>
                             <a:srgbClr val="1A1A2E"/>
                           </a:solidFill>
@@ -8136,7 +8681,7 @@
                         </a:rPr>
                         <a:t>10%</a:t>
                       </a:r>
-                      <a:endParaRPr lang="en-US" sz="1300" dirty="0">
+                      <a:endParaRPr lang="en-US" sz="1200" dirty="0">
                         <a:latin typeface="Arial" charset="0"/>
                         <a:ea typeface="Arial" charset="0"/>
                         <a:cs typeface="Arial" charset="0"/>

</xml_diff>

<commit_message>
Add product economics slide to deck
New slide after the vertical view compares interest-bearing, 0% APR and
Split Pay on loss, merchant fee, interest and margin to support the 0%
APR repricing recommendation; vertical slide's product card now covers
healthcare and home furnishing.

Co-Authored-By: Claude Opus 5.5 <noreply@anthropic.com>
Claude-Session: https://claude.ai/code/session_01W2UPg5WygeJNMeisH6AsMo
</commit_message>
<xml_diff>
--- a/deck/portfolio_recommendation.pptx
+++ b/deck/portfolio_recommendation.pptx
@@ -15,9 +15,10 @@
     <p:sldId id="263" r:id="rId9"/>
     <p:sldId id="264" r:id="rId10"/>
     <p:sldId id="265" r:id="rId11"/>
+    <p:sldId id="266" r:id="rId12"/>
   </p:sldIdLst>
   <p:notesMasterIdLst>
-    <p:notesMasterId r:id="rId12"/>
+    <p:notesMasterId r:id="rId13"/>
   </p:notesMasterIdLst>
   <p:sldSz cx="12192000" cy="6858000"/>
   <p:notesSz cx="6858000" cy="12192000"/>
@@ -601,7 +602,7 @@
             <c:size val="7"/>
             <c:spPr>
               <a:solidFill>
-                <a:srgbClr val="5B5B73"/>
+                <a:srgbClr val="C93B3B"/>
               </a:solidFill>
               <a:ln w="9525" cap="flat">
                 <a:solidFill>
@@ -2374,6 +2375,94 @@
 </p:notes>
 </file>
 
+<file path=ppt/notesSlides/notesSlide11.xml><?xml version="1.0" encoding="utf-8"?>
+<p:notes xmlns:a="http://schemas.openxmlformats.org/drawingml/2006/main" xmlns:r="http://schemas.openxmlformats.org/officeDocument/2006/relationships" xmlns:p="http://schemas.openxmlformats.org/presentationml/2006/main">
+  <p:cSld>
+    <p:spTree>
+      <p:nvGrpSpPr>
+        <p:cNvPr id="1" name=""/>
+        <p:cNvGrpSpPr/>
+        <p:nvPr/>
+      </p:nvGrpSpPr>
+      <p:grpSpPr>
+        <a:xfrm>
+          <a:off x="0" y="0"/>
+          <a:ext cx="0" cy="0"/>
+          <a:chOff x="0" y="0"/>
+          <a:chExt cx="0" cy="0"/>
+        </a:xfrm>
+      </p:grpSpPr>
+      <p:sp>
+        <p:nvSpPr>
+          <p:cNvPr id="2" name="Slide Image Placeholder 1"/>
+          <p:cNvSpPr>
+            <a:spLocks noGrp="1" noRot="1" noChangeAspect="1"/>
+          </p:cNvSpPr>
+          <p:nvPr>
+            <p:ph type="sldImg"/>
+          </p:nvPr>
+        </p:nvSpPr>
+        <p:spPr/>
+      </p:sp>
+      <p:sp>
+        <p:nvSpPr>
+          <p:cNvPr id="3" name="Notes Placeholder 2"/>
+          <p:cNvSpPr>
+            <a:spLocks noGrp="1"/>
+          </p:cNvSpPr>
+          <p:nvPr>
+            <p:ph type="body" idx="1"/>
+          </p:nvPr>
+        </p:nvSpPr>
+        <p:spPr/>
+        <p:txBody>
+          <a:bodyPr/>
+          <a:lstStyle/>
+          <a:p>
+            <a:r>
+              <a:rPr lang="en-US" dirty="0"/>
+              <a:t/>
+            </a:r>
+            <a:endParaRPr lang="en-US" dirty="0"/>
+          </a:p>
+        </p:txBody>
+      </p:sp>
+      <p:sp>
+        <p:nvSpPr>
+          <p:cNvPr id="4" name="Slide Number Placeholder 3"/>
+          <p:cNvSpPr>
+            <a:spLocks noGrp="1"/>
+          </p:cNvSpPr>
+          <p:nvPr>
+            <p:ph type="sldNum" sz="quarter" idx="10"/>
+          </p:nvPr>
+        </p:nvSpPr>
+        <p:spPr/>
+        <p:txBody>
+          <a:bodyPr/>
+          <a:lstStyle/>
+          <a:p>
+            <a:fld id="{F7021451-1387-4CA6-816F-3879F97B5CBC}" type="slidenum">
+              <a:rPr lang="en-US"/>
+              <a:t>11</a:t>
+            </a:fld>
+            <a:endParaRPr lang="en-US"/>
+          </a:p>
+        </p:txBody>
+      </p:sp>
+    </p:spTree>
+    <p:extLst>
+      <p:ext uri="{BB962C8B-B14F-4D97-AF65-F5344CB8AC3E}">
+        <p14:creationId xmlns:p14="http://schemas.microsoft.com/office/powerpoint/2010/main" val="1024086991"/>
+      </p:ext>
+    </p:extLst>
+  </p:cSld>
+  <p:clrMapOvr>
+    <a:masterClrMapping/>
+  </p:clrMapOvr>
+</p:notes>
+</file>
+
 <file path=ppt/notesSlides/notesSlide2.xml><?xml version="1.0" encoding="utf-8"?>
 <p:notes xmlns:a="http://schemas.openxmlformats.org/drawingml/2006/main" xmlns:r="http://schemas.openxmlformats.org/officeDocument/2006/relationships" xmlns:p="http://schemas.openxmlformats.org/presentationml/2006/main">
   <p:cSld>
@@ -2596,7 +2685,7 @@
           <a:p>
             <a:r>
               <a:rPr lang="en-US" dirty="0"/>
-              <a:t>A customer who repays their first loan is a much better risk the second time: loss falls from 2.6% to 1.0%, and that holds in every vertical and product, including on seasoned loans. 82% of loss dollars come from first loans. Repeat rates are set by the vertical: frequent-purchase verticals like fashion and electronics already get ~95%; big-ticket verticals only ~20%, which is where the upside is. And Split Pay works as an entry product: most customers move to interest-bearing, our highest-margin product, on their next loan.</a:t>
+              <a:t>Same view by product. Interest-bearing is where the profit is: its loss rate is the highest, but interest income more than covers it. 0% APR is our safest product, yet it earns a third of the interest-bearing margin: we give up the interest, fund a 12-18 month loan, and the merchant fee is not higher — at the same merchants it is actually lower than on interest-bearing loans. That is the basis for repricing. Split Pay is thin too, but it is the entry product that leads customers to interest-bearing, so we keep it as an acquisition tool rather than reprice it.</a:t>
             </a:r>
             <a:endParaRPr lang="en-US" dirty="0"/>
           </a:p>
@@ -2684,7 +2773,7 @@
           <a:p>
             <a:r>
               <a:rPr lang="en-US" dirty="0"/>
-              <a:t>Four moves. Two where we invest: merchant acquisition in healthcare and home furnishing, and converting first-time customers into repeat customers. One where we pull back: travel borrowers below 640 FICO, via the risk model rather than a blunt cut-off. One pricing fix: 0% APR merchant fee. Together: profit grows faster than GMV and the loss rate goes down, because growth is steered toward low-loss segments.</a:t>
+              <a:t>A customer who repays their first loan is a much better risk the second time: loss falls from 2.6% to 1.0%, and that holds in every vertical and product, including on seasoned loans. 82% of loss dollars come from first loans. Repeat rates are set by the vertical: frequent-purchase verticals like fashion and electronics already get ~95%; big-ticket verticals only ~20%, which is where the upside is. And Split Pay works as an entry product: most customers move to interest-bearing, our highest-margin product, on their next loan.</a:t>
             </a:r>
             <a:endParaRPr lang="en-US" dirty="0"/>
           </a:p>
@@ -2772,7 +2861,7 @@
           <a:p>
             <a:r>
               <a:rPr lang="en-US" dirty="0"/>
-              <a:t>Each lever is sized on 2025 volume at seasoned margins, with a conservative and an ambitious case. Repeat customers are the biggest profit lever. Merchant acquisition adds steady growth: each vertical only has 3–4 merchants, so one new average merchant adds 25–35% to the vertical. Tightening travel costs some profit, which is a deliberate trade for lower risk. Net: profit +7–15%, GMV +4–8%, and the loss rate goes down. 0% APR repricing is on top, but depends on merchant response.</a:t>
+              <a:t>Four moves. Two where we invest: merchant acquisition in healthcare and home furnishing, and converting first-time customers into repeat customers. One where we pull back: travel borrowers below 640 FICO, via the risk model rather than a blunt cut-off. One pricing fix: 0% APR merchant fee. Together: profit grows faster than GMV and the loss rate goes down, because growth is steered toward low-loss segments.</a:t>
             </a:r>
             <a:endParaRPr lang="en-US" dirty="0"/>
           </a:p>
@@ -2860,7 +2949,7 @@
           <a:p>
             <a:r>
               <a:rPr lang="en-US" dirty="0"/>
-              <a:t>Be explicit about trade-offs: the travel tightening is a risk decision, not a profit one. Caveats on data. Three things to watch, notably Split Pay loss creeping up, which is the cleanest read on credit trend because those loans complete in six weeks. Next steps are pilots rather than big-bang changes.</a:t>
+              <a:t>Each lever is sized on 2025 volume at seasoned margins, with a conservative and an ambitious case. Repeat customers are the biggest profit lever. Merchant acquisition adds steady growth: each vertical only has 3–4 merchants, so one new average merchant adds 25–35% to the vertical. Tightening travel costs some profit, which is a deliberate trade for lower risk. Net: profit +7–15%, GMV +4–8%, and the loss rate goes down. 0% APR repricing is on top, but depends on merchant response.</a:t>
             </a:r>
             <a:endParaRPr lang="en-US" dirty="0"/>
           </a:p>
@@ -2948,7 +3037,7 @@
           <a:p>
             <a:r>
               <a:rPr lang="en-US" dirty="0"/>
-              <a:t/>
+              <a:t>Be explicit about trade-offs: the travel tightening is a risk decision, not a profit one. Caveats on data. Three things to watch, notably Split Pay loss creeping up, which is the cleanest read on credit trend because those loans complete in six weeks. Next steps are pilots rather than big-bang changes.</a:t>
             </a:r>
             <a:endParaRPr lang="en-US" dirty="0"/>
           </a:p>
@@ -3992,6 +4081,575 @@
                 <a:ea typeface="Arial" pitchFamily="34" charset="-122"/>
                 <a:cs typeface="Arial" pitchFamily="34" charset="-120"/>
               </a:rPr>
+              <a:t>APPENDIX B · METHODOLOGY</a:t>
+            </a:r>
+            <a:endParaRPr lang="en-US" sz="1100" dirty="0"/>
+          </a:p>
+        </p:txBody>
+      </p:sp>
+      <p:sp>
+        <p:nvSpPr>
+          <p:cNvPr id="3" name="Text 1"/>
+          <p:cNvSpPr txBox="1"/>
+          <p:nvPr/>
+        </p:nvSpPr>
+        <p:spPr>
+          <a:xfrm>
+            <a:off x="548640" y="411480"/>
+            <a:ext cx="11094415" cy="868680"/>
+          </a:xfrm>
+          <a:prstGeom prst="rect">
+            <a:avLst/>
+          </a:prstGeom>
+          <a:noFill/>
+          <a:ln/>
+        </p:spPr>
+        <p:txBody>
+          <a:bodyPr wrap="square" lIns="0" tIns="0" rIns="0" bIns="0" rtlCol="0" anchor="t"/>
+          <a:lstStyle/>
+          <a:p>
+            <a:pPr indent="0" marL="0">
+              <a:buNone/>
+            </a:pPr>
+            <a:r>
+              <a:rPr lang="en-US" sz="2600" b="1" dirty="0">
+                <a:solidFill>
+                  <a:srgbClr val="1A1A2E"/>
+                </a:solidFill>
+                <a:latin typeface="Arial" pitchFamily="34" charset="0"/>
+                <a:ea typeface="Arial" pitchFamily="34" charset="-122"/>
+                <a:cs typeface="Arial" pitchFamily="34" charset="-120"/>
+              </a:rPr>
+              <a:t>How the numbers were built</a:t>
+            </a:r>
+            <a:endParaRPr lang="en-US" sz="2600" dirty="0"/>
+          </a:p>
+        </p:txBody>
+      </p:sp>
+      <p:sp>
+        <p:nvSpPr>
+          <p:cNvPr id="4" name="Shape 2"/>
+          <p:cNvSpPr/>
+          <p:nvPr/>
+        </p:nvSpPr>
+        <p:spPr>
+          <a:xfrm>
+            <a:off x="548640" y="1463040"/>
+            <a:ext cx="5394960" cy="1691640"/>
+          </a:xfrm>
+          <a:prstGeom prst="roundRect">
+            <a:avLst>
+              <a:gd name="adj" fmla="val 6486"/>
+            </a:avLst>
+          </a:prstGeom>
+          <a:solidFill>
+            <a:srgbClr val="F6F6FE"/>
+          </a:solidFill>
+          <a:ln w="12700">
+            <a:solidFill>
+              <a:srgbClr val="F6F6FE"/>
+            </a:solidFill>
+            <a:prstDash val="solid"/>
+          </a:ln>
+        </p:spPr>
+      </p:sp>
+      <p:sp>
+        <p:nvSpPr>
+          <p:cNvPr id="5" name="Text 3"/>
+          <p:cNvSpPr txBox="1"/>
+          <p:nvPr/>
+        </p:nvSpPr>
+        <p:spPr>
+          <a:xfrm>
+            <a:off x="822960" y="1645920"/>
+            <a:ext cx="4846320" cy="365760"/>
+          </a:xfrm>
+          <a:prstGeom prst="rect">
+            <a:avLst/>
+          </a:prstGeom>
+          <a:noFill/>
+          <a:ln/>
+        </p:spPr>
+        <p:txBody>
+          <a:bodyPr wrap="square" lIns="0" tIns="0" rIns="0" bIns="0" rtlCol="0" anchor="ctr"/>
+          <a:lstStyle/>
+          <a:p>
+            <a:pPr indent="0" marL="0">
+              <a:buNone/>
+            </a:pPr>
+            <a:r>
+              <a:rPr lang="en-US" sz="1500" b="1" dirty="0">
+                <a:solidFill>
+                  <a:srgbClr val="4A4AF4"/>
+                </a:solidFill>
+                <a:latin typeface="Arial" pitchFamily="34" charset="0"/>
+                <a:ea typeface="Arial" pitchFamily="34" charset="-122"/>
+                <a:cs typeface="Arial" pitchFamily="34" charset="-120"/>
+              </a:rPr>
+              <a:t>Unit economics per loan</a:t>
+            </a:r>
+            <a:endParaRPr lang="en-US" sz="1500" dirty="0"/>
+          </a:p>
+        </p:txBody>
+      </p:sp>
+      <p:sp>
+        <p:nvSpPr>
+          <p:cNvPr id="6" name="Text 4"/>
+          <p:cNvSpPr txBox="1"/>
+          <p:nvPr/>
+        </p:nvSpPr>
+        <p:spPr>
+          <a:xfrm>
+            <a:off x="822960" y="2057400"/>
+            <a:ext cx="4846320" cy="1005840"/>
+          </a:xfrm>
+          <a:prstGeom prst="rect">
+            <a:avLst/>
+          </a:prstGeom>
+          <a:noFill/>
+          <a:ln/>
+        </p:spPr>
+        <p:txBody>
+          <a:bodyPr wrap="square" lIns="0" tIns="0" rIns="0" bIns="0" rtlCol="0" anchor="t"/>
+          <a:lstStyle/>
+          <a:p>
+            <a:pPr indent="0" marL="0">
+              <a:buNone/>
+            </a:pPr>
+            <a:r>
+              <a:rPr lang="en-US" sz="1250" dirty="0">
+                <a:solidFill>
+                  <a:srgbClr val="1A1A2E"/>
+                </a:solidFill>
+                <a:latin typeface="Arial" pitchFamily="34" charset="0"/>
+                <a:ea typeface="Arial" pitchFamily="34" charset="-122"/>
+                <a:cs typeface="Arial" pitchFamily="34" charset="-120"/>
+              </a:rPr>
+              <a:t>Contribution = merchant fee + interest collected − credit loss − funding cost. Funding = cost of funds × term × ½ principal (average balance of an amortizing loan). Full principal would lower margins ~1 pt but not change the vertical ranking.</a:t>
+            </a:r>
+            <a:endParaRPr lang="en-US" sz="1250" dirty="0"/>
+          </a:p>
+        </p:txBody>
+      </p:sp>
+      <p:sp>
+        <p:nvSpPr>
+          <p:cNvPr id="7" name="Shape 5"/>
+          <p:cNvSpPr/>
+          <p:nvPr/>
+        </p:nvSpPr>
+        <p:spPr>
+          <a:xfrm>
+            <a:off x="6217920" y="1463040"/>
+            <a:ext cx="5394960" cy="1691640"/>
+          </a:xfrm>
+          <a:prstGeom prst="roundRect">
+            <a:avLst>
+              <a:gd name="adj" fmla="val 6486"/>
+            </a:avLst>
+          </a:prstGeom>
+          <a:solidFill>
+            <a:srgbClr val="F6F6FE"/>
+          </a:solidFill>
+          <a:ln w="12700">
+            <a:solidFill>
+              <a:srgbClr val="F6F6FE"/>
+            </a:solidFill>
+            <a:prstDash val="solid"/>
+          </a:ln>
+        </p:spPr>
+      </p:sp>
+      <p:sp>
+        <p:nvSpPr>
+          <p:cNvPr id="8" name="Text 6"/>
+          <p:cNvSpPr txBox="1"/>
+          <p:nvPr/>
+        </p:nvSpPr>
+        <p:spPr>
+          <a:xfrm>
+            <a:off x="6492240" y="1645920"/>
+            <a:ext cx="4846320" cy="365760"/>
+          </a:xfrm>
+          <a:prstGeom prst="rect">
+            <a:avLst/>
+          </a:prstGeom>
+          <a:noFill/>
+          <a:ln/>
+        </p:spPr>
+        <p:txBody>
+          <a:bodyPr wrap="square" lIns="0" tIns="0" rIns="0" bIns="0" rtlCol="0" anchor="ctr"/>
+          <a:lstStyle/>
+          <a:p>
+            <a:pPr indent="0" marL="0">
+              <a:buNone/>
+            </a:pPr>
+            <a:r>
+              <a:rPr lang="en-US" sz="1500" b="1" dirty="0">
+                <a:solidFill>
+                  <a:srgbClr val="4A4AF4"/>
+                </a:solidFill>
+                <a:latin typeface="Arial" pitchFamily="34" charset="0"/>
+                <a:ea typeface="Arial" pitchFamily="34" charset="-122"/>
+                <a:cs typeface="Arial" pitchFamily="34" charset="-120"/>
+              </a:rPr>
+              <a:t>Maturity</a:t>
+            </a:r>
+            <a:endParaRPr lang="en-US" sz="1500" dirty="0"/>
+          </a:p>
+        </p:txBody>
+      </p:sp>
+      <p:sp>
+        <p:nvSpPr>
+          <p:cNvPr id="9" name="Text 7"/>
+          <p:cNvSpPr txBox="1"/>
+          <p:nvPr/>
+        </p:nvSpPr>
+        <p:spPr>
+          <a:xfrm>
+            <a:off x="6492240" y="2057400"/>
+            <a:ext cx="4846320" cy="1005840"/>
+          </a:xfrm>
+          <a:prstGeom prst="rect">
+            <a:avLst/>
+          </a:prstGeom>
+          <a:noFill/>
+          <a:ln/>
+        </p:spPr>
+        <p:txBody>
+          <a:bodyPr wrap="square" lIns="0" tIns="0" rIns="0" bIns="0" rtlCol="0" anchor="t"/>
+          <a:lstStyle/>
+          <a:p>
+            <a:pPr indent="0" marL="0">
+              <a:buNone/>
+            </a:pPr>
+            <a:r>
+              <a:rPr lang="en-US" sz="1250" dirty="0">
+                <a:solidFill>
+                  <a:srgbClr val="1A1A2E"/>
+                </a:solidFill>
+                <a:latin typeface="Arial" pitchFamily="34" charset="0"/>
+                <a:ea typeface="Arial" pitchFamily="34" charset="-122"/>
+                <a:cs typeface="Arial" pitchFamily="34" charset="-120"/>
+              </a:rPr>
+              <a:t>Young loans haven't paid interest or defaulted yet. Loss/margin comparisons are checked on seasoned loans (originated by Jun 2025).</a:t>
+            </a:r>
+            <a:endParaRPr lang="en-US" sz="1250" dirty="0"/>
+          </a:p>
+        </p:txBody>
+      </p:sp>
+      <p:sp>
+        <p:nvSpPr>
+          <p:cNvPr id="10" name="Shape 8"/>
+          <p:cNvSpPr/>
+          <p:nvPr/>
+        </p:nvSpPr>
+        <p:spPr>
+          <a:xfrm>
+            <a:off x="548640" y="3383280"/>
+            <a:ext cx="5394960" cy="1691640"/>
+          </a:xfrm>
+          <a:prstGeom prst="roundRect">
+            <a:avLst>
+              <a:gd name="adj" fmla="val 6486"/>
+            </a:avLst>
+          </a:prstGeom>
+          <a:solidFill>
+            <a:srgbClr val="F6F6FE"/>
+          </a:solidFill>
+          <a:ln w="12700">
+            <a:solidFill>
+              <a:srgbClr val="F6F6FE"/>
+            </a:solidFill>
+            <a:prstDash val="solid"/>
+          </a:ln>
+        </p:spPr>
+      </p:sp>
+      <p:sp>
+        <p:nvSpPr>
+          <p:cNvPr id="11" name="Text 9"/>
+          <p:cNvSpPr txBox="1"/>
+          <p:nvPr/>
+        </p:nvSpPr>
+        <p:spPr>
+          <a:xfrm>
+            <a:off x="822960" y="3566160"/>
+            <a:ext cx="4846320" cy="365760"/>
+          </a:xfrm>
+          <a:prstGeom prst="rect">
+            <a:avLst/>
+          </a:prstGeom>
+          <a:noFill/>
+          <a:ln/>
+        </p:spPr>
+        <p:txBody>
+          <a:bodyPr wrap="square" lIns="0" tIns="0" rIns="0" bIns="0" rtlCol="0" anchor="ctr"/>
+          <a:lstStyle/>
+          <a:p>
+            <a:pPr indent="0" marL="0">
+              <a:buNone/>
+            </a:pPr>
+            <a:r>
+              <a:rPr lang="en-US" sz="1500" b="1" dirty="0">
+                <a:solidFill>
+                  <a:srgbClr val="4A4AF4"/>
+                </a:solidFill>
+                <a:latin typeface="Arial" pitchFamily="34" charset="0"/>
+                <a:ea typeface="Arial" pitchFamily="34" charset="-122"/>
+                <a:cs typeface="Arial" pitchFamily="34" charset="-120"/>
+              </a:rPr>
+              <a:t>Repeat customers</a:t>
+            </a:r>
+            <a:endParaRPr lang="en-US" sz="1500" dirty="0"/>
+          </a:p>
+        </p:txBody>
+      </p:sp>
+      <p:sp>
+        <p:nvSpPr>
+          <p:cNvPr id="12" name="Text 10"/>
+          <p:cNvSpPr txBox="1"/>
+          <p:nvPr/>
+        </p:nvSpPr>
+        <p:spPr>
+          <a:xfrm>
+            <a:off x="822960" y="3977640"/>
+            <a:ext cx="4846320" cy="1005840"/>
+          </a:xfrm>
+          <a:prstGeom prst="rect">
+            <a:avLst/>
+          </a:prstGeom>
+          <a:noFill/>
+          <a:ln/>
+        </p:spPr>
+        <p:txBody>
+          <a:bodyPr wrap="square" lIns="0" tIns="0" rIns="0" bIns="0" rtlCol="0" anchor="t"/>
+          <a:lstStyle/>
+          <a:p>
+            <a:pPr indent="0" marL="0">
+              <a:buNone/>
+            </a:pPr>
+            <a:r>
+              <a:rPr lang="en-US" sz="1250" dirty="0">
+                <a:solidFill>
+                  <a:srgbClr val="1A1A2E"/>
+                </a:solidFill>
+                <a:latin typeface="Arial" pitchFamily="34" charset="0"/>
+                <a:ea typeface="Arial" pitchFamily="34" charset="-122"/>
+                <a:cs typeface="Arial" pitchFamily="34" charset="-120"/>
+              </a:rPr>
+              <a:t>First loans by Jun 2025; repeat = another loan within 180 days. Loss by new vs repeat checked on seasoned loans.</a:t>
+            </a:r>
+            <a:endParaRPr lang="en-US" sz="1250" dirty="0"/>
+          </a:p>
+        </p:txBody>
+      </p:sp>
+      <p:sp>
+        <p:nvSpPr>
+          <p:cNvPr id="13" name="Shape 11"/>
+          <p:cNvSpPr/>
+          <p:nvPr/>
+        </p:nvSpPr>
+        <p:spPr>
+          <a:xfrm>
+            <a:off x="6217920" y="3383280"/>
+            <a:ext cx="5394960" cy="1691640"/>
+          </a:xfrm>
+          <a:prstGeom prst="roundRect">
+            <a:avLst>
+              <a:gd name="adj" fmla="val 6486"/>
+            </a:avLst>
+          </a:prstGeom>
+          <a:solidFill>
+            <a:srgbClr val="F6F6FE"/>
+          </a:solidFill>
+          <a:ln w="12700">
+            <a:solidFill>
+              <a:srgbClr val="F6F6FE"/>
+            </a:solidFill>
+            <a:prstDash val="solid"/>
+          </a:ln>
+        </p:spPr>
+      </p:sp>
+      <p:sp>
+        <p:nvSpPr>
+          <p:cNvPr id="14" name="Text 12"/>
+          <p:cNvSpPr txBox="1"/>
+          <p:nvPr/>
+        </p:nvSpPr>
+        <p:spPr>
+          <a:xfrm>
+            <a:off x="6492240" y="3566160"/>
+            <a:ext cx="4846320" cy="365760"/>
+          </a:xfrm>
+          <a:prstGeom prst="rect">
+            <a:avLst/>
+          </a:prstGeom>
+          <a:noFill/>
+          <a:ln/>
+        </p:spPr>
+        <p:txBody>
+          <a:bodyPr wrap="square" lIns="0" tIns="0" rIns="0" bIns="0" rtlCol="0" anchor="ctr"/>
+          <a:lstStyle/>
+          <a:p>
+            <a:pPr indent="0" marL="0">
+              <a:buNone/>
+            </a:pPr>
+            <a:r>
+              <a:rPr lang="en-US" sz="1500" b="1" dirty="0">
+                <a:solidFill>
+                  <a:srgbClr val="4A4AF4"/>
+                </a:solidFill>
+                <a:latin typeface="Arial" pitchFamily="34" charset="0"/>
+                <a:ea typeface="Arial" pitchFamily="34" charset="-122"/>
+                <a:cs typeface="Arial" pitchFamily="34" charset="-120"/>
+              </a:rPr>
+              <a:t>Sizing</a:t>
+            </a:r>
+            <a:endParaRPr lang="en-US" sz="1500" dirty="0"/>
+          </a:p>
+        </p:txBody>
+      </p:sp>
+      <p:sp>
+        <p:nvSpPr>
+          <p:cNvPr id="15" name="Text 13"/>
+          <p:cNvSpPr txBox="1"/>
+          <p:nvPr/>
+        </p:nvSpPr>
+        <p:spPr>
+          <a:xfrm>
+            <a:off x="6492240" y="3977640"/>
+            <a:ext cx="4846320" cy="1005840"/>
+          </a:xfrm>
+          <a:prstGeom prst="rect">
+            <a:avLst/>
+          </a:prstGeom>
+          <a:noFill/>
+          <a:ln/>
+        </p:spPr>
+        <p:txBody>
+          <a:bodyPr wrap="square" lIns="0" tIns="0" rIns="0" bIns="0" rtlCol="0" anchor="t"/>
+          <a:lstStyle/>
+          <a:p>
+            <a:pPr indent="0" marL="0">
+              <a:buNone/>
+            </a:pPr>
+            <a:r>
+              <a:rPr lang="en-US" sz="1250" dirty="0">
+                <a:solidFill>
+                  <a:srgbClr val="1A1A2E"/>
+                </a:solidFill>
+                <a:latin typeface="Arial" pitchFamily="34" charset="0"/>
+                <a:ea typeface="Arial" pitchFamily="34" charset="-122"/>
+                <a:cs typeface="Arial" pitchFamily="34" charset="-120"/>
+              </a:rPr>
+              <a:t>One year = 2025 volume × seasoned rates. Changes scale proportionally; new merchants perform like the vertical average.</a:t>
+            </a:r>
+            <a:endParaRPr lang="en-US" sz="1250" dirty="0"/>
+          </a:p>
+        </p:txBody>
+      </p:sp>
+      <p:sp>
+        <p:nvSpPr>
+          <p:cNvPr id="16" name="Text 14"/>
+          <p:cNvSpPr txBox="1"/>
+          <p:nvPr/>
+        </p:nvSpPr>
+        <p:spPr>
+          <a:xfrm>
+            <a:off x="548640" y="6355080"/>
+            <a:ext cx="11094415" cy="320040"/>
+          </a:xfrm>
+          <a:prstGeom prst="rect">
+            <a:avLst/>
+          </a:prstGeom>
+          <a:noFill/>
+          <a:ln/>
+        </p:spPr>
+        <p:txBody>
+          <a:bodyPr wrap="square" lIns="0" tIns="0" rIns="0" bIns="0" rtlCol="0" anchor="b"/>
+          <a:lstStyle/>
+          <a:p>
+            <a:pPr indent="0" marL="0">
+              <a:buNone/>
+            </a:pPr>
+            <a:r>
+              <a:rPr lang="en-US" sz="1000" dirty="0">
+                <a:solidFill>
+                  <a:srgbClr val="5B5B73"/>
+                </a:solidFill>
+                <a:latin typeface="Arial" pitchFamily="34" charset="0"/>
+                <a:ea typeface="Arial" pitchFamily="34" charset="-122"/>
+                <a:cs typeface="Arial" pitchFamily="34" charset="-120"/>
+              </a:rPr>
+              <a:t>Code: notebooks/01_data_integrity.ipynb, 02_portfolio_risk.ipynb, 03_recommendation_sizing.ipynb.</a:t>
+            </a:r>
+            <a:endParaRPr lang="en-US" sz="1000" dirty="0"/>
+          </a:p>
+        </p:txBody>
+      </p:sp>
+    </p:spTree>
+  </p:cSld>
+  <p:clrMapOvr>
+    <a:masterClrMapping/>
+  </p:clrMapOvr>
+</p:sld>
+</file>
+
+<file path=ppt/slides/slide11.xml><?xml version="1.0" encoding="utf-8"?>
+<p:sld xmlns:a="http://schemas.openxmlformats.org/drawingml/2006/main" xmlns:r="http://schemas.openxmlformats.org/officeDocument/2006/relationships" xmlns:p="http://schemas.openxmlformats.org/presentationml/2006/main">
+  <p:cSld name="Slide 11">
+    <p:bg>
+      <p:bgPr>
+        <a:solidFill>
+          <a:srgbClr val="FFFFFF"/>
+        </a:solidFill>
+      </p:bgPr>
+    </p:bg>
+    <p:spTree>
+      <p:nvGrpSpPr>
+        <p:cNvPr id="1" name=""/>
+        <p:cNvGrpSpPr/>
+        <p:nvPr/>
+      </p:nvGrpSpPr>
+      <p:grpSpPr>
+        <a:xfrm>
+          <a:off x="0" y="0"/>
+          <a:ext cx="0" cy="0"/>
+          <a:chOff x="0" y="0"/>
+          <a:chExt cx="0" cy="0"/>
+        </a:xfrm>
+      </p:grpSpPr>
+      <p:sp>
+        <p:nvSpPr>
+          <p:cNvPr id="2" name="Text 0"/>
+          <p:cNvSpPr txBox="1"/>
+          <p:nvPr/>
+        </p:nvSpPr>
+        <p:spPr>
+          <a:xfrm>
+            <a:off x="548640" y="164592"/>
+            <a:ext cx="7315200" cy="274320"/>
+          </a:xfrm>
+          <a:prstGeom prst="rect">
+            <a:avLst/>
+          </a:prstGeom>
+          <a:noFill/>
+          <a:ln/>
+        </p:spPr>
+        <p:txBody>
+          <a:bodyPr wrap="square" lIns="0" tIns="0" rIns="0" bIns="0" rtlCol="0" anchor="ctr"/>
+          <a:lstStyle/>
+          <a:p>
+            <a:pPr indent="0" marL="0">
+              <a:buNone/>
+            </a:pPr>
+            <a:r>
+              <a:rPr lang="en-US" sz="1100" b="1" spc="200" kern="0" dirty="0">
+                <a:solidFill>
+                  <a:srgbClr val="5B5B73"/>
+                </a:solidFill>
+                <a:latin typeface="Arial" pitchFamily="34" charset="0"/>
+                <a:ea typeface="Arial" pitchFamily="34" charset="-122"/>
+                <a:cs typeface="Arial" pitchFamily="34" charset="-120"/>
+              </a:rPr>
               <a:t>APPENDIX C · TREND</a:t>
             </a:r>
             <a:endParaRPr lang="en-US" sz="1100" dirty="0"/>
@@ -8999,13 +9657,13 @@
             <a:r>
               <a:rPr lang="en-US" sz="1400" b="1" dirty="0">
                 <a:solidFill>
-                  <a:srgbClr val="4A4AF4"/>
+                  <a:srgbClr val="1E8A4C"/>
                 </a:solidFill>
                 <a:latin typeface="Arial" pitchFamily="34" charset="0"/>
                 <a:ea typeface="Arial" pitchFamily="34" charset="-122"/>
                 <a:cs typeface="Arial" pitchFamily="34" charset="-120"/>
               </a:rPr>
-              <a:t>By product</a:t>
+              <a:t>Healthcare &amp; home furnishing</a:t>
             </a:r>
             <a:endParaRPr lang="en-US" sz="1400" dirty="0"/>
           </a:p>
@@ -9044,7 +9702,7 @@
                 <a:ea typeface="Arial" pitchFamily="34" charset="-122"/>
                 <a:cs typeface="Arial" pitchFamily="34" charset="-120"/>
               </a:rPr>
-              <a:t>Interest-bearing is 58% of GMV and 82% of profit. Split Pay (2.6%) and 0% APR (3.4%) margins are thin.</a:t>
+              <a:t>Low loss (1.2–1.5%) with high revenue. A healthcare customer is worth ~$215 in profit over their loans.</a:t>
             </a:r>
             <a:endParaRPr lang="en-US" sz="1200" dirty="0"/>
           </a:p>
@@ -9100,6 +9758,2963 @@
 <file path=ppt/slides/slide4.xml><?xml version="1.0" encoding="utf-8"?>
 <p:sld xmlns:a="http://schemas.openxmlformats.org/drawingml/2006/main" xmlns:r="http://schemas.openxmlformats.org/officeDocument/2006/relationships" xmlns:p="http://schemas.openxmlformats.org/presentationml/2006/main">
   <p:cSld name="Slide 4">
+    <p:bg>
+      <p:bgPr>
+        <a:solidFill>
+          <a:srgbClr val="FFFFFF"/>
+        </a:solidFill>
+      </p:bgPr>
+    </p:bg>
+    <p:spTree>
+      <p:nvGrpSpPr>
+        <p:cNvPr id="1" name=""/>
+        <p:cNvGrpSpPr/>
+        <p:nvPr/>
+      </p:nvGrpSpPr>
+      <p:grpSpPr>
+        <a:xfrm>
+          <a:off x="0" y="0"/>
+          <a:ext cx="0" cy="0"/>
+          <a:chOff x="0" y="0"/>
+          <a:chExt cx="0" cy="0"/>
+        </a:xfrm>
+      </p:grpSpPr>
+      <p:sp>
+        <p:nvSpPr>
+          <p:cNvPr id="2" name="Text 0"/>
+          <p:cNvSpPr txBox="1"/>
+          <p:nvPr/>
+        </p:nvSpPr>
+        <p:spPr>
+          <a:xfrm>
+            <a:off x="548640" y="164592"/>
+            <a:ext cx="7315200" cy="274320"/>
+          </a:xfrm>
+          <a:prstGeom prst="rect">
+            <a:avLst/>
+          </a:prstGeom>
+          <a:noFill/>
+          <a:ln/>
+        </p:spPr>
+        <p:txBody>
+          <a:bodyPr wrap="square" lIns="0" tIns="0" rIns="0" bIns="0" rtlCol="0" anchor="ctr"/>
+          <a:lstStyle/>
+          <a:p>
+            <a:pPr indent="0" marL="0">
+              <a:buNone/>
+            </a:pPr>
+            <a:r>
+              <a:rPr lang="en-US" sz="1100" b="1" spc="200" kern="0" dirty="0">
+                <a:solidFill>
+                  <a:srgbClr val="4A4AF4"/>
+                </a:solidFill>
+                <a:latin typeface="Arial" pitchFamily="34" charset="0"/>
+                <a:ea typeface="Arial" pitchFamily="34" charset="-122"/>
+                <a:cs typeface="Arial" pitchFamily="34" charset="-120"/>
+              </a:rPr>
+              <a:t>WHERE VALUE SITS BY PRODUCT</a:t>
+            </a:r>
+            <a:endParaRPr lang="en-US" sz="1100" dirty="0"/>
+          </a:p>
+        </p:txBody>
+      </p:sp>
+      <p:sp>
+        <p:nvSpPr>
+          <p:cNvPr id="3" name="Text 1"/>
+          <p:cNvSpPr txBox="1"/>
+          <p:nvPr/>
+        </p:nvSpPr>
+        <p:spPr>
+          <a:xfrm>
+            <a:off x="548640" y="411480"/>
+            <a:ext cx="11094415" cy="868680"/>
+          </a:xfrm>
+          <a:prstGeom prst="rect">
+            <a:avLst/>
+          </a:prstGeom>
+          <a:noFill/>
+          <a:ln/>
+        </p:spPr>
+        <p:txBody>
+          <a:bodyPr wrap="square" lIns="0" tIns="0" rIns="0" bIns="0" rtlCol="0" anchor="t"/>
+          <a:lstStyle/>
+          <a:p>
+            <a:pPr indent="0" marL="0">
+              <a:buNone/>
+            </a:pPr>
+            <a:r>
+              <a:rPr lang="en-US" sz="2600" b="1" dirty="0">
+                <a:solidFill>
+                  <a:srgbClr val="1A1A2E"/>
+                </a:solidFill>
+                <a:latin typeface="Arial" pitchFamily="34" charset="0"/>
+                <a:ea typeface="Arial" pitchFamily="34" charset="-122"/>
+                <a:cs typeface="Arial" pitchFamily="34" charset="-120"/>
+              </a:rPr>
+              <a:t>Interest-bearing earns 82% of profit; 0% APR gives up interest without a higher merchant fee</a:t>
+            </a:r>
+            <a:endParaRPr lang="en-US" sz="2600" dirty="0"/>
+          </a:p>
+        </p:txBody>
+      </p:sp>
+      <p:graphicFrame>
+        <p:nvGraphicFramePr>
+          <p:cNvPr id="5" name="Table 0"/>
+          <p:cNvGraphicFramePr>
+            <a:graphicFrameLocks noGrp="1"/>
+          </p:cNvGraphicFramePr>
+          <p:nvPr>
+            <p:extLst>
+              <p:ext uri="{D42A27DB-BD31-4B8C-83A1-F6EECF244321}">
+                <p14:modId xmlns:p14="http://schemas.microsoft.com/office/powerpoint/2010/main" val="1579011935"/>
+              </p:ext>
+            </p:extLst>
+          </p:nvPr>
+        </p:nvGraphicFramePr>
+        <p:xfrm>
+          <a:off x="548640" y="1463040"/>
+          <a:ext cx="11094415" cy="914400"/>
+        </p:xfrm>
+        <a:graphic>
+          <a:graphicData uri="http://schemas.openxmlformats.org/drawingml/2006/table">
+            <a:tbl>
+              <a:tblPr/>
+              <a:tblGrid>
+                <a:gridCol w="1828800"/>
+                <a:gridCol w="1188720"/>
+                <a:gridCol w="1188720"/>
+                <a:gridCol w="1005840"/>
+                <a:gridCol w="1097280"/>
+                <a:gridCol w="1234440"/>
+                <a:gridCol w="1097280"/>
+                <a:gridCol w="1097280"/>
+                <a:gridCol w="1356055"/>
+              </a:tblGrid>
+              <a:tr h="548640">
+                <a:tc>
+                  <a:txBody>
+                    <a:bodyPr/>
+                    <a:lstStyle/>
+                    <a:p>
+                      <a:pPr algn="l" indent="0" marL="0">
+                        <a:buNone/>
+                      </a:pPr>
+                      <a:r>
+                        <a:rPr lang="en-US" sz="1300" b="1" dirty="0">
+                          <a:solidFill>
+                            <a:srgbClr val="FFFFFF"/>
+                          </a:solidFill>
+                          <a:latin typeface="Arial" pitchFamily="34" charset="0"/>
+                          <a:ea typeface="Arial" pitchFamily="34" charset="-122"/>
+                          <a:cs typeface="Arial" pitchFamily="34" charset="-120"/>
+                        </a:rPr>
+                        <a:t>Product</a:t>
+                      </a:r>
+                      <a:endParaRPr lang="en-US" sz="1300" dirty="0">
+                        <a:latin typeface="Arial" charset="0"/>
+                        <a:ea typeface="Arial" charset="0"/>
+                        <a:cs typeface="Arial" charset="0"/>
+                      </a:endParaRPr>
+                    </a:p>
+                  </a:txBody>
+                  <a:tcPr marL="91440" marR="91440" marT="27432" marB="27432" anchor="ctr">
+                    <a:lnL w="6350" cap="flat" cmpd="sng" algn="ctr">
+                      <a:solidFill>
+                        <a:srgbClr val="DADAF0"/>
+                      </a:solidFill>
+                      <a:prstDash val="solid"/>
+                      <a:round/>
+                      <a:headEnd type="none" w="med" len="med"/>
+                      <a:tailEnd type="none" w="med" len="med"/>
+                    </a:lnL>
+                    <a:lnR w="6350" cap="flat" cmpd="sng" algn="ctr">
+                      <a:solidFill>
+                        <a:srgbClr val="DADAF0"/>
+                      </a:solidFill>
+                      <a:prstDash val="solid"/>
+                      <a:round/>
+                      <a:headEnd type="none" w="med" len="med"/>
+                      <a:tailEnd type="none" w="med" len="med"/>
+                    </a:lnR>
+                    <a:lnT w="6350" cap="flat" cmpd="sng" algn="ctr">
+                      <a:solidFill>
+                        <a:srgbClr val="DADAF0"/>
+                      </a:solidFill>
+                      <a:prstDash val="solid"/>
+                      <a:round/>
+                      <a:headEnd type="none" w="med" len="med"/>
+                      <a:tailEnd type="none" w="med" len="med"/>
+                    </a:lnT>
+                    <a:lnB w="6350" cap="flat" cmpd="sng" algn="ctr">
+                      <a:solidFill>
+                        <a:srgbClr val="DADAF0"/>
+                      </a:solidFill>
+                      <a:prstDash val="solid"/>
+                      <a:round/>
+                      <a:headEnd type="none" w="med" len="med"/>
+                      <a:tailEnd type="none" w="med" len="med"/>
+                    </a:lnB>
+                    <a:solidFill>
+                      <a:srgbClr val="0F1033"/>
+                    </a:solidFill>
+                  </a:tcPr>
+                </a:tc>
+                <a:tc>
+                  <a:txBody>
+                    <a:bodyPr/>
+                    <a:lstStyle/>
+                    <a:p>
+                      <a:pPr algn="ctr" indent="0" marL="0">
+                        <a:buNone/>
+                      </a:pPr>
+                      <a:r>
+                        <a:rPr lang="en-US" sz="1300" b="1" dirty="0">
+                          <a:solidFill>
+                            <a:srgbClr val="FFFFFF"/>
+                          </a:solidFill>
+                          <a:latin typeface="Arial" pitchFamily="34" charset="0"/>
+                          <a:ea typeface="Arial" pitchFamily="34" charset="-122"/>
+                          <a:cs typeface="Arial" pitchFamily="34" charset="-120"/>
+                        </a:rPr>
+                        <a:t>Share of loans</a:t>
+                      </a:r>
+                      <a:endParaRPr lang="en-US" sz="1300" dirty="0">
+                        <a:latin typeface="Arial" charset="0"/>
+                        <a:ea typeface="Arial" charset="0"/>
+                        <a:cs typeface="Arial" charset="0"/>
+                      </a:endParaRPr>
+                    </a:p>
+                  </a:txBody>
+                  <a:tcPr marL="91440" marR="91440" marT="27432" marB="27432" anchor="ctr">
+                    <a:lnL w="6350" cap="flat" cmpd="sng" algn="ctr">
+                      <a:solidFill>
+                        <a:srgbClr val="DADAF0"/>
+                      </a:solidFill>
+                      <a:prstDash val="solid"/>
+                      <a:round/>
+                      <a:headEnd type="none" w="med" len="med"/>
+                      <a:tailEnd type="none" w="med" len="med"/>
+                    </a:lnL>
+                    <a:lnR w="6350" cap="flat" cmpd="sng" algn="ctr">
+                      <a:solidFill>
+                        <a:srgbClr val="DADAF0"/>
+                      </a:solidFill>
+                      <a:prstDash val="solid"/>
+                      <a:round/>
+                      <a:headEnd type="none" w="med" len="med"/>
+                      <a:tailEnd type="none" w="med" len="med"/>
+                    </a:lnR>
+                    <a:lnT w="6350" cap="flat" cmpd="sng" algn="ctr">
+                      <a:solidFill>
+                        <a:srgbClr val="DADAF0"/>
+                      </a:solidFill>
+                      <a:prstDash val="solid"/>
+                      <a:round/>
+                      <a:headEnd type="none" w="med" len="med"/>
+                      <a:tailEnd type="none" w="med" len="med"/>
+                    </a:lnT>
+                    <a:lnB w="6350" cap="flat" cmpd="sng" algn="ctr">
+                      <a:solidFill>
+                        <a:srgbClr val="DADAF0"/>
+                      </a:solidFill>
+                      <a:prstDash val="solid"/>
+                      <a:round/>
+                      <a:headEnd type="none" w="med" len="med"/>
+                      <a:tailEnd type="none" w="med" len="med"/>
+                    </a:lnB>
+                    <a:solidFill>
+                      <a:srgbClr val="0F1033"/>
+                    </a:solidFill>
+                  </a:tcPr>
+                </a:tc>
+                <a:tc>
+                  <a:txBody>
+                    <a:bodyPr/>
+                    <a:lstStyle/>
+                    <a:p>
+                      <a:pPr algn="ctr" indent="0" marL="0">
+                        <a:buNone/>
+                      </a:pPr>
+                      <a:r>
+                        <a:rPr lang="en-US" sz="1300" b="1" dirty="0">
+                          <a:solidFill>
+                            <a:srgbClr val="FFFFFF"/>
+                          </a:solidFill>
+                          <a:latin typeface="Arial" pitchFamily="34" charset="0"/>
+                          <a:ea typeface="Arial" pitchFamily="34" charset="-122"/>
+                          <a:cs typeface="Arial" pitchFamily="34" charset="-120"/>
+                        </a:rPr>
+                        <a:t>Share of GMV</a:t>
+                      </a:r>
+                      <a:endParaRPr lang="en-US" sz="1300" dirty="0">
+                        <a:latin typeface="Arial" charset="0"/>
+                        <a:ea typeface="Arial" charset="0"/>
+                        <a:cs typeface="Arial" charset="0"/>
+                      </a:endParaRPr>
+                    </a:p>
+                  </a:txBody>
+                  <a:tcPr marL="91440" marR="91440" marT="27432" marB="27432" anchor="ctr">
+                    <a:lnL w="6350" cap="flat" cmpd="sng" algn="ctr">
+                      <a:solidFill>
+                        <a:srgbClr val="DADAF0"/>
+                      </a:solidFill>
+                      <a:prstDash val="solid"/>
+                      <a:round/>
+                      <a:headEnd type="none" w="med" len="med"/>
+                      <a:tailEnd type="none" w="med" len="med"/>
+                    </a:lnL>
+                    <a:lnR w="6350" cap="flat" cmpd="sng" algn="ctr">
+                      <a:solidFill>
+                        <a:srgbClr val="DADAF0"/>
+                      </a:solidFill>
+                      <a:prstDash val="solid"/>
+                      <a:round/>
+                      <a:headEnd type="none" w="med" len="med"/>
+                      <a:tailEnd type="none" w="med" len="med"/>
+                    </a:lnR>
+                    <a:lnT w="6350" cap="flat" cmpd="sng" algn="ctr">
+                      <a:solidFill>
+                        <a:srgbClr val="DADAF0"/>
+                      </a:solidFill>
+                      <a:prstDash val="solid"/>
+                      <a:round/>
+                      <a:headEnd type="none" w="med" len="med"/>
+                      <a:tailEnd type="none" w="med" len="med"/>
+                    </a:lnT>
+                    <a:lnB w="6350" cap="flat" cmpd="sng" algn="ctr">
+                      <a:solidFill>
+                        <a:srgbClr val="DADAF0"/>
+                      </a:solidFill>
+                      <a:prstDash val="solid"/>
+                      <a:round/>
+                      <a:headEnd type="none" w="med" len="med"/>
+                      <a:tailEnd type="none" w="med" len="med"/>
+                    </a:lnB>
+                    <a:solidFill>
+                      <a:srgbClr val="0F1033"/>
+                    </a:solidFill>
+                  </a:tcPr>
+                </a:tc>
+                <a:tc>
+                  <a:txBody>
+                    <a:bodyPr/>
+                    <a:lstStyle/>
+                    <a:p>
+                      <a:pPr algn="ctr" indent="0" marL="0">
+                        <a:buNone/>
+                      </a:pPr>
+                      <a:r>
+                        <a:rPr lang="en-US" sz="1300" b="1" dirty="0">
+                          <a:solidFill>
+                            <a:srgbClr val="FFFFFF"/>
+                          </a:solidFill>
+                          <a:latin typeface="Arial" pitchFamily="34" charset="0"/>
+                          <a:ea typeface="Arial" pitchFamily="34" charset="-122"/>
+                          <a:cs typeface="Arial" pitchFamily="34" charset="-120"/>
+                        </a:rPr>
+                        <a:t>Avg FICO</a:t>
+                      </a:r>
+                      <a:endParaRPr lang="en-US" sz="1300" dirty="0">
+                        <a:latin typeface="Arial" charset="0"/>
+                        <a:ea typeface="Arial" charset="0"/>
+                        <a:cs typeface="Arial" charset="0"/>
+                      </a:endParaRPr>
+                    </a:p>
+                  </a:txBody>
+                  <a:tcPr marL="91440" marR="91440" marT="27432" marB="27432" anchor="ctr">
+                    <a:lnL w="6350" cap="flat" cmpd="sng" algn="ctr">
+                      <a:solidFill>
+                        <a:srgbClr val="DADAF0"/>
+                      </a:solidFill>
+                      <a:prstDash val="solid"/>
+                      <a:round/>
+                      <a:headEnd type="none" w="med" len="med"/>
+                      <a:tailEnd type="none" w="med" len="med"/>
+                    </a:lnL>
+                    <a:lnR w="6350" cap="flat" cmpd="sng" algn="ctr">
+                      <a:solidFill>
+                        <a:srgbClr val="DADAF0"/>
+                      </a:solidFill>
+                      <a:prstDash val="solid"/>
+                      <a:round/>
+                      <a:headEnd type="none" w="med" len="med"/>
+                      <a:tailEnd type="none" w="med" len="med"/>
+                    </a:lnR>
+                    <a:lnT w="6350" cap="flat" cmpd="sng" algn="ctr">
+                      <a:solidFill>
+                        <a:srgbClr val="DADAF0"/>
+                      </a:solidFill>
+                      <a:prstDash val="solid"/>
+                      <a:round/>
+                      <a:headEnd type="none" w="med" len="med"/>
+                      <a:tailEnd type="none" w="med" len="med"/>
+                    </a:lnT>
+                    <a:lnB w="6350" cap="flat" cmpd="sng" algn="ctr">
+                      <a:solidFill>
+                        <a:srgbClr val="DADAF0"/>
+                      </a:solidFill>
+                      <a:prstDash val="solid"/>
+                      <a:round/>
+                      <a:headEnd type="none" w="med" len="med"/>
+                      <a:tailEnd type="none" w="med" len="med"/>
+                    </a:lnB>
+                    <a:solidFill>
+                      <a:srgbClr val="0F1033"/>
+                    </a:solidFill>
+                  </a:tcPr>
+                </a:tc>
+                <a:tc>
+                  <a:txBody>
+                    <a:bodyPr/>
+                    <a:lstStyle/>
+                    <a:p>
+                      <a:pPr algn="ctr" indent="0" marL="0">
+                        <a:buNone/>
+                      </a:pPr>
+                      <a:r>
+                        <a:rPr lang="en-US" sz="1300" b="1" dirty="0">
+                          <a:solidFill>
+                            <a:srgbClr val="FFFFFF"/>
+                          </a:solidFill>
+                          <a:latin typeface="Arial" pitchFamily="34" charset="0"/>
+                          <a:ea typeface="Arial" pitchFamily="34" charset="-122"/>
+                          <a:cs typeface="Arial" pitchFamily="34" charset="-120"/>
+                        </a:rPr>
+                        <a:t>Loss rate</a:t>
+                      </a:r>
+                      <a:endParaRPr lang="en-US" sz="1300" dirty="0">
+                        <a:latin typeface="Arial" charset="0"/>
+                        <a:ea typeface="Arial" charset="0"/>
+                        <a:cs typeface="Arial" charset="0"/>
+                      </a:endParaRPr>
+                    </a:p>
+                  </a:txBody>
+                  <a:tcPr marL="91440" marR="91440" marT="27432" marB="27432" anchor="ctr">
+                    <a:lnL w="6350" cap="flat" cmpd="sng" algn="ctr">
+                      <a:solidFill>
+                        <a:srgbClr val="DADAF0"/>
+                      </a:solidFill>
+                      <a:prstDash val="solid"/>
+                      <a:round/>
+                      <a:headEnd type="none" w="med" len="med"/>
+                      <a:tailEnd type="none" w="med" len="med"/>
+                    </a:lnL>
+                    <a:lnR w="6350" cap="flat" cmpd="sng" algn="ctr">
+                      <a:solidFill>
+                        <a:srgbClr val="DADAF0"/>
+                      </a:solidFill>
+                      <a:prstDash val="solid"/>
+                      <a:round/>
+                      <a:headEnd type="none" w="med" len="med"/>
+                      <a:tailEnd type="none" w="med" len="med"/>
+                    </a:lnR>
+                    <a:lnT w="6350" cap="flat" cmpd="sng" algn="ctr">
+                      <a:solidFill>
+                        <a:srgbClr val="DADAF0"/>
+                      </a:solidFill>
+                      <a:prstDash val="solid"/>
+                      <a:round/>
+                      <a:headEnd type="none" w="med" len="med"/>
+                      <a:tailEnd type="none" w="med" len="med"/>
+                    </a:lnT>
+                    <a:lnB w="6350" cap="flat" cmpd="sng" algn="ctr">
+                      <a:solidFill>
+                        <a:srgbClr val="DADAF0"/>
+                      </a:solidFill>
+                      <a:prstDash val="solid"/>
+                      <a:round/>
+                      <a:headEnd type="none" w="med" len="med"/>
+                      <a:tailEnd type="none" w="med" len="med"/>
+                    </a:lnB>
+                    <a:solidFill>
+                      <a:srgbClr val="0F1033"/>
+                    </a:solidFill>
+                  </a:tcPr>
+                </a:tc>
+                <a:tc>
+                  <a:txBody>
+                    <a:bodyPr/>
+                    <a:lstStyle/>
+                    <a:p>
+                      <a:pPr algn="ctr" indent="0" marL="0">
+                        <a:buNone/>
+                      </a:pPr>
+                      <a:r>
+                        <a:rPr lang="en-US" sz="1300" b="1" dirty="0">
+                          <a:solidFill>
+                            <a:srgbClr val="FFFFFF"/>
+                          </a:solidFill>
+                          <a:latin typeface="Arial" pitchFamily="34" charset="0"/>
+                          <a:ea typeface="Arial" pitchFamily="34" charset="-122"/>
+                          <a:cs typeface="Arial" pitchFamily="34" charset="-120"/>
+                        </a:rPr>
+                        <a:t>Merchant fee</a:t>
+                      </a:r>
+                      <a:endParaRPr lang="en-US" sz="1300" dirty="0">
+                        <a:latin typeface="Arial" charset="0"/>
+                        <a:ea typeface="Arial" charset="0"/>
+                        <a:cs typeface="Arial" charset="0"/>
+                      </a:endParaRPr>
+                    </a:p>
+                  </a:txBody>
+                  <a:tcPr marL="91440" marR="91440" marT="27432" marB="27432" anchor="ctr">
+                    <a:lnL w="6350" cap="flat" cmpd="sng" algn="ctr">
+                      <a:solidFill>
+                        <a:srgbClr val="DADAF0"/>
+                      </a:solidFill>
+                      <a:prstDash val="solid"/>
+                      <a:round/>
+                      <a:headEnd type="none" w="med" len="med"/>
+                      <a:tailEnd type="none" w="med" len="med"/>
+                    </a:lnL>
+                    <a:lnR w="6350" cap="flat" cmpd="sng" algn="ctr">
+                      <a:solidFill>
+                        <a:srgbClr val="DADAF0"/>
+                      </a:solidFill>
+                      <a:prstDash val="solid"/>
+                      <a:round/>
+                      <a:headEnd type="none" w="med" len="med"/>
+                      <a:tailEnd type="none" w="med" len="med"/>
+                    </a:lnR>
+                    <a:lnT w="6350" cap="flat" cmpd="sng" algn="ctr">
+                      <a:solidFill>
+                        <a:srgbClr val="DADAF0"/>
+                      </a:solidFill>
+                      <a:prstDash val="solid"/>
+                      <a:round/>
+                      <a:headEnd type="none" w="med" len="med"/>
+                      <a:tailEnd type="none" w="med" len="med"/>
+                    </a:lnT>
+                    <a:lnB w="6350" cap="flat" cmpd="sng" algn="ctr">
+                      <a:solidFill>
+                        <a:srgbClr val="DADAF0"/>
+                      </a:solidFill>
+                      <a:prstDash val="solid"/>
+                      <a:round/>
+                      <a:headEnd type="none" w="med" len="med"/>
+                      <a:tailEnd type="none" w="med" len="med"/>
+                    </a:lnB>
+                    <a:solidFill>
+                      <a:srgbClr val="0F1033"/>
+                    </a:solidFill>
+                  </a:tcPr>
+                </a:tc>
+                <a:tc>
+                  <a:txBody>
+                    <a:bodyPr/>
+                    <a:lstStyle/>
+                    <a:p>
+                      <a:pPr algn="ctr" indent="0" marL="0">
+                        <a:buNone/>
+                      </a:pPr>
+                      <a:r>
+                        <a:rPr lang="en-US" sz="1300" b="1" dirty="0">
+                          <a:solidFill>
+                            <a:srgbClr val="FFFFFF"/>
+                          </a:solidFill>
+                          <a:latin typeface="Arial" pitchFamily="34" charset="0"/>
+                          <a:ea typeface="Arial" pitchFamily="34" charset="-122"/>
+                          <a:cs typeface="Arial" pitchFamily="34" charset="-120"/>
+                        </a:rPr>
+                        <a:t>Interest</a:t>
+                      </a:r>
+                      <a:endParaRPr lang="en-US" sz="1300" dirty="0">
+                        <a:latin typeface="Arial" charset="0"/>
+                        <a:ea typeface="Arial" charset="0"/>
+                        <a:cs typeface="Arial" charset="0"/>
+                      </a:endParaRPr>
+                    </a:p>
+                  </a:txBody>
+                  <a:tcPr marL="91440" marR="91440" marT="27432" marB="27432" anchor="ctr">
+                    <a:lnL w="6350" cap="flat" cmpd="sng" algn="ctr">
+                      <a:solidFill>
+                        <a:srgbClr val="DADAF0"/>
+                      </a:solidFill>
+                      <a:prstDash val="solid"/>
+                      <a:round/>
+                      <a:headEnd type="none" w="med" len="med"/>
+                      <a:tailEnd type="none" w="med" len="med"/>
+                    </a:lnL>
+                    <a:lnR w="6350" cap="flat" cmpd="sng" algn="ctr">
+                      <a:solidFill>
+                        <a:srgbClr val="DADAF0"/>
+                      </a:solidFill>
+                      <a:prstDash val="solid"/>
+                      <a:round/>
+                      <a:headEnd type="none" w="med" len="med"/>
+                      <a:tailEnd type="none" w="med" len="med"/>
+                    </a:lnR>
+                    <a:lnT w="6350" cap="flat" cmpd="sng" algn="ctr">
+                      <a:solidFill>
+                        <a:srgbClr val="DADAF0"/>
+                      </a:solidFill>
+                      <a:prstDash val="solid"/>
+                      <a:round/>
+                      <a:headEnd type="none" w="med" len="med"/>
+                      <a:tailEnd type="none" w="med" len="med"/>
+                    </a:lnT>
+                    <a:lnB w="6350" cap="flat" cmpd="sng" algn="ctr">
+                      <a:solidFill>
+                        <a:srgbClr val="DADAF0"/>
+                      </a:solidFill>
+                      <a:prstDash val="solid"/>
+                      <a:round/>
+                      <a:headEnd type="none" w="med" len="med"/>
+                      <a:tailEnd type="none" w="med" len="med"/>
+                    </a:lnB>
+                    <a:solidFill>
+                      <a:srgbClr val="0F1033"/>
+                    </a:solidFill>
+                  </a:tcPr>
+                </a:tc>
+                <a:tc>
+                  <a:txBody>
+                    <a:bodyPr/>
+                    <a:lstStyle/>
+                    <a:p>
+                      <a:pPr algn="ctr" indent="0" marL="0">
+                        <a:buNone/>
+                      </a:pPr>
+                      <a:r>
+                        <a:rPr lang="en-US" sz="1300" b="1" dirty="0">
+                          <a:solidFill>
+                            <a:srgbClr val="FFFFFF"/>
+                          </a:solidFill>
+                          <a:latin typeface="Arial" pitchFamily="34" charset="0"/>
+                          <a:ea typeface="Arial" pitchFamily="34" charset="-122"/>
+                          <a:cs typeface="Arial" pitchFamily="34" charset="-120"/>
+                        </a:rPr>
+                        <a:t>Margin</a:t>
+                      </a:r>
+                      <a:endParaRPr lang="en-US" sz="1300" dirty="0">
+                        <a:latin typeface="Arial" charset="0"/>
+                        <a:ea typeface="Arial" charset="0"/>
+                        <a:cs typeface="Arial" charset="0"/>
+                      </a:endParaRPr>
+                    </a:p>
+                  </a:txBody>
+                  <a:tcPr marL="91440" marR="91440" marT="27432" marB="27432" anchor="ctr">
+                    <a:lnL w="6350" cap="flat" cmpd="sng" algn="ctr">
+                      <a:solidFill>
+                        <a:srgbClr val="DADAF0"/>
+                      </a:solidFill>
+                      <a:prstDash val="solid"/>
+                      <a:round/>
+                      <a:headEnd type="none" w="med" len="med"/>
+                      <a:tailEnd type="none" w="med" len="med"/>
+                    </a:lnL>
+                    <a:lnR w="6350" cap="flat" cmpd="sng" algn="ctr">
+                      <a:solidFill>
+                        <a:srgbClr val="DADAF0"/>
+                      </a:solidFill>
+                      <a:prstDash val="solid"/>
+                      <a:round/>
+                      <a:headEnd type="none" w="med" len="med"/>
+                      <a:tailEnd type="none" w="med" len="med"/>
+                    </a:lnR>
+                    <a:lnT w="6350" cap="flat" cmpd="sng" algn="ctr">
+                      <a:solidFill>
+                        <a:srgbClr val="DADAF0"/>
+                      </a:solidFill>
+                      <a:prstDash val="solid"/>
+                      <a:round/>
+                      <a:headEnd type="none" w="med" len="med"/>
+                      <a:tailEnd type="none" w="med" len="med"/>
+                    </a:lnT>
+                    <a:lnB w="6350" cap="flat" cmpd="sng" algn="ctr">
+                      <a:solidFill>
+                        <a:srgbClr val="DADAF0"/>
+                      </a:solidFill>
+                      <a:prstDash val="solid"/>
+                      <a:round/>
+                      <a:headEnd type="none" w="med" len="med"/>
+                      <a:tailEnd type="none" w="med" len="med"/>
+                    </a:lnB>
+                    <a:solidFill>
+                      <a:srgbClr val="0F1033"/>
+                    </a:solidFill>
+                  </a:tcPr>
+                </a:tc>
+                <a:tc>
+                  <a:txBody>
+                    <a:bodyPr/>
+                    <a:lstStyle/>
+                    <a:p>
+                      <a:pPr algn="ctr" indent="0" marL="0">
+                        <a:buNone/>
+                      </a:pPr>
+                      <a:r>
+                        <a:rPr lang="en-US" sz="1300" b="1" dirty="0">
+                          <a:solidFill>
+                            <a:srgbClr val="FFFFFF"/>
+                          </a:solidFill>
+                          <a:latin typeface="Arial" pitchFamily="34" charset="0"/>
+                          <a:ea typeface="Arial" pitchFamily="34" charset="-122"/>
+                          <a:cs typeface="Arial" pitchFamily="34" charset="-120"/>
+                        </a:rPr>
+                        <a:t>Share of profit</a:t>
+                      </a:r>
+                      <a:endParaRPr lang="en-US" sz="1300" dirty="0">
+                        <a:latin typeface="Arial" charset="0"/>
+                        <a:ea typeface="Arial" charset="0"/>
+                        <a:cs typeface="Arial" charset="0"/>
+                      </a:endParaRPr>
+                    </a:p>
+                  </a:txBody>
+                  <a:tcPr marL="91440" marR="91440" marT="27432" marB="27432" anchor="ctr">
+                    <a:lnL w="6350" cap="flat" cmpd="sng" algn="ctr">
+                      <a:solidFill>
+                        <a:srgbClr val="DADAF0"/>
+                      </a:solidFill>
+                      <a:prstDash val="solid"/>
+                      <a:round/>
+                      <a:headEnd type="none" w="med" len="med"/>
+                      <a:tailEnd type="none" w="med" len="med"/>
+                    </a:lnL>
+                    <a:lnR w="6350" cap="flat" cmpd="sng" algn="ctr">
+                      <a:solidFill>
+                        <a:srgbClr val="DADAF0"/>
+                      </a:solidFill>
+                      <a:prstDash val="solid"/>
+                      <a:round/>
+                      <a:headEnd type="none" w="med" len="med"/>
+                      <a:tailEnd type="none" w="med" len="med"/>
+                    </a:lnR>
+                    <a:lnT w="6350" cap="flat" cmpd="sng" algn="ctr">
+                      <a:solidFill>
+                        <a:srgbClr val="DADAF0"/>
+                      </a:solidFill>
+                      <a:prstDash val="solid"/>
+                      <a:round/>
+                      <a:headEnd type="none" w="med" len="med"/>
+                      <a:tailEnd type="none" w="med" len="med"/>
+                    </a:lnT>
+                    <a:lnB w="6350" cap="flat" cmpd="sng" algn="ctr">
+                      <a:solidFill>
+                        <a:srgbClr val="DADAF0"/>
+                      </a:solidFill>
+                      <a:prstDash val="solid"/>
+                      <a:round/>
+                      <a:headEnd type="none" w="med" len="med"/>
+                      <a:tailEnd type="none" w="med" len="med"/>
+                    </a:lnB>
+                    <a:solidFill>
+                      <a:srgbClr val="0F1033"/>
+                    </a:solidFill>
+                  </a:tcPr>
+                </a:tc>
+              </a:tr>
+              <a:tr h="548640">
+                <a:tc>
+                  <a:txBody>
+                    <a:bodyPr/>
+                    <a:lstStyle/>
+                    <a:p>
+                      <a:pPr algn="l" indent="0" marL="0">
+                        <a:buNone/>
+                      </a:pPr>
+                      <a:r>
+                        <a:rPr lang="en-US" sz="1300" b="1" dirty="0">
+                          <a:solidFill>
+                            <a:srgbClr val="1A1A2E"/>
+                          </a:solidFill>
+                          <a:latin typeface="Arial" pitchFamily="34" charset="0"/>
+                          <a:ea typeface="Arial" pitchFamily="34" charset="-122"/>
+                          <a:cs typeface="Arial" pitchFamily="34" charset="-120"/>
+                        </a:rPr>
+                        <a:t>Interest-bearing</a:t>
+                      </a:r>
+                      <a:endParaRPr lang="en-US" sz="1300" dirty="0">
+                        <a:latin typeface="Arial" charset="0"/>
+                        <a:ea typeface="Arial" charset="0"/>
+                        <a:cs typeface="Arial" charset="0"/>
+                      </a:endParaRPr>
+                    </a:p>
+                  </a:txBody>
+                  <a:tcPr marL="91440" marR="91440" marT="27432" marB="27432" anchor="ctr">
+                    <a:lnL w="6350" cap="flat" cmpd="sng" algn="ctr">
+                      <a:solidFill>
+                        <a:srgbClr val="DADAF0"/>
+                      </a:solidFill>
+                      <a:prstDash val="solid"/>
+                      <a:round/>
+                      <a:headEnd type="none" w="med" len="med"/>
+                      <a:tailEnd type="none" w="med" len="med"/>
+                    </a:lnL>
+                    <a:lnR w="6350" cap="flat" cmpd="sng" algn="ctr">
+                      <a:solidFill>
+                        <a:srgbClr val="DADAF0"/>
+                      </a:solidFill>
+                      <a:prstDash val="solid"/>
+                      <a:round/>
+                      <a:headEnd type="none" w="med" len="med"/>
+                      <a:tailEnd type="none" w="med" len="med"/>
+                    </a:lnR>
+                    <a:lnT w="6350" cap="flat" cmpd="sng" algn="ctr">
+                      <a:solidFill>
+                        <a:srgbClr val="DADAF0"/>
+                      </a:solidFill>
+                      <a:prstDash val="solid"/>
+                      <a:round/>
+                      <a:headEnd type="none" w="med" len="med"/>
+                      <a:tailEnd type="none" w="med" len="med"/>
+                    </a:lnT>
+                    <a:lnB w="6350" cap="flat" cmpd="sng" algn="ctr">
+                      <a:solidFill>
+                        <a:srgbClr val="DADAF0"/>
+                      </a:solidFill>
+                      <a:prstDash val="solid"/>
+                      <a:round/>
+                      <a:headEnd type="none" w="med" len="med"/>
+                      <a:tailEnd type="none" w="med" len="med"/>
+                    </a:lnB>
+                    <a:solidFill>
+                      <a:srgbClr val="FFFFFF"/>
+                    </a:solidFill>
+                  </a:tcPr>
+                </a:tc>
+                <a:tc>
+                  <a:txBody>
+                    <a:bodyPr/>
+                    <a:lstStyle/>
+                    <a:p>
+                      <a:pPr algn="ctr" indent="0" marL="0">
+                        <a:buNone/>
+                      </a:pPr>
+                      <a:r>
+                        <a:rPr lang="en-US" sz="1300" dirty="0">
+                          <a:solidFill>
+                            <a:srgbClr val="1A1A2E"/>
+                          </a:solidFill>
+                          <a:latin typeface="Arial" pitchFamily="34" charset="0"/>
+                          <a:ea typeface="Arial" pitchFamily="34" charset="-122"/>
+                          <a:cs typeface="Arial" pitchFamily="34" charset="-120"/>
+                        </a:rPr>
+                        <a:t>48%</a:t>
+                      </a:r>
+                      <a:endParaRPr lang="en-US" sz="1300" dirty="0">
+                        <a:latin typeface="Arial" charset="0"/>
+                        <a:ea typeface="Arial" charset="0"/>
+                        <a:cs typeface="Arial" charset="0"/>
+                      </a:endParaRPr>
+                    </a:p>
+                  </a:txBody>
+                  <a:tcPr marL="91440" marR="91440" marT="27432" marB="27432" anchor="ctr">
+                    <a:lnL w="6350" cap="flat" cmpd="sng" algn="ctr">
+                      <a:solidFill>
+                        <a:srgbClr val="DADAF0"/>
+                      </a:solidFill>
+                      <a:prstDash val="solid"/>
+                      <a:round/>
+                      <a:headEnd type="none" w="med" len="med"/>
+                      <a:tailEnd type="none" w="med" len="med"/>
+                    </a:lnL>
+                    <a:lnR w="6350" cap="flat" cmpd="sng" algn="ctr">
+                      <a:solidFill>
+                        <a:srgbClr val="DADAF0"/>
+                      </a:solidFill>
+                      <a:prstDash val="solid"/>
+                      <a:round/>
+                      <a:headEnd type="none" w="med" len="med"/>
+                      <a:tailEnd type="none" w="med" len="med"/>
+                    </a:lnR>
+                    <a:lnT w="6350" cap="flat" cmpd="sng" algn="ctr">
+                      <a:solidFill>
+                        <a:srgbClr val="DADAF0"/>
+                      </a:solidFill>
+                      <a:prstDash val="solid"/>
+                      <a:round/>
+                      <a:headEnd type="none" w="med" len="med"/>
+                      <a:tailEnd type="none" w="med" len="med"/>
+                    </a:lnT>
+                    <a:lnB w="6350" cap="flat" cmpd="sng" algn="ctr">
+                      <a:solidFill>
+                        <a:srgbClr val="DADAF0"/>
+                      </a:solidFill>
+                      <a:prstDash val="solid"/>
+                      <a:round/>
+                      <a:headEnd type="none" w="med" len="med"/>
+                      <a:tailEnd type="none" w="med" len="med"/>
+                    </a:lnB>
+                    <a:solidFill>
+                      <a:srgbClr val="FFFFFF"/>
+                    </a:solidFill>
+                  </a:tcPr>
+                </a:tc>
+                <a:tc>
+                  <a:txBody>
+                    <a:bodyPr/>
+                    <a:lstStyle/>
+                    <a:p>
+                      <a:pPr algn="ctr" indent="0" marL="0">
+                        <a:buNone/>
+                      </a:pPr>
+                      <a:r>
+                        <a:rPr lang="en-US" sz="1300" dirty="0">
+                          <a:solidFill>
+                            <a:srgbClr val="1A1A2E"/>
+                          </a:solidFill>
+                          <a:latin typeface="Arial" pitchFamily="34" charset="0"/>
+                          <a:ea typeface="Arial" pitchFamily="34" charset="-122"/>
+                          <a:cs typeface="Arial" pitchFamily="34" charset="-120"/>
+                        </a:rPr>
+                        <a:t>58%</a:t>
+                      </a:r>
+                      <a:endParaRPr lang="en-US" sz="1300" dirty="0">
+                        <a:latin typeface="Arial" charset="0"/>
+                        <a:ea typeface="Arial" charset="0"/>
+                        <a:cs typeface="Arial" charset="0"/>
+                      </a:endParaRPr>
+                    </a:p>
+                  </a:txBody>
+                  <a:tcPr marL="91440" marR="91440" marT="27432" marB="27432" anchor="ctr">
+                    <a:lnL w="6350" cap="flat" cmpd="sng" algn="ctr">
+                      <a:solidFill>
+                        <a:srgbClr val="DADAF0"/>
+                      </a:solidFill>
+                      <a:prstDash val="solid"/>
+                      <a:round/>
+                      <a:headEnd type="none" w="med" len="med"/>
+                      <a:tailEnd type="none" w="med" len="med"/>
+                    </a:lnL>
+                    <a:lnR w="6350" cap="flat" cmpd="sng" algn="ctr">
+                      <a:solidFill>
+                        <a:srgbClr val="DADAF0"/>
+                      </a:solidFill>
+                      <a:prstDash val="solid"/>
+                      <a:round/>
+                      <a:headEnd type="none" w="med" len="med"/>
+                      <a:tailEnd type="none" w="med" len="med"/>
+                    </a:lnR>
+                    <a:lnT w="6350" cap="flat" cmpd="sng" algn="ctr">
+                      <a:solidFill>
+                        <a:srgbClr val="DADAF0"/>
+                      </a:solidFill>
+                      <a:prstDash val="solid"/>
+                      <a:round/>
+                      <a:headEnd type="none" w="med" len="med"/>
+                      <a:tailEnd type="none" w="med" len="med"/>
+                    </a:lnT>
+                    <a:lnB w="6350" cap="flat" cmpd="sng" algn="ctr">
+                      <a:solidFill>
+                        <a:srgbClr val="DADAF0"/>
+                      </a:solidFill>
+                      <a:prstDash val="solid"/>
+                      <a:round/>
+                      <a:headEnd type="none" w="med" len="med"/>
+                      <a:tailEnd type="none" w="med" len="med"/>
+                    </a:lnB>
+                    <a:solidFill>
+                      <a:srgbClr val="FFFFFF"/>
+                    </a:solidFill>
+                  </a:tcPr>
+                </a:tc>
+                <a:tc>
+                  <a:txBody>
+                    <a:bodyPr/>
+                    <a:lstStyle/>
+                    <a:p>
+                      <a:pPr algn="ctr" indent="0" marL="0">
+                        <a:buNone/>
+                      </a:pPr>
+                      <a:r>
+                        <a:rPr lang="en-US" sz="1300" dirty="0">
+                          <a:solidFill>
+                            <a:srgbClr val="1A1A2E"/>
+                          </a:solidFill>
+                          <a:latin typeface="Arial" pitchFamily="34" charset="0"/>
+                          <a:ea typeface="Arial" pitchFamily="34" charset="-122"/>
+                          <a:cs typeface="Arial" pitchFamily="34" charset="-120"/>
+                        </a:rPr>
+                        <a:t>644</a:t>
+                      </a:r>
+                      <a:endParaRPr lang="en-US" sz="1300" dirty="0">
+                        <a:latin typeface="Arial" charset="0"/>
+                        <a:ea typeface="Arial" charset="0"/>
+                        <a:cs typeface="Arial" charset="0"/>
+                      </a:endParaRPr>
+                    </a:p>
+                  </a:txBody>
+                  <a:tcPr marL="91440" marR="91440" marT="27432" marB="27432" anchor="ctr">
+                    <a:lnL w="6350" cap="flat" cmpd="sng" algn="ctr">
+                      <a:solidFill>
+                        <a:srgbClr val="DADAF0"/>
+                      </a:solidFill>
+                      <a:prstDash val="solid"/>
+                      <a:round/>
+                      <a:headEnd type="none" w="med" len="med"/>
+                      <a:tailEnd type="none" w="med" len="med"/>
+                    </a:lnL>
+                    <a:lnR w="6350" cap="flat" cmpd="sng" algn="ctr">
+                      <a:solidFill>
+                        <a:srgbClr val="DADAF0"/>
+                      </a:solidFill>
+                      <a:prstDash val="solid"/>
+                      <a:round/>
+                      <a:headEnd type="none" w="med" len="med"/>
+                      <a:tailEnd type="none" w="med" len="med"/>
+                    </a:lnR>
+                    <a:lnT w="6350" cap="flat" cmpd="sng" algn="ctr">
+                      <a:solidFill>
+                        <a:srgbClr val="DADAF0"/>
+                      </a:solidFill>
+                      <a:prstDash val="solid"/>
+                      <a:round/>
+                      <a:headEnd type="none" w="med" len="med"/>
+                      <a:tailEnd type="none" w="med" len="med"/>
+                    </a:lnT>
+                    <a:lnB w="6350" cap="flat" cmpd="sng" algn="ctr">
+                      <a:solidFill>
+                        <a:srgbClr val="DADAF0"/>
+                      </a:solidFill>
+                      <a:prstDash val="solid"/>
+                      <a:round/>
+                      <a:headEnd type="none" w="med" len="med"/>
+                      <a:tailEnd type="none" w="med" len="med"/>
+                    </a:lnB>
+                    <a:solidFill>
+                      <a:srgbClr val="FFFFFF"/>
+                    </a:solidFill>
+                  </a:tcPr>
+                </a:tc>
+                <a:tc>
+                  <a:txBody>
+                    <a:bodyPr/>
+                    <a:lstStyle/>
+                    <a:p>
+                      <a:pPr algn="ctr" indent="0" marL="0">
+                        <a:buNone/>
+                      </a:pPr>
+                      <a:r>
+                        <a:rPr lang="en-US" sz="1300" dirty="0">
+                          <a:solidFill>
+                            <a:srgbClr val="1A1A2E"/>
+                          </a:solidFill>
+                          <a:latin typeface="Arial" pitchFamily="34" charset="0"/>
+                          <a:ea typeface="Arial" pitchFamily="34" charset="-122"/>
+                          <a:cs typeface="Arial" pitchFamily="34" charset="-120"/>
+                        </a:rPr>
+                        <a:t>2.3%</a:t>
+                      </a:r>
+                      <a:endParaRPr lang="en-US" sz="1300" dirty="0">
+                        <a:latin typeface="Arial" charset="0"/>
+                        <a:ea typeface="Arial" charset="0"/>
+                        <a:cs typeface="Arial" charset="0"/>
+                      </a:endParaRPr>
+                    </a:p>
+                  </a:txBody>
+                  <a:tcPr marL="91440" marR="91440" marT="27432" marB="27432" anchor="ctr">
+                    <a:lnL w="6350" cap="flat" cmpd="sng" algn="ctr">
+                      <a:solidFill>
+                        <a:srgbClr val="DADAF0"/>
+                      </a:solidFill>
+                      <a:prstDash val="solid"/>
+                      <a:round/>
+                      <a:headEnd type="none" w="med" len="med"/>
+                      <a:tailEnd type="none" w="med" len="med"/>
+                    </a:lnL>
+                    <a:lnR w="6350" cap="flat" cmpd="sng" algn="ctr">
+                      <a:solidFill>
+                        <a:srgbClr val="DADAF0"/>
+                      </a:solidFill>
+                      <a:prstDash val="solid"/>
+                      <a:round/>
+                      <a:headEnd type="none" w="med" len="med"/>
+                      <a:tailEnd type="none" w="med" len="med"/>
+                    </a:lnR>
+                    <a:lnT w="6350" cap="flat" cmpd="sng" algn="ctr">
+                      <a:solidFill>
+                        <a:srgbClr val="DADAF0"/>
+                      </a:solidFill>
+                      <a:prstDash val="solid"/>
+                      <a:round/>
+                      <a:headEnd type="none" w="med" len="med"/>
+                      <a:tailEnd type="none" w="med" len="med"/>
+                    </a:lnT>
+                    <a:lnB w="6350" cap="flat" cmpd="sng" algn="ctr">
+                      <a:solidFill>
+                        <a:srgbClr val="DADAF0"/>
+                      </a:solidFill>
+                      <a:prstDash val="solid"/>
+                      <a:round/>
+                      <a:headEnd type="none" w="med" len="med"/>
+                      <a:tailEnd type="none" w="med" len="med"/>
+                    </a:lnB>
+                    <a:solidFill>
+                      <a:srgbClr val="FFFFFF"/>
+                    </a:solidFill>
+                  </a:tcPr>
+                </a:tc>
+                <a:tc>
+                  <a:txBody>
+                    <a:bodyPr/>
+                    <a:lstStyle/>
+                    <a:p>
+                      <a:pPr algn="ctr" indent="0" marL="0">
+                        <a:buNone/>
+                      </a:pPr>
+                      <a:r>
+                        <a:rPr lang="en-US" sz="1300" dirty="0">
+                          <a:solidFill>
+                            <a:srgbClr val="1A1A2E"/>
+                          </a:solidFill>
+                          <a:latin typeface="Arial" pitchFamily="34" charset="0"/>
+                          <a:ea typeface="Arial" pitchFamily="34" charset="-122"/>
+                          <a:cs typeface="Arial" pitchFamily="34" charset="-120"/>
+                        </a:rPr>
+                        <a:t>6.1%</a:t>
+                      </a:r>
+                      <a:endParaRPr lang="en-US" sz="1300" dirty="0">
+                        <a:latin typeface="Arial" charset="0"/>
+                        <a:ea typeface="Arial" charset="0"/>
+                        <a:cs typeface="Arial" charset="0"/>
+                      </a:endParaRPr>
+                    </a:p>
+                  </a:txBody>
+                  <a:tcPr marL="91440" marR="91440" marT="27432" marB="27432" anchor="ctr">
+                    <a:lnL w="6350" cap="flat" cmpd="sng" algn="ctr">
+                      <a:solidFill>
+                        <a:srgbClr val="DADAF0"/>
+                      </a:solidFill>
+                      <a:prstDash val="solid"/>
+                      <a:round/>
+                      <a:headEnd type="none" w="med" len="med"/>
+                      <a:tailEnd type="none" w="med" len="med"/>
+                    </a:lnL>
+                    <a:lnR w="6350" cap="flat" cmpd="sng" algn="ctr">
+                      <a:solidFill>
+                        <a:srgbClr val="DADAF0"/>
+                      </a:solidFill>
+                      <a:prstDash val="solid"/>
+                      <a:round/>
+                      <a:headEnd type="none" w="med" len="med"/>
+                      <a:tailEnd type="none" w="med" len="med"/>
+                    </a:lnR>
+                    <a:lnT w="6350" cap="flat" cmpd="sng" algn="ctr">
+                      <a:solidFill>
+                        <a:srgbClr val="DADAF0"/>
+                      </a:solidFill>
+                      <a:prstDash val="solid"/>
+                      <a:round/>
+                      <a:headEnd type="none" w="med" len="med"/>
+                      <a:tailEnd type="none" w="med" len="med"/>
+                    </a:lnT>
+                    <a:lnB w="6350" cap="flat" cmpd="sng" algn="ctr">
+                      <a:solidFill>
+                        <a:srgbClr val="DADAF0"/>
+                      </a:solidFill>
+                      <a:prstDash val="solid"/>
+                      <a:round/>
+                      <a:headEnd type="none" w="med" len="med"/>
+                      <a:tailEnd type="none" w="med" len="med"/>
+                    </a:lnB>
+                    <a:solidFill>
+                      <a:srgbClr val="FFFFFF"/>
+                    </a:solidFill>
+                  </a:tcPr>
+                </a:tc>
+                <a:tc>
+                  <a:txBody>
+                    <a:bodyPr/>
+                    <a:lstStyle/>
+                    <a:p>
+                      <a:pPr algn="ctr" indent="0" marL="0">
+                        <a:buNone/>
+                      </a:pPr>
+                      <a:r>
+                        <a:rPr lang="en-US" sz="1300" b="1" dirty="0">
+                          <a:solidFill>
+                            <a:srgbClr val="1E8A4C"/>
+                          </a:solidFill>
+                          <a:latin typeface="Arial" pitchFamily="34" charset="0"/>
+                          <a:ea typeface="Arial" pitchFamily="34" charset="-122"/>
+                          <a:cs typeface="Arial" pitchFamily="34" charset="-120"/>
+                        </a:rPr>
+                        <a:t>7.4%</a:t>
+                      </a:r>
+                      <a:endParaRPr lang="en-US" sz="1300" dirty="0">
+                        <a:latin typeface="Arial" charset="0"/>
+                        <a:ea typeface="Arial" charset="0"/>
+                        <a:cs typeface="Arial" charset="0"/>
+                      </a:endParaRPr>
+                    </a:p>
+                  </a:txBody>
+                  <a:tcPr marL="91440" marR="91440" marT="27432" marB="27432" anchor="ctr">
+                    <a:lnL w="6350" cap="flat" cmpd="sng" algn="ctr">
+                      <a:solidFill>
+                        <a:srgbClr val="DADAF0"/>
+                      </a:solidFill>
+                      <a:prstDash val="solid"/>
+                      <a:round/>
+                      <a:headEnd type="none" w="med" len="med"/>
+                      <a:tailEnd type="none" w="med" len="med"/>
+                    </a:lnL>
+                    <a:lnR w="6350" cap="flat" cmpd="sng" algn="ctr">
+                      <a:solidFill>
+                        <a:srgbClr val="DADAF0"/>
+                      </a:solidFill>
+                      <a:prstDash val="solid"/>
+                      <a:round/>
+                      <a:headEnd type="none" w="med" len="med"/>
+                      <a:tailEnd type="none" w="med" len="med"/>
+                    </a:lnR>
+                    <a:lnT w="6350" cap="flat" cmpd="sng" algn="ctr">
+                      <a:solidFill>
+                        <a:srgbClr val="DADAF0"/>
+                      </a:solidFill>
+                      <a:prstDash val="solid"/>
+                      <a:round/>
+                      <a:headEnd type="none" w="med" len="med"/>
+                      <a:tailEnd type="none" w="med" len="med"/>
+                    </a:lnT>
+                    <a:lnB w="6350" cap="flat" cmpd="sng" algn="ctr">
+                      <a:solidFill>
+                        <a:srgbClr val="DADAF0"/>
+                      </a:solidFill>
+                      <a:prstDash val="solid"/>
+                      <a:round/>
+                      <a:headEnd type="none" w="med" len="med"/>
+                      <a:tailEnd type="none" w="med" len="med"/>
+                    </a:lnB>
+                    <a:solidFill>
+                      <a:srgbClr val="FFFFFF"/>
+                    </a:solidFill>
+                  </a:tcPr>
+                </a:tc>
+                <a:tc>
+                  <a:txBody>
+                    <a:bodyPr/>
+                    <a:lstStyle/>
+                    <a:p>
+                      <a:pPr algn="ctr" indent="0" marL="0">
+                        <a:buNone/>
+                      </a:pPr>
+                      <a:r>
+                        <a:rPr lang="en-US" sz="1300" b="1" dirty="0">
+                          <a:solidFill>
+                            <a:srgbClr val="1E8A4C"/>
+                          </a:solidFill>
+                          <a:latin typeface="Arial" pitchFamily="34" charset="0"/>
+                          <a:ea typeface="Arial" pitchFamily="34" charset="-122"/>
+                          <a:cs typeface="Arial" pitchFamily="34" charset="-120"/>
+                        </a:rPr>
+                        <a:t>9.9%</a:t>
+                      </a:r>
+                      <a:endParaRPr lang="en-US" sz="1300" dirty="0">
+                        <a:latin typeface="Arial" charset="0"/>
+                        <a:ea typeface="Arial" charset="0"/>
+                        <a:cs typeface="Arial" charset="0"/>
+                      </a:endParaRPr>
+                    </a:p>
+                  </a:txBody>
+                  <a:tcPr marL="91440" marR="91440" marT="27432" marB="27432" anchor="ctr">
+                    <a:lnL w="6350" cap="flat" cmpd="sng" algn="ctr">
+                      <a:solidFill>
+                        <a:srgbClr val="DADAF0"/>
+                      </a:solidFill>
+                      <a:prstDash val="solid"/>
+                      <a:round/>
+                      <a:headEnd type="none" w="med" len="med"/>
+                      <a:tailEnd type="none" w="med" len="med"/>
+                    </a:lnL>
+                    <a:lnR w="6350" cap="flat" cmpd="sng" algn="ctr">
+                      <a:solidFill>
+                        <a:srgbClr val="DADAF0"/>
+                      </a:solidFill>
+                      <a:prstDash val="solid"/>
+                      <a:round/>
+                      <a:headEnd type="none" w="med" len="med"/>
+                      <a:tailEnd type="none" w="med" len="med"/>
+                    </a:lnR>
+                    <a:lnT w="6350" cap="flat" cmpd="sng" algn="ctr">
+                      <a:solidFill>
+                        <a:srgbClr val="DADAF0"/>
+                      </a:solidFill>
+                      <a:prstDash val="solid"/>
+                      <a:round/>
+                      <a:headEnd type="none" w="med" len="med"/>
+                      <a:tailEnd type="none" w="med" len="med"/>
+                    </a:lnT>
+                    <a:lnB w="6350" cap="flat" cmpd="sng" algn="ctr">
+                      <a:solidFill>
+                        <a:srgbClr val="DADAF0"/>
+                      </a:solidFill>
+                      <a:prstDash val="solid"/>
+                      <a:round/>
+                      <a:headEnd type="none" w="med" len="med"/>
+                      <a:tailEnd type="none" w="med" len="med"/>
+                    </a:lnB>
+                    <a:solidFill>
+                      <a:srgbClr val="FFFFFF"/>
+                    </a:solidFill>
+                  </a:tcPr>
+                </a:tc>
+                <a:tc>
+                  <a:txBody>
+                    <a:bodyPr/>
+                    <a:lstStyle/>
+                    <a:p>
+                      <a:pPr algn="ctr" indent="0" marL="0">
+                        <a:buNone/>
+                      </a:pPr>
+                      <a:r>
+                        <a:rPr lang="en-US" sz="1300" b="1" dirty="0">
+                          <a:solidFill>
+                            <a:srgbClr val="1E8A4C"/>
+                          </a:solidFill>
+                          <a:latin typeface="Arial" pitchFamily="34" charset="0"/>
+                          <a:ea typeface="Arial" pitchFamily="34" charset="-122"/>
+                          <a:cs typeface="Arial" pitchFamily="34" charset="-120"/>
+                        </a:rPr>
+                        <a:t>82%</a:t>
+                      </a:r>
+                      <a:endParaRPr lang="en-US" sz="1300" dirty="0">
+                        <a:latin typeface="Arial" charset="0"/>
+                        <a:ea typeface="Arial" charset="0"/>
+                        <a:cs typeface="Arial" charset="0"/>
+                      </a:endParaRPr>
+                    </a:p>
+                  </a:txBody>
+                  <a:tcPr marL="91440" marR="91440" marT="27432" marB="27432" anchor="ctr">
+                    <a:lnL w="6350" cap="flat" cmpd="sng" algn="ctr">
+                      <a:solidFill>
+                        <a:srgbClr val="DADAF0"/>
+                      </a:solidFill>
+                      <a:prstDash val="solid"/>
+                      <a:round/>
+                      <a:headEnd type="none" w="med" len="med"/>
+                      <a:tailEnd type="none" w="med" len="med"/>
+                    </a:lnL>
+                    <a:lnR w="6350" cap="flat" cmpd="sng" algn="ctr">
+                      <a:solidFill>
+                        <a:srgbClr val="DADAF0"/>
+                      </a:solidFill>
+                      <a:prstDash val="solid"/>
+                      <a:round/>
+                      <a:headEnd type="none" w="med" len="med"/>
+                      <a:tailEnd type="none" w="med" len="med"/>
+                    </a:lnR>
+                    <a:lnT w="6350" cap="flat" cmpd="sng" algn="ctr">
+                      <a:solidFill>
+                        <a:srgbClr val="DADAF0"/>
+                      </a:solidFill>
+                      <a:prstDash val="solid"/>
+                      <a:round/>
+                      <a:headEnd type="none" w="med" len="med"/>
+                      <a:tailEnd type="none" w="med" len="med"/>
+                    </a:lnT>
+                    <a:lnB w="6350" cap="flat" cmpd="sng" algn="ctr">
+                      <a:solidFill>
+                        <a:srgbClr val="DADAF0"/>
+                      </a:solidFill>
+                      <a:prstDash val="solid"/>
+                      <a:round/>
+                      <a:headEnd type="none" w="med" len="med"/>
+                      <a:tailEnd type="none" w="med" len="med"/>
+                    </a:lnB>
+                    <a:solidFill>
+                      <a:srgbClr val="FFFFFF"/>
+                    </a:solidFill>
+                  </a:tcPr>
+                </a:tc>
+              </a:tr>
+              <a:tr h="548640">
+                <a:tc>
+                  <a:txBody>
+                    <a:bodyPr/>
+                    <a:lstStyle/>
+                    <a:p>
+                      <a:pPr algn="l" indent="0" marL="0">
+                        <a:buNone/>
+                      </a:pPr>
+                      <a:r>
+                        <a:rPr lang="en-US" sz="1300" b="1" dirty="0">
+                          <a:solidFill>
+                            <a:srgbClr val="1A1A2E"/>
+                          </a:solidFill>
+                          <a:latin typeface="Arial" pitchFamily="34" charset="0"/>
+                          <a:ea typeface="Arial" pitchFamily="34" charset="-122"/>
+                          <a:cs typeface="Arial" pitchFamily="34" charset="-120"/>
+                        </a:rPr>
+                        <a:t>0% APR</a:t>
+                      </a:r>
+                      <a:endParaRPr lang="en-US" sz="1300" dirty="0">
+                        <a:latin typeface="Arial" charset="0"/>
+                        <a:ea typeface="Arial" charset="0"/>
+                        <a:cs typeface="Arial" charset="0"/>
+                      </a:endParaRPr>
+                    </a:p>
+                  </a:txBody>
+                  <a:tcPr marL="91440" marR="91440" marT="27432" marB="27432" anchor="ctr">
+                    <a:lnL w="6350" cap="flat" cmpd="sng" algn="ctr">
+                      <a:solidFill>
+                        <a:srgbClr val="DADAF0"/>
+                      </a:solidFill>
+                      <a:prstDash val="solid"/>
+                      <a:round/>
+                      <a:headEnd type="none" w="med" len="med"/>
+                      <a:tailEnd type="none" w="med" len="med"/>
+                    </a:lnL>
+                    <a:lnR w="6350" cap="flat" cmpd="sng" algn="ctr">
+                      <a:solidFill>
+                        <a:srgbClr val="DADAF0"/>
+                      </a:solidFill>
+                      <a:prstDash val="solid"/>
+                      <a:round/>
+                      <a:headEnd type="none" w="med" len="med"/>
+                      <a:tailEnd type="none" w="med" len="med"/>
+                    </a:lnR>
+                    <a:lnT w="6350" cap="flat" cmpd="sng" algn="ctr">
+                      <a:solidFill>
+                        <a:srgbClr val="DADAF0"/>
+                      </a:solidFill>
+                      <a:prstDash val="solid"/>
+                      <a:round/>
+                      <a:headEnd type="none" w="med" len="med"/>
+                      <a:tailEnd type="none" w="med" len="med"/>
+                    </a:lnT>
+                    <a:lnB w="6350" cap="flat" cmpd="sng" algn="ctr">
+                      <a:solidFill>
+                        <a:srgbClr val="DADAF0"/>
+                      </a:solidFill>
+                      <a:prstDash val="solid"/>
+                      <a:round/>
+                      <a:headEnd type="none" w="med" len="med"/>
+                      <a:tailEnd type="none" w="med" len="med"/>
+                    </a:lnB>
+                    <a:solidFill>
+                      <a:srgbClr val="F6F6FE"/>
+                    </a:solidFill>
+                  </a:tcPr>
+                </a:tc>
+                <a:tc>
+                  <a:txBody>
+                    <a:bodyPr/>
+                    <a:lstStyle/>
+                    <a:p>
+                      <a:pPr algn="ctr" indent="0" marL="0">
+                        <a:buNone/>
+                      </a:pPr>
+                      <a:r>
+                        <a:rPr lang="en-US" sz="1300" dirty="0">
+                          <a:solidFill>
+                            <a:srgbClr val="1A1A2E"/>
+                          </a:solidFill>
+                          <a:latin typeface="Arial" pitchFamily="34" charset="0"/>
+                          <a:ea typeface="Arial" pitchFamily="34" charset="-122"/>
+                          <a:cs typeface="Arial" pitchFamily="34" charset="-120"/>
+                        </a:rPr>
+                        <a:t>11%</a:t>
+                      </a:r>
+                      <a:endParaRPr lang="en-US" sz="1300" dirty="0">
+                        <a:latin typeface="Arial" charset="0"/>
+                        <a:ea typeface="Arial" charset="0"/>
+                        <a:cs typeface="Arial" charset="0"/>
+                      </a:endParaRPr>
+                    </a:p>
+                  </a:txBody>
+                  <a:tcPr marL="91440" marR="91440" marT="27432" marB="27432" anchor="ctr">
+                    <a:lnL w="6350" cap="flat" cmpd="sng" algn="ctr">
+                      <a:solidFill>
+                        <a:srgbClr val="DADAF0"/>
+                      </a:solidFill>
+                      <a:prstDash val="solid"/>
+                      <a:round/>
+                      <a:headEnd type="none" w="med" len="med"/>
+                      <a:tailEnd type="none" w="med" len="med"/>
+                    </a:lnL>
+                    <a:lnR w="6350" cap="flat" cmpd="sng" algn="ctr">
+                      <a:solidFill>
+                        <a:srgbClr val="DADAF0"/>
+                      </a:solidFill>
+                      <a:prstDash val="solid"/>
+                      <a:round/>
+                      <a:headEnd type="none" w="med" len="med"/>
+                      <a:tailEnd type="none" w="med" len="med"/>
+                    </a:lnR>
+                    <a:lnT w="6350" cap="flat" cmpd="sng" algn="ctr">
+                      <a:solidFill>
+                        <a:srgbClr val="DADAF0"/>
+                      </a:solidFill>
+                      <a:prstDash val="solid"/>
+                      <a:round/>
+                      <a:headEnd type="none" w="med" len="med"/>
+                      <a:tailEnd type="none" w="med" len="med"/>
+                    </a:lnT>
+                    <a:lnB w="6350" cap="flat" cmpd="sng" algn="ctr">
+                      <a:solidFill>
+                        <a:srgbClr val="DADAF0"/>
+                      </a:solidFill>
+                      <a:prstDash val="solid"/>
+                      <a:round/>
+                      <a:headEnd type="none" w="med" len="med"/>
+                      <a:tailEnd type="none" w="med" len="med"/>
+                    </a:lnB>
+                    <a:solidFill>
+                      <a:srgbClr val="F6F6FE"/>
+                    </a:solidFill>
+                  </a:tcPr>
+                </a:tc>
+                <a:tc>
+                  <a:txBody>
+                    <a:bodyPr/>
+                    <a:lstStyle/>
+                    <a:p>
+                      <a:pPr algn="ctr" indent="0" marL="0">
+                        <a:buNone/>
+                      </a:pPr>
+                      <a:r>
+                        <a:rPr lang="en-US" sz="1300" dirty="0">
+                          <a:solidFill>
+                            <a:srgbClr val="1A1A2E"/>
+                          </a:solidFill>
+                          <a:latin typeface="Arial" pitchFamily="34" charset="0"/>
+                          <a:ea typeface="Arial" pitchFamily="34" charset="-122"/>
+                          <a:cs typeface="Arial" pitchFamily="34" charset="-120"/>
+                        </a:rPr>
+                        <a:t>18%</a:t>
+                      </a:r>
+                      <a:endParaRPr lang="en-US" sz="1300" dirty="0">
+                        <a:latin typeface="Arial" charset="0"/>
+                        <a:ea typeface="Arial" charset="0"/>
+                        <a:cs typeface="Arial" charset="0"/>
+                      </a:endParaRPr>
+                    </a:p>
+                  </a:txBody>
+                  <a:tcPr marL="91440" marR="91440" marT="27432" marB="27432" anchor="ctr">
+                    <a:lnL w="6350" cap="flat" cmpd="sng" algn="ctr">
+                      <a:solidFill>
+                        <a:srgbClr val="DADAF0"/>
+                      </a:solidFill>
+                      <a:prstDash val="solid"/>
+                      <a:round/>
+                      <a:headEnd type="none" w="med" len="med"/>
+                      <a:tailEnd type="none" w="med" len="med"/>
+                    </a:lnL>
+                    <a:lnR w="6350" cap="flat" cmpd="sng" algn="ctr">
+                      <a:solidFill>
+                        <a:srgbClr val="DADAF0"/>
+                      </a:solidFill>
+                      <a:prstDash val="solid"/>
+                      <a:round/>
+                      <a:headEnd type="none" w="med" len="med"/>
+                      <a:tailEnd type="none" w="med" len="med"/>
+                    </a:lnR>
+                    <a:lnT w="6350" cap="flat" cmpd="sng" algn="ctr">
+                      <a:solidFill>
+                        <a:srgbClr val="DADAF0"/>
+                      </a:solidFill>
+                      <a:prstDash val="solid"/>
+                      <a:round/>
+                      <a:headEnd type="none" w="med" len="med"/>
+                      <a:tailEnd type="none" w="med" len="med"/>
+                    </a:lnT>
+                    <a:lnB w="6350" cap="flat" cmpd="sng" algn="ctr">
+                      <a:solidFill>
+                        <a:srgbClr val="DADAF0"/>
+                      </a:solidFill>
+                      <a:prstDash val="solid"/>
+                      <a:round/>
+                      <a:headEnd type="none" w="med" len="med"/>
+                      <a:tailEnd type="none" w="med" len="med"/>
+                    </a:lnB>
+                    <a:solidFill>
+                      <a:srgbClr val="F6F6FE"/>
+                    </a:solidFill>
+                  </a:tcPr>
+                </a:tc>
+                <a:tc>
+                  <a:txBody>
+                    <a:bodyPr/>
+                    <a:lstStyle/>
+                    <a:p>
+                      <a:pPr algn="ctr" indent="0" marL="0">
+                        <a:buNone/>
+                      </a:pPr>
+                      <a:r>
+                        <a:rPr lang="en-US" sz="1300" b="1" dirty="0">
+                          <a:solidFill>
+                            <a:srgbClr val="1E8A4C"/>
+                          </a:solidFill>
+                          <a:latin typeface="Arial" pitchFamily="34" charset="0"/>
+                          <a:ea typeface="Arial" pitchFamily="34" charset="-122"/>
+                          <a:cs typeface="Arial" pitchFamily="34" charset="-120"/>
+                        </a:rPr>
+                        <a:t>683</a:t>
+                      </a:r>
+                      <a:endParaRPr lang="en-US" sz="1300" dirty="0">
+                        <a:latin typeface="Arial" charset="0"/>
+                        <a:ea typeface="Arial" charset="0"/>
+                        <a:cs typeface="Arial" charset="0"/>
+                      </a:endParaRPr>
+                    </a:p>
+                  </a:txBody>
+                  <a:tcPr marL="91440" marR="91440" marT="27432" marB="27432" anchor="ctr">
+                    <a:lnL w="6350" cap="flat" cmpd="sng" algn="ctr">
+                      <a:solidFill>
+                        <a:srgbClr val="DADAF0"/>
+                      </a:solidFill>
+                      <a:prstDash val="solid"/>
+                      <a:round/>
+                      <a:headEnd type="none" w="med" len="med"/>
+                      <a:tailEnd type="none" w="med" len="med"/>
+                    </a:lnL>
+                    <a:lnR w="6350" cap="flat" cmpd="sng" algn="ctr">
+                      <a:solidFill>
+                        <a:srgbClr val="DADAF0"/>
+                      </a:solidFill>
+                      <a:prstDash val="solid"/>
+                      <a:round/>
+                      <a:headEnd type="none" w="med" len="med"/>
+                      <a:tailEnd type="none" w="med" len="med"/>
+                    </a:lnR>
+                    <a:lnT w="6350" cap="flat" cmpd="sng" algn="ctr">
+                      <a:solidFill>
+                        <a:srgbClr val="DADAF0"/>
+                      </a:solidFill>
+                      <a:prstDash val="solid"/>
+                      <a:round/>
+                      <a:headEnd type="none" w="med" len="med"/>
+                      <a:tailEnd type="none" w="med" len="med"/>
+                    </a:lnT>
+                    <a:lnB w="6350" cap="flat" cmpd="sng" algn="ctr">
+                      <a:solidFill>
+                        <a:srgbClr val="DADAF0"/>
+                      </a:solidFill>
+                      <a:prstDash val="solid"/>
+                      <a:round/>
+                      <a:headEnd type="none" w="med" len="med"/>
+                      <a:tailEnd type="none" w="med" len="med"/>
+                    </a:lnB>
+                    <a:solidFill>
+                      <a:srgbClr val="F6F6FE"/>
+                    </a:solidFill>
+                  </a:tcPr>
+                </a:tc>
+                <a:tc>
+                  <a:txBody>
+                    <a:bodyPr/>
+                    <a:lstStyle/>
+                    <a:p>
+                      <a:pPr algn="ctr" indent="0" marL="0">
+                        <a:buNone/>
+                      </a:pPr>
+                      <a:r>
+                        <a:rPr lang="en-US" sz="1300" b="1" dirty="0">
+                          <a:solidFill>
+                            <a:srgbClr val="1E8A4C"/>
+                          </a:solidFill>
+                          <a:latin typeface="Arial" pitchFamily="34" charset="0"/>
+                          <a:ea typeface="Arial" pitchFamily="34" charset="-122"/>
+                          <a:cs typeface="Arial" pitchFamily="34" charset="-120"/>
+                        </a:rPr>
+                        <a:t>1.0%</a:t>
+                      </a:r>
+                      <a:endParaRPr lang="en-US" sz="1300" dirty="0">
+                        <a:latin typeface="Arial" charset="0"/>
+                        <a:ea typeface="Arial" charset="0"/>
+                        <a:cs typeface="Arial" charset="0"/>
+                      </a:endParaRPr>
+                    </a:p>
+                  </a:txBody>
+                  <a:tcPr marL="91440" marR="91440" marT="27432" marB="27432" anchor="ctr">
+                    <a:lnL w="6350" cap="flat" cmpd="sng" algn="ctr">
+                      <a:solidFill>
+                        <a:srgbClr val="DADAF0"/>
+                      </a:solidFill>
+                      <a:prstDash val="solid"/>
+                      <a:round/>
+                      <a:headEnd type="none" w="med" len="med"/>
+                      <a:tailEnd type="none" w="med" len="med"/>
+                    </a:lnL>
+                    <a:lnR w="6350" cap="flat" cmpd="sng" algn="ctr">
+                      <a:solidFill>
+                        <a:srgbClr val="DADAF0"/>
+                      </a:solidFill>
+                      <a:prstDash val="solid"/>
+                      <a:round/>
+                      <a:headEnd type="none" w="med" len="med"/>
+                      <a:tailEnd type="none" w="med" len="med"/>
+                    </a:lnR>
+                    <a:lnT w="6350" cap="flat" cmpd="sng" algn="ctr">
+                      <a:solidFill>
+                        <a:srgbClr val="DADAF0"/>
+                      </a:solidFill>
+                      <a:prstDash val="solid"/>
+                      <a:round/>
+                      <a:headEnd type="none" w="med" len="med"/>
+                      <a:tailEnd type="none" w="med" len="med"/>
+                    </a:lnT>
+                    <a:lnB w="6350" cap="flat" cmpd="sng" algn="ctr">
+                      <a:solidFill>
+                        <a:srgbClr val="DADAF0"/>
+                      </a:solidFill>
+                      <a:prstDash val="solid"/>
+                      <a:round/>
+                      <a:headEnd type="none" w="med" len="med"/>
+                      <a:tailEnd type="none" w="med" len="med"/>
+                    </a:lnB>
+                    <a:solidFill>
+                      <a:srgbClr val="F6F6FE"/>
+                    </a:solidFill>
+                  </a:tcPr>
+                </a:tc>
+                <a:tc>
+                  <a:txBody>
+                    <a:bodyPr/>
+                    <a:lstStyle/>
+                    <a:p>
+                      <a:pPr algn="ctr" indent="0" marL="0">
+                        <a:buNone/>
+                      </a:pPr>
+                      <a:r>
+                        <a:rPr lang="en-US" sz="1300" b="1" dirty="0">
+                          <a:solidFill>
+                            <a:srgbClr val="C93B3B"/>
+                          </a:solidFill>
+                          <a:latin typeface="Arial" pitchFamily="34" charset="0"/>
+                          <a:ea typeface="Arial" pitchFamily="34" charset="-122"/>
+                          <a:cs typeface="Arial" pitchFamily="34" charset="-120"/>
+                        </a:rPr>
+                        <a:t>5.7%</a:t>
+                      </a:r>
+                      <a:endParaRPr lang="en-US" sz="1300" dirty="0">
+                        <a:latin typeface="Arial" charset="0"/>
+                        <a:ea typeface="Arial" charset="0"/>
+                        <a:cs typeface="Arial" charset="0"/>
+                      </a:endParaRPr>
+                    </a:p>
+                  </a:txBody>
+                  <a:tcPr marL="91440" marR="91440" marT="27432" marB="27432" anchor="ctr">
+                    <a:lnL w="6350" cap="flat" cmpd="sng" algn="ctr">
+                      <a:solidFill>
+                        <a:srgbClr val="DADAF0"/>
+                      </a:solidFill>
+                      <a:prstDash val="solid"/>
+                      <a:round/>
+                      <a:headEnd type="none" w="med" len="med"/>
+                      <a:tailEnd type="none" w="med" len="med"/>
+                    </a:lnL>
+                    <a:lnR w="6350" cap="flat" cmpd="sng" algn="ctr">
+                      <a:solidFill>
+                        <a:srgbClr val="DADAF0"/>
+                      </a:solidFill>
+                      <a:prstDash val="solid"/>
+                      <a:round/>
+                      <a:headEnd type="none" w="med" len="med"/>
+                      <a:tailEnd type="none" w="med" len="med"/>
+                    </a:lnR>
+                    <a:lnT w="6350" cap="flat" cmpd="sng" algn="ctr">
+                      <a:solidFill>
+                        <a:srgbClr val="DADAF0"/>
+                      </a:solidFill>
+                      <a:prstDash val="solid"/>
+                      <a:round/>
+                      <a:headEnd type="none" w="med" len="med"/>
+                      <a:tailEnd type="none" w="med" len="med"/>
+                    </a:lnT>
+                    <a:lnB w="6350" cap="flat" cmpd="sng" algn="ctr">
+                      <a:solidFill>
+                        <a:srgbClr val="DADAF0"/>
+                      </a:solidFill>
+                      <a:prstDash val="solid"/>
+                      <a:round/>
+                      <a:headEnd type="none" w="med" len="med"/>
+                      <a:tailEnd type="none" w="med" len="med"/>
+                    </a:lnB>
+                    <a:solidFill>
+                      <a:srgbClr val="F6F6FE"/>
+                    </a:solidFill>
+                  </a:tcPr>
+                </a:tc>
+                <a:tc>
+                  <a:txBody>
+                    <a:bodyPr/>
+                    <a:lstStyle/>
+                    <a:p>
+                      <a:pPr algn="ctr" indent="0" marL="0">
+                        <a:buNone/>
+                      </a:pPr>
+                      <a:r>
+                        <a:rPr lang="en-US" sz="1300" dirty="0">
+                          <a:solidFill>
+                            <a:srgbClr val="1A1A2E"/>
+                          </a:solidFill>
+                          <a:latin typeface="Arial" pitchFamily="34" charset="0"/>
+                          <a:ea typeface="Arial" pitchFamily="34" charset="-122"/>
+                          <a:cs typeface="Arial" pitchFamily="34" charset="-120"/>
+                        </a:rPr>
+                        <a:t>—</a:t>
+                      </a:r>
+                      <a:endParaRPr lang="en-US" sz="1300" dirty="0">
+                        <a:latin typeface="Arial" charset="0"/>
+                        <a:ea typeface="Arial" charset="0"/>
+                        <a:cs typeface="Arial" charset="0"/>
+                      </a:endParaRPr>
+                    </a:p>
+                  </a:txBody>
+                  <a:tcPr marL="91440" marR="91440" marT="27432" marB="27432" anchor="ctr">
+                    <a:lnL w="6350" cap="flat" cmpd="sng" algn="ctr">
+                      <a:solidFill>
+                        <a:srgbClr val="DADAF0"/>
+                      </a:solidFill>
+                      <a:prstDash val="solid"/>
+                      <a:round/>
+                      <a:headEnd type="none" w="med" len="med"/>
+                      <a:tailEnd type="none" w="med" len="med"/>
+                    </a:lnL>
+                    <a:lnR w="6350" cap="flat" cmpd="sng" algn="ctr">
+                      <a:solidFill>
+                        <a:srgbClr val="DADAF0"/>
+                      </a:solidFill>
+                      <a:prstDash val="solid"/>
+                      <a:round/>
+                      <a:headEnd type="none" w="med" len="med"/>
+                      <a:tailEnd type="none" w="med" len="med"/>
+                    </a:lnR>
+                    <a:lnT w="6350" cap="flat" cmpd="sng" algn="ctr">
+                      <a:solidFill>
+                        <a:srgbClr val="DADAF0"/>
+                      </a:solidFill>
+                      <a:prstDash val="solid"/>
+                      <a:round/>
+                      <a:headEnd type="none" w="med" len="med"/>
+                      <a:tailEnd type="none" w="med" len="med"/>
+                    </a:lnT>
+                    <a:lnB w="6350" cap="flat" cmpd="sng" algn="ctr">
+                      <a:solidFill>
+                        <a:srgbClr val="DADAF0"/>
+                      </a:solidFill>
+                      <a:prstDash val="solid"/>
+                      <a:round/>
+                      <a:headEnd type="none" w="med" len="med"/>
+                      <a:tailEnd type="none" w="med" len="med"/>
+                    </a:lnB>
+                    <a:solidFill>
+                      <a:srgbClr val="F6F6FE"/>
+                    </a:solidFill>
+                  </a:tcPr>
+                </a:tc>
+                <a:tc>
+                  <a:txBody>
+                    <a:bodyPr/>
+                    <a:lstStyle/>
+                    <a:p>
+                      <a:pPr algn="ctr" indent="0" marL="0">
+                        <a:buNone/>
+                      </a:pPr>
+                      <a:r>
+                        <a:rPr lang="en-US" sz="1300" b="1" dirty="0">
+                          <a:solidFill>
+                            <a:srgbClr val="C93B3B"/>
+                          </a:solidFill>
+                          <a:latin typeface="Arial" pitchFamily="34" charset="0"/>
+                          <a:ea typeface="Arial" pitchFamily="34" charset="-122"/>
+                          <a:cs typeface="Arial" pitchFamily="34" charset="-120"/>
+                        </a:rPr>
+                        <a:t>3.4%</a:t>
+                      </a:r>
+                      <a:endParaRPr lang="en-US" sz="1300" dirty="0">
+                        <a:latin typeface="Arial" charset="0"/>
+                        <a:ea typeface="Arial" charset="0"/>
+                        <a:cs typeface="Arial" charset="0"/>
+                      </a:endParaRPr>
+                    </a:p>
+                  </a:txBody>
+                  <a:tcPr marL="91440" marR="91440" marT="27432" marB="27432" anchor="ctr">
+                    <a:lnL w="6350" cap="flat" cmpd="sng" algn="ctr">
+                      <a:solidFill>
+                        <a:srgbClr val="DADAF0"/>
+                      </a:solidFill>
+                      <a:prstDash val="solid"/>
+                      <a:round/>
+                      <a:headEnd type="none" w="med" len="med"/>
+                      <a:tailEnd type="none" w="med" len="med"/>
+                    </a:lnL>
+                    <a:lnR w="6350" cap="flat" cmpd="sng" algn="ctr">
+                      <a:solidFill>
+                        <a:srgbClr val="DADAF0"/>
+                      </a:solidFill>
+                      <a:prstDash val="solid"/>
+                      <a:round/>
+                      <a:headEnd type="none" w="med" len="med"/>
+                      <a:tailEnd type="none" w="med" len="med"/>
+                    </a:lnR>
+                    <a:lnT w="6350" cap="flat" cmpd="sng" algn="ctr">
+                      <a:solidFill>
+                        <a:srgbClr val="DADAF0"/>
+                      </a:solidFill>
+                      <a:prstDash val="solid"/>
+                      <a:round/>
+                      <a:headEnd type="none" w="med" len="med"/>
+                      <a:tailEnd type="none" w="med" len="med"/>
+                    </a:lnT>
+                    <a:lnB w="6350" cap="flat" cmpd="sng" algn="ctr">
+                      <a:solidFill>
+                        <a:srgbClr val="DADAF0"/>
+                      </a:solidFill>
+                      <a:prstDash val="solid"/>
+                      <a:round/>
+                      <a:headEnd type="none" w="med" len="med"/>
+                      <a:tailEnd type="none" w="med" len="med"/>
+                    </a:lnB>
+                    <a:solidFill>
+                      <a:srgbClr val="F6F6FE"/>
+                    </a:solidFill>
+                  </a:tcPr>
+                </a:tc>
+                <a:tc>
+                  <a:txBody>
+                    <a:bodyPr/>
+                    <a:lstStyle/>
+                    <a:p>
+                      <a:pPr algn="ctr" indent="0" marL="0">
+                        <a:buNone/>
+                      </a:pPr>
+                      <a:r>
+                        <a:rPr lang="en-US" sz="1300" dirty="0">
+                          <a:solidFill>
+                            <a:srgbClr val="1A1A2E"/>
+                          </a:solidFill>
+                          <a:latin typeface="Arial" pitchFamily="34" charset="0"/>
+                          <a:ea typeface="Arial" pitchFamily="34" charset="-122"/>
+                          <a:cs typeface="Arial" pitchFamily="34" charset="-120"/>
+                        </a:rPr>
+                        <a:t>9%</a:t>
+                      </a:r>
+                      <a:endParaRPr lang="en-US" sz="1300" dirty="0">
+                        <a:latin typeface="Arial" charset="0"/>
+                        <a:ea typeface="Arial" charset="0"/>
+                        <a:cs typeface="Arial" charset="0"/>
+                      </a:endParaRPr>
+                    </a:p>
+                  </a:txBody>
+                  <a:tcPr marL="91440" marR="91440" marT="27432" marB="27432" anchor="ctr">
+                    <a:lnL w="6350" cap="flat" cmpd="sng" algn="ctr">
+                      <a:solidFill>
+                        <a:srgbClr val="DADAF0"/>
+                      </a:solidFill>
+                      <a:prstDash val="solid"/>
+                      <a:round/>
+                      <a:headEnd type="none" w="med" len="med"/>
+                      <a:tailEnd type="none" w="med" len="med"/>
+                    </a:lnL>
+                    <a:lnR w="6350" cap="flat" cmpd="sng" algn="ctr">
+                      <a:solidFill>
+                        <a:srgbClr val="DADAF0"/>
+                      </a:solidFill>
+                      <a:prstDash val="solid"/>
+                      <a:round/>
+                      <a:headEnd type="none" w="med" len="med"/>
+                      <a:tailEnd type="none" w="med" len="med"/>
+                    </a:lnR>
+                    <a:lnT w="6350" cap="flat" cmpd="sng" algn="ctr">
+                      <a:solidFill>
+                        <a:srgbClr val="DADAF0"/>
+                      </a:solidFill>
+                      <a:prstDash val="solid"/>
+                      <a:round/>
+                      <a:headEnd type="none" w="med" len="med"/>
+                      <a:tailEnd type="none" w="med" len="med"/>
+                    </a:lnT>
+                    <a:lnB w="6350" cap="flat" cmpd="sng" algn="ctr">
+                      <a:solidFill>
+                        <a:srgbClr val="DADAF0"/>
+                      </a:solidFill>
+                      <a:prstDash val="solid"/>
+                      <a:round/>
+                      <a:headEnd type="none" w="med" len="med"/>
+                      <a:tailEnd type="none" w="med" len="med"/>
+                    </a:lnB>
+                    <a:solidFill>
+                      <a:srgbClr val="F6F6FE"/>
+                    </a:solidFill>
+                  </a:tcPr>
+                </a:tc>
+              </a:tr>
+              <a:tr h="548640">
+                <a:tc>
+                  <a:txBody>
+                    <a:bodyPr/>
+                    <a:lstStyle/>
+                    <a:p>
+                      <a:pPr algn="l" indent="0" marL="0">
+                        <a:buNone/>
+                      </a:pPr>
+                      <a:r>
+                        <a:rPr lang="en-US" sz="1300" b="1" dirty="0">
+                          <a:solidFill>
+                            <a:srgbClr val="1A1A2E"/>
+                          </a:solidFill>
+                          <a:latin typeface="Arial" pitchFamily="34" charset="0"/>
+                          <a:ea typeface="Arial" pitchFamily="34" charset="-122"/>
+                          <a:cs typeface="Arial" pitchFamily="34" charset="-120"/>
+                        </a:rPr>
+                        <a:t>Split Pay</a:t>
+                      </a:r>
+                      <a:endParaRPr lang="en-US" sz="1300" dirty="0">
+                        <a:latin typeface="Arial" charset="0"/>
+                        <a:ea typeface="Arial" charset="0"/>
+                        <a:cs typeface="Arial" charset="0"/>
+                      </a:endParaRPr>
+                    </a:p>
+                  </a:txBody>
+                  <a:tcPr marL="91440" marR="91440" marT="27432" marB="27432" anchor="ctr">
+                    <a:lnL w="6350" cap="flat" cmpd="sng" algn="ctr">
+                      <a:solidFill>
+                        <a:srgbClr val="DADAF0"/>
+                      </a:solidFill>
+                      <a:prstDash val="solid"/>
+                      <a:round/>
+                      <a:headEnd type="none" w="med" len="med"/>
+                      <a:tailEnd type="none" w="med" len="med"/>
+                    </a:lnL>
+                    <a:lnR w="6350" cap="flat" cmpd="sng" algn="ctr">
+                      <a:solidFill>
+                        <a:srgbClr val="DADAF0"/>
+                      </a:solidFill>
+                      <a:prstDash val="solid"/>
+                      <a:round/>
+                      <a:headEnd type="none" w="med" len="med"/>
+                      <a:tailEnd type="none" w="med" len="med"/>
+                    </a:lnR>
+                    <a:lnT w="6350" cap="flat" cmpd="sng" algn="ctr">
+                      <a:solidFill>
+                        <a:srgbClr val="DADAF0"/>
+                      </a:solidFill>
+                      <a:prstDash val="solid"/>
+                      <a:round/>
+                      <a:headEnd type="none" w="med" len="med"/>
+                      <a:tailEnd type="none" w="med" len="med"/>
+                    </a:lnT>
+                    <a:lnB w="6350" cap="flat" cmpd="sng" algn="ctr">
+                      <a:solidFill>
+                        <a:srgbClr val="DADAF0"/>
+                      </a:solidFill>
+                      <a:prstDash val="solid"/>
+                      <a:round/>
+                      <a:headEnd type="none" w="med" len="med"/>
+                      <a:tailEnd type="none" w="med" len="med"/>
+                    </a:lnB>
+                    <a:solidFill>
+                      <a:srgbClr val="FFFFFF"/>
+                    </a:solidFill>
+                  </a:tcPr>
+                </a:tc>
+                <a:tc>
+                  <a:txBody>
+                    <a:bodyPr/>
+                    <a:lstStyle/>
+                    <a:p>
+                      <a:pPr algn="ctr" indent="0" marL="0">
+                        <a:buNone/>
+                      </a:pPr>
+                      <a:r>
+                        <a:rPr lang="en-US" sz="1300" dirty="0">
+                          <a:solidFill>
+                            <a:srgbClr val="1A1A2E"/>
+                          </a:solidFill>
+                          <a:latin typeface="Arial" pitchFamily="34" charset="0"/>
+                          <a:ea typeface="Arial" pitchFamily="34" charset="-122"/>
+                          <a:cs typeface="Arial" pitchFamily="34" charset="-120"/>
+                        </a:rPr>
+                        <a:t>41%</a:t>
+                      </a:r>
+                      <a:endParaRPr lang="en-US" sz="1300" dirty="0">
+                        <a:latin typeface="Arial" charset="0"/>
+                        <a:ea typeface="Arial" charset="0"/>
+                        <a:cs typeface="Arial" charset="0"/>
+                      </a:endParaRPr>
+                    </a:p>
+                  </a:txBody>
+                  <a:tcPr marL="91440" marR="91440" marT="27432" marB="27432" anchor="ctr">
+                    <a:lnL w="6350" cap="flat" cmpd="sng" algn="ctr">
+                      <a:solidFill>
+                        <a:srgbClr val="DADAF0"/>
+                      </a:solidFill>
+                      <a:prstDash val="solid"/>
+                      <a:round/>
+                      <a:headEnd type="none" w="med" len="med"/>
+                      <a:tailEnd type="none" w="med" len="med"/>
+                    </a:lnL>
+                    <a:lnR w="6350" cap="flat" cmpd="sng" algn="ctr">
+                      <a:solidFill>
+                        <a:srgbClr val="DADAF0"/>
+                      </a:solidFill>
+                      <a:prstDash val="solid"/>
+                      <a:round/>
+                      <a:headEnd type="none" w="med" len="med"/>
+                      <a:tailEnd type="none" w="med" len="med"/>
+                    </a:lnR>
+                    <a:lnT w="6350" cap="flat" cmpd="sng" algn="ctr">
+                      <a:solidFill>
+                        <a:srgbClr val="DADAF0"/>
+                      </a:solidFill>
+                      <a:prstDash val="solid"/>
+                      <a:round/>
+                      <a:headEnd type="none" w="med" len="med"/>
+                      <a:tailEnd type="none" w="med" len="med"/>
+                    </a:lnT>
+                    <a:lnB w="6350" cap="flat" cmpd="sng" algn="ctr">
+                      <a:solidFill>
+                        <a:srgbClr val="DADAF0"/>
+                      </a:solidFill>
+                      <a:prstDash val="solid"/>
+                      <a:round/>
+                      <a:headEnd type="none" w="med" len="med"/>
+                      <a:tailEnd type="none" w="med" len="med"/>
+                    </a:lnB>
+                    <a:solidFill>
+                      <a:srgbClr val="FFFFFF"/>
+                    </a:solidFill>
+                  </a:tcPr>
+                </a:tc>
+                <a:tc>
+                  <a:txBody>
+                    <a:bodyPr/>
+                    <a:lstStyle/>
+                    <a:p>
+                      <a:pPr algn="ctr" indent="0" marL="0">
+                        <a:buNone/>
+                      </a:pPr>
+                      <a:r>
+                        <a:rPr lang="en-US" sz="1300" dirty="0">
+                          <a:solidFill>
+                            <a:srgbClr val="1A1A2E"/>
+                          </a:solidFill>
+                          <a:latin typeface="Arial" pitchFamily="34" charset="0"/>
+                          <a:ea typeface="Arial" pitchFamily="34" charset="-122"/>
+                          <a:cs typeface="Arial" pitchFamily="34" charset="-120"/>
+                        </a:rPr>
+                        <a:t>24%</a:t>
+                      </a:r>
+                      <a:endParaRPr lang="en-US" sz="1300" dirty="0">
+                        <a:latin typeface="Arial" charset="0"/>
+                        <a:ea typeface="Arial" charset="0"/>
+                        <a:cs typeface="Arial" charset="0"/>
+                      </a:endParaRPr>
+                    </a:p>
+                  </a:txBody>
+                  <a:tcPr marL="91440" marR="91440" marT="27432" marB="27432" anchor="ctr">
+                    <a:lnL w="6350" cap="flat" cmpd="sng" algn="ctr">
+                      <a:solidFill>
+                        <a:srgbClr val="DADAF0"/>
+                      </a:solidFill>
+                      <a:prstDash val="solid"/>
+                      <a:round/>
+                      <a:headEnd type="none" w="med" len="med"/>
+                      <a:tailEnd type="none" w="med" len="med"/>
+                    </a:lnL>
+                    <a:lnR w="6350" cap="flat" cmpd="sng" algn="ctr">
+                      <a:solidFill>
+                        <a:srgbClr val="DADAF0"/>
+                      </a:solidFill>
+                      <a:prstDash val="solid"/>
+                      <a:round/>
+                      <a:headEnd type="none" w="med" len="med"/>
+                      <a:tailEnd type="none" w="med" len="med"/>
+                    </a:lnR>
+                    <a:lnT w="6350" cap="flat" cmpd="sng" algn="ctr">
+                      <a:solidFill>
+                        <a:srgbClr val="DADAF0"/>
+                      </a:solidFill>
+                      <a:prstDash val="solid"/>
+                      <a:round/>
+                      <a:headEnd type="none" w="med" len="med"/>
+                      <a:tailEnd type="none" w="med" len="med"/>
+                    </a:lnT>
+                    <a:lnB w="6350" cap="flat" cmpd="sng" algn="ctr">
+                      <a:solidFill>
+                        <a:srgbClr val="DADAF0"/>
+                      </a:solidFill>
+                      <a:prstDash val="solid"/>
+                      <a:round/>
+                      <a:headEnd type="none" w="med" len="med"/>
+                      <a:tailEnd type="none" w="med" len="med"/>
+                    </a:lnB>
+                    <a:solidFill>
+                      <a:srgbClr val="FFFFFF"/>
+                    </a:solidFill>
+                  </a:tcPr>
+                </a:tc>
+                <a:tc>
+                  <a:txBody>
+                    <a:bodyPr/>
+                    <a:lstStyle/>
+                    <a:p>
+                      <a:pPr algn="ctr" indent="0" marL="0">
+                        <a:buNone/>
+                      </a:pPr>
+                      <a:r>
+                        <a:rPr lang="en-US" sz="1300" dirty="0">
+                          <a:solidFill>
+                            <a:srgbClr val="1A1A2E"/>
+                          </a:solidFill>
+                          <a:latin typeface="Arial" pitchFamily="34" charset="0"/>
+                          <a:ea typeface="Arial" pitchFamily="34" charset="-122"/>
+                          <a:cs typeface="Arial" pitchFamily="34" charset="-120"/>
+                        </a:rPr>
+                        <a:t>656</a:t>
+                      </a:r>
+                      <a:endParaRPr lang="en-US" sz="1300" dirty="0">
+                        <a:latin typeface="Arial" charset="0"/>
+                        <a:ea typeface="Arial" charset="0"/>
+                        <a:cs typeface="Arial" charset="0"/>
+                      </a:endParaRPr>
+                    </a:p>
+                  </a:txBody>
+                  <a:tcPr marL="91440" marR="91440" marT="27432" marB="27432" anchor="ctr">
+                    <a:lnL w="6350" cap="flat" cmpd="sng" algn="ctr">
+                      <a:solidFill>
+                        <a:srgbClr val="DADAF0"/>
+                      </a:solidFill>
+                      <a:prstDash val="solid"/>
+                      <a:round/>
+                      <a:headEnd type="none" w="med" len="med"/>
+                      <a:tailEnd type="none" w="med" len="med"/>
+                    </a:lnL>
+                    <a:lnR w="6350" cap="flat" cmpd="sng" algn="ctr">
+                      <a:solidFill>
+                        <a:srgbClr val="DADAF0"/>
+                      </a:solidFill>
+                      <a:prstDash val="solid"/>
+                      <a:round/>
+                      <a:headEnd type="none" w="med" len="med"/>
+                      <a:tailEnd type="none" w="med" len="med"/>
+                    </a:lnR>
+                    <a:lnT w="6350" cap="flat" cmpd="sng" algn="ctr">
+                      <a:solidFill>
+                        <a:srgbClr val="DADAF0"/>
+                      </a:solidFill>
+                      <a:prstDash val="solid"/>
+                      <a:round/>
+                      <a:headEnd type="none" w="med" len="med"/>
+                      <a:tailEnd type="none" w="med" len="med"/>
+                    </a:lnT>
+                    <a:lnB w="6350" cap="flat" cmpd="sng" algn="ctr">
+                      <a:solidFill>
+                        <a:srgbClr val="DADAF0"/>
+                      </a:solidFill>
+                      <a:prstDash val="solid"/>
+                      <a:round/>
+                      <a:headEnd type="none" w="med" len="med"/>
+                      <a:tailEnd type="none" w="med" len="med"/>
+                    </a:lnB>
+                    <a:solidFill>
+                      <a:srgbClr val="FFFFFF"/>
+                    </a:solidFill>
+                  </a:tcPr>
+                </a:tc>
+                <a:tc>
+                  <a:txBody>
+                    <a:bodyPr/>
+                    <a:lstStyle/>
+                    <a:p>
+                      <a:pPr algn="ctr" indent="0" marL="0">
+                        <a:buNone/>
+                      </a:pPr>
+                      <a:r>
+                        <a:rPr lang="en-US" sz="1300" b="1" dirty="0">
+                          <a:solidFill>
+                            <a:srgbClr val="C93B3B"/>
+                          </a:solidFill>
+                          <a:latin typeface="Arial" pitchFamily="34" charset="0"/>
+                          <a:ea typeface="Arial" pitchFamily="34" charset="-122"/>
+                          <a:cs typeface="Arial" pitchFamily="34" charset="-120"/>
+                        </a:rPr>
+                        <a:t>2.2%</a:t>
+                      </a:r>
+                      <a:endParaRPr lang="en-US" sz="1300" dirty="0">
+                        <a:latin typeface="Arial" charset="0"/>
+                        <a:ea typeface="Arial" charset="0"/>
+                        <a:cs typeface="Arial" charset="0"/>
+                      </a:endParaRPr>
+                    </a:p>
+                  </a:txBody>
+                  <a:tcPr marL="91440" marR="91440" marT="27432" marB="27432" anchor="ctr">
+                    <a:lnL w="6350" cap="flat" cmpd="sng" algn="ctr">
+                      <a:solidFill>
+                        <a:srgbClr val="DADAF0"/>
+                      </a:solidFill>
+                      <a:prstDash val="solid"/>
+                      <a:round/>
+                      <a:headEnd type="none" w="med" len="med"/>
+                      <a:tailEnd type="none" w="med" len="med"/>
+                    </a:lnL>
+                    <a:lnR w="6350" cap="flat" cmpd="sng" algn="ctr">
+                      <a:solidFill>
+                        <a:srgbClr val="DADAF0"/>
+                      </a:solidFill>
+                      <a:prstDash val="solid"/>
+                      <a:round/>
+                      <a:headEnd type="none" w="med" len="med"/>
+                      <a:tailEnd type="none" w="med" len="med"/>
+                    </a:lnR>
+                    <a:lnT w="6350" cap="flat" cmpd="sng" algn="ctr">
+                      <a:solidFill>
+                        <a:srgbClr val="DADAF0"/>
+                      </a:solidFill>
+                      <a:prstDash val="solid"/>
+                      <a:round/>
+                      <a:headEnd type="none" w="med" len="med"/>
+                      <a:tailEnd type="none" w="med" len="med"/>
+                    </a:lnT>
+                    <a:lnB w="6350" cap="flat" cmpd="sng" algn="ctr">
+                      <a:solidFill>
+                        <a:srgbClr val="DADAF0"/>
+                      </a:solidFill>
+                      <a:prstDash val="solid"/>
+                      <a:round/>
+                      <a:headEnd type="none" w="med" len="med"/>
+                      <a:tailEnd type="none" w="med" len="med"/>
+                    </a:lnB>
+                    <a:solidFill>
+                      <a:srgbClr val="FFFFFF"/>
+                    </a:solidFill>
+                  </a:tcPr>
+                </a:tc>
+                <a:tc>
+                  <a:txBody>
+                    <a:bodyPr/>
+                    <a:lstStyle/>
+                    <a:p>
+                      <a:pPr algn="ctr" indent="0" marL="0">
+                        <a:buNone/>
+                      </a:pPr>
+                      <a:r>
+                        <a:rPr lang="en-US" sz="1300" dirty="0">
+                          <a:solidFill>
+                            <a:srgbClr val="1A1A2E"/>
+                          </a:solidFill>
+                          <a:latin typeface="Arial" pitchFamily="34" charset="0"/>
+                          <a:ea typeface="Arial" pitchFamily="34" charset="-122"/>
+                          <a:cs typeface="Arial" pitchFamily="34" charset="-120"/>
+                        </a:rPr>
+                        <a:t>5.0%</a:t>
+                      </a:r>
+                      <a:endParaRPr lang="en-US" sz="1300" dirty="0">
+                        <a:latin typeface="Arial" charset="0"/>
+                        <a:ea typeface="Arial" charset="0"/>
+                        <a:cs typeface="Arial" charset="0"/>
+                      </a:endParaRPr>
+                    </a:p>
+                  </a:txBody>
+                  <a:tcPr marL="91440" marR="91440" marT="27432" marB="27432" anchor="ctr">
+                    <a:lnL w="6350" cap="flat" cmpd="sng" algn="ctr">
+                      <a:solidFill>
+                        <a:srgbClr val="DADAF0"/>
+                      </a:solidFill>
+                      <a:prstDash val="solid"/>
+                      <a:round/>
+                      <a:headEnd type="none" w="med" len="med"/>
+                      <a:tailEnd type="none" w="med" len="med"/>
+                    </a:lnL>
+                    <a:lnR w="6350" cap="flat" cmpd="sng" algn="ctr">
+                      <a:solidFill>
+                        <a:srgbClr val="DADAF0"/>
+                      </a:solidFill>
+                      <a:prstDash val="solid"/>
+                      <a:round/>
+                      <a:headEnd type="none" w="med" len="med"/>
+                      <a:tailEnd type="none" w="med" len="med"/>
+                    </a:lnR>
+                    <a:lnT w="6350" cap="flat" cmpd="sng" algn="ctr">
+                      <a:solidFill>
+                        <a:srgbClr val="DADAF0"/>
+                      </a:solidFill>
+                      <a:prstDash val="solid"/>
+                      <a:round/>
+                      <a:headEnd type="none" w="med" len="med"/>
+                      <a:tailEnd type="none" w="med" len="med"/>
+                    </a:lnT>
+                    <a:lnB w="6350" cap="flat" cmpd="sng" algn="ctr">
+                      <a:solidFill>
+                        <a:srgbClr val="DADAF0"/>
+                      </a:solidFill>
+                      <a:prstDash val="solid"/>
+                      <a:round/>
+                      <a:headEnd type="none" w="med" len="med"/>
+                      <a:tailEnd type="none" w="med" len="med"/>
+                    </a:lnB>
+                    <a:solidFill>
+                      <a:srgbClr val="FFFFFF"/>
+                    </a:solidFill>
+                  </a:tcPr>
+                </a:tc>
+                <a:tc>
+                  <a:txBody>
+                    <a:bodyPr/>
+                    <a:lstStyle/>
+                    <a:p>
+                      <a:pPr algn="ctr" indent="0" marL="0">
+                        <a:buNone/>
+                      </a:pPr>
+                      <a:r>
+                        <a:rPr lang="en-US" sz="1300" dirty="0">
+                          <a:solidFill>
+                            <a:srgbClr val="1A1A2E"/>
+                          </a:solidFill>
+                          <a:latin typeface="Arial" pitchFamily="34" charset="0"/>
+                          <a:ea typeface="Arial" pitchFamily="34" charset="-122"/>
+                          <a:cs typeface="Arial" pitchFamily="34" charset="-120"/>
+                        </a:rPr>
+                        <a:t>—</a:t>
+                      </a:r>
+                      <a:endParaRPr lang="en-US" sz="1300" dirty="0">
+                        <a:latin typeface="Arial" charset="0"/>
+                        <a:ea typeface="Arial" charset="0"/>
+                        <a:cs typeface="Arial" charset="0"/>
+                      </a:endParaRPr>
+                    </a:p>
+                  </a:txBody>
+                  <a:tcPr marL="91440" marR="91440" marT="27432" marB="27432" anchor="ctr">
+                    <a:lnL w="6350" cap="flat" cmpd="sng" algn="ctr">
+                      <a:solidFill>
+                        <a:srgbClr val="DADAF0"/>
+                      </a:solidFill>
+                      <a:prstDash val="solid"/>
+                      <a:round/>
+                      <a:headEnd type="none" w="med" len="med"/>
+                      <a:tailEnd type="none" w="med" len="med"/>
+                    </a:lnL>
+                    <a:lnR w="6350" cap="flat" cmpd="sng" algn="ctr">
+                      <a:solidFill>
+                        <a:srgbClr val="DADAF0"/>
+                      </a:solidFill>
+                      <a:prstDash val="solid"/>
+                      <a:round/>
+                      <a:headEnd type="none" w="med" len="med"/>
+                      <a:tailEnd type="none" w="med" len="med"/>
+                    </a:lnR>
+                    <a:lnT w="6350" cap="flat" cmpd="sng" algn="ctr">
+                      <a:solidFill>
+                        <a:srgbClr val="DADAF0"/>
+                      </a:solidFill>
+                      <a:prstDash val="solid"/>
+                      <a:round/>
+                      <a:headEnd type="none" w="med" len="med"/>
+                      <a:tailEnd type="none" w="med" len="med"/>
+                    </a:lnT>
+                    <a:lnB w="6350" cap="flat" cmpd="sng" algn="ctr">
+                      <a:solidFill>
+                        <a:srgbClr val="DADAF0"/>
+                      </a:solidFill>
+                      <a:prstDash val="solid"/>
+                      <a:round/>
+                      <a:headEnd type="none" w="med" len="med"/>
+                      <a:tailEnd type="none" w="med" len="med"/>
+                    </a:lnB>
+                    <a:solidFill>
+                      <a:srgbClr val="FFFFFF"/>
+                    </a:solidFill>
+                  </a:tcPr>
+                </a:tc>
+                <a:tc>
+                  <a:txBody>
+                    <a:bodyPr/>
+                    <a:lstStyle/>
+                    <a:p>
+                      <a:pPr algn="ctr" indent="0" marL="0">
+                        <a:buNone/>
+                      </a:pPr>
+                      <a:r>
+                        <a:rPr lang="en-US" sz="1300" b="1" dirty="0">
+                          <a:solidFill>
+                            <a:srgbClr val="C93B3B"/>
+                          </a:solidFill>
+                          <a:latin typeface="Arial" pitchFamily="34" charset="0"/>
+                          <a:ea typeface="Arial" pitchFamily="34" charset="-122"/>
+                          <a:cs typeface="Arial" pitchFamily="34" charset="-120"/>
+                        </a:rPr>
+                        <a:t>2.6%</a:t>
+                      </a:r>
+                      <a:endParaRPr lang="en-US" sz="1300" dirty="0">
+                        <a:latin typeface="Arial" charset="0"/>
+                        <a:ea typeface="Arial" charset="0"/>
+                        <a:cs typeface="Arial" charset="0"/>
+                      </a:endParaRPr>
+                    </a:p>
+                  </a:txBody>
+                  <a:tcPr marL="91440" marR="91440" marT="27432" marB="27432" anchor="ctr">
+                    <a:lnL w="6350" cap="flat" cmpd="sng" algn="ctr">
+                      <a:solidFill>
+                        <a:srgbClr val="DADAF0"/>
+                      </a:solidFill>
+                      <a:prstDash val="solid"/>
+                      <a:round/>
+                      <a:headEnd type="none" w="med" len="med"/>
+                      <a:tailEnd type="none" w="med" len="med"/>
+                    </a:lnL>
+                    <a:lnR w="6350" cap="flat" cmpd="sng" algn="ctr">
+                      <a:solidFill>
+                        <a:srgbClr val="DADAF0"/>
+                      </a:solidFill>
+                      <a:prstDash val="solid"/>
+                      <a:round/>
+                      <a:headEnd type="none" w="med" len="med"/>
+                      <a:tailEnd type="none" w="med" len="med"/>
+                    </a:lnR>
+                    <a:lnT w="6350" cap="flat" cmpd="sng" algn="ctr">
+                      <a:solidFill>
+                        <a:srgbClr val="DADAF0"/>
+                      </a:solidFill>
+                      <a:prstDash val="solid"/>
+                      <a:round/>
+                      <a:headEnd type="none" w="med" len="med"/>
+                      <a:tailEnd type="none" w="med" len="med"/>
+                    </a:lnT>
+                    <a:lnB w="6350" cap="flat" cmpd="sng" algn="ctr">
+                      <a:solidFill>
+                        <a:srgbClr val="DADAF0"/>
+                      </a:solidFill>
+                      <a:prstDash val="solid"/>
+                      <a:round/>
+                      <a:headEnd type="none" w="med" len="med"/>
+                      <a:tailEnd type="none" w="med" len="med"/>
+                    </a:lnB>
+                    <a:solidFill>
+                      <a:srgbClr val="FFFFFF"/>
+                    </a:solidFill>
+                  </a:tcPr>
+                </a:tc>
+                <a:tc>
+                  <a:txBody>
+                    <a:bodyPr/>
+                    <a:lstStyle/>
+                    <a:p>
+                      <a:pPr algn="ctr" indent="0" marL="0">
+                        <a:buNone/>
+                      </a:pPr>
+                      <a:r>
+                        <a:rPr lang="en-US" sz="1300" dirty="0">
+                          <a:solidFill>
+                            <a:srgbClr val="1A1A2E"/>
+                          </a:solidFill>
+                          <a:latin typeface="Arial" pitchFamily="34" charset="0"/>
+                          <a:ea typeface="Arial" pitchFamily="34" charset="-122"/>
+                          <a:cs typeface="Arial" pitchFamily="34" charset="-120"/>
+                        </a:rPr>
+                        <a:t>9%</a:t>
+                      </a:r>
+                      <a:endParaRPr lang="en-US" sz="1300" dirty="0">
+                        <a:latin typeface="Arial" charset="0"/>
+                        <a:ea typeface="Arial" charset="0"/>
+                        <a:cs typeface="Arial" charset="0"/>
+                      </a:endParaRPr>
+                    </a:p>
+                  </a:txBody>
+                  <a:tcPr marL="91440" marR="91440" marT="27432" marB="27432" anchor="ctr">
+                    <a:lnL w="6350" cap="flat" cmpd="sng" algn="ctr">
+                      <a:solidFill>
+                        <a:srgbClr val="DADAF0"/>
+                      </a:solidFill>
+                      <a:prstDash val="solid"/>
+                      <a:round/>
+                      <a:headEnd type="none" w="med" len="med"/>
+                      <a:tailEnd type="none" w="med" len="med"/>
+                    </a:lnL>
+                    <a:lnR w="6350" cap="flat" cmpd="sng" algn="ctr">
+                      <a:solidFill>
+                        <a:srgbClr val="DADAF0"/>
+                      </a:solidFill>
+                      <a:prstDash val="solid"/>
+                      <a:round/>
+                      <a:headEnd type="none" w="med" len="med"/>
+                      <a:tailEnd type="none" w="med" len="med"/>
+                    </a:lnR>
+                    <a:lnT w="6350" cap="flat" cmpd="sng" algn="ctr">
+                      <a:solidFill>
+                        <a:srgbClr val="DADAF0"/>
+                      </a:solidFill>
+                      <a:prstDash val="solid"/>
+                      <a:round/>
+                      <a:headEnd type="none" w="med" len="med"/>
+                      <a:tailEnd type="none" w="med" len="med"/>
+                    </a:lnT>
+                    <a:lnB w="6350" cap="flat" cmpd="sng" algn="ctr">
+                      <a:solidFill>
+                        <a:srgbClr val="DADAF0"/>
+                      </a:solidFill>
+                      <a:prstDash val="solid"/>
+                      <a:round/>
+                      <a:headEnd type="none" w="med" len="med"/>
+                      <a:tailEnd type="none" w="med" len="med"/>
+                    </a:lnB>
+                    <a:solidFill>
+                      <a:srgbClr val="FFFFFF"/>
+                    </a:solidFill>
+                  </a:tcPr>
+                </a:tc>
+              </a:tr>
+            </a:tbl>
+          </a:graphicData>
+        </a:graphic>
+      </p:graphicFrame>
+      <p:sp>
+        <p:nvSpPr>
+          <p:cNvPr id="5" name="Shape 2"/>
+          <p:cNvSpPr/>
+          <p:nvPr/>
+        </p:nvSpPr>
+        <p:spPr>
+          <a:xfrm>
+            <a:off x="548640" y="3840480"/>
+            <a:ext cx="3515258" cy="1874520"/>
+          </a:xfrm>
+          <a:prstGeom prst="roundRect">
+            <a:avLst>
+              <a:gd name="adj" fmla="val 5854"/>
+            </a:avLst>
+          </a:prstGeom>
+          <a:solidFill>
+            <a:srgbClr val="F6F6FE"/>
+          </a:solidFill>
+          <a:ln w="12700">
+            <a:solidFill>
+              <a:srgbClr val="F6F6FE"/>
+            </a:solidFill>
+            <a:prstDash val="solid"/>
+          </a:ln>
+        </p:spPr>
+      </p:sp>
+      <p:sp>
+        <p:nvSpPr>
+          <p:cNvPr id="6" name="Text 3"/>
+          <p:cNvSpPr txBox="1"/>
+          <p:nvPr/>
+        </p:nvSpPr>
+        <p:spPr>
+          <a:xfrm>
+            <a:off x="777240" y="3977640"/>
+            <a:ext cx="3058058" cy="365760"/>
+          </a:xfrm>
+          <a:prstGeom prst="rect">
+            <a:avLst/>
+          </a:prstGeom>
+          <a:noFill/>
+          <a:ln/>
+        </p:spPr>
+        <p:txBody>
+          <a:bodyPr wrap="square" lIns="0" tIns="0" rIns="0" bIns="0" rtlCol="0" anchor="ctr"/>
+          <a:lstStyle/>
+          <a:p>
+            <a:pPr indent="0" marL="0">
+              <a:buNone/>
+            </a:pPr>
+            <a:r>
+              <a:rPr lang="en-US" sz="1400" b="1" dirty="0">
+                <a:solidFill>
+                  <a:srgbClr val="C93B3B"/>
+                </a:solidFill>
+                <a:latin typeface="Arial" pitchFamily="34" charset="0"/>
+                <a:ea typeface="Arial" pitchFamily="34" charset="-122"/>
+                <a:cs typeface="Arial" pitchFamily="34" charset="-120"/>
+              </a:rPr>
+              <a:t>0% APR is under-priced</a:t>
+            </a:r>
+            <a:endParaRPr lang="en-US" sz="1400" dirty="0"/>
+          </a:p>
+        </p:txBody>
+      </p:sp>
+      <p:sp>
+        <p:nvSpPr>
+          <p:cNvPr id="7" name="Text 4"/>
+          <p:cNvSpPr txBox="1"/>
+          <p:nvPr/>
+        </p:nvSpPr>
+        <p:spPr>
+          <a:xfrm>
+            <a:off x="777240" y="4389120"/>
+            <a:ext cx="3058058" cy="1234440"/>
+          </a:xfrm>
+          <a:prstGeom prst="rect">
+            <a:avLst/>
+          </a:prstGeom>
+          <a:noFill/>
+          <a:ln/>
+        </p:spPr>
+        <p:txBody>
+          <a:bodyPr wrap="square" lIns="0" tIns="0" rIns="0" bIns="0" rtlCol="0" anchor="t"/>
+          <a:lstStyle/>
+          <a:p>
+            <a:pPr indent="0" marL="0">
+              <a:buNone/>
+            </a:pPr>
+            <a:r>
+              <a:rPr lang="en-US" sz="1200" dirty="0">
+                <a:solidFill>
+                  <a:srgbClr val="1A1A2E"/>
+                </a:solidFill>
+                <a:latin typeface="Arial" pitchFamily="34" charset="0"/>
+                <a:ea typeface="Arial" pitchFamily="34" charset="-122"/>
+                <a:cs typeface="Arial" pitchFamily="34" charset="-120"/>
+              </a:rPr>
+              <a:t>Lowest risk (FICO 683, 1.0% loss), but no interest and a 12–18 month term to fund. The promo is meant to be paid for by a higher merchant fee — yet at the same promo merchants its fee averages 5.0% vs 5.4% for interest-bearing.</a:t>
+            </a:r>
+            <a:endParaRPr lang="en-US" sz="1200" dirty="0"/>
+          </a:p>
+        </p:txBody>
+      </p:sp>
+      <p:sp>
+        <p:nvSpPr>
+          <p:cNvPr id="8" name="Shape 5"/>
+          <p:cNvSpPr/>
+          <p:nvPr/>
+        </p:nvSpPr>
+        <p:spPr>
+          <a:xfrm>
+            <a:off x="4338218" y="3840480"/>
+            <a:ext cx="3515258" cy="1874520"/>
+          </a:xfrm>
+          <a:prstGeom prst="roundRect">
+            <a:avLst>
+              <a:gd name="adj" fmla="val 5854"/>
+            </a:avLst>
+          </a:prstGeom>
+          <a:solidFill>
+            <a:srgbClr val="F6F6FE"/>
+          </a:solidFill>
+          <a:ln w="12700">
+            <a:solidFill>
+              <a:srgbClr val="F6F6FE"/>
+            </a:solidFill>
+            <a:prstDash val="solid"/>
+          </a:ln>
+        </p:spPr>
+      </p:sp>
+      <p:sp>
+        <p:nvSpPr>
+          <p:cNvPr id="9" name="Text 6"/>
+          <p:cNvSpPr txBox="1"/>
+          <p:nvPr/>
+        </p:nvSpPr>
+        <p:spPr>
+          <a:xfrm>
+            <a:off x="4566818" y="3977640"/>
+            <a:ext cx="3058058" cy="365760"/>
+          </a:xfrm>
+          <a:prstGeom prst="rect">
+            <a:avLst/>
+          </a:prstGeom>
+          <a:noFill/>
+          <a:ln/>
+        </p:spPr>
+        <p:txBody>
+          <a:bodyPr wrap="square" lIns="0" tIns="0" rIns="0" bIns="0" rtlCol="0" anchor="ctr"/>
+          <a:lstStyle/>
+          <a:p>
+            <a:pPr indent="0" marL="0">
+              <a:buNone/>
+            </a:pPr>
+            <a:r>
+              <a:rPr lang="en-US" sz="1400" b="1" dirty="0">
+                <a:solidFill>
+                  <a:srgbClr val="4A4AF4"/>
+                </a:solidFill>
+                <a:latin typeface="Arial" pitchFamily="34" charset="0"/>
+                <a:ea typeface="Arial" pitchFamily="34" charset="-122"/>
+                <a:cs typeface="Arial" pitchFamily="34" charset="-120"/>
+              </a:rPr>
+              <a:t>Split Pay is an entry product</a:t>
+            </a:r>
+            <a:endParaRPr lang="en-US" sz="1400" dirty="0"/>
+          </a:p>
+        </p:txBody>
+      </p:sp>
+      <p:sp>
+        <p:nvSpPr>
+          <p:cNvPr id="10" name="Text 7"/>
+          <p:cNvSpPr txBox="1"/>
+          <p:nvPr/>
+        </p:nvSpPr>
+        <p:spPr>
+          <a:xfrm>
+            <a:off x="4566818" y="4389120"/>
+            <a:ext cx="3058058" cy="1234440"/>
+          </a:xfrm>
+          <a:prstGeom prst="rect">
+            <a:avLst/>
+          </a:prstGeom>
+          <a:noFill/>
+          <a:ln/>
+        </p:spPr>
+        <p:txBody>
+          <a:bodyPr wrap="square" lIns="0" tIns="0" rIns="0" bIns="0" rtlCol="0" anchor="t"/>
+          <a:lstStyle/>
+          <a:p>
+            <a:pPr indent="0" marL="0">
+              <a:buNone/>
+            </a:pPr>
+            <a:r>
+              <a:rPr lang="en-US" sz="1200" dirty="0">
+                <a:solidFill>
+                  <a:srgbClr val="1A1A2E"/>
+                </a:solidFill>
+                <a:latin typeface="Arial" pitchFamily="34" charset="0"/>
+                <a:ea typeface="Arial" pitchFamily="34" charset="-122"/>
+                <a:cs typeface="Arial" pitchFamily="34" charset="-120"/>
+              </a:rPr>
+              <a:t>Thin margin (2.6%) with loss as high as interest-bearing, but 63% of customers who start with Split Pay take an interest-bearing loan next.</a:t>
+            </a:r>
+            <a:endParaRPr lang="en-US" sz="1200" dirty="0"/>
+          </a:p>
+        </p:txBody>
+      </p:sp>
+      <p:sp>
+        <p:nvSpPr>
+          <p:cNvPr id="11" name="Shape 8"/>
+          <p:cNvSpPr/>
+          <p:nvPr/>
+        </p:nvSpPr>
+        <p:spPr>
+          <a:xfrm>
+            <a:off x="8127797" y="3840480"/>
+            <a:ext cx="3515258" cy="1874520"/>
+          </a:xfrm>
+          <a:prstGeom prst="roundRect">
+            <a:avLst>
+              <a:gd name="adj" fmla="val 5854"/>
+            </a:avLst>
+          </a:prstGeom>
+          <a:solidFill>
+            <a:srgbClr val="F6F6FE"/>
+          </a:solidFill>
+          <a:ln w="12700">
+            <a:solidFill>
+              <a:srgbClr val="F6F6FE"/>
+            </a:solidFill>
+            <a:prstDash val="solid"/>
+          </a:ln>
+        </p:spPr>
+      </p:sp>
+      <p:sp>
+        <p:nvSpPr>
+          <p:cNvPr id="12" name="Text 9"/>
+          <p:cNvSpPr txBox="1"/>
+          <p:nvPr/>
+        </p:nvSpPr>
+        <p:spPr>
+          <a:xfrm>
+            <a:off x="8356397" y="3977640"/>
+            <a:ext cx="3058058" cy="365760"/>
+          </a:xfrm>
+          <a:prstGeom prst="rect">
+            <a:avLst/>
+          </a:prstGeom>
+          <a:noFill/>
+          <a:ln/>
+        </p:spPr>
+        <p:txBody>
+          <a:bodyPr wrap="square" lIns="0" tIns="0" rIns="0" bIns="0" rtlCol="0" anchor="ctr"/>
+          <a:lstStyle/>
+          <a:p>
+            <a:pPr indent="0" marL="0">
+              <a:buNone/>
+            </a:pPr>
+            <a:r>
+              <a:rPr lang="en-US" sz="1400" b="1" dirty="0">
+                <a:solidFill>
+                  <a:srgbClr val="1E8A4C"/>
+                </a:solidFill>
+                <a:latin typeface="Arial" pitchFamily="34" charset="0"/>
+                <a:ea typeface="Arial" pitchFamily="34" charset="-122"/>
+                <a:cs typeface="Arial" pitchFamily="34" charset="-120"/>
+              </a:rPr>
+              <a:t>Interest-bearing pays for the risk</a:t>
+            </a:r>
+            <a:endParaRPr lang="en-US" sz="1400" dirty="0"/>
+          </a:p>
+        </p:txBody>
+      </p:sp>
+      <p:sp>
+        <p:nvSpPr>
+          <p:cNvPr id="13" name="Text 10"/>
+          <p:cNvSpPr txBox="1"/>
+          <p:nvPr/>
+        </p:nvSpPr>
+        <p:spPr>
+          <a:xfrm>
+            <a:off x="8356397" y="4389120"/>
+            <a:ext cx="3058058" cy="1234440"/>
+          </a:xfrm>
+          <a:prstGeom prst="rect">
+            <a:avLst/>
+          </a:prstGeom>
+          <a:noFill/>
+          <a:ln/>
+        </p:spPr>
+        <p:txBody>
+          <a:bodyPr wrap="square" lIns="0" tIns="0" rIns="0" bIns="0" rtlCol="0" anchor="t"/>
+          <a:lstStyle/>
+          <a:p>
+            <a:pPr indent="0" marL="0">
+              <a:buNone/>
+            </a:pPr>
+            <a:r>
+              <a:rPr lang="en-US" sz="1200" dirty="0">
+                <a:solidFill>
+                  <a:srgbClr val="1A1A2E"/>
+                </a:solidFill>
+                <a:latin typeface="Arial" pitchFamily="34" charset="0"/>
+                <a:ea typeface="Arial" pitchFamily="34" charset="-122"/>
+                <a:cs typeface="Arial" pitchFamily="34" charset="-120"/>
+              </a:rPr>
+              <a:t>Highest loss (2.3%) is more than covered by 7.4% interest income — 58% of GMV, 82% of profit.</a:t>
+            </a:r>
+            <a:endParaRPr lang="en-US" sz="1200" dirty="0"/>
+          </a:p>
+        </p:txBody>
+      </p:sp>
+      <p:sp>
+        <p:nvSpPr>
+          <p:cNvPr id="14" name="Text 11"/>
+          <p:cNvSpPr txBox="1"/>
+          <p:nvPr/>
+        </p:nvSpPr>
+        <p:spPr>
+          <a:xfrm>
+            <a:off x="548640" y="6355080"/>
+            <a:ext cx="11094415" cy="320040"/>
+          </a:xfrm>
+          <a:prstGeom prst="rect">
+            <a:avLst/>
+          </a:prstGeom>
+          <a:noFill/>
+          <a:ln/>
+        </p:spPr>
+        <p:txBody>
+          <a:bodyPr wrap="square" lIns="0" tIns="0" rIns="0" bIns="0" rtlCol="0" anchor="b"/>
+          <a:lstStyle/>
+          <a:p>
+            <a:pPr indent="0" marL="0">
+              <a:buNone/>
+            </a:pPr>
+            <a:r>
+              <a:rPr lang="en-US" sz="1000" dirty="0">
+                <a:solidFill>
+                  <a:srgbClr val="5B5B73"/>
+                </a:solidFill>
+                <a:latin typeface="Arial" pitchFamily="34" charset="0"/>
+                <a:ea typeface="Arial" pitchFamily="34" charset="-122"/>
+                <a:cs typeface="Arial" pitchFamily="34" charset="-120"/>
+              </a:rPr>
+              <a:t>Merchant fee and interest are % of GMV (dollar-weighted). Same-merchant comparison uses merchants with a promo program. Loss rate includes expected loss on delinquent loans.</a:t>
+            </a:r>
+            <a:endParaRPr lang="en-US" sz="1000" dirty="0"/>
+          </a:p>
+        </p:txBody>
+      </p:sp>
+    </p:spTree>
+  </p:cSld>
+  <p:clrMapOvr>
+    <a:masterClrMapping/>
+  </p:clrMapOvr>
+</p:sld>
+</file>
+
+<file path=ppt/slides/slide5.xml><?xml version="1.0" encoding="utf-8"?>
+<p:sld xmlns:a="http://schemas.openxmlformats.org/drawingml/2006/main" xmlns:r="http://schemas.openxmlformats.org/officeDocument/2006/relationships" xmlns:p="http://schemas.openxmlformats.org/presentationml/2006/main">
+  <p:cSld name="Slide 5">
     <p:bg>
       <p:bgPr>
         <a:solidFill>
@@ -9616,9 +13231,9 @@
 </p:sld>
 </file>
 
-<file path=ppt/slides/slide5.xml><?xml version="1.0" encoding="utf-8"?>
+<file path=ppt/slides/slide6.xml><?xml version="1.0" encoding="utf-8"?>
 <p:sld xmlns:a="http://schemas.openxmlformats.org/drawingml/2006/main" xmlns:r="http://schemas.openxmlformats.org/officeDocument/2006/relationships" xmlns:p="http://schemas.openxmlformats.org/presentationml/2006/main">
-  <p:cSld name="Slide 5">
+  <p:cSld name="Slide 6">
     <p:bg>
       <p:bgPr>
         <a:solidFill>
@@ -10788,9 +14403,9 @@
 </p:sld>
 </file>
 
-<file path=ppt/slides/slide6.xml><?xml version="1.0" encoding="utf-8"?>
+<file path=ppt/slides/slide7.xml><?xml version="1.0" encoding="utf-8"?>
 <p:sld xmlns:a="http://schemas.openxmlformats.org/drawingml/2006/main" xmlns:r="http://schemas.openxmlformats.org/officeDocument/2006/relationships" xmlns:p="http://schemas.openxmlformats.org/presentationml/2006/main">
-  <p:cSld name="Slide 6">
+  <p:cSld name="Slide 7">
     <p:bg>
       <p:bgPr>
         <a:solidFill>
@@ -10892,7 +14507,7 @@
       </p:sp>
       <p:graphicFrame>
         <p:nvGraphicFramePr>
-          <p:cNvPr id="7" name="Table 0"/>
+          <p:cNvPr id="8" name="Table 0"/>
           <p:cNvGraphicFramePr>
             <a:graphicFrameLocks noGrp="1"/>
           </p:cNvGraphicFramePr>
@@ -12812,9 +16427,9 @@
 </p:sld>
 </file>
 
-<file path=ppt/slides/slide7.xml><?xml version="1.0" encoding="utf-8"?>
+<file path=ppt/slides/slide8.xml><?xml version="1.0" encoding="utf-8"?>
 <p:sld xmlns:a="http://schemas.openxmlformats.org/drawingml/2006/main" xmlns:r="http://schemas.openxmlformats.org/officeDocument/2006/relationships" xmlns:p="http://schemas.openxmlformats.org/presentationml/2006/main">
-  <p:cSld name="Slide 7">
+  <p:cSld name="Slide 8">
     <p:bg>
       <p:bgPr>
         <a:solidFill>
@@ -13396,9 +17011,9 @@
 </p:sld>
 </file>
 
-<file path=ppt/slides/slide8.xml><?xml version="1.0" encoding="utf-8"?>
+<file path=ppt/slides/slide9.xml><?xml version="1.0" encoding="utf-8"?>
 <p:sld xmlns:a="http://schemas.openxmlformats.org/drawingml/2006/main" xmlns:r="http://schemas.openxmlformats.org/officeDocument/2006/relationships" xmlns:p="http://schemas.openxmlformats.org/presentationml/2006/main">
-  <p:cSld name="Slide 8">
+  <p:cSld name="Slide 9">
     <p:bg>
       <p:bgPr>
         <a:solidFill>
@@ -13500,7 +17115,7 @@
       </p:sp>
       <p:graphicFrame>
         <p:nvGraphicFramePr>
-          <p:cNvPr id="9" name="Table 0"/>
+          <p:cNvPr id="10" name="Table 0"/>
           <p:cNvGraphicFramePr>
             <a:graphicFrameLocks noGrp="1"/>
           </p:cNvGraphicFramePr>
@@ -15005,575 +18620,6 @@
                 <a:cs typeface="Arial" pitchFamily="34" charset="-120"/>
               </a:rPr>
               <a:t>Also checked and clean: keys and joins, product/term/APR rules, fee and repayment arithmetic. Code: notebooks/01_data_integrity.ipynb.</a:t>
-            </a:r>
-            <a:endParaRPr lang="en-US" sz="1000" dirty="0"/>
-          </a:p>
-        </p:txBody>
-      </p:sp>
-    </p:spTree>
-  </p:cSld>
-  <p:clrMapOvr>
-    <a:masterClrMapping/>
-  </p:clrMapOvr>
-</p:sld>
-</file>
-
-<file path=ppt/slides/slide9.xml><?xml version="1.0" encoding="utf-8"?>
-<p:sld xmlns:a="http://schemas.openxmlformats.org/drawingml/2006/main" xmlns:r="http://schemas.openxmlformats.org/officeDocument/2006/relationships" xmlns:p="http://schemas.openxmlformats.org/presentationml/2006/main">
-  <p:cSld name="Slide 9">
-    <p:bg>
-      <p:bgPr>
-        <a:solidFill>
-          <a:srgbClr val="FFFFFF"/>
-        </a:solidFill>
-      </p:bgPr>
-    </p:bg>
-    <p:spTree>
-      <p:nvGrpSpPr>
-        <p:cNvPr id="1" name=""/>
-        <p:cNvGrpSpPr/>
-        <p:nvPr/>
-      </p:nvGrpSpPr>
-      <p:grpSpPr>
-        <a:xfrm>
-          <a:off x="0" y="0"/>
-          <a:ext cx="0" cy="0"/>
-          <a:chOff x="0" y="0"/>
-          <a:chExt cx="0" cy="0"/>
-        </a:xfrm>
-      </p:grpSpPr>
-      <p:sp>
-        <p:nvSpPr>
-          <p:cNvPr id="2" name="Text 0"/>
-          <p:cNvSpPr txBox="1"/>
-          <p:nvPr/>
-        </p:nvSpPr>
-        <p:spPr>
-          <a:xfrm>
-            <a:off x="548640" y="164592"/>
-            <a:ext cx="7315200" cy="274320"/>
-          </a:xfrm>
-          <a:prstGeom prst="rect">
-            <a:avLst/>
-          </a:prstGeom>
-          <a:noFill/>
-          <a:ln/>
-        </p:spPr>
-        <p:txBody>
-          <a:bodyPr wrap="square" lIns="0" tIns="0" rIns="0" bIns="0" rtlCol="0" anchor="ctr"/>
-          <a:lstStyle/>
-          <a:p>
-            <a:pPr indent="0" marL="0">
-              <a:buNone/>
-            </a:pPr>
-            <a:r>
-              <a:rPr lang="en-US" sz="1100" b="1" spc="200" kern="0" dirty="0">
-                <a:solidFill>
-                  <a:srgbClr val="5B5B73"/>
-                </a:solidFill>
-                <a:latin typeface="Arial" pitchFamily="34" charset="0"/>
-                <a:ea typeface="Arial" pitchFamily="34" charset="-122"/>
-                <a:cs typeface="Arial" pitchFamily="34" charset="-120"/>
-              </a:rPr>
-              <a:t>APPENDIX B · METHODOLOGY</a:t>
-            </a:r>
-            <a:endParaRPr lang="en-US" sz="1100" dirty="0"/>
-          </a:p>
-        </p:txBody>
-      </p:sp>
-      <p:sp>
-        <p:nvSpPr>
-          <p:cNvPr id="3" name="Text 1"/>
-          <p:cNvSpPr txBox="1"/>
-          <p:nvPr/>
-        </p:nvSpPr>
-        <p:spPr>
-          <a:xfrm>
-            <a:off x="548640" y="411480"/>
-            <a:ext cx="11094415" cy="868680"/>
-          </a:xfrm>
-          <a:prstGeom prst="rect">
-            <a:avLst/>
-          </a:prstGeom>
-          <a:noFill/>
-          <a:ln/>
-        </p:spPr>
-        <p:txBody>
-          <a:bodyPr wrap="square" lIns="0" tIns="0" rIns="0" bIns="0" rtlCol="0" anchor="t"/>
-          <a:lstStyle/>
-          <a:p>
-            <a:pPr indent="0" marL="0">
-              <a:buNone/>
-            </a:pPr>
-            <a:r>
-              <a:rPr lang="en-US" sz="2600" b="1" dirty="0">
-                <a:solidFill>
-                  <a:srgbClr val="1A1A2E"/>
-                </a:solidFill>
-                <a:latin typeface="Arial" pitchFamily="34" charset="0"/>
-                <a:ea typeface="Arial" pitchFamily="34" charset="-122"/>
-                <a:cs typeface="Arial" pitchFamily="34" charset="-120"/>
-              </a:rPr>
-              <a:t>How the numbers were built</a:t>
-            </a:r>
-            <a:endParaRPr lang="en-US" sz="2600" dirty="0"/>
-          </a:p>
-        </p:txBody>
-      </p:sp>
-      <p:sp>
-        <p:nvSpPr>
-          <p:cNvPr id="4" name="Shape 2"/>
-          <p:cNvSpPr/>
-          <p:nvPr/>
-        </p:nvSpPr>
-        <p:spPr>
-          <a:xfrm>
-            <a:off x="548640" y="1463040"/>
-            <a:ext cx="5394960" cy="1691640"/>
-          </a:xfrm>
-          <a:prstGeom prst="roundRect">
-            <a:avLst>
-              <a:gd name="adj" fmla="val 6486"/>
-            </a:avLst>
-          </a:prstGeom>
-          <a:solidFill>
-            <a:srgbClr val="F6F6FE"/>
-          </a:solidFill>
-          <a:ln w="12700">
-            <a:solidFill>
-              <a:srgbClr val="F6F6FE"/>
-            </a:solidFill>
-            <a:prstDash val="solid"/>
-          </a:ln>
-        </p:spPr>
-      </p:sp>
-      <p:sp>
-        <p:nvSpPr>
-          <p:cNvPr id="5" name="Text 3"/>
-          <p:cNvSpPr txBox="1"/>
-          <p:nvPr/>
-        </p:nvSpPr>
-        <p:spPr>
-          <a:xfrm>
-            <a:off x="822960" y="1645920"/>
-            <a:ext cx="4846320" cy="365760"/>
-          </a:xfrm>
-          <a:prstGeom prst="rect">
-            <a:avLst/>
-          </a:prstGeom>
-          <a:noFill/>
-          <a:ln/>
-        </p:spPr>
-        <p:txBody>
-          <a:bodyPr wrap="square" lIns="0" tIns="0" rIns="0" bIns="0" rtlCol="0" anchor="ctr"/>
-          <a:lstStyle/>
-          <a:p>
-            <a:pPr indent="0" marL="0">
-              <a:buNone/>
-            </a:pPr>
-            <a:r>
-              <a:rPr lang="en-US" sz="1500" b="1" dirty="0">
-                <a:solidFill>
-                  <a:srgbClr val="4A4AF4"/>
-                </a:solidFill>
-                <a:latin typeface="Arial" pitchFamily="34" charset="0"/>
-                <a:ea typeface="Arial" pitchFamily="34" charset="-122"/>
-                <a:cs typeface="Arial" pitchFamily="34" charset="-120"/>
-              </a:rPr>
-              <a:t>Unit economics per loan</a:t>
-            </a:r>
-            <a:endParaRPr lang="en-US" sz="1500" dirty="0"/>
-          </a:p>
-        </p:txBody>
-      </p:sp>
-      <p:sp>
-        <p:nvSpPr>
-          <p:cNvPr id="6" name="Text 4"/>
-          <p:cNvSpPr txBox="1"/>
-          <p:nvPr/>
-        </p:nvSpPr>
-        <p:spPr>
-          <a:xfrm>
-            <a:off x="822960" y="2057400"/>
-            <a:ext cx="4846320" cy="1005840"/>
-          </a:xfrm>
-          <a:prstGeom prst="rect">
-            <a:avLst/>
-          </a:prstGeom>
-          <a:noFill/>
-          <a:ln/>
-        </p:spPr>
-        <p:txBody>
-          <a:bodyPr wrap="square" lIns="0" tIns="0" rIns="0" bIns="0" rtlCol="0" anchor="t"/>
-          <a:lstStyle/>
-          <a:p>
-            <a:pPr indent="0" marL="0">
-              <a:buNone/>
-            </a:pPr>
-            <a:r>
-              <a:rPr lang="en-US" sz="1250" dirty="0">
-                <a:solidFill>
-                  <a:srgbClr val="1A1A2E"/>
-                </a:solidFill>
-                <a:latin typeface="Arial" pitchFamily="34" charset="0"/>
-                <a:ea typeface="Arial" pitchFamily="34" charset="-122"/>
-                <a:cs typeface="Arial" pitchFamily="34" charset="-120"/>
-              </a:rPr>
-              <a:t>Contribution = merchant fee + interest collected − credit loss − funding cost. Funding = cost of funds × term × ½ principal (average balance of an amortizing loan). Full principal would lower margins ~1 pt but not change the vertical ranking.</a:t>
-            </a:r>
-            <a:endParaRPr lang="en-US" sz="1250" dirty="0"/>
-          </a:p>
-        </p:txBody>
-      </p:sp>
-      <p:sp>
-        <p:nvSpPr>
-          <p:cNvPr id="7" name="Shape 5"/>
-          <p:cNvSpPr/>
-          <p:nvPr/>
-        </p:nvSpPr>
-        <p:spPr>
-          <a:xfrm>
-            <a:off x="6217920" y="1463040"/>
-            <a:ext cx="5394960" cy="1691640"/>
-          </a:xfrm>
-          <a:prstGeom prst="roundRect">
-            <a:avLst>
-              <a:gd name="adj" fmla="val 6486"/>
-            </a:avLst>
-          </a:prstGeom>
-          <a:solidFill>
-            <a:srgbClr val="F6F6FE"/>
-          </a:solidFill>
-          <a:ln w="12700">
-            <a:solidFill>
-              <a:srgbClr val="F6F6FE"/>
-            </a:solidFill>
-            <a:prstDash val="solid"/>
-          </a:ln>
-        </p:spPr>
-      </p:sp>
-      <p:sp>
-        <p:nvSpPr>
-          <p:cNvPr id="8" name="Text 6"/>
-          <p:cNvSpPr txBox="1"/>
-          <p:nvPr/>
-        </p:nvSpPr>
-        <p:spPr>
-          <a:xfrm>
-            <a:off x="6492240" y="1645920"/>
-            <a:ext cx="4846320" cy="365760"/>
-          </a:xfrm>
-          <a:prstGeom prst="rect">
-            <a:avLst/>
-          </a:prstGeom>
-          <a:noFill/>
-          <a:ln/>
-        </p:spPr>
-        <p:txBody>
-          <a:bodyPr wrap="square" lIns="0" tIns="0" rIns="0" bIns="0" rtlCol="0" anchor="ctr"/>
-          <a:lstStyle/>
-          <a:p>
-            <a:pPr indent="0" marL="0">
-              <a:buNone/>
-            </a:pPr>
-            <a:r>
-              <a:rPr lang="en-US" sz="1500" b="1" dirty="0">
-                <a:solidFill>
-                  <a:srgbClr val="4A4AF4"/>
-                </a:solidFill>
-                <a:latin typeface="Arial" pitchFamily="34" charset="0"/>
-                <a:ea typeface="Arial" pitchFamily="34" charset="-122"/>
-                <a:cs typeface="Arial" pitchFamily="34" charset="-120"/>
-              </a:rPr>
-              <a:t>Maturity</a:t>
-            </a:r>
-            <a:endParaRPr lang="en-US" sz="1500" dirty="0"/>
-          </a:p>
-        </p:txBody>
-      </p:sp>
-      <p:sp>
-        <p:nvSpPr>
-          <p:cNvPr id="9" name="Text 7"/>
-          <p:cNvSpPr txBox="1"/>
-          <p:nvPr/>
-        </p:nvSpPr>
-        <p:spPr>
-          <a:xfrm>
-            <a:off x="6492240" y="2057400"/>
-            <a:ext cx="4846320" cy="1005840"/>
-          </a:xfrm>
-          <a:prstGeom prst="rect">
-            <a:avLst/>
-          </a:prstGeom>
-          <a:noFill/>
-          <a:ln/>
-        </p:spPr>
-        <p:txBody>
-          <a:bodyPr wrap="square" lIns="0" tIns="0" rIns="0" bIns="0" rtlCol="0" anchor="t"/>
-          <a:lstStyle/>
-          <a:p>
-            <a:pPr indent="0" marL="0">
-              <a:buNone/>
-            </a:pPr>
-            <a:r>
-              <a:rPr lang="en-US" sz="1250" dirty="0">
-                <a:solidFill>
-                  <a:srgbClr val="1A1A2E"/>
-                </a:solidFill>
-                <a:latin typeface="Arial" pitchFamily="34" charset="0"/>
-                <a:ea typeface="Arial" pitchFamily="34" charset="-122"/>
-                <a:cs typeface="Arial" pitchFamily="34" charset="-120"/>
-              </a:rPr>
-              <a:t>Young loans haven't paid interest or defaulted yet. Loss/margin comparisons are checked on seasoned loans (originated by Jun 2025).</a:t>
-            </a:r>
-            <a:endParaRPr lang="en-US" sz="1250" dirty="0"/>
-          </a:p>
-        </p:txBody>
-      </p:sp>
-      <p:sp>
-        <p:nvSpPr>
-          <p:cNvPr id="10" name="Shape 8"/>
-          <p:cNvSpPr/>
-          <p:nvPr/>
-        </p:nvSpPr>
-        <p:spPr>
-          <a:xfrm>
-            <a:off x="548640" y="3383280"/>
-            <a:ext cx="5394960" cy="1691640"/>
-          </a:xfrm>
-          <a:prstGeom prst="roundRect">
-            <a:avLst>
-              <a:gd name="adj" fmla="val 6486"/>
-            </a:avLst>
-          </a:prstGeom>
-          <a:solidFill>
-            <a:srgbClr val="F6F6FE"/>
-          </a:solidFill>
-          <a:ln w="12700">
-            <a:solidFill>
-              <a:srgbClr val="F6F6FE"/>
-            </a:solidFill>
-            <a:prstDash val="solid"/>
-          </a:ln>
-        </p:spPr>
-      </p:sp>
-      <p:sp>
-        <p:nvSpPr>
-          <p:cNvPr id="11" name="Text 9"/>
-          <p:cNvSpPr txBox="1"/>
-          <p:nvPr/>
-        </p:nvSpPr>
-        <p:spPr>
-          <a:xfrm>
-            <a:off x="822960" y="3566160"/>
-            <a:ext cx="4846320" cy="365760"/>
-          </a:xfrm>
-          <a:prstGeom prst="rect">
-            <a:avLst/>
-          </a:prstGeom>
-          <a:noFill/>
-          <a:ln/>
-        </p:spPr>
-        <p:txBody>
-          <a:bodyPr wrap="square" lIns="0" tIns="0" rIns="0" bIns="0" rtlCol="0" anchor="ctr"/>
-          <a:lstStyle/>
-          <a:p>
-            <a:pPr indent="0" marL="0">
-              <a:buNone/>
-            </a:pPr>
-            <a:r>
-              <a:rPr lang="en-US" sz="1500" b="1" dirty="0">
-                <a:solidFill>
-                  <a:srgbClr val="4A4AF4"/>
-                </a:solidFill>
-                <a:latin typeface="Arial" pitchFamily="34" charset="0"/>
-                <a:ea typeface="Arial" pitchFamily="34" charset="-122"/>
-                <a:cs typeface="Arial" pitchFamily="34" charset="-120"/>
-              </a:rPr>
-              <a:t>Repeat customers</a:t>
-            </a:r>
-            <a:endParaRPr lang="en-US" sz="1500" dirty="0"/>
-          </a:p>
-        </p:txBody>
-      </p:sp>
-      <p:sp>
-        <p:nvSpPr>
-          <p:cNvPr id="12" name="Text 10"/>
-          <p:cNvSpPr txBox="1"/>
-          <p:nvPr/>
-        </p:nvSpPr>
-        <p:spPr>
-          <a:xfrm>
-            <a:off x="822960" y="3977640"/>
-            <a:ext cx="4846320" cy="1005840"/>
-          </a:xfrm>
-          <a:prstGeom prst="rect">
-            <a:avLst/>
-          </a:prstGeom>
-          <a:noFill/>
-          <a:ln/>
-        </p:spPr>
-        <p:txBody>
-          <a:bodyPr wrap="square" lIns="0" tIns="0" rIns="0" bIns="0" rtlCol="0" anchor="t"/>
-          <a:lstStyle/>
-          <a:p>
-            <a:pPr indent="0" marL="0">
-              <a:buNone/>
-            </a:pPr>
-            <a:r>
-              <a:rPr lang="en-US" sz="1250" dirty="0">
-                <a:solidFill>
-                  <a:srgbClr val="1A1A2E"/>
-                </a:solidFill>
-                <a:latin typeface="Arial" pitchFamily="34" charset="0"/>
-                <a:ea typeface="Arial" pitchFamily="34" charset="-122"/>
-                <a:cs typeface="Arial" pitchFamily="34" charset="-120"/>
-              </a:rPr>
-              <a:t>First loans by Jun 2025; repeat = another loan within 180 days. Loss by new vs repeat checked on seasoned loans.</a:t>
-            </a:r>
-            <a:endParaRPr lang="en-US" sz="1250" dirty="0"/>
-          </a:p>
-        </p:txBody>
-      </p:sp>
-      <p:sp>
-        <p:nvSpPr>
-          <p:cNvPr id="13" name="Shape 11"/>
-          <p:cNvSpPr/>
-          <p:nvPr/>
-        </p:nvSpPr>
-        <p:spPr>
-          <a:xfrm>
-            <a:off x="6217920" y="3383280"/>
-            <a:ext cx="5394960" cy="1691640"/>
-          </a:xfrm>
-          <a:prstGeom prst="roundRect">
-            <a:avLst>
-              <a:gd name="adj" fmla="val 6486"/>
-            </a:avLst>
-          </a:prstGeom>
-          <a:solidFill>
-            <a:srgbClr val="F6F6FE"/>
-          </a:solidFill>
-          <a:ln w="12700">
-            <a:solidFill>
-              <a:srgbClr val="F6F6FE"/>
-            </a:solidFill>
-            <a:prstDash val="solid"/>
-          </a:ln>
-        </p:spPr>
-      </p:sp>
-      <p:sp>
-        <p:nvSpPr>
-          <p:cNvPr id="14" name="Text 12"/>
-          <p:cNvSpPr txBox="1"/>
-          <p:nvPr/>
-        </p:nvSpPr>
-        <p:spPr>
-          <a:xfrm>
-            <a:off x="6492240" y="3566160"/>
-            <a:ext cx="4846320" cy="365760"/>
-          </a:xfrm>
-          <a:prstGeom prst="rect">
-            <a:avLst/>
-          </a:prstGeom>
-          <a:noFill/>
-          <a:ln/>
-        </p:spPr>
-        <p:txBody>
-          <a:bodyPr wrap="square" lIns="0" tIns="0" rIns="0" bIns="0" rtlCol="0" anchor="ctr"/>
-          <a:lstStyle/>
-          <a:p>
-            <a:pPr indent="0" marL="0">
-              <a:buNone/>
-            </a:pPr>
-            <a:r>
-              <a:rPr lang="en-US" sz="1500" b="1" dirty="0">
-                <a:solidFill>
-                  <a:srgbClr val="4A4AF4"/>
-                </a:solidFill>
-                <a:latin typeface="Arial" pitchFamily="34" charset="0"/>
-                <a:ea typeface="Arial" pitchFamily="34" charset="-122"/>
-                <a:cs typeface="Arial" pitchFamily="34" charset="-120"/>
-              </a:rPr>
-              <a:t>Sizing</a:t>
-            </a:r>
-            <a:endParaRPr lang="en-US" sz="1500" dirty="0"/>
-          </a:p>
-        </p:txBody>
-      </p:sp>
-      <p:sp>
-        <p:nvSpPr>
-          <p:cNvPr id="15" name="Text 13"/>
-          <p:cNvSpPr txBox="1"/>
-          <p:nvPr/>
-        </p:nvSpPr>
-        <p:spPr>
-          <a:xfrm>
-            <a:off x="6492240" y="3977640"/>
-            <a:ext cx="4846320" cy="1005840"/>
-          </a:xfrm>
-          <a:prstGeom prst="rect">
-            <a:avLst/>
-          </a:prstGeom>
-          <a:noFill/>
-          <a:ln/>
-        </p:spPr>
-        <p:txBody>
-          <a:bodyPr wrap="square" lIns="0" tIns="0" rIns="0" bIns="0" rtlCol="0" anchor="t"/>
-          <a:lstStyle/>
-          <a:p>
-            <a:pPr indent="0" marL="0">
-              <a:buNone/>
-            </a:pPr>
-            <a:r>
-              <a:rPr lang="en-US" sz="1250" dirty="0">
-                <a:solidFill>
-                  <a:srgbClr val="1A1A2E"/>
-                </a:solidFill>
-                <a:latin typeface="Arial" pitchFamily="34" charset="0"/>
-                <a:ea typeface="Arial" pitchFamily="34" charset="-122"/>
-                <a:cs typeface="Arial" pitchFamily="34" charset="-120"/>
-              </a:rPr>
-              <a:t>One year = 2025 volume × seasoned rates. Changes scale proportionally; new merchants perform like the vertical average.</a:t>
-            </a:r>
-            <a:endParaRPr lang="en-US" sz="1250" dirty="0"/>
-          </a:p>
-        </p:txBody>
-      </p:sp>
-      <p:sp>
-        <p:nvSpPr>
-          <p:cNvPr id="16" name="Text 14"/>
-          <p:cNvSpPr txBox="1"/>
-          <p:nvPr/>
-        </p:nvSpPr>
-        <p:spPr>
-          <a:xfrm>
-            <a:off x="548640" y="6355080"/>
-            <a:ext cx="11094415" cy="320040"/>
-          </a:xfrm>
-          <a:prstGeom prst="rect">
-            <a:avLst/>
-          </a:prstGeom>
-          <a:noFill/>
-          <a:ln/>
-        </p:spPr>
-        <p:txBody>
-          <a:bodyPr wrap="square" lIns="0" tIns="0" rIns="0" bIns="0" rtlCol="0" anchor="b"/>
-          <a:lstStyle/>
-          <a:p>
-            <a:pPr indent="0" marL="0">
-              <a:buNone/>
-            </a:pPr>
-            <a:r>
-              <a:rPr lang="en-US" sz="1000" dirty="0">
-                <a:solidFill>
-                  <a:srgbClr val="5B5B73"/>
-                </a:solidFill>
-                <a:latin typeface="Arial" pitchFamily="34" charset="0"/>
-                <a:ea typeface="Arial" pitchFamily="34" charset="-122"/>
-                <a:cs typeface="Arial" pitchFamily="34" charset="-120"/>
-              </a:rPr>
-              <a:t>Code: notebooks/01_data_integrity.ipynb, 02_portfolio_risk.ipynb, 03_recommendation_sizing.ipynb.</a:t>
             </a:r>
             <a:endParaRPr lang="en-US" sz="1000" dirty="0"/>
           </a:p>

</xml_diff>

<commit_message>
Use seasoned loans for segment rates in deck and notebook
Bad rate, loss, fees, interest and margin on the vertical, product,
repeat and plan slides now use loans originated by Jun 2025; shares stay
on all loans. Part 2 notebook adds the matching seasoned tables.

Co-Authored-By: Claude Opus 5.5 <noreply@anthropic.com>
Claude-Session: https://claude.ai/code/session_01W2UPg5WygeJNMeisH6AsMo
</commit_message>
<xml_diff>
--- a/deck/portfolio_recommendation.pptx
+++ b/deck/portfolio_recommendation.pptx
@@ -602,7 +602,7 @@
             <c:size val="7"/>
             <c:spPr>
               <a:solidFill>
-                <a:srgbClr val="C93B3B"/>
+                <a:srgbClr val="4A4AF4"/>
               </a:solidFill>
               <a:ln w="9525" cap="flat">
                 <a:solidFill>
@@ -2597,7 +2597,7 @@
           <a:p>
             <a:r>
               <a:rPr lang="en-US" dirty="0"/>
-              <a:t>Sorted by margin. Travel has five times the bad rate of any other vertical, but it is still our largest profit pool because revenue is high. The risk is concentrated in sub-640 FICO travel borrowers: 40% bad rate, and the margin disappears if the delinquent loans charge off. Fashion is half our loans but a tenth of profit. Healthcare and home furnishing combine low loss with high revenue. By product, interest-bearing earns 82% of profit.</a:t>
+              <a:t>Sorted by margin; rates are on seasoned loans so young loans do not flatter them. Travel has five times the bad rate of any other vertical, but it is still our largest profit pool because revenue is high. The risk is concentrated in sub-640 FICO travel borrowers: 43% bad rate, and the margin disappears if the delinquent loans charge off. Fashion is half our loans but a tenth of profit. Healthcare and home furnishing combine low loss with high revenue. Shares of loans, GMV and profit use all loans.</a:t>
             </a:r>
             <a:endParaRPr lang="en-US" dirty="0"/>
           </a:p>
@@ -2773,7 +2773,7 @@
           <a:p>
             <a:r>
               <a:rPr lang="en-US" dirty="0"/>
-              <a:t>A customer who repays their first loan is a much better risk the second time: loss falls from 2.6% to 1.0%, and that holds in every vertical and product, including on seasoned loans. 82% of loss dollars come from first loans. Repeat rates are set by the vertical: frequent-purchase verticals like fashion and electronics already get ~95%; big-ticket verticals only ~20%, which is where the upside is. Split Pay works as an entry product: most customers move to interest-bearing on their next loan. And customers mostly come back to the same vertical (86%), so repeat growth has to be built vertical by vertical — cross-selling is small.</a:t>
+              <a:t>A customer who repays their first loan is a much better risk the second time: on seasoned loans, loss falls from 2.8% to 1.1%, and that holds in every vertical and product. 82% of loss dollars come from first loans. Repeat rates are set by the vertical: frequent-purchase verticals like fashion and electronics already get ~95%; big-ticket verticals only ~20%, which is where the upside is. Split Pay works as an entry product: most customers move to interest-bearing on their next loan. And customers mostly come back to the same vertical (86%), so repeat growth has to be built vertical by vertical — cross-selling is small.</a:t>
             </a:r>
             <a:endParaRPr lang="en-US" dirty="0"/>
           </a:p>
@@ -10299,7 +10299,7 @@
                           <a:ea typeface="Arial" pitchFamily="34" charset="-122"/>
                           <a:cs typeface="Arial" pitchFamily="34" charset="-120"/>
                         </a:rPr>
-                        <a:t>Bad rate</a:t>
+                        <a:t>Bad rate*</a:t>
                       </a:r>
                       <a:endParaRPr lang="en-US" sz="1200" dirty="0">
                         <a:latin typeface="Arial" charset="0"/>
@@ -10367,7 +10367,7 @@
                           <a:ea typeface="Arial" pitchFamily="34" charset="-122"/>
                           <a:cs typeface="Arial" pitchFamily="34" charset="-120"/>
                         </a:rPr>
-                        <a:t>Loss rate</a:t>
+                        <a:t>Loss rate*</a:t>
                       </a:r>
                       <a:endParaRPr lang="en-US" sz="1200" dirty="0">
                         <a:latin typeface="Arial" charset="0"/>
@@ -10435,7 +10435,7 @@
                           <a:ea typeface="Arial" pitchFamily="34" charset="-122"/>
                           <a:cs typeface="Arial" pitchFamily="34" charset="-120"/>
                         </a:rPr>
-                        <a:t>Margin</a:t>
+                        <a:t>Margin*</a:t>
                       </a:r>
                       <a:endParaRPr lang="en-US" sz="1200" dirty="0">
                         <a:latin typeface="Arial" charset="0"/>
@@ -10777,7 +10777,7 @@
                           <a:ea typeface="Arial" pitchFamily="34" charset="-122"/>
                           <a:cs typeface="Arial" pitchFamily="34" charset="-120"/>
                         </a:rPr>
-                        <a:t>4%</a:t>
+                        <a:t>4.8%</a:t>
                       </a:r>
                       <a:endParaRPr lang="en-US" sz="1200" dirty="0">
                         <a:latin typeface="Arial" charset="0"/>
@@ -10845,7 +10845,7 @@
                           <a:ea typeface="Arial" pitchFamily="34" charset="-122"/>
                           <a:cs typeface="Arial" pitchFamily="34" charset="-120"/>
                         </a:rPr>
-                        <a:t>1.5%</a:t>
+                        <a:t>2.0%</a:t>
                       </a:r>
                       <a:endParaRPr lang="en-US" sz="1200" dirty="0">
                         <a:latin typeface="Arial" charset="0"/>
@@ -10913,7 +10913,7 @@
                           <a:ea typeface="Arial" pitchFamily="34" charset="-122"/>
                           <a:cs typeface="Arial" pitchFamily="34" charset="-120"/>
                         </a:rPr>
-                        <a:t>9.1%</a:t>
+                        <a:t>9.8%</a:t>
                       </a:r>
                       <a:endParaRPr lang="en-US" sz="1200" dirty="0">
                         <a:latin typeface="Arial" charset="0"/>
@@ -11255,7 +11255,7 @@
                           <a:ea typeface="Arial" pitchFamily="34" charset="-122"/>
                           <a:cs typeface="Arial" pitchFamily="34" charset="-120"/>
                         </a:rPr>
-                        <a:t>21%</a:t>
+                        <a:t>23.5%</a:t>
                       </a:r>
                       <a:endParaRPr lang="en-US" sz="1200" dirty="0">
                         <a:latin typeface="Arial" charset="0"/>
@@ -11323,7 +11323,7 @@
                           <a:ea typeface="Arial" pitchFamily="34" charset="-122"/>
                           <a:cs typeface="Arial" pitchFamily="34" charset="-120"/>
                         </a:rPr>
-                        <a:t>3.5%</a:t>
+                        <a:t>3.6%</a:t>
                       </a:r>
                       <a:endParaRPr lang="en-US" sz="1200" dirty="0">
                         <a:latin typeface="Arial" charset="0"/>
@@ -11391,7 +11391,7 @@
                           <a:ea typeface="Arial" pitchFamily="34" charset="-122"/>
                           <a:cs typeface="Arial" pitchFamily="34" charset="-120"/>
                         </a:rPr>
-                        <a:t>8.7%</a:t>
+                        <a:t>9.4%</a:t>
                       </a:r>
                       <a:endParaRPr lang="en-US" sz="1200" dirty="0">
                         <a:latin typeface="Arial" charset="0"/>
@@ -11529,7 +11529,7 @@
                           <a:ea typeface="Arial" pitchFamily="34" charset="-122"/>
                           <a:cs typeface="Arial" pitchFamily="34" charset="-120"/>
                         </a:rPr>
-                        <a:t>Fitness</a:t>
+                        <a:t>Home furnishing</a:t>
                       </a:r>
                       <a:endParaRPr lang="en-US" sz="1200" dirty="0">
                         <a:latin typeface="Arial" charset="0"/>
@@ -11665,7 +11665,7 @@
                           <a:ea typeface="Arial" pitchFamily="34" charset="-122"/>
                           <a:cs typeface="Arial" pitchFamily="34" charset="-120"/>
                         </a:rPr>
-                        <a:t>7%</a:t>
+                        <a:t>14%</a:t>
                       </a:r>
                       <a:endParaRPr lang="en-US" sz="1200" dirty="0">
                         <a:latin typeface="Arial" charset="0"/>
@@ -11733,7 +11733,143 @@
                           <a:ea typeface="Arial" pitchFamily="34" charset="-122"/>
                           <a:cs typeface="Arial" pitchFamily="34" charset="-120"/>
                         </a:rPr>
-                        <a:t>5%</a:t>
+                        <a:t>4.6%</a:t>
+                      </a:r>
+                      <a:endParaRPr lang="en-US" sz="1200" dirty="0">
+                        <a:latin typeface="Arial" charset="0"/>
+                        <a:ea typeface="Arial" charset="0"/>
+                        <a:cs typeface="Arial" charset="0"/>
+                      </a:endParaRPr>
+                    </a:p>
+                  </a:txBody>
+                  <a:tcPr marL="91440" marR="91440" marT="27432" marB="27432" anchor="ctr">
+                    <a:lnL w="6350" cap="flat" cmpd="sng" algn="ctr">
+                      <a:solidFill>
+                        <a:srgbClr val="DADAF0"/>
+                      </a:solidFill>
+                      <a:prstDash val="solid"/>
+                      <a:round/>
+                      <a:headEnd type="none" w="med" len="med"/>
+                      <a:tailEnd type="none" w="med" len="med"/>
+                    </a:lnL>
+                    <a:lnR w="6350" cap="flat" cmpd="sng" algn="ctr">
+                      <a:solidFill>
+                        <a:srgbClr val="DADAF0"/>
+                      </a:solidFill>
+                      <a:prstDash val="solid"/>
+                      <a:round/>
+                      <a:headEnd type="none" w="med" len="med"/>
+                      <a:tailEnd type="none" w="med" len="med"/>
+                    </a:lnR>
+                    <a:lnT w="6350" cap="flat" cmpd="sng" algn="ctr">
+                      <a:solidFill>
+                        <a:srgbClr val="DADAF0"/>
+                      </a:solidFill>
+                      <a:prstDash val="solid"/>
+                      <a:round/>
+                      <a:headEnd type="none" w="med" len="med"/>
+                      <a:tailEnd type="none" w="med" len="med"/>
+                    </a:lnT>
+                    <a:lnB w="6350" cap="flat" cmpd="sng" algn="ctr">
+                      <a:solidFill>
+                        <a:srgbClr val="DADAF0"/>
+                      </a:solidFill>
+                      <a:prstDash val="solid"/>
+                      <a:round/>
+                      <a:headEnd type="none" w="med" len="med"/>
+                      <a:tailEnd type="none" w="med" len="med"/>
+                    </a:lnB>
+                    <a:solidFill>
+                      <a:srgbClr val="FFFFFF"/>
+                    </a:solidFill>
+                  </a:tcPr>
+                </a:tc>
+                <a:tc>
+                  <a:txBody>
+                    <a:bodyPr/>
+                    <a:lstStyle/>
+                    <a:p>
+                      <a:pPr algn="ctr" indent="0" marL="0">
+                        <a:buNone/>
+                      </a:pPr>
+                      <a:r>
+                        <a:rPr lang="en-US" sz="1200" b="1" dirty="0">
+                          <a:solidFill>
+                            <a:srgbClr val="1E8A4C"/>
+                          </a:solidFill>
+                          <a:latin typeface="Arial" pitchFamily="34" charset="0"/>
+                          <a:ea typeface="Arial" pitchFamily="34" charset="-122"/>
+                          <a:cs typeface="Arial" pitchFamily="34" charset="-120"/>
+                        </a:rPr>
+                        <a:t>1.3%</a:t>
+                      </a:r>
+                      <a:endParaRPr lang="en-US" sz="1200" dirty="0">
+                        <a:latin typeface="Arial" charset="0"/>
+                        <a:ea typeface="Arial" charset="0"/>
+                        <a:cs typeface="Arial" charset="0"/>
+                      </a:endParaRPr>
+                    </a:p>
+                  </a:txBody>
+                  <a:tcPr marL="91440" marR="91440" marT="27432" marB="27432" anchor="ctr">
+                    <a:lnL w="6350" cap="flat" cmpd="sng" algn="ctr">
+                      <a:solidFill>
+                        <a:srgbClr val="DADAF0"/>
+                      </a:solidFill>
+                      <a:prstDash val="solid"/>
+                      <a:round/>
+                      <a:headEnd type="none" w="med" len="med"/>
+                      <a:tailEnd type="none" w="med" len="med"/>
+                    </a:lnL>
+                    <a:lnR w="6350" cap="flat" cmpd="sng" algn="ctr">
+                      <a:solidFill>
+                        <a:srgbClr val="DADAF0"/>
+                      </a:solidFill>
+                      <a:prstDash val="solid"/>
+                      <a:round/>
+                      <a:headEnd type="none" w="med" len="med"/>
+                      <a:tailEnd type="none" w="med" len="med"/>
+                    </a:lnR>
+                    <a:lnT w="6350" cap="flat" cmpd="sng" algn="ctr">
+                      <a:solidFill>
+                        <a:srgbClr val="DADAF0"/>
+                      </a:solidFill>
+                      <a:prstDash val="solid"/>
+                      <a:round/>
+                      <a:headEnd type="none" w="med" len="med"/>
+                      <a:tailEnd type="none" w="med" len="med"/>
+                    </a:lnT>
+                    <a:lnB w="6350" cap="flat" cmpd="sng" algn="ctr">
+                      <a:solidFill>
+                        <a:srgbClr val="DADAF0"/>
+                      </a:solidFill>
+                      <a:prstDash val="solid"/>
+                      <a:round/>
+                      <a:headEnd type="none" w="med" len="med"/>
+                      <a:tailEnd type="none" w="med" len="med"/>
+                    </a:lnB>
+                    <a:solidFill>
+                      <a:srgbClr val="FFFFFF"/>
+                    </a:solidFill>
+                  </a:tcPr>
+                </a:tc>
+                <a:tc>
+                  <a:txBody>
+                    <a:bodyPr/>
+                    <a:lstStyle/>
+                    <a:p>
+                      <a:pPr algn="ctr" indent="0" marL="0">
+                        <a:buNone/>
+                      </a:pPr>
+                      <a:r>
+                        <a:rPr lang="en-US" sz="1200" b="1" dirty="0">
+                          <a:solidFill>
+                            <a:srgbClr val="1E8A4C"/>
+                          </a:solidFill>
+                          <a:latin typeface="Arial" pitchFamily="34" charset="0"/>
+                          <a:ea typeface="Arial" pitchFamily="34" charset="-122"/>
+                          <a:cs typeface="Arial" pitchFamily="34" charset="-120"/>
+                        </a:rPr>
+                        <a:t>8.2%</a:t>
                       </a:r>
                       <a:endParaRPr lang="en-US" sz="1200" dirty="0">
                         <a:latin typeface="Arial" charset="0"/>
@@ -11801,143 +11937,7 @@
                           <a:ea typeface="Arial" pitchFamily="34" charset="-122"/>
                           <a:cs typeface="Arial" pitchFamily="34" charset="-120"/>
                         </a:rPr>
-                        <a:t>1.2%</a:t>
-                      </a:r>
-                      <a:endParaRPr lang="en-US" sz="1200" dirty="0">
-                        <a:latin typeface="Arial" charset="0"/>
-                        <a:ea typeface="Arial" charset="0"/>
-                        <a:cs typeface="Arial" charset="0"/>
-                      </a:endParaRPr>
-                    </a:p>
-                  </a:txBody>
-                  <a:tcPr marL="91440" marR="91440" marT="27432" marB="27432" anchor="ctr">
-                    <a:lnL w="6350" cap="flat" cmpd="sng" algn="ctr">
-                      <a:solidFill>
-                        <a:srgbClr val="DADAF0"/>
-                      </a:solidFill>
-                      <a:prstDash val="solid"/>
-                      <a:round/>
-                      <a:headEnd type="none" w="med" len="med"/>
-                      <a:tailEnd type="none" w="med" len="med"/>
-                    </a:lnL>
-                    <a:lnR w="6350" cap="flat" cmpd="sng" algn="ctr">
-                      <a:solidFill>
-                        <a:srgbClr val="DADAF0"/>
-                      </a:solidFill>
-                      <a:prstDash val="solid"/>
-                      <a:round/>
-                      <a:headEnd type="none" w="med" len="med"/>
-                      <a:tailEnd type="none" w="med" len="med"/>
-                    </a:lnR>
-                    <a:lnT w="6350" cap="flat" cmpd="sng" algn="ctr">
-                      <a:solidFill>
-                        <a:srgbClr val="DADAF0"/>
-                      </a:solidFill>
-                      <a:prstDash val="solid"/>
-                      <a:round/>
-                      <a:headEnd type="none" w="med" len="med"/>
-                      <a:tailEnd type="none" w="med" len="med"/>
-                    </a:lnT>
-                    <a:lnB w="6350" cap="flat" cmpd="sng" algn="ctr">
-                      <a:solidFill>
-                        <a:srgbClr val="DADAF0"/>
-                      </a:solidFill>
-                      <a:prstDash val="solid"/>
-                      <a:round/>
-                      <a:headEnd type="none" w="med" len="med"/>
-                      <a:tailEnd type="none" w="med" len="med"/>
-                    </a:lnB>
-                    <a:solidFill>
-                      <a:srgbClr val="FFFFFF"/>
-                    </a:solidFill>
-                  </a:tcPr>
-                </a:tc>
-                <a:tc>
-                  <a:txBody>
-                    <a:bodyPr/>
-                    <a:lstStyle/>
-                    <a:p>
-                      <a:pPr algn="ctr" indent="0" marL="0">
-                        <a:buNone/>
-                      </a:pPr>
-                      <a:r>
-                        <a:rPr lang="en-US" sz="1200" dirty="0">
-                          <a:solidFill>
-                            <a:srgbClr val="1A1A2E"/>
-                          </a:solidFill>
-                          <a:latin typeface="Arial" pitchFamily="34" charset="0"/>
-                          <a:ea typeface="Arial" pitchFamily="34" charset="-122"/>
-                          <a:cs typeface="Arial" pitchFamily="34" charset="-120"/>
-                        </a:rPr>
-                        <a:t>7.4%</a:t>
-                      </a:r>
-                      <a:endParaRPr lang="en-US" sz="1200" dirty="0">
-                        <a:latin typeface="Arial" charset="0"/>
-                        <a:ea typeface="Arial" charset="0"/>
-                        <a:cs typeface="Arial" charset="0"/>
-                      </a:endParaRPr>
-                    </a:p>
-                  </a:txBody>
-                  <a:tcPr marL="91440" marR="91440" marT="27432" marB="27432" anchor="ctr">
-                    <a:lnL w="6350" cap="flat" cmpd="sng" algn="ctr">
-                      <a:solidFill>
-                        <a:srgbClr val="DADAF0"/>
-                      </a:solidFill>
-                      <a:prstDash val="solid"/>
-                      <a:round/>
-                      <a:headEnd type="none" w="med" len="med"/>
-                      <a:tailEnd type="none" w="med" len="med"/>
-                    </a:lnL>
-                    <a:lnR w="6350" cap="flat" cmpd="sng" algn="ctr">
-                      <a:solidFill>
-                        <a:srgbClr val="DADAF0"/>
-                      </a:solidFill>
-                      <a:prstDash val="solid"/>
-                      <a:round/>
-                      <a:headEnd type="none" w="med" len="med"/>
-                      <a:tailEnd type="none" w="med" len="med"/>
-                    </a:lnR>
-                    <a:lnT w="6350" cap="flat" cmpd="sng" algn="ctr">
-                      <a:solidFill>
-                        <a:srgbClr val="DADAF0"/>
-                      </a:solidFill>
-                      <a:prstDash val="solid"/>
-                      <a:round/>
-                      <a:headEnd type="none" w="med" len="med"/>
-                      <a:tailEnd type="none" w="med" len="med"/>
-                    </a:lnT>
-                    <a:lnB w="6350" cap="flat" cmpd="sng" algn="ctr">
-                      <a:solidFill>
-                        <a:srgbClr val="DADAF0"/>
-                      </a:solidFill>
-                      <a:prstDash val="solid"/>
-                      <a:round/>
-                      <a:headEnd type="none" w="med" len="med"/>
-                      <a:tailEnd type="none" w="med" len="med"/>
-                    </a:lnB>
-                    <a:solidFill>
-                      <a:srgbClr val="FFFFFF"/>
-                    </a:solidFill>
-                  </a:tcPr>
-                </a:tc>
-                <a:tc>
-                  <a:txBody>
-                    <a:bodyPr/>
-                    <a:lstStyle/>
-                    <a:p>
-                      <a:pPr algn="ctr" indent="0" marL="0">
-                        <a:buNone/>
-                      </a:pPr>
-                      <a:r>
-                        <a:rPr lang="en-US" sz="1200" dirty="0">
-                          <a:solidFill>
-                            <a:srgbClr val="1A1A2E"/>
-                          </a:solidFill>
-                          <a:latin typeface="Arial" pitchFamily="34" charset="0"/>
-                          <a:ea typeface="Arial" pitchFamily="34" charset="-122"/>
-                          <a:cs typeface="Arial" pitchFamily="34" charset="-120"/>
-                        </a:rPr>
-                        <a:t>7%</a:t>
+                        <a:t>15%</a:t>
                       </a:r>
                       <a:endParaRPr lang="en-US" sz="1200" dirty="0">
                         <a:latin typeface="Arial" charset="0"/>
@@ -12007,7 +12007,7 @@
                           <a:ea typeface="Arial" pitchFamily="34" charset="-122"/>
                           <a:cs typeface="Arial" pitchFamily="34" charset="-120"/>
                         </a:rPr>
-                        <a:t>Home furnishing</a:t>
+                        <a:t>Fitness</a:t>
                       </a:r>
                       <a:endParaRPr lang="en-US" sz="1200" dirty="0">
                         <a:latin typeface="Arial" charset="0"/>
@@ -12143,7 +12143,7 @@
                           <a:ea typeface="Arial" pitchFamily="34" charset="-122"/>
                           <a:cs typeface="Arial" pitchFamily="34" charset="-120"/>
                         </a:rPr>
-                        <a:t>14%</a:t>
+                        <a:t>7%</a:t>
                       </a:r>
                       <a:endParaRPr lang="en-US" sz="1200" dirty="0">
                         <a:latin typeface="Arial" charset="0"/>
@@ -12211,143 +12211,7 @@
                           <a:ea typeface="Arial" pitchFamily="34" charset="-122"/>
                           <a:cs typeface="Arial" pitchFamily="34" charset="-120"/>
                         </a:rPr>
-                        <a:t>4%</a:t>
-                      </a:r>
-                      <a:endParaRPr lang="en-US" sz="1200" dirty="0">
-                        <a:latin typeface="Arial" charset="0"/>
-                        <a:ea typeface="Arial" charset="0"/>
-                        <a:cs typeface="Arial" charset="0"/>
-                      </a:endParaRPr>
-                    </a:p>
-                  </a:txBody>
-                  <a:tcPr marL="91440" marR="91440" marT="27432" marB="27432" anchor="ctr">
-                    <a:lnL w="6350" cap="flat" cmpd="sng" algn="ctr">
-                      <a:solidFill>
-                        <a:srgbClr val="DADAF0"/>
-                      </a:solidFill>
-                      <a:prstDash val="solid"/>
-                      <a:round/>
-                      <a:headEnd type="none" w="med" len="med"/>
-                      <a:tailEnd type="none" w="med" len="med"/>
-                    </a:lnL>
-                    <a:lnR w="6350" cap="flat" cmpd="sng" algn="ctr">
-                      <a:solidFill>
-                        <a:srgbClr val="DADAF0"/>
-                      </a:solidFill>
-                      <a:prstDash val="solid"/>
-                      <a:round/>
-                      <a:headEnd type="none" w="med" len="med"/>
-                      <a:tailEnd type="none" w="med" len="med"/>
-                    </a:lnR>
-                    <a:lnT w="6350" cap="flat" cmpd="sng" algn="ctr">
-                      <a:solidFill>
-                        <a:srgbClr val="DADAF0"/>
-                      </a:solidFill>
-                      <a:prstDash val="solid"/>
-                      <a:round/>
-                      <a:headEnd type="none" w="med" len="med"/>
-                      <a:tailEnd type="none" w="med" len="med"/>
-                    </a:lnT>
-                    <a:lnB w="6350" cap="flat" cmpd="sng" algn="ctr">
-                      <a:solidFill>
-                        <a:srgbClr val="DADAF0"/>
-                      </a:solidFill>
-                      <a:prstDash val="solid"/>
-                      <a:round/>
-                      <a:headEnd type="none" w="med" len="med"/>
-                      <a:tailEnd type="none" w="med" len="med"/>
-                    </a:lnB>
-                    <a:solidFill>
-                      <a:srgbClr val="F6F6FE"/>
-                    </a:solidFill>
-                  </a:tcPr>
-                </a:tc>
-                <a:tc>
-                  <a:txBody>
-                    <a:bodyPr/>
-                    <a:lstStyle/>
-                    <a:p>
-                      <a:pPr algn="ctr" indent="0" marL="0">
-                        <a:buNone/>
-                      </a:pPr>
-                      <a:r>
-                        <a:rPr lang="en-US" sz="1200" b="1" dirty="0">
-                          <a:solidFill>
-                            <a:srgbClr val="1E8A4C"/>
-                          </a:solidFill>
-                          <a:latin typeface="Arial" pitchFamily="34" charset="0"/>
-                          <a:ea typeface="Arial" pitchFamily="34" charset="-122"/>
-                          <a:cs typeface="Arial" pitchFamily="34" charset="-120"/>
-                        </a:rPr>
-                        <a:t>1.2%</a:t>
-                      </a:r>
-                      <a:endParaRPr lang="en-US" sz="1200" dirty="0">
-                        <a:latin typeface="Arial" charset="0"/>
-                        <a:ea typeface="Arial" charset="0"/>
-                        <a:cs typeface="Arial" charset="0"/>
-                      </a:endParaRPr>
-                    </a:p>
-                  </a:txBody>
-                  <a:tcPr marL="91440" marR="91440" marT="27432" marB="27432" anchor="ctr">
-                    <a:lnL w="6350" cap="flat" cmpd="sng" algn="ctr">
-                      <a:solidFill>
-                        <a:srgbClr val="DADAF0"/>
-                      </a:solidFill>
-                      <a:prstDash val="solid"/>
-                      <a:round/>
-                      <a:headEnd type="none" w="med" len="med"/>
-                      <a:tailEnd type="none" w="med" len="med"/>
-                    </a:lnL>
-                    <a:lnR w="6350" cap="flat" cmpd="sng" algn="ctr">
-                      <a:solidFill>
-                        <a:srgbClr val="DADAF0"/>
-                      </a:solidFill>
-                      <a:prstDash val="solid"/>
-                      <a:round/>
-                      <a:headEnd type="none" w="med" len="med"/>
-                      <a:tailEnd type="none" w="med" len="med"/>
-                    </a:lnR>
-                    <a:lnT w="6350" cap="flat" cmpd="sng" algn="ctr">
-                      <a:solidFill>
-                        <a:srgbClr val="DADAF0"/>
-                      </a:solidFill>
-                      <a:prstDash val="solid"/>
-                      <a:round/>
-                      <a:headEnd type="none" w="med" len="med"/>
-                      <a:tailEnd type="none" w="med" len="med"/>
-                    </a:lnT>
-                    <a:lnB w="6350" cap="flat" cmpd="sng" algn="ctr">
-                      <a:solidFill>
-                        <a:srgbClr val="DADAF0"/>
-                      </a:solidFill>
-                      <a:prstDash val="solid"/>
-                      <a:round/>
-                      <a:headEnd type="none" w="med" len="med"/>
-                      <a:tailEnd type="none" w="med" len="med"/>
-                    </a:lnB>
-                    <a:solidFill>
-                      <a:srgbClr val="F6F6FE"/>
-                    </a:solidFill>
-                  </a:tcPr>
-                </a:tc>
-                <a:tc>
-                  <a:txBody>
-                    <a:bodyPr/>
-                    <a:lstStyle/>
-                    <a:p>
-                      <a:pPr algn="ctr" indent="0" marL="0">
-                        <a:buNone/>
-                      </a:pPr>
-                      <a:r>
-                        <a:rPr lang="en-US" sz="1200" b="1" dirty="0">
-                          <a:solidFill>
-                            <a:srgbClr val="1E8A4C"/>
-                          </a:solidFill>
-                          <a:latin typeface="Arial" pitchFamily="34" charset="0"/>
-                          <a:ea typeface="Arial" pitchFamily="34" charset="-122"/>
-                          <a:cs typeface="Arial" pitchFamily="34" charset="-120"/>
-                        </a:rPr>
-                        <a:t>7.4%</a:t>
+                        <a:t>4.8%</a:t>
                       </a:r>
                       <a:endParaRPr lang="en-US" sz="1200" dirty="0">
                         <a:latin typeface="Arial" charset="0"/>
@@ -12415,7 +12279,143 @@
                           <a:ea typeface="Arial" pitchFamily="34" charset="-122"/>
                           <a:cs typeface="Arial" pitchFamily="34" charset="-120"/>
                         </a:rPr>
-                        <a:t>15%</a:t>
+                        <a:t>1.3%</a:t>
+                      </a:r>
+                      <a:endParaRPr lang="en-US" sz="1200" dirty="0">
+                        <a:latin typeface="Arial" charset="0"/>
+                        <a:ea typeface="Arial" charset="0"/>
+                        <a:cs typeface="Arial" charset="0"/>
+                      </a:endParaRPr>
+                    </a:p>
+                  </a:txBody>
+                  <a:tcPr marL="91440" marR="91440" marT="27432" marB="27432" anchor="ctr">
+                    <a:lnL w="6350" cap="flat" cmpd="sng" algn="ctr">
+                      <a:solidFill>
+                        <a:srgbClr val="DADAF0"/>
+                      </a:solidFill>
+                      <a:prstDash val="solid"/>
+                      <a:round/>
+                      <a:headEnd type="none" w="med" len="med"/>
+                      <a:tailEnd type="none" w="med" len="med"/>
+                    </a:lnL>
+                    <a:lnR w="6350" cap="flat" cmpd="sng" algn="ctr">
+                      <a:solidFill>
+                        <a:srgbClr val="DADAF0"/>
+                      </a:solidFill>
+                      <a:prstDash val="solid"/>
+                      <a:round/>
+                      <a:headEnd type="none" w="med" len="med"/>
+                      <a:tailEnd type="none" w="med" len="med"/>
+                    </a:lnR>
+                    <a:lnT w="6350" cap="flat" cmpd="sng" algn="ctr">
+                      <a:solidFill>
+                        <a:srgbClr val="DADAF0"/>
+                      </a:solidFill>
+                      <a:prstDash val="solid"/>
+                      <a:round/>
+                      <a:headEnd type="none" w="med" len="med"/>
+                      <a:tailEnd type="none" w="med" len="med"/>
+                    </a:lnT>
+                    <a:lnB w="6350" cap="flat" cmpd="sng" algn="ctr">
+                      <a:solidFill>
+                        <a:srgbClr val="DADAF0"/>
+                      </a:solidFill>
+                      <a:prstDash val="solid"/>
+                      <a:round/>
+                      <a:headEnd type="none" w="med" len="med"/>
+                      <a:tailEnd type="none" w="med" len="med"/>
+                    </a:lnB>
+                    <a:solidFill>
+                      <a:srgbClr val="F6F6FE"/>
+                    </a:solidFill>
+                  </a:tcPr>
+                </a:tc>
+                <a:tc>
+                  <a:txBody>
+                    <a:bodyPr/>
+                    <a:lstStyle/>
+                    <a:p>
+                      <a:pPr algn="ctr" indent="0" marL="0">
+                        <a:buNone/>
+                      </a:pPr>
+                      <a:r>
+                        <a:rPr lang="en-US" sz="1200" dirty="0">
+                          <a:solidFill>
+                            <a:srgbClr val="1A1A2E"/>
+                          </a:solidFill>
+                          <a:latin typeface="Arial" pitchFamily="34" charset="0"/>
+                          <a:ea typeface="Arial" pitchFamily="34" charset="-122"/>
+                          <a:cs typeface="Arial" pitchFamily="34" charset="-120"/>
+                        </a:rPr>
+                        <a:t>8.1%</a:t>
+                      </a:r>
+                      <a:endParaRPr lang="en-US" sz="1200" dirty="0">
+                        <a:latin typeface="Arial" charset="0"/>
+                        <a:ea typeface="Arial" charset="0"/>
+                        <a:cs typeface="Arial" charset="0"/>
+                      </a:endParaRPr>
+                    </a:p>
+                  </a:txBody>
+                  <a:tcPr marL="91440" marR="91440" marT="27432" marB="27432" anchor="ctr">
+                    <a:lnL w="6350" cap="flat" cmpd="sng" algn="ctr">
+                      <a:solidFill>
+                        <a:srgbClr val="DADAF0"/>
+                      </a:solidFill>
+                      <a:prstDash val="solid"/>
+                      <a:round/>
+                      <a:headEnd type="none" w="med" len="med"/>
+                      <a:tailEnd type="none" w="med" len="med"/>
+                    </a:lnL>
+                    <a:lnR w="6350" cap="flat" cmpd="sng" algn="ctr">
+                      <a:solidFill>
+                        <a:srgbClr val="DADAF0"/>
+                      </a:solidFill>
+                      <a:prstDash val="solid"/>
+                      <a:round/>
+                      <a:headEnd type="none" w="med" len="med"/>
+                      <a:tailEnd type="none" w="med" len="med"/>
+                    </a:lnR>
+                    <a:lnT w="6350" cap="flat" cmpd="sng" algn="ctr">
+                      <a:solidFill>
+                        <a:srgbClr val="DADAF0"/>
+                      </a:solidFill>
+                      <a:prstDash val="solid"/>
+                      <a:round/>
+                      <a:headEnd type="none" w="med" len="med"/>
+                      <a:tailEnd type="none" w="med" len="med"/>
+                    </a:lnT>
+                    <a:lnB w="6350" cap="flat" cmpd="sng" algn="ctr">
+                      <a:solidFill>
+                        <a:srgbClr val="DADAF0"/>
+                      </a:solidFill>
+                      <a:prstDash val="solid"/>
+                      <a:round/>
+                      <a:headEnd type="none" w="med" len="med"/>
+                      <a:tailEnd type="none" w="med" len="med"/>
+                    </a:lnB>
+                    <a:solidFill>
+                      <a:srgbClr val="F6F6FE"/>
+                    </a:solidFill>
+                  </a:tcPr>
+                </a:tc>
+                <a:tc>
+                  <a:txBody>
+                    <a:bodyPr/>
+                    <a:lstStyle/>
+                    <a:p>
+                      <a:pPr algn="ctr" indent="0" marL="0">
+                        <a:buNone/>
+                      </a:pPr>
+                      <a:r>
+                        <a:rPr lang="en-US" sz="1200" dirty="0">
+                          <a:solidFill>
+                            <a:srgbClr val="1A1A2E"/>
+                          </a:solidFill>
+                          <a:latin typeface="Arial" pitchFamily="34" charset="0"/>
+                          <a:ea typeface="Arial" pitchFamily="34" charset="-122"/>
+                          <a:cs typeface="Arial" pitchFamily="34" charset="-120"/>
+                        </a:rPr>
+                        <a:t>7%</a:t>
                       </a:r>
                       <a:endParaRPr lang="en-US" sz="1200" dirty="0">
                         <a:latin typeface="Arial" charset="0"/>
@@ -12689,7 +12689,7 @@
                           <a:ea typeface="Arial" pitchFamily="34" charset="-122"/>
                           <a:cs typeface="Arial" pitchFamily="34" charset="-120"/>
                         </a:rPr>
-                        <a:t>4%</a:t>
+                        <a:t>4.5%</a:t>
                       </a:r>
                       <a:endParaRPr lang="en-US" sz="1200" dirty="0">
                         <a:latin typeface="Arial" charset="0"/>
@@ -12757,7 +12757,7 @@
                           <a:ea typeface="Arial" pitchFamily="34" charset="-122"/>
                           <a:cs typeface="Arial" pitchFamily="34" charset="-120"/>
                         </a:rPr>
-                        <a:t>1.4%</a:t>
+                        <a:t>1.6%</a:t>
                       </a:r>
                       <a:endParaRPr lang="en-US" sz="1200" dirty="0">
                         <a:latin typeface="Arial" charset="0"/>
@@ -12825,7 +12825,7 @@
                           <a:ea typeface="Arial" pitchFamily="34" charset="-122"/>
                           <a:cs typeface="Arial" pitchFamily="34" charset="-120"/>
                         </a:rPr>
-                        <a:t>6.4%</a:t>
+                        <a:t>7.2%</a:t>
                       </a:r>
                       <a:endParaRPr lang="en-US" sz="1200" dirty="0">
                         <a:latin typeface="Arial" charset="0"/>
@@ -13167,7 +13167,7 @@
                           <a:ea typeface="Arial" pitchFamily="34" charset="-122"/>
                           <a:cs typeface="Arial" pitchFamily="34" charset="-120"/>
                         </a:rPr>
-                        <a:t>4%</a:t>
+                        <a:t>4.5%</a:t>
                       </a:r>
                       <a:endParaRPr lang="en-US" sz="1200" dirty="0">
                         <a:latin typeface="Arial" charset="0"/>
@@ -13235,7 +13235,7 @@
                           <a:ea typeface="Arial" pitchFamily="34" charset="-122"/>
                           <a:cs typeface="Arial" pitchFamily="34" charset="-120"/>
                         </a:rPr>
-                        <a:t>1.9%</a:t>
+                        <a:t>1.7%</a:t>
                       </a:r>
                       <a:endParaRPr lang="en-US" sz="1200" dirty="0">
                         <a:latin typeface="Arial" charset="0"/>
@@ -13303,7 +13303,7 @@
                           <a:ea typeface="Arial" pitchFamily="34" charset="-122"/>
                           <a:cs typeface="Arial" pitchFamily="34" charset="-120"/>
                         </a:rPr>
-                        <a:t>6.1%</a:t>
+                        <a:t>6.9%</a:t>
                       </a:r>
                       <a:endParaRPr lang="en-US" sz="1200" dirty="0">
                         <a:latin typeface="Arial" charset="0"/>
@@ -13637,15 +13637,15 @@
                         <a:buNone/>
                       </a:pPr>
                       <a:r>
-                        <a:rPr lang="en-US" sz="1200" dirty="0">
+                        <a:rPr lang="en-US" sz="1200" b="1" dirty="0">
                           <a:solidFill>
-                            <a:srgbClr val="1A1A2E"/>
+                            <a:srgbClr val="C93B3B"/>
                           </a:solidFill>
                           <a:latin typeface="Arial" pitchFamily="34" charset="0"/>
                           <a:ea typeface="Arial" pitchFamily="34" charset="-122"/>
                           <a:cs typeface="Arial" pitchFamily="34" charset="-120"/>
                         </a:rPr>
-                        <a:t>5%</a:t>
+                        <a:t>6.2%</a:t>
                       </a:r>
                       <a:endParaRPr lang="en-US" sz="1200" dirty="0">
                         <a:latin typeface="Arial" charset="0"/>
@@ -13713,7 +13713,7 @@
                           <a:ea typeface="Arial" pitchFamily="34" charset="-122"/>
                           <a:cs typeface="Arial" pitchFamily="34" charset="-120"/>
                         </a:rPr>
-                        <a:t>2.5%</a:t>
+                        <a:t>3.2%</a:t>
                       </a:r>
                       <a:endParaRPr lang="en-US" sz="1200" dirty="0">
                         <a:latin typeface="Arial" charset="0"/>
@@ -13781,7 +13781,7 @@
                           <a:ea typeface="Arial" pitchFamily="34" charset="-122"/>
                           <a:cs typeface="Arial" pitchFamily="34" charset="-120"/>
                         </a:rPr>
-                        <a:t>3.8%</a:t>
+                        <a:t>3.5%</a:t>
                       </a:r>
                       <a:endParaRPr lang="en-US" sz="1200" dirty="0">
                         <a:latin typeface="Arial" charset="0"/>
@@ -14004,7 +14004,7 @@
                 <a:ea typeface="Arial" pitchFamily="34" charset="-122"/>
                 <a:cs typeface="Arial" pitchFamily="34" charset="-120"/>
               </a:rPr>
-              <a:t>~40% delinquent or charged off; 6.3% loss. Margin 6.7% falls to ~0% if delinquent loans charge off.</a:t>
+              <a:t>~43% delinquent or charged off; 6.4% loss. Margin 7.1% falls to ~1% if delinquent loans charge off.</a:t>
             </a:r>
             <a:endParaRPr lang="en-US" sz="1200" dirty="0"/>
           </a:p>
@@ -14109,7 +14109,7 @@
                 <a:ea typeface="Arial" pitchFamily="34" charset="-122"/>
                 <a:cs typeface="Arial" pitchFamily="34" charset="-120"/>
               </a:rPr>
-              <a:t>51% of loans but 10% of profit. Small tickets; fashion Split Pay earns ~1% margin.</a:t>
+              <a:t>51% of loans but 10% of profit. Small tickets; fashion Split Pay earns ~0.5% margin.</a:t>
             </a:r>
             <a:endParaRPr lang="en-US" sz="1200" dirty="0"/>
           </a:p>
@@ -14214,7 +14214,7 @@
                 <a:ea typeface="Arial" pitchFamily="34" charset="-122"/>
                 <a:cs typeface="Arial" pitchFamily="34" charset="-120"/>
               </a:rPr>
-              <a:t>Low loss (1.2–1.5%) with high revenue. A healthcare customer is worth ~$215 in profit over their loans.</a:t>
+              <a:t>Low loss (1.3–2.0%) with high revenue. A healthcare customer is worth ~$215 in profit over their loans.</a:t>
             </a:r>
             <a:endParaRPr lang="en-US" sz="1200" dirty="0"/>
           </a:p>
@@ -14253,7 +14253,7 @@
                 <a:ea typeface="Arial" pitchFamily="34" charset="-122"/>
                 <a:cs typeface="Arial" pitchFamily="34" charset="-120"/>
               </a:rPr>
-              <a:t>Bad rate = share of loans delinquent 30/60 or charged off. Rates are % of GMV. Ranking holds on seasoned loans (originated by Jun 2025).</a:t>
+              <a:t>* Rates on seasoned loans (originated Jul 2024–Jun 2025); shares on all loans. Bad rate = delinquent 30/60 or charged off. Rates are % of GMV.</a:t>
             </a:r>
             <a:endParaRPr lang="en-US" sz="1000" dirty="0"/>
           </a:p>
@@ -14692,7 +14692,7 @@
                           <a:ea typeface="Arial" pitchFamily="34" charset="-122"/>
                           <a:cs typeface="Arial" pitchFamily="34" charset="-120"/>
                         </a:rPr>
-                        <a:t>Loss rate</a:t>
+                        <a:t>Loss rate*</a:t>
                       </a:r>
                       <a:endParaRPr lang="en-US" sz="1300" dirty="0">
                         <a:latin typeface="Arial" charset="0"/>
@@ -14760,7 +14760,7 @@
                           <a:ea typeface="Arial" pitchFamily="34" charset="-122"/>
                           <a:cs typeface="Arial" pitchFamily="34" charset="-120"/>
                         </a:rPr>
-                        <a:t>Merchant fee</a:t>
+                        <a:t>Merchant fee*</a:t>
                       </a:r>
                       <a:endParaRPr lang="en-US" sz="1300" dirty="0">
                         <a:latin typeface="Arial" charset="0"/>
@@ -14828,7 +14828,7 @@
                           <a:ea typeface="Arial" pitchFamily="34" charset="-122"/>
                           <a:cs typeface="Arial" pitchFamily="34" charset="-120"/>
                         </a:rPr>
-                        <a:t>Interest</a:t>
+                        <a:t>Interest*</a:t>
                       </a:r>
                       <a:endParaRPr lang="en-US" sz="1300" dirty="0">
                         <a:latin typeface="Arial" charset="0"/>
@@ -14896,7 +14896,7 @@
                           <a:ea typeface="Arial" pitchFamily="34" charset="-122"/>
                           <a:cs typeface="Arial" pitchFamily="34" charset="-120"/>
                         </a:rPr>
-                        <a:t>Margin</a:t>
+                        <a:t>Margin*</a:t>
                       </a:r>
                       <a:endParaRPr lang="en-US" sz="1300" dirty="0">
                         <a:latin typeface="Arial" charset="0"/>
@@ -15306,7 +15306,7 @@
                           <a:ea typeface="Arial" pitchFamily="34" charset="-122"/>
                           <a:cs typeface="Arial" pitchFamily="34" charset="-120"/>
                         </a:rPr>
-                        <a:t>2.3%</a:t>
+                        <a:t>2.8%</a:t>
                       </a:r>
                       <a:endParaRPr lang="en-US" sz="1300" dirty="0">
                         <a:latin typeface="Arial" charset="0"/>
@@ -15374,7 +15374,7 @@
                           <a:ea typeface="Arial" pitchFamily="34" charset="-122"/>
                           <a:cs typeface="Arial" pitchFamily="34" charset="-120"/>
                         </a:rPr>
-                        <a:t>6.1%</a:t>
+                        <a:t>6.2%</a:t>
                       </a:r>
                       <a:endParaRPr lang="en-US" sz="1300" dirty="0">
                         <a:latin typeface="Arial" charset="0"/>
@@ -15442,7 +15442,7 @@
                           <a:ea typeface="Arial" pitchFamily="34" charset="-122"/>
                           <a:cs typeface="Arial" pitchFamily="34" charset="-120"/>
                         </a:rPr>
-                        <a:t>7.4%</a:t>
+                        <a:t>9.3%</a:t>
                       </a:r>
                       <a:endParaRPr lang="en-US" sz="1300" dirty="0">
                         <a:latin typeface="Arial" charset="0"/>
@@ -15510,7 +15510,7 @@
                           <a:ea typeface="Arial" pitchFamily="34" charset="-122"/>
                           <a:cs typeface="Arial" pitchFamily="34" charset="-120"/>
                         </a:rPr>
-                        <a:t>9.9%</a:t>
+                        <a:t>11.3%</a:t>
                       </a:r>
                       <a:endParaRPr lang="en-US" sz="1300" dirty="0">
                         <a:latin typeface="Arial" charset="0"/>
@@ -15920,7 +15920,7 @@
                           <a:ea typeface="Arial" pitchFamily="34" charset="-122"/>
                           <a:cs typeface="Arial" pitchFamily="34" charset="-120"/>
                         </a:rPr>
-                        <a:t>1.0%</a:t>
+                        <a:t>0.7%</a:t>
                       </a:r>
                       <a:endParaRPr lang="en-US" sz="1300" dirty="0">
                         <a:latin typeface="Arial" charset="0"/>
@@ -16124,7 +16124,7 @@
                           <a:ea typeface="Arial" pitchFamily="34" charset="-122"/>
                           <a:cs typeface="Arial" pitchFamily="34" charset="-120"/>
                         </a:rPr>
-                        <a:t>3.4%</a:t>
+                        <a:t>3.7%</a:t>
                       </a:r>
                       <a:endParaRPr lang="en-US" sz="1300" dirty="0">
                         <a:latin typeface="Arial" charset="0"/>
@@ -16534,7 +16534,7 @@
                           <a:ea typeface="Arial" pitchFamily="34" charset="-122"/>
                           <a:cs typeface="Arial" pitchFamily="34" charset="-120"/>
                         </a:rPr>
-                        <a:t>2.2%</a:t>
+                        <a:t>2.5%</a:t>
                       </a:r>
                       <a:endParaRPr lang="en-US" sz="1300" dirty="0">
                         <a:latin typeface="Arial" charset="0"/>
@@ -16602,7 +16602,7 @@
                           <a:ea typeface="Arial" pitchFamily="34" charset="-122"/>
                           <a:cs typeface="Arial" pitchFamily="34" charset="-120"/>
                         </a:rPr>
-                        <a:t>5.0%</a:t>
+                        <a:t>5.1%</a:t>
                       </a:r>
                       <a:endParaRPr lang="en-US" sz="1300" dirty="0">
                         <a:latin typeface="Arial" charset="0"/>
@@ -16738,7 +16738,7 @@
                           <a:ea typeface="Arial" pitchFamily="34" charset="-122"/>
                           <a:cs typeface="Arial" pitchFamily="34" charset="-120"/>
                         </a:rPr>
-                        <a:t>2.6%</a:t>
+                        <a:t>2.4%</a:t>
                       </a:r>
                       <a:endParaRPr lang="en-US" sz="1300" dirty="0">
                         <a:latin typeface="Arial" charset="0"/>
@@ -16961,7 +16961,7 @@
                 <a:ea typeface="Arial" pitchFamily="34" charset="-122"/>
                 <a:cs typeface="Arial" pitchFamily="34" charset="-120"/>
               </a:rPr>
-              <a:t>Lowest risk (FICO 683, 1.0% loss), but no interest and a 12–18 month term to fund. The promo is meant to be paid for by a higher merchant fee — yet at the same promo merchants its fee averages 5.0% vs 5.4% for interest-bearing.</a:t>
+              <a:t>Lowest risk (FICO 683, 0.7% loss), but no interest and a 12–18 month term to fund. The promo is meant to be paid for by a higher merchant fee — yet at the same promo merchants its fee averages 5.1% vs 5.5% for interest-bearing.</a:t>
             </a:r>
             <a:endParaRPr lang="en-US" sz="1200" dirty="0"/>
           </a:p>
@@ -17066,7 +17066,7 @@
                 <a:ea typeface="Arial" pitchFamily="34" charset="-122"/>
                 <a:cs typeface="Arial" pitchFamily="34" charset="-120"/>
               </a:rPr>
-              <a:t>Thin margin (2.6%) with loss as high as interest-bearing, but 63% of customers who start with Split Pay take an interest-bearing loan next.</a:t>
+              <a:t>Thin margin (2.4%) with loss (2.5%) close to interest-bearing, but 63% of customers who start with Split Pay take an interest-bearing loan next.</a:t>
             </a:r>
             <a:endParaRPr lang="en-US" sz="1200" dirty="0"/>
           </a:p>
@@ -17171,7 +17171,7 @@
                 <a:ea typeface="Arial" pitchFamily="34" charset="-122"/>
                 <a:cs typeface="Arial" pitchFamily="34" charset="-120"/>
               </a:rPr>
-              <a:t>Highest loss (2.3%) is more than covered by 7.4% interest income — 58% of GMV, 82% of profit.</a:t>
+              <a:t>Highest loss (2.8%) is more than covered by 9.3% interest income — 58% of GMV, 82% of profit.</a:t>
             </a:r>
             <a:endParaRPr lang="en-US" sz="1200" dirty="0"/>
           </a:p>
@@ -17210,7 +17210,7 @@
                 <a:ea typeface="Arial" pitchFamily="34" charset="-122"/>
                 <a:cs typeface="Arial" pitchFamily="34" charset="-120"/>
               </a:rPr>
-              <a:t>Merchant fee and interest are % of GMV (dollar-weighted). Same-merchant comparison uses merchants with a promo program. Loss rate includes expected loss on delinquent loans.</a:t>
+              <a:t>* Rates on seasoned loans (originated Jul 2024–Jun 2025), % of GMV; shares and FICO on all loans. Same-merchant fee comparison uses merchants with a promo program.</a:t>
             </a:r>
             <a:endParaRPr lang="en-US" sz="1000" dirty="0"/>
           </a:p>
@@ -17402,7 +17402,7 @@
                 <a:ea typeface="Arial" pitchFamily="34" charset="-122"/>
                 <a:cs typeface="Arial" pitchFamily="34" charset="-120"/>
               </a:rPr>
-              <a:t>2.6% vs 1.0%</a:t>
+              <a:t>2.8% vs 1.1%</a:t>
             </a:r>
             <a:endParaRPr lang="en-US" sz="2400" dirty="0"/>
           </a:p>
@@ -17441,7 +17441,7 @@
                 <a:ea typeface="Arial" pitchFamily="34" charset="-122"/>
                 <a:cs typeface="Arial" pitchFamily="34" charset="-120"/>
               </a:rPr>
-              <a:t>Loss rate, first loans vs repeat loans — lower in every vertical and product</a:t>
+              <a:t>Loss rate on seasoned loans, first vs repeat — lower in every vertical and product</a:t>
             </a:r>
             <a:endParaRPr lang="en-US" sz="1150" dirty="0"/>
           </a:p>
@@ -18458,7 +18458,7 @@
                           <a:ea typeface="Arial" pitchFamily="34" charset="-122"/>
                           <a:cs typeface="Arial" pitchFamily="34" charset="-120"/>
                         </a:rPr>
-                        <a:t>Best risk-adjusted margins (9.1%, 7.4%) with 1.2–1.5% loss</a:t>
+                        <a:t>Best risk-adjusted margins (9.8%, 8.2%) with 1.3–2.0% loss</a:t>
                       </a:r>
                       <a:endParaRPr lang="en-US" sz="1100" dirty="0">
                         <a:latin typeface="Arial" charset="0"/>
@@ -19446,7 +19446,7 @@
                           <a:ea typeface="Arial" pitchFamily="34" charset="-122"/>
                           <a:cs typeface="Arial" pitchFamily="34" charset="-120"/>
                         </a:rPr>
-                        <a:t>~40% bad rate, 6.3% loss; margin ~0% if delinquents charge off</a:t>
+                        <a:t>~43% bad rate, 6.4% loss; margin ~1% if delinquents charge off</a:t>
                       </a:r>
                       <a:endParaRPr lang="en-US" sz="1100" dirty="0">
                         <a:latin typeface="Arial" charset="0"/>
@@ -19940,7 +19940,7 @@
                           <a:ea typeface="Arial" pitchFamily="34" charset="-122"/>
                           <a:cs typeface="Arial" pitchFamily="34" charset="-120"/>
                         </a:rPr>
-                        <a:t>Fee is 5.0% vs 5.4% for interest-bearing at the same merchants</a:t>
+                        <a:t>Fee is 5.1% vs 5.5% for interest-bearing at the same merchants</a:t>
                       </a:r>
                       <a:endParaRPr lang="en-US" sz="1100" dirty="0">
                         <a:latin typeface="Arial" charset="0"/>
@@ -23211,7 +23211,7 @@
                 <a:ea typeface="Arial" pitchFamily="34" charset="-122"/>
                 <a:cs typeface="Arial" pitchFamily="34" charset="-120"/>
               </a:rPr>
-              <a:t>Young loans haven't paid interest or defaulted yet. Loss/margin comparisons are checked on seasoned loans (originated by Jun 2025).</a:t>
+              <a:t>Young loans haven't paid interest or defaulted yet, so segment rates (bad rate, loss, fees, interest, margin) use seasoned loans (originated Jul 2024–Jun 2025); shares use all loans.</a:t>
             </a:r>
             <a:endParaRPr lang="en-US" sz="1250" dirty="0"/>
           </a:p>

</xml_diff>

<commit_message>
Clarify why/how on investment plan slide
Travel row now shows its share of travel GMV vs losses and the stress
margin; merchant row gives customers and profit per merchant and loan;
repeat row leads with Split Pay to interest-bearing conversion value.

Co-Authored-By: Claude Opus 5.5 <noreply@anthropic.com>
Claude-Session: https://claude.ai/code/session_01W2UPg5WygeJNMeisH6AsMo
</commit_message>
<xml_diff>
--- a/deck/portfolio_recommendation.pptx
+++ b/deck/portfolio_recommendation.pptx
@@ -602,7 +602,7 @@
             <c:size val="7"/>
             <c:spPr>
               <a:solidFill>
-                <a:srgbClr val="4A4AF4"/>
+                <a:srgbClr val="5B5B73"/>
               </a:solidFill>
               <a:ln w="9525" cap="flat">
                 <a:solidFill>
@@ -17934,9 +17934,9 @@
             <a:tbl>
               <a:tblPr/>
               <a:tblGrid>
-                <a:gridCol w="2148840"/>
-                <a:gridCol w="2651760"/>
-                <a:gridCol w="2788920"/>
+                <a:gridCol w="2103120"/>
+                <a:gridCol w="2377440"/>
+                <a:gridCol w="3108960"/>
                 <a:gridCol w="1143000"/>
                 <a:gridCol w="1188720"/>
                 <a:gridCol w="1173175"/>
@@ -18351,7 +18351,7 @@
                   </a:tcPr>
                 </a:tc>
               </a:tr>
-              <a:tr h="804672">
+              <a:tr h="960120">
                 <a:tc>
                   <a:txBody>
                     <a:bodyPr/>
@@ -18526,7 +18526,7 @@
                           <a:ea typeface="Arial" pitchFamily="34" charset="-122"/>
                           <a:cs typeface="Arial" pitchFamily="34" charset="-120"/>
                         </a:rPr>
-                        <a:t>Merchant acquisition: +10% / +20% vertical GMV (≈ 1 new merchant each at +20%)</a:t>
+                        <a:t>Each new merchant brings ~57 (healthcare) / ~122 (home) customers a year, ~1 loan each, at ~$176 / ~$78 profit per loan (~$10K per merchant). +10% / +20% GMV ≈ 0.3–0.8 new merchants per vertical</a:t>
                       </a:r>
                       <a:endParaRPr lang="en-US" sz="1100" dirty="0">
                         <a:latin typeface="Arial" charset="0"/>
@@ -18845,7 +18845,7 @@
                   </a:tcPr>
                 </a:tc>
               </a:tr>
-              <a:tr h="804672">
+              <a:tr h="960120">
                 <a:tc>
                   <a:txBody>
                     <a:bodyPr/>
@@ -19020,7 +19020,7 @@
                           <a:ea typeface="Arial" pitchFamily="34" charset="-122"/>
                           <a:cs typeface="Arial" pitchFamily="34" charset="-120"/>
                         </a:rPr>
-                        <a:t>+5 / +10 pts big-ticket repeat rate; 5% / 10% of repeat loans Split Pay → interest-bearing</a:t>
+                        <a:t>Marketing offers that move repeat Split Pay customers to interest-bearing: +$49 profit per conversion (~145 / ~290 conversions). Plus +5 / +10 pts big-ticket repeat rate (~$126 profit per extra loan)</a:t>
                       </a:r>
                       <a:endParaRPr lang="en-US" sz="1100" dirty="0">
                         <a:latin typeface="Arial" charset="0"/>
@@ -19339,7 +19339,7 @@
                   </a:tcPr>
                 </a:tc>
               </a:tr>
-              <a:tr h="804672">
+              <a:tr h="868680">
                 <a:tc>
                   <a:txBody>
                     <a:bodyPr/>
@@ -19446,7 +19446,7 @@
                           <a:ea typeface="Arial" pitchFamily="34" charset="-122"/>
                           <a:cs typeface="Arial" pitchFamily="34" charset="-120"/>
                         </a:rPr>
-                        <a:t>~43% bad rate, 6.4% loss; margin ~1% if delinquents charge off</a:t>
+                        <a:t>35% of travel GMV but 64% of its losses (43% bad rate); if delinquents charge off, travel margin falls 9.4% → 5.2%</a:t>
                       </a:r>
                       <a:endParaRPr lang="en-US" sz="1100" dirty="0">
                         <a:latin typeface="Arial" charset="0"/>
@@ -19833,7 +19833,7 @@
                   </a:tcPr>
                 </a:tc>
               </a:tr>
-              <a:tr h="804672">
+              <a:tr h="731520">
                 <a:tc>
                   <a:txBody>
                     <a:bodyPr/>
@@ -20264,7 +20264,7 @@
                   </a:tcPr>
                 </a:tc>
               </a:tr>
-              <a:tr h="566928">
+              <a:tr h="548640">
                 <a:tc>
                   <a:txBody>
                     <a:bodyPr/>
@@ -20616,45 +20616,6 @@
       <p:sp>
         <p:nvSpPr>
           <p:cNvPr id="5" name="Text 2"/>
-          <p:cNvSpPr txBox="1"/>
-          <p:nvPr/>
-        </p:nvSpPr>
-        <p:spPr>
-          <a:xfrm>
-            <a:off x="548640" y="5715000"/>
-            <a:ext cx="11094415" cy="457200"/>
-          </a:xfrm>
-          <a:prstGeom prst="rect">
-            <a:avLst/>
-          </a:prstGeom>
-          <a:noFill/>
-          <a:ln/>
-        </p:spPr>
-        <p:txBody>
-          <a:bodyPr wrap="square" lIns="0" tIns="0" rIns="0" bIns="0" rtlCol="0" anchor="t"/>
-          <a:lstStyle/>
-          <a:p>
-            <a:pPr indent="0" marL="0">
-              <a:buNone/>
-            </a:pPr>
-            <a:r>
-              <a:rPr lang="en-US" sz="1200" i="1" dirty="0">
-                <a:solidFill>
-                  <a:srgbClr val="5B5B73"/>
-                </a:solidFill>
-                <a:latin typeface="Arial" pitchFamily="34" charset="0"/>
-                <a:ea typeface="Arial" pitchFamily="34" charset="-122"/>
-                <a:cs typeface="Arial" pitchFamily="34" charset="-120"/>
-              </a:rPr>
-              <a:t>Profit grows faster than GMV and the loss rate falls: growth goes to low-loss verticals and repeat customers, and exposure is cut where risk is concentrated.</a:t>
-            </a:r>
-            <a:endParaRPr lang="en-US" sz="1200" dirty="0"/>
-          </a:p>
-        </p:txBody>
-      </p:sp>
-      <p:sp>
-        <p:nvSpPr>
-          <p:cNvPr id="6" name="Text 3"/>
           <p:cNvSpPr txBox="1"/>
           <p:nvPr/>
         </p:nvSpPr>

</xml_diff>

<commit_message>
Update deck to latest hand-edited version; add new-customer flag row
Take the author's latest deck and add a data-quality row for the
is_new_to_affirm inconsistencies resolved by de-duplication.

Co-Authored-By: Claude Opus 5.5 <noreply@anthropic.com>
Claude-Session: https://claude.ai/code/session_01W2UPg5WygeJNMeisH6AsMo
</commit_message>
<xml_diff>
--- a/deck/portfolio_recommendation.pptx
+++ b/deck/portfolio_recommendation.pptx
@@ -13,7 +13,7 @@
     <p:sldId id="258" r:id="rId4"/>
     <p:sldId id="266" r:id="rId5"/>
     <p:sldId id="267" r:id="rId6"/>
-    <p:sldId id="261" r:id="rId7"/>
+    <p:sldId id="269" r:id="rId7"/>
     <p:sldId id="262" r:id="rId8"/>
     <p:sldId id="263" r:id="rId9"/>
     <p:sldId id="264" r:id="rId10"/>
@@ -1824,10 +1824,7 @@
           <a:bodyPr/>
           <a:lstStyle/>
           <a:p>
-            <a:r>
-              <a:rPr lang="en-US" dirty="0"/>
-              <a:t>Goal: where to add and where to pull back capital next year. One-line answer: grow healthcare and home furnishing merchants, invest in turning first-time customers into repeat customers, and tighten credit for the riskiest travel borrowers. The portfolio in scope: $4.0M GMV, 7,134 loans, 4,000 consumers, ~7% contribution margin after losses and funding.</a:t>
-            </a:r>
+            <a:endParaRPr lang="en-US" dirty="0"/>
           </a:p>
         </p:txBody>
       </p:sp>
@@ -2079,10 +2076,7 @@
           <a:bodyPr/>
           <a:lstStyle/>
           <a:p>
-            <a:r>
-              <a:rPr lang="en-US" dirty="0"/>
-              <a:t>Healthy trajectory: GMV up every quarter, 33% year over year for the second half. Credit quality is stable: average FICO ~652 throughout. Economics: revenue 10% of GMV, loss 2%, funding 1%, leaving ~7% contribution. Two things to flag: growth is led by interest-bearing, which is good, but also by fashion, our lowest-margin vertical; and the Q4-2024 holiday vintage had double the bad rate. Recent quarters show lower margins only because those loans are young.</a:t>
-            </a:r>
+            <a:endParaRPr lang="en-US" dirty="0"/>
           </a:p>
         </p:txBody>
       </p:sp>
@@ -2166,10 +2160,7 @@
           <a:bodyPr/>
           <a:lstStyle/>
           <a:p>
-            <a:r>
-              <a:rPr lang="en-US" dirty="0"/>
-              <a:t>Sorted by margin. Travel has five times the bad rate of any other vertical, but it is still our largest profit pool because revenue is high. The risk is concentrated in sub-640 FICO travel borrowers: 40% bad rate, and the margin disappears if the delinquent loans charge off. Fashion is half our loans but a tenth of profit. Healthcare and home furnishing combine low loss with high revenue. By product, interest-bearing earns 82% of profit.</a:t>
-            </a:r>
+            <a:endParaRPr lang="en-US" dirty="0"/>
           </a:p>
         </p:txBody>
       </p:sp>
@@ -2253,10 +2244,7 @@
           <a:bodyPr/>
           <a:lstStyle/>
           <a:p>
-            <a:r>
-              <a:rPr lang="en-US" dirty="0"/>
-              <a:t>Same view by product. Interest-bearing is where the profit is: its loss rate is the highest, but interest income more than covers it. 0% APR is our safest product, yet it earns a third of the interest-bearing margin: we give up the interest, fund a 12-18 month loan, and the merchant fee is not higher — at the same merchants it is actually lower than on interest-bearing loans. That is the basis for repricing. Split Pay is thin too, but it is the entry product that leads customers to interest-bearing, so we keep it as an acquisition tool rather than reprice it.</a:t>
-            </a:r>
+            <a:endParaRPr lang="en-US" dirty="0"/>
           </a:p>
         </p:txBody>
       </p:sp>
@@ -2340,10 +2328,7 @@
           <a:bodyPr/>
           <a:lstStyle/>
           <a:p>
-            <a:r>
-              <a:rPr lang="en-US" dirty="0"/>
-              <a:t>A customer who repays their first loan is a much better risk the second time: loss falls from 2.6% to 1.0%, and that holds in every vertical and product, including on seasoned loans. 82% of loss dollars come from first loans. Repeat rates are set by the vertical: frequent-purchase verticals like fashion and electronics already get ~95%; big-ticket verticals only ~20%, which is where the upside is. Split Pay works as an entry product: most customers move to interest-bearing on their next loan. And customers mostly come back to the same vertical (86%), so repeat growth has to be built vertical by vertical — cross-selling is small.</a:t>
-            </a:r>
+            <a:endParaRPr lang="en-US" dirty="0"/>
           </a:p>
         </p:txBody>
       </p:sp>
@@ -2427,10 +2412,7 @@
           <a:bodyPr/>
           <a:lstStyle/>
           <a:p>
-            <a:r>
-              <a:rPr lang="en-US" dirty="0"/>
-              <a:t>Four moves, each with the evidence and the sizing on one line. Two where we invest: healthcare and home furnishing merchants — one new average merchant adds 25–35% to the vertical — and repeat customers, which is the biggest profit lever. One where we pull back: travel below 640 FICO, through the risk model's cut-off and limits; it costs some profit, a deliberate trade for lower risk. One pricing fix: 0% APR merchant fee, shown separately because it depends on how merchants respond. Net: profit +7–15%, GMV +4–8%, and the loss rate goes down.</a:t>
-            </a:r>
+            <a:endParaRPr lang="en-US" dirty="0"/>
           </a:p>
         </p:txBody>
       </p:sp>
@@ -2514,10 +2496,7 @@
           <a:bodyPr/>
           <a:lstStyle/>
           <a:p>
-            <a:r>
-              <a:rPr lang="en-US" dirty="0"/>
-              <a:t>Be explicit about trade-offs: the travel tightening is a risk decision, not a profit one. Caveats on data. Three things to watch, notably Split Pay loss creeping up, which is the cleanest read on credit trend because those loans complete in six weeks. Next steps are pilots rather than big-bang changes.</a:t>
-            </a:r>
+            <a:endParaRPr lang="en-US" dirty="0"/>
           </a:p>
         </p:txBody>
       </p:sp>
@@ -9763,7 +9742,7 @@
           <p:nvPr>
             <p:extLst>
               <p:ext uri="{D42A27DB-BD31-4B8C-83A1-F6EECF244321}">
-                <p14:modId xmlns:p14="http://schemas.microsoft.com/office/powerpoint/2010/main" val="3999698773"/>
+                <p14:modId xmlns:p14="http://schemas.microsoft.com/office/powerpoint/2010/main" val="698644564"/>
               </p:ext>
             </p:extLst>
           </p:nvPr>
@@ -11694,8 +11673,22 @@
                     <a:bodyPr/>
                     <a:lstStyle/>
                     <a:p>
-                      <a:pPr marL="0" indent="0" algn="l">
+                      <a:pPr marL="0" marR="0" lvl="0" indent="0" algn="l" defTabSz="914400" rtl="0" eaLnBrk="1" fontAlgn="auto" latinLnBrk="0" hangingPunct="1">
+                        <a:lnSpc>
+                          <a:spcPct val="100000"/>
+                        </a:lnSpc>
+                        <a:spcBef>
+                          <a:spcPts val="0"/>
+                        </a:spcBef>
+                        <a:spcAft>
+                          <a:spcPts val="0"/>
+                        </a:spcAft>
+                        <a:buClrTx/>
+                        <a:buSzTx/>
+                        <a:buFontTx/>
                         <a:buNone/>
+                        <a:tabLst/>
+                        <a:defRPr/>
                       </a:pPr>
                       <a:r>
                         <a:rPr lang="en-US" sz="1200" b="1" dirty="0">
@@ -11706,13 +11699,8 @@
                           <a:ea typeface="Arial" pitchFamily="34" charset="-122"/>
                           <a:cs typeface="Arial" pitchFamily="34" charset="-120"/>
                         </a:rPr>
-                        <a:t>Fitness</a:t>
+                        <a:t>Home furnishing</a:t>
                       </a:r>
-                      <a:endParaRPr lang="en-US" sz="1200" dirty="0">
-                        <a:latin typeface="Arial" charset="0"/>
-                        <a:ea typeface="Arial" charset="0"/>
-                        <a:cs typeface="Arial" charset="0"/>
-                      </a:endParaRPr>
                     </a:p>
                   </a:txBody>
                   <a:tcPr marT="27432" marB="27432" anchor="ctr">
@@ -11834,6 +11822,17 @@
                         <a:buNone/>
                       </a:pPr>
                       <a:r>
+                        <a:rPr lang="en-US" altLang="zh-CN" sz="1200" dirty="0">
+                          <a:solidFill>
+                            <a:srgbClr val="1A1A2E"/>
+                          </a:solidFill>
+                          <a:latin typeface="Arial" pitchFamily="34" charset="0"/>
+                          <a:ea typeface="Arial" pitchFamily="34" charset="-122"/>
+                          <a:cs typeface="Arial" pitchFamily="34" charset="-120"/>
+                        </a:rPr>
+                        <a:t>14</a:t>
+                      </a:r>
+                      <a:r>
                         <a:rPr lang="en-US" sz="1200" dirty="0">
                           <a:solidFill>
                             <a:srgbClr val="1A1A2E"/>
@@ -11842,7 +11841,7 @@
                           <a:ea typeface="Arial" pitchFamily="34" charset="-122"/>
                           <a:cs typeface="Arial" pitchFamily="34" charset="-120"/>
                         </a:rPr>
-                        <a:t>7%</a:t>
+                        <a:t>%</a:t>
                       </a:r>
                       <a:endParaRPr lang="en-US" sz="1200" dirty="0">
                         <a:latin typeface="Arial" charset="0"/>
@@ -12106,6 +12105,17 @@
                         <a:buNone/>
                       </a:pPr>
                       <a:r>
+                        <a:rPr lang="en-US" altLang="zh-CN" sz="1200" dirty="0">
+                          <a:solidFill>
+                            <a:srgbClr val="1A1A2E"/>
+                          </a:solidFill>
+                          <a:latin typeface="Arial" pitchFamily="34" charset="0"/>
+                          <a:ea typeface="Arial" pitchFamily="34" charset="-122"/>
+                          <a:cs typeface="Arial" pitchFamily="34" charset="-120"/>
+                        </a:rPr>
+                        <a:t>15</a:t>
+                      </a:r>
+                      <a:r>
                         <a:rPr lang="en-US" sz="1200" dirty="0">
                           <a:solidFill>
                             <a:srgbClr val="1A1A2E"/>
@@ -12114,7 +12124,7 @@
                           <a:ea typeface="Arial" pitchFamily="34" charset="-122"/>
                           <a:cs typeface="Arial" pitchFamily="34" charset="-120"/>
                         </a:rPr>
-                        <a:t>7%</a:t>
+                        <a:t>%</a:t>
                       </a:r>
                       <a:endParaRPr lang="en-US" sz="1200" dirty="0">
                         <a:latin typeface="Arial" charset="0"/>
@@ -12177,8 +12187,22 @@
                     <a:bodyPr/>
                     <a:lstStyle/>
                     <a:p>
-                      <a:pPr marL="0" indent="0" algn="l">
+                      <a:pPr marL="0" marR="0" lvl="0" indent="0" algn="l" defTabSz="914400" rtl="0" eaLnBrk="1" fontAlgn="auto" latinLnBrk="0" hangingPunct="1">
+                        <a:lnSpc>
+                          <a:spcPct val="100000"/>
+                        </a:lnSpc>
+                        <a:spcBef>
+                          <a:spcPts val="0"/>
+                        </a:spcBef>
+                        <a:spcAft>
+                          <a:spcPts val="0"/>
+                        </a:spcAft>
+                        <a:buClrTx/>
+                        <a:buSzTx/>
+                        <a:buFontTx/>
                         <a:buNone/>
+                        <a:tabLst/>
+                        <a:defRPr/>
                       </a:pPr>
                       <a:r>
                         <a:rPr lang="en-US" sz="1200" b="1" dirty="0">
@@ -12189,7 +12213,7 @@
                           <a:ea typeface="Arial" pitchFamily="34" charset="-122"/>
                           <a:cs typeface="Arial" pitchFamily="34" charset="-120"/>
                         </a:rPr>
-                        <a:t>Home furnishing</a:t>
+                        <a:t>Fitness</a:t>
                       </a:r>
                       <a:endParaRPr lang="en-US" sz="1200" dirty="0">
                         <a:latin typeface="Arial" charset="0"/>
@@ -12317,6 +12341,17 @@
                         <a:buNone/>
                       </a:pPr>
                       <a:r>
+                        <a:rPr lang="en-US" altLang="zh-CN" sz="1200" dirty="0">
+                          <a:solidFill>
+                            <a:srgbClr val="1A1A2E"/>
+                          </a:solidFill>
+                          <a:latin typeface="Arial" pitchFamily="34" charset="0"/>
+                          <a:ea typeface="Arial" pitchFamily="34" charset="-122"/>
+                          <a:cs typeface="Arial" pitchFamily="34" charset="-120"/>
+                        </a:rPr>
+                        <a:t>7</a:t>
+                      </a:r>
+                      <a:r>
                         <a:rPr lang="en-US" sz="1200" dirty="0">
                           <a:solidFill>
                             <a:srgbClr val="1A1A2E"/>
@@ -12325,7 +12360,7 @@
                           <a:ea typeface="Arial" pitchFamily="34" charset="-122"/>
                           <a:cs typeface="Arial" pitchFamily="34" charset="-120"/>
                         </a:rPr>
-                        <a:t>14%</a:t>
+                        <a:t>%</a:t>
                       </a:r>
                       <a:endParaRPr lang="en-US" sz="1200" dirty="0">
                         <a:latin typeface="Arial" charset="0"/>
@@ -12449,13 +12484,13 @@
                     <a:bodyPr/>
                     <a:lstStyle/>
                     <a:p>
-                      <a:pPr marL="0" indent="0" algn="ctr">
+                      <a:pPr marL="0" indent="0" algn="ctr" defTabSz="914400" rtl="0" eaLnBrk="1" latinLnBrk="0" hangingPunct="1">
                         <a:buNone/>
                       </a:pPr>
                       <a:r>
-                        <a:rPr lang="en-US" sz="1200" dirty="0">
+                        <a:rPr lang="en-US" sz="1200" b="1" kern="1200" dirty="0">
                           <a:solidFill>
-                            <a:srgbClr val="1A1A2E"/>
+                            <a:srgbClr val="1E8A4C"/>
                           </a:solidFill>
                           <a:latin typeface="Arial" pitchFamily="34" charset="0"/>
                           <a:ea typeface="Arial" pitchFamily="34" charset="-122"/>
@@ -12463,10 +12498,13 @@
                         </a:rPr>
                         <a:t>1.3%</a:t>
                       </a:r>
-                      <a:endParaRPr lang="en-US" sz="1200" dirty="0">
-                        <a:latin typeface="Arial" charset="0"/>
+                      <a:endParaRPr lang="en-US" sz="1200" b="1" kern="1200" dirty="0">
+                        <a:solidFill>
+                          <a:srgbClr val="1E8A4C"/>
+                        </a:solidFill>
+                        <a:latin typeface="Arial" pitchFamily="34" charset="0"/>
                         <a:ea typeface="Arial" charset="0"/>
-                        <a:cs typeface="Arial" charset="0"/>
+                        <a:cs typeface="Arial" pitchFamily="34" charset="-120"/>
                       </a:endParaRPr>
                     </a:p>
                   </a:txBody>
@@ -12589,6 +12627,17 @@
                         <a:buNone/>
                       </a:pPr>
                       <a:r>
+                        <a:rPr lang="en-US" altLang="zh-CN" sz="1200" dirty="0">
+                          <a:solidFill>
+                            <a:srgbClr val="1A1A2E"/>
+                          </a:solidFill>
+                          <a:latin typeface="Arial" pitchFamily="34" charset="0"/>
+                          <a:ea typeface="Arial" pitchFamily="34" charset="-122"/>
+                          <a:cs typeface="Arial" pitchFamily="34" charset="-120"/>
+                        </a:rPr>
+                        <a:t>7</a:t>
+                      </a:r>
+                      <a:r>
                         <a:rPr lang="en-US" sz="1200" dirty="0">
                           <a:solidFill>
                             <a:srgbClr val="1A1A2E"/>
@@ -12597,7 +12646,7 @@
                           <a:ea typeface="Arial" pitchFamily="34" charset="-122"/>
                           <a:cs typeface="Arial" pitchFamily="34" charset="-120"/>
                         </a:rPr>
-                        <a:t>15%</a:t>
+                        <a:t>%</a:t>
                       </a:r>
                       <a:endParaRPr lang="en-US" sz="1200" dirty="0">
                         <a:latin typeface="Arial" charset="0"/>
@@ -14263,7 +14312,7 @@
                   <a:ea typeface="Arial" pitchFamily="34" charset="-122"/>
                   <a:cs typeface="Arial" pitchFamily="34" charset="-120"/>
                 </a:rPr>
-                <a:t>. It is 35% of travel GMV but 64% of travel losses. If delinquent loans charge off, travel's margin falls from 9.4% to 5.2%</a:t>
+                <a:t>. It is 35% of travel GMV but 64% of travel losses. If delinquent loans charge off, travel‘s margin falls from 9.4% to 5.2%.</a:t>
               </a:r>
               <a:endParaRPr lang="en-US" sz="1200" dirty="0"/>
             </a:p>
@@ -14409,7 +14458,29 @@
                 <a:ea typeface="Arial" pitchFamily="34" charset="-122"/>
                 <a:cs typeface="Arial" pitchFamily="34" charset="-120"/>
               </a:rPr>
-              <a:t> only earns ~1.2% margin, compared to 7.2% margin of interest-bearing in this vertical.</a:t>
+              <a:t> only earns ~1.2% margin, compared to 7.</a:t>
+            </a:r>
+            <a:r>
+              <a:rPr lang="en-US" altLang="zh-CN" sz="1200" dirty="0">
+                <a:solidFill>
+                  <a:srgbClr val="1A1A2E"/>
+                </a:solidFill>
+                <a:latin typeface="Arial" pitchFamily="34" charset="0"/>
+                <a:ea typeface="Arial" pitchFamily="34" charset="-122"/>
+                <a:cs typeface="Arial" pitchFamily="34" charset="-120"/>
+              </a:rPr>
+              <a:t>4</a:t>
+            </a:r>
+            <a:r>
+              <a:rPr lang="en-US" sz="1200" dirty="0">
+                <a:solidFill>
+                  <a:srgbClr val="1A1A2E"/>
+                </a:solidFill>
+                <a:latin typeface="Arial" pitchFamily="34" charset="0"/>
+                <a:ea typeface="Arial" pitchFamily="34" charset="-122"/>
+                <a:cs typeface="Arial" pitchFamily="34" charset="-120"/>
+              </a:rPr>
+              <a:t>% margin of interest-bearing in this vertical.</a:t>
             </a:r>
             <a:endParaRPr lang="en-US" sz="1200" dirty="0"/>
           </a:p>
@@ -18125,7 +18196,7 @@
                 <a:ea typeface="Arial" pitchFamily="34" charset="-122"/>
                 <a:cs typeface="Arial" pitchFamily="34" charset="-120"/>
               </a:rPr>
-              <a:t>Thin margin (2.4%) with loss as high as interest-bearing, but 63% of customers who start with Split Pay take an interest-bearing loan next.</a:t>
+              <a:t>Thin margin (2.4%) with loss close to interest-bearing, but 63% of customers who start with Split Pay take an interest-bearing loan next.</a:t>
             </a:r>
             <a:endParaRPr lang="en-US" sz="1200" dirty="0"/>
           </a:p>
@@ -18237,7 +18308,29 @@
                 <a:ea typeface="Arial" pitchFamily="34" charset="-122"/>
                 <a:cs typeface="Arial" pitchFamily="34" charset="-120"/>
               </a:rPr>
-              <a:t>Highest loss (2.38) is more than covered by 9.3% interest income — 58% of GMV, 82% of profit.</a:t>
+              <a:t>Highest loss (2.8</a:t>
+            </a:r>
+            <a:r>
+              <a:rPr lang="en-US" altLang="zh-CN" sz="1200" dirty="0">
+                <a:solidFill>
+                  <a:srgbClr val="1A1A2E"/>
+                </a:solidFill>
+                <a:latin typeface="Arial" pitchFamily="34" charset="0"/>
+                <a:ea typeface="Arial" pitchFamily="34" charset="-122"/>
+                <a:cs typeface="Arial" pitchFamily="34" charset="-120"/>
+              </a:rPr>
+              <a:t>%</a:t>
+            </a:r>
+            <a:r>
+              <a:rPr lang="en-US" sz="1200" dirty="0">
+                <a:solidFill>
+                  <a:srgbClr val="1A1A2E"/>
+                </a:solidFill>
+                <a:latin typeface="Arial" pitchFamily="34" charset="0"/>
+                <a:ea typeface="Arial" pitchFamily="34" charset="-122"/>
+                <a:cs typeface="Arial" pitchFamily="34" charset="-120"/>
+              </a:rPr>
+              <a:t>) is more than covered by 9.3% interest income — 58% of GMV, 82% of profit.</a:t>
             </a:r>
             <a:endParaRPr lang="en-US" sz="1200" dirty="0"/>
           </a:p>
@@ -18292,7 +18385,7 @@
                 <a:ea typeface="Arial" pitchFamily="34" charset="-122"/>
                 <a:cs typeface="Arial" pitchFamily="34" charset="-120"/>
               </a:rPr>
-              <a:t>Merchant fee and interest are % of GMV (dollar-weighted). Same-merchant comparison uses merchants have promo program. </a:t>
+              <a:t>Merchant fee and interest are % of GMV (dollar-weighted). Same-merchant comparison uses merchants with promo program. </a:t>
             </a:r>
           </a:p>
           <a:p>
@@ -18499,7 +18592,51 @@
                 <a:ea typeface="Arial" pitchFamily="34" charset="-122"/>
                 <a:cs typeface="Arial" pitchFamily="34" charset="-120"/>
               </a:rPr>
-              <a:t>2.6% vs 1.0%</a:t>
+              <a:t>2.</a:t>
+            </a:r>
+            <a:r>
+              <a:rPr lang="en-US" altLang="zh-CN" sz="2400" b="1" dirty="0">
+                <a:solidFill>
+                  <a:srgbClr val="4A4AF4"/>
+                </a:solidFill>
+                <a:latin typeface="Arial" pitchFamily="34" charset="0"/>
+                <a:ea typeface="Arial" pitchFamily="34" charset="-122"/>
+                <a:cs typeface="Arial" pitchFamily="34" charset="-120"/>
+              </a:rPr>
+              <a:t>8</a:t>
+            </a:r>
+            <a:r>
+              <a:rPr lang="en-US" sz="2400" b="1" dirty="0">
+                <a:solidFill>
+                  <a:srgbClr val="4A4AF4"/>
+                </a:solidFill>
+                <a:latin typeface="Arial" pitchFamily="34" charset="0"/>
+                <a:ea typeface="Arial" pitchFamily="34" charset="-122"/>
+                <a:cs typeface="Arial" pitchFamily="34" charset="-120"/>
+              </a:rPr>
+              <a:t>% vs 1.</a:t>
+            </a:r>
+            <a:r>
+              <a:rPr lang="en-US" altLang="zh-CN" sz="2400" b="1" dirty="0">
+                <a:solidFill>
+                  <a:srgbClr val="4A4AF4"/>
+                </a:solidFill>
+                <a:latin typeface="Arial" pitchFamily="34" charset="0"/>
+                <a:ea typeface="Arial" pitchFamily="34" charset="-122"/>
+                <a:cs typeface="Arial" pitchFamily="34" charset="-120"/>
+              </a:rPr>
+              <a:t>1</a:t>
+            </a:r>
+            <a:r>
+              <a:rPr lang="en-US" sz="2400" b="1" dirty="0">
+                <a:solidFill>
+                  <a:srgbClr val="4A4AF4"/>
+                </a:solidFill>
+                <a:latin typeface="Arial" pitchFamily="34" charset="0"/>
+                <a:ea typeface="Arial" pitchFamily="34" charset="-122"/>
+                <a:cs typeface="Arial" pitchFamily="34" charset="-120"/>
+              </a:rPr>
+              <a:t>%</a:t>
             </a:r>
             <a:endParaRPr lang="en-US" sz="2400" dirty="0"/>
           </a:p>
@@ -19065,7 +19202,13 @@
           <p:cNvGraphicFramePr>
             <a:graphicFrameLocks noGrp="1"/>
           </p:cNvGraphicFramePr>
-          <p:nvPr/>
+          <p:nvPr>
+            <p:extLst>
+              <p:ext uri="{D42A27DB-BD31-4B8C-83A1-F6EECF244321}">
+                <p14:modId xmlns:p14="http://schemas.microsoft.com/office/powerpoint/2010/main" val="819181488"/>
+              </p:ext>
+            </p:extLst>
+          </p:nvPr>
         </p:nvGraphicFramePr>
         <p:xfrm>
           <a:off x="548640" y="1371600"/>
@@ -19573,7 +19716,23 @@
                           <a:ea typeface="Arial" pitchFamily="34" charset="-122"/>
                           <a:cs typeface="Arial" pitchFamily="34" charset="-120"/>
                         </a:rPr>
-                        <a:t>Grow healthcare &amp; home furnishing</a:t>
+                        <a:t>Grow healthcare &amp;</a:t>
+                      </a:r>
+                    </a:p>
+                    <a:p>
+                      <a:pPr marL="0" indent="0">
+                        <a:buNone/>
+                      </a:pPr>
+                      <a:r>
+                        <a:rPr lang="en-US" sz="1100" b="1" dirty="0">
+                          <a:solidFill>
+                            <a:srgbClr val="1A1A2E"/>
+                          </a:solidFill>
+                          <a:latin typeface="Arial" pitchFamily="34" charset="0"/>
+                          <a:ea typeface="Arial" pitchFamily="34" charset="-122"/>
+                          <a:cs typeface="Arial" pitchFamily="34" charset="-120"/>
+                        </a:rPr>
+                        <a:t>home furnishing</a:t>
                       </a:r>
                       <a:endParaRPr lang="en-US" sz="1100" dirty="0">
                         <a:latin typeface="Arial" charset="0"/>
@@ -22632,14 +22791,14 @@
           <p:nvPr>
             <p:extLst>
               <p:ext uri="{D42A27DB-BD31-4B8C-83A1-F6EECF244321}">
-                <p14:modId xmlns:p14="http://schemas.microsoft.com/office/powerpoint/2010/main" val="1579011935"/>
+                <p14:modId xmlns:p14="http://schemas.microsoft.com/office/powerpoint/2010/main" val="4020984345"/>
               </p:ext>
             </p:extLst>
           </p:nvPr>
         </p:nvGraphicFramePr>
         <p:xfrm>
           <a:off x="548640" y="1463040"/>
-          <a:ext cx="11094415" cy="3968496"/>
+          <a:ext cx="11094415" cy="4023360"/>
         </p:xfrm>
         <a:graphic>
           <a:graphicData uri="http://schemas.openxmlformats.org/drawingml/2006/table">
@@ -22668,7 +22827,7 @@
                   </a:extLst>
                 </a:gridCol>
               </a:tblGrid>
-              <a:tr h="566928">
+              <a:tr h="502920">
                 <a:tc>
                   <a:txBody>
                     <a:bodyPr/>
@@ -22879,7 +23038,7 @@
                   </a:ext>
                 </a:extLst>
               </a:tr>
-              <a:tr h="566928">
+              <a:tr h="502920">
                 <a:tc>
                   <a:txBody>
                     <a:bodyPr/>
@@ -23033,7 +23192,7 @@
                           <a:ea typeface="Arial" pitchFamily="34" charset="-122"/>
                           <a:cs typeface="Arial" pitchFamily="34" charset="-120"/>
                         </a:rPr>
-                        <a:t>Dropped the bad copy — also fixed user-table mismatches and new-customer flags</a:t>
+                        <a:t>Dropped the bad copy — also fixed user-table mismatches</a:t>
                       </a:r>
                       <a:endParaRPr lang="en-US" sz="1200" dirty="0">
                         <a:latin typeface="Arial" charset="0"/>
@@ -23090,7 +23249,218 @@
                   </a:ext>
                 </a:extLst>
               </a:tr>
-              <a:tr h="566928">
+              <a:tr h="502920">
+                <a:tc>
+                  <a:txBody>
+                    <a:bodyPr/>
+                    <a:lstStyle/>
+                    <a:p>
+                      <a:pPr marL="0" indent="0" algn="l">
+                        <a:buNone/>
+                      </a:pPr>
+                      <a:r>
+                        <a:rPr lang="en-US" sz="1200" dirty="0">
+                          <a:solidFill>
+                            <a:srgbClr val="1A1A2E"/>
+                          </a:solidFill>
+                          <a:latin typeface="Arial" pitchFamily="34" charset="0"/>
+                          <a:ea typeface="Arial" pitchFamily="34" charset="-122"/>
+                          <a:cs typeface="Arial" pitchFamily="34" charset="-120"/>
+                        </a:rPr>
+                        <a:t>New-customer flag inconsistent with loan order (flagged new but not the first loan, or first loan not flagged)</a:t>
+                      </a:r>
+                      <a:endParaRPr lang="en-US" sz="1200" dirty="0">
+                        <a:latin typeface="Arial" charset="0"/>
+                        <a:ea typeface="Arial" charset="0"/>
+                        <a:cs typeface="Arial" charset="0"/>
+                      </a:endParaRPr>
+                    </a:p>
+                  </a:txBody>
+                  <a:tcPr marT="27432" marB="27432" anchor="ctr">
+                    <a:lnL w="6350" cap="flat" cmpd="sng" algn="ctr">
+                      <a:solidFill>
+                        <a:srgbClr val="DADAF0"/>
+                      </a:solidFill>
+                      <a:prstDash val="solid"/>
+                      <a:round/>
+                      <a:headEnd type="none" w="med" len="med"/>
+                      <a:tailEnd type="none" w="med" len="med"/>
+                    </a:lnL>
+                    <a:lnR w="6350" cap="flat" cmpd="sng" algn="ctr">
+                      <a:solidFill>
+                        <a:srgbClr val="DADAF0"/>
+                      </a:solidFill>
+                      <a:prstDash val="solid"/>
+                      <a:round/>
+                      <a:headEnd type="none" w="med" len="med"/>
+                      <a:tailEnd type="none" w="med" len="med"/>
+                    </a:lnR>
+                    <a:lnT w="6350" cap="flat" cmpd="sng" algn="ctr">
+                      <a:solidFill>
+                        <a:srgbClr val="DADAF0"/>
+                      </a:solidFill>
+                      <a:prstDash val="solid"/>
+                      <a:round/>
+                      <a:headEnd type="none" w="med" len="med"/>
+                      <a:tailEnd type="none" w="med" len="med"/>
+                    </a:lnT>
+                    <a:lnB w="6350" cap="flat" cmpd="sng" algn="ctr">
+                      <a:solidFill>
+                        <a:srgbClr val="DADAF0"/>
+                      </a:solidFill>
+                      <a:prstDash val="solid"/>
+                      <a:round/>
+                      <a:headEnd type="none" w="med" len="med"/>
+                      <a:tailEnd type="none" w="med" len="med"/>
+                    </a:lnB>
+                    <a:solidFill>
+                      <a:srgbClr val="F6F6FE"/>
+                    </a:solidFill>
+                  </a:tcPr>
+                </a:tc>
+                <a:tc>
+                  <a:txBody>
+                    <a:bodyPr/>
+                    <a:lstStyle/>
+                    <a:p>
+                      <a:pPr marL="0" indent="0" algn="ctr">
+                        <a:buNone/>
+                      </a:pPr>
+                      <a:r>
+                        <a:rPr lang="en-US" sz="1200" b="1" dirty="0">
+                          <a:solidFill>
+                            <a:srgbClr val="1A1A2E"/>
+                          </a:solidFill>
+                          <a:latin typeface="Arial" pitchFamily="34" charset="0"/>
+                          <a:ea typeface="Arial" pitchFamily="34" charset="-122"/>
+                          <a:cs typeface="Arial" pitchFamily="34" charset="-120"/>
+                        </a:rPr>
+                        <a:t>152 (133 + 19)</a:t>
+                      </a:r>
+                      <a:endParaRPr lang="en-US" sz="1200" dirty="0">
+                        <a:latin typeface="Arial" charset="0"/>
+                        <a:ea typeface="Arial" charset="0"/>
+                        <a:cs typeface="Arial" charset="0"/>
+                      </a:endParaRPr>
+                    </a:p>
+                  </a:txBody>
+                  <a:tcPr marT="27432" marB="27432" anchor="ctr">
+                    <a:lnL w="6350" cap="flat" cmpd="sng" algn="ctr">
+                      <a:solidFill>
+                        <a:srgbClr val="DADAF0"/>
+                      </a:solidFill>
+                      <a:prstDash val="solid"/>
+                      <a:round/>
+                      <a:headEnd type="none" w="med" len="med"/>
+                      <a:tailEnd type="none" w="med" len="med"/>
+                    </a:lnL>
+                    <a:lnR w="6350" cap="flat" cmpd="sng" algn="ctr">
+                      <a:solidFill>
+                        <a:srgbClr val="DADAF0"/>
+                      </a:solidFill>
+                      <a:prstDash val="solid"/>
+                      <a:round/>
+                      <a:headEnd type="none" w="med" len="med"/>
+                      <a:tailEnd type="none" w="med" len="med"/>
+                    </a:lnR>
+                    <a:lnT w="6350" cap="flat" cmpd="sng" algn="ctr">
+                      <a:solidFill>
+                        <a:srgbClr val="DADAF0"/>
+                      </a:solidFill>
+                      <a:prstDash val="solid"/>
+                      <a:round/>
+                      <a:headEnd type="none" w="med" len="med"/>
+                      <a:tailEnd type="none" w="med" len="med"/>
+                    </a:lnT>
+                    <a:lnB w="6350" cap="flat" cmpd="sng" algn="ctr">
+                      <a:solidFill>
+                        <a:srgbClr val="DADAF0"/>
+                      </a:solidFill>
+                      <a:prstDash val="solid"/>
+                      <a:round/>
+                      <a:headEnd type="none" w="med" len="med"/>
+                      <a:tailEnd type="none" w="med" len="med"/>
+                    </a:lnB>
+                    <a:solidFill>
+                      <a:srgbClr val="F6F6FE"/>
+                    </a:solidFill>
+                  </a:tcPr>
+                </a:tc>
+                <a:tc>
+                  <a:txBody>
+                    <a:bodyPr/>
+                    <a:lstStyle/>
+                    <a:p>
+                      <a:pPr marL="0" indent="0" algn="l">
+                        <a:buNone/>
+                      </a:pPr>
+                      <a:r>
+                        <a:rPr lang="en-US" sz="1200" dirty="0">
+                          <a:solidFill>
+                            <a:srgbClr val="1A1A2E"/>
+                          </a:solidFill>
+                          <a:latin typeface="Arial" pitchFamily="34" charset="0"/>
+                          <a:ea typeface="Arial" pitchFamily="34" charset="-122"/>
+                          <a:cs typeface="Arial" pitchFamily="34" charset="-120"/>
+                        </a:rPr>
+                        <a:t>No separate fix needed — resolved by dropping the duplicates; the flag now matches each user's first loan exactly</a:t>
+                      </a:r>
+                      <a:endParaRPr lang="en-US" sz="1200" dirty="0">
+                        <a:latin typeface="Arial" charset="0"/>
+                        <a:ea typeface="Arial" charset="0"/>
+                        <a:cs typeface="Arial" charset="0"/>
+                      </a:endParaRPr>
+                    </a:p>
+                  </a:txBody>
+                  <a:tcPr marT="27432" marB="27432" anchor="ctr">
+                    <a:lnL w="6350" cap="flat" cmpd="sng" algn="ctr">
+                      <a:solidFill>
+                        <a:srgbClr val="DADAF0"/>
+                      </a:solidFill>
+                      <a:prstDash val="solid"/>
+                      <a:round/>
+                      <a:headEnd type="none" w="med" len="med"/>
+                      <a:tailEnd type="none" w="med" len="med"/>
+                    </a:lnL>
+                    <a:lnR w="6350" cap="flat" cmpd="sng" algn="ctr">
+                      <a:solidFill>
+                        <a:srgbClr val="DADAF0"/>
+                      </a:solidFill>
+                      <a:prstDash val="solid"/>
+                      <a:round/>
+                      <a:headEnd type="none" w="med" len="med"/>
+                      <a:tailEnd type="none" w="med" len="med"/>
+                    </a:lnR>
+                    <a:lnT w="6350" cap="flat" cmpd="sng" algn="ctr">
+                      <a:solidFill>
+                        <a:srgbClr val="DADAF0"/>
+                      </a:solidFill>
+                      <a:prstDash val="solid"/>
+                      <a:round/>
+                      <a:headEnd type="none" w="med" len="med"/>
+                      <a:tailEnd type="none" w="med" len="med"/>
+                    </a:lnT>
+                    <a:lnB w="6350" cap="flat" cmpd="sng" algn="ctr">
+                      <a:solidFill>
+                        <a:srgbClr val="DADAF0"/>
+                      </a:solidFill>
+                      <a:prstDash val="solid"/>
+                      <a:round/>
+                      <a:headEnd type="none" w="med" len="med"/>
+                      <a:tailEnd type="none" w="med" len="med"/>
+                    </a:lnB>
+                    <a:solidFill>
+                      <a:srgbClr val="F6F6FE"/>
+                    </a:solidFill>
+                  </a:tcPr>
+                </a:tc>
+                <a:extLst>
+                  <a:ext uri="{0D108BD9-81ED-4DB2-BD59-A6C34878D82A}">
+                    <a16:rowId xmlns:a16="http://schemas.microsoft.com/office/drawing/2014/main" val="10002"/>
+                  </a:ext>
+                </a:extLst>
+              </a:tr>
+              <a:tr h="502920">
                 <a:tc>
                   <a:txBody>
                     <a:bodyPr/>
@@ -23155,7 +23525,7 @@
                       <a:tailEnd type="none" w="med" len="med"/>
                     </a:lnB>
                     <a:solidFill>
-                      <a:srgbClr val="F6F6FE"/>
+                      <a:srgbClr val="FFFFFF"/>
                     </a:solidFill>
                   </a:tcPr>
                 </a:tc>
@@ -23223,7 +23593,7 @@
                       <a:tailEnd type="none" w="med" len="med"/>
                     </a:lnB>
                     <a:solidFill>
-                      <a:srgbClr val="F6F6FE"/>
+                      <a:srgbClr val="FFFFFF"/>
                     </a:solidFill>
                   </a:tcPr>
                 </a:tc>
@@ -23291,7 +23661,7 @@
                       <a:tailEnd type="none" w="med" len="med"/>
                     </a:lnB>
                     <a:solidFill>
-                      <a:srgbClr val="F6F6FE"/>
+                      <a:srgbClr val="FFFFFF"/>
                     </a:solidFill>
                   </a:tcPr>
                 </a:tc>
@@ -23301,7 +23671,7 @@
                   </a:ext>
                 </a:extLst>
               </a:tr>
-              <a:tr h="566928">
+              <a:tr h="502920">
                 <a:tc>
                   <a:txBody>
                     <a:bodyPr/>
@@ -23366,7 +23736,7 @@
                       <a:tailEnd type="none" w="med" len="med"/>
                     </a:lnB>
                     <a:solidFill>
-                      <a:srgbClr val="FFFFFF"/>
+                      <a:srgbClr val="F6F6FE"/>
                     </a:solidFill>
                   </a:tcPr>
                 </a:tc>
@@ -23434,7 +23804,7 @@
                       <a:tailEnd type="none" w="med" len="med"/>
                     </a:lnB>
                     <a:solidFill>
-                      <a:srgbClr val="FFFFFF"/>
+                      <a:srgbClr val="F6F6FE"/>
                     </a:solidFill>
                   </a:tcPr>
                 </a:tc>
@@ -23502,7 +23872,7 @@
                       <a:tailEnd type="none" w="med" len="med"/>
                     </a:lnB>
                     <a:solidFill>
-                      <a:srgbClr val="FFFFFF"/>
+                      <a:srgbClr val="F6F6FE"/>
                     </a:solidFill>
                   </a:tcPr>
                 </a:tc>
@@ -23512,7 +23882,7 @@
                   </a:ext>
                 </a:extLst>
               </a:tr>
-              <a:tr h="566928">
+              <a:tr h="502920">
                 <a:tc>
                   <a:txBody>
                     <a:bodyPr/>
@@ -23577,7 +23947,7 @@
                       <a:tailEnd type="none" w="med" len="med"/>
                     </a:lnB>
                     <a:solidFill>
-                      <a:srgbClr val="F6F6FE"/>
+                      <a:srgbClr val="FFFFFF"/>
                     </a:solidFill>
                   </a:tcPr>
                 </a:tc>
@@ -23645,7 +24015,7 @@
                       <a:tailEnd type="none" w="med" len="med"/>
                     </a:lnB>
                     <a:solidFill>
-                      <a:srgbClr val="F6F6FE"/>
+                      <a:srgbClr val="FFFFFF"/>
                     </a:solidFill>
                   </a:tcPr>
                 </a:tc>
@@ -23713,7 +24083,7 @@
                       <a:tailEnd type="none" w="med" len="med"/>
                     </a:lnB>
                     <a:solidFill>
-                      <a:srgbClr val="F6F6FE"/>
+                      <a:srgbClr val="FFFFFF"/>
                     </a:solidFill>
                   </a:tcPr>
                 </a:tc>
@@ -23723,7 +24093,7 @@
                   </a:ext>
                 </a:extLst>
               </a:tr>
-              <a:tr h="566928">
+              <a:tr h="502920">
                 <a:tc>
                   <a:txBody>
                     <a:bodyPr/>
@@ -23788,7 +24158,7 @@
                       <a:tailEnd type="none" w="med" len="med"/>
                     </a:lnB>
                     <a:solidFill>
-                      <a:srgbClr val="FFFFFF"/>
+                      <a:srgbClr val="F6F6FE"/>
                     </a:solidFill>
                   </a:tcPr>
                 </a:tc>
@@ -23856,7 +24226,7 @@
                       <a:tailEnd type="none" w="med" len="med"/>
                     </a:lnB>
                     <a:solidFill>
-                      <a:srgbClr val="FFFFFF"/>
+                      <a:srgbClr val="F6F6FE"/>
                     </a:solidFill>
                   </a:tcPr>
                 </a:tc>
@@ -23924,7 +24294,7 @@
                       <a:tailEnd type="none" w="med" len="med"/>
                     </a:lnB>
                     <a:solidFill>
-                      <a:srgbClr val="FFFFFF"/>
+                      <a:srgbClr val="F6F6FE"/>
                     </a:solidFill>
                   </a:tcPr>
                 </a:tc>
@@ -23934,7 +24304,7 @@
                   </a:ext>
                 </a:extLst>
               </a:tr>
-              <a:tr h="566928">
+              <a:tr h="502920">
                 <a:tc>
                   <a:txBody>
                     <a:bodyPr/>
@@ -23999,7 +24369,7 @@
                       <a:tailEnd type="none" w="med" len="med"/>
                     </a:lnB>
                     <a:solidFill>
-                      <a:srgbClr val="F6F6FE"/>
+                      <a:srgbClr val="FFFFFF"/>
                     </a:solidFill>
                   </a:tcPr>
                 </a:tc>
@@ -24067,7 +24437,7 @@
                       <a:tailEnd type="none" w="med" len="med"/>
                     </a:lnB>
                     <a:solidFill>
-                      <a:srgbClr val="F6F6FE"/>
+                      <a:srgbClr val="FFFFFF"/>
                     </a:solidFill>
                   </a:tcPr>
                 </a:tc>
@@ -24135,7 +24505,7 @@
                       <a:tailEnd type="none" w="med" len="med"/>
                     </a:lnB>
                     <a:solidFill>
-                      <a:srgbClr val="F6F6FE"/>
+                      <a:srgbClr val="FFFFFF"/>
                     </a:solidFill>
                   </a:tcPr>
                 </a:tc>
@@ -24505,9 +24875,6 @@
           <a:bodyPr wrap="square" lIns="0" tIns="0" rIns="0" bIns="0" rtlCol="0" anchor="t"/>
           <a:lstStyle/>
           <a:p>
-            <a:pPr marL="0" indent="0">
-              <a:buNone/>
-            </a:pPr>
             <a:r>
               <a:rPr lang="en-US" sz="1250" dirty="0">
                 <a:solidFill>
@@ -24517,7 +24884,7 @@
                 <a:ea typeface="Arial" pitchFamily="34" charset="-122"/>
                 <a:cs typeface="Arial" pitchFamily="34" charset="-120"/>
               </a:rPr>
-              <a:t>Young loans haven't paid interest or defaulted yet. Loss/margin comparisons are checked on seasoned loans (originated by Jun 2025).</a:t>
+              <a:t>Young loans haven't paid interest or defaulted yet. Segment rates (bad rate, loss, fees, interest, margin) use seasoned loans (originated Jul 2024–Jun 2025); shares use all loans.</a:t>
             </a:r>
             <a:endParaRPr lang="en-US" sz="1250" dirty="0"/>
           </a:p>

</xml_diff>